<commit_message>
feat(01-02): tighten slide_motivation and rewrite slide_status as research journey
- slide_motivation: removed verbose secondary bullets, kept Problem/Solution/Impact
  and thesis question line (story arc load-bearing); down to 12 lines
- slide_status: replaced git-task-list with what-we-built/ran/found/open narrative;
  removed '131 tests', 'CI on every push', 'PubChem fetcher' language
- Script still generates 11 slides cleanly
</commit_message>
<xml_diff>
--- a/presentation/presentation_v2.pptx
+++ b/presentation/presentation_v2.pptx
@@ -4139,21 +4139,146 @@
               </a:defRPr>
             </a:pPr>
             <a:r>
-              <a:t># Current status (v1.1 in progress)</a:t>
-            </a:r>
-          </a:p>
-          <a:p>
-            <a:pPr>
-              <a:spcAft>
-                <a:spcPts val="300"/>
-              </a:spcAft>
-              <a:defRPr sz="1300">
-                <a:solidFill>
-                  <a:srgbClr val="8B949E"/>
-                </a:solidFill>
-                <a:latin typeface="Consolas"/>
-              </a:defRPr>
-            </a:pPr>
+              <a:t># What we built</a:t>
+            </a:r>
+          </a:p>
+          <a:p>
+            <a:pPr>
+              <a:spcAft>
+                <a:spcPts val="300"/>
+              </a:spcAft>
+              <a:defRPr sz="1300">
+                <a:solidFill>
+                  <a:srgbClr val="C9D1D9"/>
+                </a:solidFill>
+                <a:latin typeface="Consolas"/>
+              </a:defRPr>
+            </a:pPr>
+            <a:r>
+              <a:t>  ZMQ bridge: ML dipoles → Gaussian VPT2</a:t>
+            </a:r>
+          </a:p>
+          <a:p>
+            <a:pPr>
+              <a:spcAft>
+                <a:spcPts val="300"/>
+              </a:spcAft>
+              <a:defRPr sz="1300">
+                <a:solidFill>
+                  <a:srgbClr val="8B949E"/>
+                </a:solidFill>
+                <a:latin typeface="Consolas"/>
+              </a:defRPr>
+            </a:pPr>
+            <a:r>
+              <a:t>  CLI: mace-gaussian run molecule.xyz</a:t>
+            </a:r>
+          </a:p>
+          <a:p>
+            <a:pPr>
+              <a:spcAft>
+                <a:spcPts val="300"/>
+              </a:spcAft>
+              <a:defRPr sz="1300">
+                <a:solidFill>
+                  <a:srgbClr val="C9D1D9"/>
+                </a:solidFill>
+                <a:latin typeface="Consolas"/>
+              </a:defRPr>
+            </a:pPr>
+            <a:r>
+              <a:t>  4 energy × 2 dipole models = 8 combinations</a:t>
+            </a:r>
+          </a:p>
+          <a:p>
+            <a:pPr>
+              <a:spcAft>
+                <a:spcPts val="300"/>
+              </a:spcAft>
+              <a:defRPr sz="1300">
+                <a:solidFill>
+                  <a:srgbClr val="8B949E"/>
+                </a:solidFill>
+                <a:latin typeface="Consolas"/>
+              </a:defRPr>
+            </a:pPr>
+          </a:p>
+          <a:p>
+            <a:pPr>
+              <a:spcAft>
+                <a:spcPts val="300"/>
+              </a:spcAft>
+              <a:defRPr sz="1300">
+                <a:solidFill>
+                  <a:srgbClr val="58A6FF"/>
+                </a:solidFill>
+                <a:latin typeface="Consolas"/>
+              </a:defRPr>
+            </a:pPr>
+            <a:r>
+              <a:t># What we ran</a:t>
+            </a:r>
+          </a:p>
+          <a:p>
+            <a:pPr>
+              <a:spcAft>
+                <a:spcPts val="300"/>
+              </a:spcAft>
+              <a:defRPr sz="1300">
+                <a:solidFill>
+                  <a:srgbClr val="C9D1D9"/>
+                </a:solidFill>
+                <a:latin typeface="Consolas"/>
+              </a:defRPr>
+            </a:pPr>
+            <a:r>
+              <a:t>  Harmonic benchmark across 8 molecules</a:t>
+            </a:r>
+          </a:p>
+          <a:p>
+            <a:pPr>
+              <a:spcAft>
+                <a:spcPts val="300"/>
+              </a:spcAft>
+              <a:defRPr sz="1300">
+                <a:solidFill>
+                  <a:srgbClr val="8B949E"/>
+                </a:solidFill>
+                <a:latin typeface="Consolas"/>
+              </a:defRPr>
+            </a:pPr>
+            <a:r>
+              <a:t>  Water, aspirin, glycine, methane, ethane, NH₃, CO</a:t>
+            </a:r>
+          </a:p>
+          <a:p>
+            <a:pPr>
+              <a:spcAft>
+                <a:spcPts val="300"/>
+              </a:spcAft>
+              <a:defRPr sz="1300">
+                <a:solidFill>
+                  <a:srgbClr val="8B949E"/>
+                </a:solidFill>
+                <a:latin typeface="Consolas"/>
+              </a:defRPr>
+            </a:pPr>
+          </a:p>
+          <a:p>
+            <a:pPr>
+              <a:spcAft>
+                <a:spcPts val="300"/>
+              </a:spcAft>
+              <a:defRPr sz="1300">
+                <a:solidFill>
+                  <a:srgbClr val="58A6FF"/>
+                </a:solidFill>
+                <a:latin typeface="Consolas"/>
+              </a:defRPr>
+            </a:pPr>
+            <a:r>
+              <a:t># What we found</a:t>
+            </a:r>
           </a:p>
           <a:p>
             <a:pPr>
@@ -4168,7 +4293,7 @@
               </a:defRPr>
             </a:pPr>
             <a:r>
-              <a:t>  ✓ ZMQ bridge — stable</a:t>
+              <a:t>  Frequencies: R² &gt; 0.999 across all combos ✓</a:t>
             </a:r>
           </a:p>
           <a:p>
@@ -4184,7 +4309,7 @@
               </a:defRPr>
             </a:pPr>
             <a:r>
-              <a:t>  ✓ Anharmonic (VPT2) pipeline</a:t>
+              <a:t>  Intensities: mace_ml &gt;&gt; espaloma (0.72 vs 0.52)</a:t>
             </a:r>
           </a:p>
           <a:p>
@@ -4200,132 +4325,7 @@
               </a:defRPr>
             </a:pPr>
             <a:r>
-              <a:t>  ✓ CLI: mace-gaussian run/list</a:t>
-            </a:r>
-          </a:p>
-          <a:p>
-            <a:pPr>
-              <a:spcAft>
-                <a:spcPts val="300"/>
-              </a:spcAft>
-              <a:defRPr sz="1300">
-                <a:solidFill>
-                  <a:srgbClr val="3FB950"/>
-                </a:solidFill>
-                <a:latin typeface="Consolas"/>
-              </a:defRPr>
-            </a:pPr>
-            <a:r>
-              <a:t>  ✓ 4 calculator combinations</a:t>
-            </a:r>
-          </a:p>
-          <a:p>
-            <a:pPr>
-              <a:spcAft>
-                <a:spcPts val="300"/>
-              </a:spcAft>
-              <a:defRPr sz="1300">
-                <a:solidFill>
-                  <a:srgbClr val="3FB950"/>
-                </a:solidFill>
-                <a:latin typeface="Consolas"/>
-              </a:defRPr>
-            </a:pPr>
-            <a:r>
-              <a:t>  ✓ 131 tests, CI on every push</a:t>
-            </a:r>
-          </a:p>
-          <a:p>
-            <a:pPr>
-              <a:spcAft>
-                <a:spcPts val="300"/>
-              </a:spcAft>
-              <a:defRPr sz="1300">
-                <a:solidFill>
-                  <a:srgbClr val="3FB950"/>
-                </a:solidFill>
-                <a:latin typeface="Consolas"/>
-              </a:defRPr>
-            </a:pPr>
-            <a:r>
-              <a:t>  ✓ Aspirin, water, CH₄, acoh, BH₃·NH₃</a:t>
-            </a:r>
-          </a:p>
-          <a:p>
-            <a:pPr>
-              <a:spcAft>
-                <a:spcPts val="300"/>
-              </a:spcAft>
-              <a:defRPr sz="1300">
-                <a:solidFill>
-                  <a:srgbClr val="3FB950"/>
-                </a:solidFill>
-                <a:latin typeface="Consolas"/>
-              </a:defRPr>
-            </a:pPr>
-            <a:r>
-              <a:t>  ✓ HTML reports per molecule</a:t>
-            </a:r>
-          </a:p>
-          <a:p>
-            <a:pPr>
-              <a:spcAft>
-                <a:spcPts val="300"/>
-              </a:spcAft>
-              <a:defRPr sz="1300">
-                <a:solidFill>
-                  <a:srgbClr val="8B949E"/>
-                </a:solidFill>
-                <a:latin typeface="Consolas"/>
-              </a:defRPr>
-            </a:pPr>
-          </a:p>
-          <a:p>
-            <a:pPr>
-              <a:spcAft>
-                <a:spcPts val="300"/>
-              </a:spcAft>
-              <a:defRPr sz="1300">
-                <a:solidFill>
-                  <a:srgbClr val="D29922"/>
-                </a:solidFill>
-                <a:latin typeface="Consolas"/>
-              </a:defRPr>
-            </a:pPr>
-            <a:r>
-              <a:t>  ⟳ mace_off + mace_anicc wiring</a:t>
-            </a:r>
-          </a:p>
-          <a:p>
-            <a:pPr>
-              <a:spcAft>
-                <a:spcPts val="300"/>
-              </a:spcAft>
-              <a:defRPr sz="1300">
-                <a:solidFill>
-                  <a:srgbClr val="D29922"/>
-                </a:solidFill>
-                <a:latin typeface="Consolas"/>
-              </a:defRPr>
-            </a:pPr>
-            <a:r>
-              <a:t>  ⟳ Batch runner (25-mol campaign)</a:t>
-            </a:r>
-          </a:p>
-          <a:p>
-            <a:pPr>
-              <a:spcAft>
-                <a:spcPts val="300"/>
-              </a:spcAft>
-              <a:defRPr sz="1300">
-                <a:solidFill>
-                  <a:srgbClr val="D29922"/>
-                </a:solidFill>
-                <a:latin typeface="Consolas"/>
-              </a:defRPr>
-            </a:pPr>
-            <a:r>
-              <a:t>  ⟳ PubChem fetcher</a:t>
+              <a:t>  Speedup scales with molecule size (aspirin: ~18×)</a:t>
             </a:r>
           </a:p>
         </p:txBody>
@@ -4364,6 +4364,157 @@
               </a:defRPr>
             </a:pPr>
             <a:r>
+              <a:t># Still open</a:t>
+            </a:r>
+          </a:p>
+          <a:p>
+            <a:pPr>
+              <a:spcAft>
+                <a:spcPts val="300"/>
+              </a:spcAft>
+              <a:defRPr sz="1300">
+                <a:solidFill>
+                  <a:srgbClr val="8B949E"/>
+                </a:solidFill>
+                <a:latin typeface="Consolas"/>
+              </a:defRPr>
+            </a:pPr>
+          </a:p>
+          <a:p>
+            <a:pPr>
+              <a:spcAft>
+                <a:spcPts val="300"/>
+              </a:spcAft>
+              <a:defRPr sz="1300">
+                <a:solidFill>
+                  <a:srgbClr val="C9D1D9"/>
+                </a:solidFill>
+                <a:latin typeface="Consolas"/>
+              </a:defRPr>
+            </a:pPr>
+            <a:r>
+              <a:t>  Anharmonic validation:</a:t>
+            </a:r>
+          </a:p>
+          <a:p>
+            <a:pPr>
+              <a:spcAft>
+                <a:spcPts val="300"/>
+              </a:spcAft>
+              <a:defRPr sz="1300">
+                <a:solidFill>
+                  <a:srgbClr val="8B949E"/>
+                </a:solidFill>
+                <a:latin typeface="Consolas"/>
+              </a:defRPr>
+            </a:pPr>
+            <a:r>
+              <a:t>  → VPT2 pipeline runs; accuracy TBD</a:t>
+            </a:r>
+          </a:p>
+          <a:p>
+            <a:pPr>
+              <a:spcAft>
+                <a:spcPts val="300"/>
+              </a:spcAft>
+              <a:defRPr sz="1300">
+                <a:solidFill>
+                  <a:srgbClr val="8B949E"/>
+                </a:solidFill>
+                <a:latin typeface="Consolas"/>
+              </a:defRPr>
+            </a:pPr>
+            <a:r>
+              <a:t>  → Overtones + combination bands</a:t>
+            </a:r>
+          </a:p>
+          <a:p>
+            <a:pPr>
+              <a:spcAft>
+                <a:spcPts val="300"/>
+              </a:spcAft>
+              <a:defRPr sz="1300">
+                <a:solidFill>
+                  <a:srgbClr val="8B949E"/>
+                </a:solidFill>
+                <a:latin typeface="Consolas"/>
+              </a:defRPr>
+            </a:pPr>
+          </a:p>
+          <a:p>
+            <a:pPr>
+              <a:spcAft>
+                <a:spcPts val="300"/>
+              </a:spcAft>
+              <a:defRPr sz="1300">
+                <a:solidFill>
+                  <a:srgbClr val="C9D1D9"/>
+                </a:solidFill>
+                <a:latin typeface="Consolas"/>
+              </a:defRPr>
+            </a:pPr>
+            <a:r>
+              <a:t>  25-molecule benchmark campaign:</a:t>
+            </a:r>
+          </a:p>
+          <a:p>
+            <a:pPr>
+              <a:spcAft>
+                <a:spcPts val="300"/>
+              </a:spcAft>
+              <a:defRPr sz="1300">
+                <a:solidFill>
+                  <a:srgbClr val="8B949E"/>
+                </a:solidFill>
+                <a:latin typeface="Consolas"/>
+              </a:defRPr>
+            </a:pPr>
+            <a:r>
+              <a:t>  → Systematic across functional groups</a:t>
+            </a:r>
+          </a:p>
+          <a:p>
+            <a:pPr>
+              <a:spcAft>
+                <a:spcPts val="300"/>
+              </a:spcAft>
+              <a:defRPr sz="1300">
+                <a:solidFill>
+                  <a:srgbClr val="8B949E"/>
+                </a:solidFill>
+                <a:latin typeface="Consolas"/>
+              </a:defRPr>
+            </a:pPr>
+            <a:r>
+              <a:t>  → Batch runner in progress</a:t>
+            </a:r>
+          </a:p>
+          <a:p>
+            <a:pPr>
+              <a:spcAft>
+                <a:spcPts val="300"/>
+              </a:spcAft>
+              <a:defRPr sz="1300">
+                <a:solidFill>
+                  <a:srgbClr val="8B949E"/>
+                </a:solidFill>
+                <a:latin typeface="Consolas"/>
+              </a:defRPr>
+            </a:pPr>
+          </a:p>
+          <a:p>
+            <a:pPr>
+              <a:spcAft>
+                <a:spcPts val="300"/>
+              </a:spcAft>
+              <a:defRPr sz="1300">
+                <a:solidFill>
+                  <a:srgbClr val="58A6FF"/>
+                </a:solidFill>
+                <a:latin typeface="Consolas"/>
+              </a:defRPr>
+            </a:pPr>
+            <a:r>
               <a:t># Thesis question</a:t>
             </a:r>
           </a:p>
@@ -4374,209 +4525,45 @@
               </a:spcAft>
               <a:defRPr sz="1300">
                 <a:solidFill>
-                  <a:srgbClr val="8B949E"/>
-                </a:solidFill>
-                <a:latin typeface="Consolas"/>
-              </a:defRPr>
-            </a:pPr>
-          </a:p>
-          <a:p>
-            <a:pPr>
-              <a:spcAft>
-                <a:spcPts val="300"/>
-              </a:spcAft>
-              <a:defRPr sz="1300">
-                <a:solidFill>
-                  <a:srgbClr val="C9D1D9"/>
-                </a:solidFill>
-                <a:latin typeface="Consolas"/>
-              </a:defRPr>
-            </a:pPr>
-            <a:r>
-              <a:t>  Does energy surface quality or</a:t>
-            </a:r>
-          </a:p>
-          <a:p>
-            <a:pPr>
-              <a:spcAft>
-                <a:spcPts val="300"/>
-              </a:spcAft>
-              <a:defRPr sz="1300">
-                <a:solidFill>
-                  <a:srgbClr val="C9D1D9"/>
-                </a:solidFill>
-                <a:latin typeface="Consolas"/>
-              </a:defRPr>
-            </a:pPr>
-            <a:r>
-              <a:t>  dipole model quality dominate</a:t>
-            </a:r>
-          </a:p>
-          <a:p>
-            <a:pPr>
-              <a:spcAft>
-                <a:spcPts val="300"/>
-              </a:spcAft>
-              <a:defRPr sz="1300">
-                <a:solidFill>
-                  <a:srgbClr val="C9D1D9"/>
-                </a:solidFill>
-                <a:latin typeface="Consolas"/>
-              </a:defRPr>
-            </a:pPr>
-            <a:r>
-              <a:t>  IR accuracy?</a:t>
-            </a:r>
-          </a:p>
-          <a:p>
-            <a:pPr>
-              <a:spcAft>
-                <a:spcPts val="300"/>
-              </a:spcAft>
-              <a:defRPr sz="1300">
-                <a:solidFill>
-                  <a:srgbClr val="8B949E"/>
-                </a:solidFill>
-                <a:latin typeface="Consolas"/>
-              </a:defRPr>
-            </a:pPr>
-          </a:p>
-          <a:p>
-            <a:pPr>
-              <a:spcAft>
-                <a:spcPts val="300"/>
-              </a:spcAft>
-              <a:defRPr sz="1300">
-                <a:solidFill>
-                  <a:srgbClr val="C9D1D9"/>
-                </a:solidFill>
-                <a:latin typeface="Consolas"/>
-              </a:defRPr>
-            </a:pPr>
-            <a:r>
-              <a:t>  → Run systematic 25-molecule</a:t>
-            </a:r>
-          </a:p>
-          <a:p>
-            <a:pPr>
-              <a:spcAft>
-                <a:spcPts val="300"/>
-              </a:spcAft>
-              <a:defRPr sz="1300">
-                <a:solidFill>
-                  <a:srgbClr val="C9D1D9"/>
-                </a:solidFill>
-                <a:latin typeface="Consolas"/>
-              </a:defRPr>
-            </a:pPr>
-            <a:r>
-              <a:t>    benchmark across functional</a:t>
-            </a:r>
-          </a:p>
-          <a:p>
-            <a:pPr>
-              <a:spcAft>
-                <a:spcPts val="300"/>
-              </a:spcAft>
-              <a:defRPr sz="1300">
-                <a:solidFill>
-                  <a:srgbClr val="C9D1D9"/>
-                </a:solidFill>
-                <a:latin typeface="Consolas"/>
-              </a:defRPr>
-            </a:pPr>
-            <a:r>
-              <a:t>    groups and molecular sizes</a:t>
-            </a:r>
-          </a:p>
-          <a:p>
-            <a:pPr>
-              <a:spcAft>
-                <a:spcPts val="300"/>
-              </a:spcAft>
-              <a:defRPr sz="1300">
-                <a:solidFill>
-                  <a:srgbClr val="8B949E"/>
-                </a:solidFill>
-                <a:latin typeface="Consolas"/>
-              </a:defRPr>
-            </a:pPr>
-          </a:p>
-          <a:p>
-            <a:pPr>
-              <a:spcAft>
-                <a:spcPts val="300"/>
-              </a:spcAft>
-              <a:defRPr sz="1300">
-                <a:solidFill>
-                  <a:srgbClr val="58A6FF"/>
-                </a:solidFill>
-                <a:latin typeface="Consolas"/>
-              </a:defRPr>
-            </a:pPr>
-            <a:r>
-              <a:t># Long-term vision</a:t>
-            </a:r>
-          </a:p>
-          <a:p>
-            <a:pPr>
-              <a:spcAft>
-                <a:spcPts val="300"/>
-              </a:spcAft>
-              <a:defRPr sz="1300">
-                <a:solidFill>
-                  <a:srgbClr val="8B949E"/>
-                </a:solidFill>
-                <a:latin typeface="Consolas"/>
-              </a:defRPr>
-            </a:pPr>
-          </a:p>
-          <a:p>
-            <a:pPr>
-              <a:spcAft>
-                <a:spcPts val="300"/>
-              </a:spcAft>
-              <a:defRPr sz="1300">
-                <a:solidFill>
-                  <a:srgbClr val="C9D1D9"/>
-                </a:solidFill>
-                <a:latin typeface="Consolas"/>
-              </a:defRPr>
-            </a:pPr>
-            <a:r>
-              <a:t>  Universal ML-QM spectroscopy tool</a:t>
-            </a:r>
-          </a:p>
-          <a:p>
-            <a:pPr>
-              <a:spcAft>
-                <a:spcPts val="300"/>
-              </a:spcAft>
-              <a:defRPr sz="1300">
-                <a:solidFill>
-                  <a:srgbClr val="C9D1D9"/>
-                </a:solidFill>
-                <a:latin typeface="Consolas"/>
-              </a:defRPr>
-            </a:pPr>
-            <a:r>
-              <a:t>  any molecule · any combination ·</a:t>
-            </a:r>
-          </a:p>
-          <a:p>
-            <a:pPr>
-              <a:spcAft>
-                <a:spcPts val="300"/>
-              </a:spcAft>
-              <a:defRPr sz="1300">
-                <a:solidFill>
-                  <a:srgbClr val="8B949E"/>
-                </a:solidFill>
-                <a:latin typeface="Consolas"/>
-              </a:defRPr>
-            </a:pPr>
-            <a:r>
-              <a:t>  one command:</a:t>
+                  <a:srgbClr val="C9D1D9"/>
+                </a:solidFill>
+                <a:latin typeface="Consolas"/>
+              </a:defRPr>
+            </a:pPr>
+            <a:r>
+              <a:t>  Energy surface quality</a:t>
+            </a:r>
+          </a:p>
+          <a:p>
+            <a:pPr>
+              <a:spcAft>
+                <a:spcPts val="300"/>
+              </a:spcAft>
+              <a:defRPr sz="1300">
+                <a:solidFill>
+                  <a:srgbClr val="C9D1D9"/>
+                </a:solidFill>
+                <a:latin typeface="Consolas"/>
+              </a:defRPr>
+            </a:pPr>
+            <a:r>
+              <a:t>  vs dipole model quality —</a:t>
+            </a:r>
+          </a:p>
+          <a:p>
+            <a:pPr>
+              <a:spcAft>
+                <a:spcPts val="300"/>
+              </a:spcAft>
+              <a:defRPr sz="1300">
+                <a:solidFill>
+                  <a:srgbClr val="C9D1D9"/>
+                </a:solidFill>
+                <a:latin typeface="Consolas"/>
+              </a:defRPr>
+            </a:pPr>
+            <a:r>
+              <a:t>  which dominates IR accuracy?</a:t>
             </a:r>
           </a:p>
           <a:p>
@@ -4947,7 +4934,7 @@
               </a:defRPr>
             </a:pPr>
             <a:r>
-              <a:t>  → Hybrid ML-QM approach: ML computes dipole derivatives,</a:t>
+              <a:t>  → Hybrid ML-QM: ML computes dipole derivatives in real-time</a:t>
             </a:r>
           </a:p>
           <a:p>
@@ -4963,7 +4950,7 @@
               </a:defRPr>
             </a:pPr>
             <a:r>
-              <a:t>    Gaussian 16 handles the VPT2 orchestration</a:t>
+              <a:t>  → ZMQ bridge injects results into Gaussian — no modifications needed</a:t>
             </a:r>
           </a:p>
           <a:p>
@@ -4979,7 +4966,7 @@
               </a:defRPr>
             </a:pPr>
             <a:r>
-              <a:t>  → Real-time injection via ZMQ bridge — no Gaussian modifications</a:t>
+              <a:t>  → 10–100× faster than pure DFT for dipole-heavy steps</a:t>
             </a:r>
           </a:p>
           <a:p>
@@ -4989,14 +4976,11 @@
               </a:spcAft>
               <a:defRPr sz="1400">
                 <a:solidFill>
-                  <a:srgbClr val="C9D1D9"/>
-                </a:solidFill>
-                <a:latin typeface="Consolas"/>
-              </a:defRPr>
-            </a:pPr>
-            <a:r>
-              <a:t>  → 10-100× faster than pure DFT for dipole-heavy steps</a:t>
-            </a:r>
+                  <a:srgbClr val="8B949E"/>
+                </a:solidFill>
+                <a:latin typeface="Consolas"/>
+              </a:defRPr>
+            </a:pPr>
           </a:p>
           <a:p>
             <a:pPr>
@@ -5005,11 +4989,14 @@
               </a:spcAft>
               <a:defRPr sz="1400">
                 <a:solidFill>
-                  <a:srgbClr val="8B949E"/>
-                </a:solidFill>
-                <a:latin typeface="Consolas"/>
-              </a:defRPr>
-            </a:pPr>
+                  <a:srgbClr val="58A6FF"/>
+                </a:solidFill>
+                <a:latin typeface="Consolas"/>
+              </a:defRPr>
+            </a:pPr>
+            <a:r>
+              <a:t># Impact</a:t>
+            </a:r>
           </a:p>
           <a:p>
             <a:pPr>
@@ -5018,45 +5005,13 @@
               </a:spcAft>
               <a:defRPr sz="1400">
                 <a:solidFill>
-                  <a:srgbClr val="58A6FF"/>
-                </a:solidFill>
-                <a:latin typeface="Consolas"/>
-              </a:defRPr>
-            </a:pPr>
-            <a:r>
-              <a:t># Impact</a:t>
-            </a:r>
-          </a:p>
-          <a:p>
-            <a:pPr>
-              <a:spcAft>
-                <a:spcPts val="400"/>
-              </a:spcAft>
-              <a:defRPr sz="1400">
-                <a:solidFill>
-                  <a:srgbClr val="C9D1D9"/>
-                </a:solidFill>
-                <a:latin typeface="Consolas"/>
-              </a:defRPr>
-            </a:pPr>
-            <a:r>
-              <a:t>  → Rapid IR spectral predictions across chemical space</a:t>
-            </a:r>
-          </a:p>
-          <a:p>
-            <a:pPr>
-              <a:spcAft>
-                <a:spcPts val="400"/>
-              </a:spcAft>
-              <a:defRPr sz="1400">
-                <a:solidFill>
-                  <a:srgbClr val="C9D1D9"/>
-                </a:solidFill>
-                <a:latin typeface="Consolas"/>
-              </a:defRPr>
-            </a:pPr>
-            <a:r>
-              <a:t>  → Systematic benchmark: which ML model combination works best?</a:t>
+                  <a:srgbClr val="C9D1D9"/>
+                </a:solidFill>
+                <a:latin typeface="Consolas"/>
+              </a:defRPr>
+            </a:pPr>
+            <a:r>
+              <a:t>  → Rapid IR predictions across chemical space</a:t>
             </a:r>
           </a:p>
           <a:p>
@@ -5209,174 +5164,190 @@
               </a:defRPr>
             </a:pPr>
             <a:r>
-              <a:t># What is IR spectroscopy?</a:t>
-            </a:r>
-          </a:p>
-          <a:p>
-            <a:pPr>
-              <a:spcAft>
-                <a:spcPts val="300"/>
-              </a:spcAft>
-              <a:defRPr sz="1300">
-                <a:solidFill>
-                  <a:srgbClr val="8B949E"/>
-                </a:solidFill>
-                <a:latin typeface="Consolas"/>
-              </a:defRPr>
-            </a:pPr>
-          </a:p>
-          <a:p>
-            <a:pPr>
-              <a:spcAft>
-                <a:spcPts val="300"/>
-              </a:spcAft>
-              <a:defRPr sz="1300">
-                <a:solidFill>
-                  <a:srgbClr val="C9D1D9"/>
-                </a:solidFill>
-                <a:latin typeface="Consolas"/>
-              </a:defRPr>
-            </a:pPr>
-            <a:r>
-              <a:t>  Molecules vibrate at specific</a:t>
-            </a:r>
-          </a:p>
-          <a:p>
-            <a:pPr>
-              <a:spcAft>
-                <a:spcPts val="300"/>
-              </a:spcAft>
-              <a:defRPr sz="1300">
-                <a:solidFill>
-                  <a:srgbClr val="C9D1D9"/>
-                </a:solidFill>
-                <a:latin typeface="Consolas"/>
-              </a:defRPr>
-            </a:pPr>
-            <a:r>
-              <a:t>  frequencies determined by:</a:t>
-            </a:r>
-          </a:p>
-          <a:p>
-            <a:pPr>
-              <a:spcAft>
-                <a:spcPts val="300"/>
-              </a:spcAft>
-              <a:defRPr sz="1300">
-                <a:solidFill>
-                  <a:srgbClr val="C9D1D9"/>
-                </a:solidFill>
-                <a:latin typeface="Consolas"/>
-              </a:defRPr>
-            </a:pPr>
-            <a:r>
-              <a:t>  → bond stiffness (k)</a:t>
-            </a:r>
-          </a:p>
-          <a:p>
-            <a:pPr>
-              <a:spcAft>
-                <a:spcPts val="300"/>
-              </a:spcAft>
-              <a:defRPr sz="1300">
-                <a:solidFill>
-                  <a:srgbClr val="C9D1D9"/>
-                </a:solidFill>
-                <a:latin typeface="Consolas"/>
-              </a:defRPr>
-            </a:pPr>
-            <a:r>
-              <a:t>  → atomic masses (m)</a:t>
-            </a:r>
-          </a:p>
-          <a:p>
-            <a:pPr>
-              <a:spcAft>
-                <a:spcPts val="300"/>
-              </a:spcAft>
-              <a:defRPr sz="1300">
-                <a:solidFill>
-                  <a:srgbClr val="8B949E"/>
-                </a:solidFill>
-                <a:latin typeface="Consolas"/>
-              </a:defRPr>
-            </a:pPr>
-          </a:p>
-          <a:p>
-            <a:pPr>
-              <a:spcAft>
-                <a:spcPts val="300"/>
-              </a:spcAft>
-              <a:defRPr sz="1300">
-                <a:solidFill>
-                  <a:srgbClr val="C9D1D9"/>
-                </a:solidFill>
-                <a:latin typeface="Consolas"/>
-              </a:defRPr>
-            </a:pPr>
-            <a:r>
-              <a:t>  ω = √(k/m)         (harmonic)</a:t>
-            </a:r>
-          </a:p>
-          <a:p>
-            <a:pPr>
-              <a:spcAft>
-                <a:spcPts val="300"/>
-              </a:spcAft>
-              <a:defRPr sz="1300">
-                <a:solidFill>
-                  <a:srgbClr val="8B949E"/>
-                </a:solidFill>
-                <a:latin typeface="Consolas"/>
-              </a:defRPr>
-            </a:pPr>
-          </a:p>
-          <a:p>
-            <a:pPr>
-              <a:spcAft>
-                <a:spcPts val="300"/>
-              </a:spcAft>
-              <a:defRPr sz="1300">
-                <a:solidFill>
-                  <a:srgbClr val="C9D1D9"/>
-                </a:solidFill>
-                <a:latin typeface="Consolas"/>
-              </a:defRPr>
-            </a:pPr>
-            <a:r>
-              <a:t>  IR light is absorbed when:</a:t>
-            </a:r>
-          </a:p>
-          <a:p>
-            <a:pPr>
-              <a:spcAft>
-                <a:spcPts val="300"/>
-              </a:spcAft>
-              <a:defRPr sz="1300">
-                <a:solidFill>
-                  <a:srgbClr val="C9D1D9"/>
-                </a:solidFill>
-                <a:latin typeface="Consolas"/>
-              </a:defRPr>
-            </a:pPr>
-            <a:r>
-              <a:t>  → photon frequency = vib. frequency</a:t>
-            </a:r>
-          </a:p>
-          <a:p>
-            <a:pPr>
-              <a:spcAft>
-                <a:spcPts val="300"/>
-              </a:spcAft>
-              <a:defRPr sz="1300">
-                <a:solidFill>
-                  <a:srgbClr val="C9D1D9"/>
-                </a:solidFill>
-                <a:latin typeface="Consolas"/>
-              </a:defRPr>
-            </a:pPr>
-            <a:r>
-              <a:t>  → dipole moment changes (Δμ ≠ 0)</a:t>
+              <a:t># What the software computes</a:t>
+            </a:r>
+          </a:p>
+          <a:p>
+            <a:pPr>
+              <a:spcAft>
+                <a:spcPts val="300"/>
+              </a:spcAft>
+              <a:defRPr sz="1300">
+                <a:solidFill>
+                  <a:srgbClr val="8B949E"/>
+                </a:solidFill>
+                <a:latin typeface="Consolas"/>
+              </a:defRPr>
+            </a:pPr>
+          </a:p>
+          <a:p>
+            <a:pPr>
+              <a:spcAft>
+                <a:spcPts val="300"/>
+              </a:spcAft>
+              <a:defRPr sz="1300">
+                <a:solidFill>
+                  <a:srgbClr val="C9D1D9"/>
+                </a:solidFill>
+                <a:latin typeface="Consolas"/>
+              </a:defRPr>
+            </a:pPr>
+            <a:r>
+              <a:t>  Harmonic approximation:</a:t>
+            </a:r>
+          </a:p>
+          <a:p>
+            <a:pPr>
+              <a:spcAft>
+                <a:spcPts val="300"/>
+              </a:spcAft>
+              <a:defRPr sz="1300">
+                <a:solidFill>
+                  <a:srgbClr val="C9D1D9"/>
+                </a:solidFill>
+                <a:latin typeface="Consolas"/>
+              </a:defRPr>
+            </a:pPr>
+            <a:r>
+              <a:t>  V(x) ≈ V₀ + ½k·x²</a:t>
+            </a:r>
+          </a:p>
+          <a:p>
+            <a:pPr>
+              <a:spcAft>
+                <a:spcPts val="300"/>
+              </a:spcAft>
+              <a:defRPr sz="1300">
+                <a:solidFill>
+                  <a:srgbClr val="8B949E"/>
+                </a:solidFill>
+                <a:latin typeface="Consolas"/>
+              </a:defRPr>
+            </a:pPr>
+          </a:p>
+          <a:p>
+            <a:pPr>
+              <a:spcAft>
+                <a:spcPts val="300"/>
+              </a:spcAft>
+              <a:defRPr sz="1300">
+                <a:solidFill>
+                  <a:srgbClr val="C9D1D9"/>
+                </a:solidFill>
+                <a:latin typeface="Consolas"/>
+              </a:defRPr>
+            </a:pPr>
+            <a:r>
+              <a:t>  → Diagonalise Hessian → normal modes</a:t>
+            </a:r>
+          </a:p>
+          <a:p>
+            <a:pPr>
+              <a:spcAft>
+                <a:spcPts val="300"/>
+              </a:spcAft>
+              <a:defRPr sz="1300">
+                <a:solidFill>
+                  <a:srgbClr val="C9D1D9"/>
+                </a:solidFill>
+                <a:latin typeface="Consolas"/>
+              </a:defRPr>
+            </a:pPr>
+            <a:r>
+              <a:t>  → 3N−6 frequencies ωᵢ</a:t>
+            </a:r>
+          </a:p>
+          <a:p>
+            <a:pPr>
+              <a:spcAft>
+                <a:spcPts val="300"/>
+              </a:spcAft>
+              <a:defRPr sz="1300">
+                <a:solidFill>
+                  <a:srgbClr val="C9D1D9"/>
+                </a:solidFill>
+                <a:latin typeface="Consolas"/>
+              </a:defRPr>
+            </a:pPr>
+            <a:r>
+              <a:t>  → Intensities ∝ |Δμ/ΔQ|²</a:t>
+            </a:r>
+          </a:p>
+          <a:p>
+            <a:pPr>
+              <a:spcAft>
+                <a:spcPts val="300"/>
+              </a:spcAft>
+              <a:defRPr sz="1300">
+                <a:solidFill>
+                  <a:srgbClr val="8B949E"/>
+                </a:solidFill>
+                <a:latin typeface="Consolas"/>
+              </a:defRPr>
+            </a:pPr>
+          </a:p>
+          <a:p>
+            <a:pPr>
+              <a:spcAft>
+                <a:spcPts val="300"/>
+              </a:spcAft>
+              <a:defRPr sz="1300">
+                <a:solidFill>
+                  <a:srgbClr val="C9D1D9"/>
+                </a:solidFill>
+                <a:latin typeface="Consolas"/>
+              </a:defRPr>
+            </a:pPr>
+            <a:r>
+              <a:t>  For each displaced geometry:</a:t>
+            </a:r>
+          </a:p>
+          <a:p>
+            <a:pPr>
+              <a:spcAft>
+                <a:spcPts val="300"/>
+              </a:spcAft>
+              <a:defRPr sz="1300">
+                <a:solidFill>
+                  <a:srgbClr val="C9D1D9"/>
+                </a:solidFill>
+                <a:latin typeface="Consolas"/>
+              </a:defRPr>
+            </a:pPr>
+            <a:r>
+              <a:t>  → energy (forces → Hessian)</a:t>
+            </a:r>
+          </a:p>
+          <a:p>
+            <a:pPr>
+              <a:spcAft>
+                <a:spcPts val="300"/>
+              </a:spcAft>
+              <a:defRPr sz="1300">
+                <a:solidFill>
+                  <a:srgbClr val="C9D1D9"/>
+                </a:solidFill>
+                <a:latin typeface="Consolas"/>
+              </a:defRPr>
+            </a:pPr>
+            <a:r>
+              <a:t>  → dipole μ⃗ (intensity)</a:t>
+            </a:r>
+          </a:p>
+          <a:p>
+            <a:pPr>
+              <a:spcAft>
+                <a:spcPts val="300"/>
+              </a:spcAft>
+              <a:defRPr sz="1300">
+                <a:solidFill>
+                  <a:srgbClr val="C9D1D9"/>
+                </a:solidFill>
+                <a:latin typeface="Consolas"/>
+              </a:defRPr>
+            </a:pPr>
+            <a:r>
+              <a:t>  → Gaussian displaces ~hundreds of times</a:t>
             </a:r>
           </a:p>
           <a:p>
@@ -5405,55 +5376,39 @@
               </a:defRPr>
             </a:pPr>
             <a:r>
-              <a:t># Energy units</a:t>
-            </a:r>
-          </a:p>
-          <a:p>
-            <a:pPr>
-              <a:spcAft>
-                <a:spcPts val="300"/>
-              </a:spcAft>
-              <a:defRPr sz="1300">
-                <a:solidFill>
-                  <a:srgbClr val="C9D1D9"/>
-                </a:solidFill>
-                <a:latin typeface="Consolas"/>
-              </a:defRPr>
-            </a:pPr>
-            <a:r>
-              <a:t>  1 cm⁻¹  ≈ 0.124 meV</a:t>
-            </a:r>
-          </a:p>
-          <a:p>
-            <a:pPr>
-              <a:spcAft>
-                <a:spcPts val="300"/>
-              </a:spcAft>
-              <a:defRPr sz="1300">
-                <a:solidFill>
-                  <a:srgbClr val="C9D1D9"/>
-                </a:solidFill>
-                <a:latin typeface="Consolas"/>
-              </a:defRPr>
-            </a:pPr>
-            <a:r>
-              <a:t>  kT@300K ≈ 200 cm⁻¹</a:t>
-            </a:r>
-          </a:p>
-          <a:p>
-            <a:pPr>
-              <a:spcAft>
-                <a:spcPts val="300"/>
-              </a:spcAft>
-              <a:defRPr sz="1300">
-                <a:solidFill>
-                  <a:srgbClr val="C9D1D9"/>
-                </a:solidFill>
-                <a:latin typeface="Consolas"/>
-              </a:defRPr>
-            </a:pPr>
-            <a:r>
-              <a:t>  IR range: 400–4000 cm⁻¹</a:t>
+              <a:t># Anharmonic (VPT2): ongoing work</a:t>
+            </a:r>
+          </a:p>
+          <a:p>
+            <a:pPr>
+              <a:spcAft>
+                <a:spcPts val="300"/>
+              </a:spcAft>
+              <a:defRPr sz="1300">
+                <a:solidFill>
+                  <a:srgbClr val="C9D1D9"/>
+                </a:solidFill>
+                <a:latin typeface="Consolas"/>
+              </a:defRPr>
+            </a:pPr>
+            <a:r>
+              <a:t>  → Already running. Overtones + combination bands.</a:t>
+            </a:r>
+          </a:p>
+          <a:p>
+            <a:pPr>
+              <a:spcAft>
+                <a:spcPts val="300"/>
+              </a:spcAft>
+              <a:defRPr sz="1300">
+                <a:solidFill>
+                  <a:srgbClr val="8B949E"/>
+                </a:solidFill>
+                <a:latin typeface="Consolas"/>
+              </a:defRPr>
+            </a:pPr>
+            <a:r>
+              <a:t>  → Results pending full validation — next direction.</a:t>
             </a:r>
           </a:p>
         </p:txBody>
@@ -5492,235 +5447,248 @@
               </a:defRPr>
             </a:pPr>
             <a:r>
-              <a:t># Why do we care?</a:t>
-            </a:r>
-          </a:p>
-          <a:p>
-            <a:pPr>
-              <a:spcAft>
-                <a:spcPts val="300"/>
-              </a:spcAft>
-              <a:defRPr sz="1300">
-                <a:solidFill>
-                  <a:srgbClr val="8B949E"/>
-                </a:solidFill>
-                <a:latin typeface="Consolas"/>
-              </a:defRPr>
-            </a:pPr>
-          </a:p>
-          <a:p>
-            <a:pPr>
-              <a:spcAft>
-                <a:spcPts val="300"/>
-              </a:spcAft>
-              <a:defRPr sz="1300">
-                <a:solidFill>
-                  <a:srgbClr val="C9D1D9"/>
-                </a:solidFill>
-                <a:latin typeface="Consolas"/>
-              </a:defRPr>
-            </a:pPr>
-            <a:r>
-              <a:t>  IR spectrum = molecular fingerprint</a:t>
-            </a:r>
-          </a:p>
-          <a:p>
-            <a:pPr>
-              <a:spcAft>
-                <a:spcPts val="300"/>
-              </a:spcAft>
-              <a:defRPr sz="1300">
-                <a:solidFill>
-                  <a:srgbClr val="C9D1D9"/>
-                </a:solidFill>
-                <a:latin typeface="Consolas"/>
-              </a:defRPr>
-            </a:pPr>
-            <a:r>
-              <a:t>  → Identify functional groups</a:t>
-            </a:r>
-          </a:p>
-          <a:p>
-            <a:pPr>
-              <a:spcAft>
-                <a:spcPts val="300"/>
-              </a:spcAft>
-              <a:defRPr sz="1300">
-                <a:solidFill>
-                  <a:srgbClr val="C9D1D9"/>
-                </a:solidFill>
-                <a:latin typeface="Consolas"/>
-              </a:defRPr>
-            </a:pPr>
-            <a:r>
-              <a:t>  → Confirm synthesis products</a:t>
-            </a:r>
-          </a:p>
-          <a:p>
-            <a:pPr>
-              <a:spcAft>
-                <a:spcPts val="300"/>
-              </a:spcAft>
-              <a:defRPr sz="1300">
-                <a:solidFill>
-                  <a:srgbClr val="C9D1D9"/>
-                </a:solidFill>
-                <a:latin typeface="Consolas"/>
-              </a:defRPr>
-            </a:pPr>
-            <a:r>
-              <a:t>  → Study protein conformations</a:t>
-            </a:r>
-          </a:p>
-          <a:p>
-            <a:pPr>
-              <a:spcAft>
-                <a:spcPts val="300"/>
-              </a:spcAft>
-              <a:defRPr sz="1300">
-                <a:solidFill>
-                  <a:srgbClr val="8B949E"/>
-                </a:solidFill>
-                <a:latin typeface="Consolas"/>
-              </a:defRPr>
-            </a:pPr>
-          </a:p>
-          <a:p>
-            <a:pPr>
-              <a:spcAft>
-                <a:spcPts val="300"/>
-              </a:spcAft>
-              <a:defRPr sz="1300">
-                <a:solidFill>
-                  <a:srgbClr val="58A6FF"/>
-                </a:solidFill>
-                <a:latin typeface="Consolas"/>
-              </a:defRPr>
-            </a:pPr>
-            <a:r>
-              <a:t># The harmonic limit</a:t>
-            </a:r>
-          </a:p>
-          <a:p>
-            <a:pPr>
-              <a:spcAft>
-                <a:spcPts val="300"/>
-              </a:spcAft>
-              <a:defRPr sz="1300">
-                <a:solidFill>
-                  <a:srgbClr val="8B949E"/>
-                </a:solidFill>
-                <a:latin typeface="Consolas"/>
-              </a:defRPr>
-            </a:pPr>
-          </a:p>
-          <a:p>
-            <a:pPr>
-              <a:spcAft>
-                <a:spcPts val="300"/>
-              </a:spcAft>
-              <a:defRPr sz="1300">
-                <a:solidFill>
-                  <a:srgbClr val="C9D1D9"/>
-                </a:solidFill>
-                <a:latin typeface="Consolas"/>
-              </a:defRPr>
-            </a:pPr>
-            <a:r>
-              <a:t>  V(x) ≈ V₀ + ½k·x²</a:t>
-            </a:r>
-          </a:p>
-          <a:p>
-            <a:pPr>
-              <a:spcAft>
-                <a:spcPts val="300"/>
-              </a:spcAft>
-              <a:defRPr sz="1300">
-                <a:solidFill>
-                  <a:srgbClr val="8B949E"/>
-                </a:solidFill>
-                <a:latin typeface="Consolas"/>
-              </a:defRPr>
-            </a:pPr>
-          </a:p>
-          <a:p>
-            <a:pPr>
-              <a:spcAft>
-                <a:spcPts val="300"/>
-              </a:spcAft>
-              <a:defRPr sz="1300">
-                <a:solidFill>
-                  <a:srgbClr val="C9D1D9"/>
-                </a:solidFill>
-                <a:latin typeface="Consolas"/>
-              </a:defRPr>
-            </a:pPr>
-            <a:r>
-              <a:t>  Works well for fundamentals.</a:t>
-            </a:r>
-          </a:p>
-          <a:p>
-            <a:pPr>
-              <a:spcAft>
-                <a:spcPts val="300"/>
-              </a:spcAft>
-              <a:defRPr sz="1300">
-                <a:solidFill>
-                  <a:srgbClr val="C9D1D9"/>
-                </a:solidFill>
-                <a:latin typeface="Consolas"/>
-              </a:defRPr>
-            </a:pPr>
-            <a:r>
-              <a:t>  Fails for overtones:</a:t>
-            </a:r>
-          </a:p>
-          <a:p>
-            <a:pPr>
-              <a:spcAft>
-                <a:spcPts val="300"/>
-              </a:spcAft>
-              <a:defRPr sz="1300">
-                <a:solidFill>
-                  <a:srgbClr val="C9D1D9"/>
-                </a:solidFill>
-                <a:latin typeface="Consolas"/>
-              </a:defRPr>
-            </a:pPr>
-            <a:r>
-              <a:t>  → predicts exactly 2×ω₀</a:t>
-            </a:r>
-          </a:p>
-          <a:p>
-            <a:pPr>
-              <a:spcAft>
-                <a:spcPts val="300"/>
-              </a:spcAft>
-              <a:defRPr sz="1300">
-                <a:solidFill>
-                  <a:srgbClr val="C9D1D9"/>
-                </a:solidFill>
-                <a:latin typeface="Consolas"/>
-              </a:defRPr>
-            </a:pPr>
-            <a:r>
-              <a:t>  → reality: slightly less</a:t>
-            </a:r>
-          </a:p>
-          <a:p>
-            <a:pPr>
-              <a:spcAft>
-                <a:spcPts val="300"/>
-              </a:spcAft>
-              <a:defRPr sz="1300">
-                <a:solidFill>
-                  <a:srgbClr val="C9D1D9"/>
-                </a:solidFill>
-                <a:latin typeface="Consolas"/>
-              </a:defRPr>
-            </a:pPr>
-            <a:r>
-              <a:t>  → asymmetric potential well</a:t>
+              <a:t># What ML provides</a:t>
+            </a:r>
+          </a:p>
+          <a:p>
+            <a:pPr>
+              <a:spcAft>
+                <a:spcPts val="300"/>
+              </a:spcAft>
+              <a:defRPr sz="1300">
+                <a:solidFill>
+                  <a:srgbClr val="8B949E"/>
+                </a:solidFill>
+                <a:latin typeface="Consolas"/>
+              </a:defRPr>
+            </a:pPr>
+          </a:p>
+          <a:p>
+            <a:pPr>
+              <a:spcAft>
+                <a:spcPts val="300"/>
+              </a:spcAft>
+              <a:defRPr sz="1300">
+                <a:solidFill>
+                  <a:srgbClr val="C9D1D9"/>
+                </a:solidFill>
+                <a:latin typeface="Consolas"/>
+              </a:defRPr>
+            </a:pPr>
+            <a:r>
+              <a:t>  Each displaced geometry → ML query:</a:t>
+            </a:r>
+          </a:p>
+          <a:p>
+            <a:pPr>
+              <a:spcAft>
+                <a:spcPts val="300"/>
+              </a:spcAft>
+              <a:defRPr sz="1300">
+                <a:solidFill>
+                  <a:srgbClr val="8B949E"/>
+                </a:solidFill>
+                <a:latin typeface="Consolas"/>
+              </a:defRPr>
+            </a:pPr>
+          </a:p>
+          <a:p>
+            <a:pPr>
+              <a:spcAft>
+                <a:spcPts val="300"/>
+              </a:spcAft>
+              <a:defRPr sz="1300">
+                <a:solidFill>
+                  <a:srgbClr val="3FB950"/>
+                </a:solidFill>
+                <a:latin typeface="Consolas"/>
+              </a:defRPr>
+            </a:pPr>
+            <a:r>
+              <a:t>  [geometry]</a:t>
+            </a:r>
+          </a:p>
+          <a:p>
+            <a:pPr>
+              <a:spcAft>
+                <a:spcPts val="300"/>
+              </a:spcAft>
+              <a:defRPr sz="1300">
+                <a:solidFill>
+                  <a:srgbClr val="C9D1D9"/>
+                </a:solidFill>
+                <a:latin typeface="Consolas"/>
+              </a:defRPr>
+            </a:pPr>
+            <a:r>
+              <a:t>      ↓  MACE energy model</a:t>
+            </a:r>
+          </a:p>
+          <a:p>
+            <a:pPr>
+              <a:spcAft>
+                <a:spcPts val="300"/>
+              </a:spcAft>
+              <a:defRPr sz="1300">
+                <a:solidFill>
+                  <a:srgbClr val="8B949E"/>
+                </a:solidFill>
+                <a:latin typeface="Consolas"/>
+              </a:defRPr>
+            </a:pPr>
+            <a:r>
+              <a:t>  E, F, Hessian contribution</a:t>
+            </a:r>
+          </a:p>
+          <a:p>
+            <a:pPr>
+              <a:spcAft>
+                <a:spcPts val="300"/>
+              </a:spcAft>
+              <a:defRPr sz="1300">
+                <a:solidFill>
+                  <a:srgbClr val="8B949E"/>
+                </a:solidFill>
+                <a:latin typeface="Consolas"/>
+              </a:defRPr>
+            </a:pPr>
+          </a:p>
+          <a:p>
+            <a:pPr>
+              <a:spcAft>
+                <a:spcPts val="300"/>
+              </a:spcAft>
+              <a:defRPr sz="1300">
+                <a:solidFill>
+                  <a:srgbClr val="3FB950"/>
+                </a:solidFill>
+                <a:latin typeface="Consolas"/>
+              </a:defRPr>
+            </a:pPr>
+            <a:r>
+              <a:t>  [geometry]</a:t>
+            </a:r>
+          </a:p>
+          <a:p>
+            <a:pPr>
+              <a:spcAft>
+                <a:spcPts val="300"/>
+              </a:spcAft>
+              <a:defRPr sz="1300">
+                <a:solidFill>
+                  <a:srgbClr val="C9D1D9"/>
+                </a:solidFill>
+                <a:latin typeface="Consolas"/>
+              </a:defRPr>
+            </a:pPr>
+            <a:r>
+              <a:t>      ↓  MACE dipole model</a:t>
+            </a:r>
+          </a:p>
+          <a:p>
+            <a:pPr>
+              <a:spcAft>
+                <a:spcPts val="300"/>
+              </a:spcAft>
+              <a:defRPr sz="1300">
+                <a:solidFill>
+                  <a:srgbClr val="8B949E"/>
+                </a:solidFill>
+                <a:latin typeface="Consolas"/>
+              </a:defRPr>
+            </a:pPr>
+            <a:r>
+              <a:t>  μ⃗ = (μ_x, μ_y, μ_z)</a:t>
+            </a:r>
+          </a:p>
+          <a:p>
+            <a:pPr>
+              <a:spcAft>
+                <a:spcPts val="300"/>
+              </a:spcAft>
+              <a:defRPr sz="1300">
+                <a:solidFill>
+                  <a:srgbClr val="8B949E"/>
+                </a:solidFill>
+                <a:latin typeface="Consolas"/>
+              </a:defRPr>
+            </a:pPr>
+          </a:p>
+          <a:p>
+            <a:pPr>
+              <a:spcAft>
+                <a:spcPts val="300"/>
+              </a:spcAft>
+              <a:defRPr sz="1300">
+                <a:solidFill>
+                  <a:srgbClr val="C9D1D9"/>
+                </a:solidFill>
+                <a:latin typeface="Consolas"/>
+              </a:defRPr>
+            </a:pPr>
+            <a:r>
+              <a:t>  Both injected into Gaussian</a:t>
+            </a:r>
+          </a:p>
+          <a:p>
+            <a:pPr>
+              <a:spcAft>
+                <a:spcPts val="300"/>
+              </a:spcAft>
+              <a:defRPr sz="1300">
+                <a:solidFill>
+                  <a:srgbClr val="C9D1D9"/>
+                </a:solidFill>
+                <a:latin typeface="Consolas"/>
+              </a:defRPr>
+            </a:pPr>
+            <a:r>
+              <a:t>  via ZMQ bridge — next slide.</a:t>
+            </a:r>
+          </a:p>
+          <a:p>
+            <a:pPr>
+              <a:spcAft>
+                <a:spcPts val="300"/>
+              </a:spcAft>
+              <a:defRPr sz="1300">
+                <a:solidFill>
+                  <a:srgbClr val="8B949E"/>
+                </a:solidFill>
+                <a:latin typeface="Consolas"/>
+              </a:defRPr>
+            </a:pPr>
+          </a:p>
+          <a:p>
+            <a:pPr>
+              <a:spcAft>
+                <a:spcPts val="300"/>
+              </a:spcAft>
+              <a:defRPr sz="1300">
+                <a:solidFill>
+                  <a:srgbClr val="8B949E"/>
+                </a:solidFill>
+                <a:latin typeface="Consolas"/>
+              </a:defRPr>
+            </a:pPr>
+            <a:r>
+              <a:t>  IR range: 400–4000 cm⁻¹</a:t>
+            </a:r>
+          </a:p>
+          <a:p>
+            <a:pPr>
+              <a:spcAft>
+                <a:spcPts val="300"/>
+              </a:spcAft>
+              <a:defRPr sz="1300">
+                <a:solidFill>
+                  <a:srgbClr val="8B949E"/>
+                </a:solidFill>
+                <a:latin typeface="Consolas"/>
+              </a:defRPr>
+            </a:pPr>
+            <a:r>
+              <a:t>  1 cm⁻¹ ≈ 0.124 meV</a:t>
             </a:r>
           </a:p>
         </p:txBody>

</xml_diff>

<commit_message>
chore: regenerate presentation_v2.pptx (13 slides)
Co-Authored-By: Claude Sonnet 4.6 <noreply@anthropic.com>
</commit_message>
<xml_diff>
--- a/presentation/presentation_v2.pptx
+++ b/presentation/presentation_v2.pptx
@@ -16,6 +16,8 @@
     <p:sldId id="264" r:id="rId15"/>
     <p:sldId id="265" r:id="rId16"/>
     <p:sldId id="266" r:id="rId17"/>
+    <p:sldId id="267" r:id="rId18"/>
+    <p:sldId id="268" r:id="rId19"/>
   </p:sldIdLst>
   <p:sldSz cx="9144000" cy="6858000" type="screen4x3"/>
   <p:notesSz cx="6858000" cy="9144000"/>
@@ -4100,7 +4102,7 @@
               </a:defRPr>
             </a:pPr>
             <a:r>
-              <a:t>$ git log --oneline --graph</a:t>
+              <a:t>$ cat analysis_results_harmonic/aspirin/data/metrics_summary.json | sort-by-mae</a:t>
             </a:r>
           </a:p>
         </p:txBody>
@@ -4113,8 +4115,8 @@
         </p:nvSpPr>
         <p:spPr>
           <a:xfrm>
-            <a:off x="457200" y="1051560"/>
-            <a:ext cx="4389120" cy="4937760"/>
+            <a:off x="685800" y="1051560"/>
+            <a:ext cx="7772400" cy="4937760"/>
           </a:xfrm>
           <a:prstGeom prst="rect">
             <a:avLst/>
@@ -4129,9 +4131,9 @@
           <a:p>
             <a:pPr>
               <a:spcAft>
-                <a:spcPts val="300"/>
-              </a:spcAft>
-              <a:defRPr sz="1300">
+                <a:spcPts val="400"/>
+              </a:spcAft>
+              <a:defRPr sz="1400">
                 <a:solidFill>
                   <a:srgbClr val="58A6FF"/>
                 </a:solidFill>
@@ -4139,193 +4141,177 @@
               </a:defRPr>
             </a:pPr>
             <a:r>
-              <a:t># What we built</a:t>
-            </a:r>
-          </a:p>
-          <a:p>
-            <a:pPr>
-              <a:spcAft>
-                <a:spcPts val="300"/>
-              </a:spcAft>
-              <a:defRPr sz="1300">
-                <a:solidFill>
-                  <a:srgbClr val="C9D1D9"/>
-                </a:solidFill>
-                <a:latin typeface="Consolas"/>
-              </a:defRPr>
-            </a:pPr>
-            <a:r>
-              <a:t>  ZMQ bridge: ML dipoles → Gaussian VPT2</a:t>
-            </a:r>
-          </a:p>
-          <a:p>
-            <a:pPr>
-              <a:spcAft>
-                <a:spcPts val="300"/>
-              </a:spcAft>
-              <a:defRPr sz="1300">
-                <a:solidFill>
-                  <a:srgbClr val="8B949E"/>
-                </a:solidFill>
-                <a:latin typeface="Consolas"/>
-              </a:defRPr>
-            </a:pPr>
-            <a:r>
-              <a:t>  CLI: mace-gaussian run molecule.xyz</a:t>
-            </a:r>
-          </a:p>
-          <a:p>
-            <a:pPr>
-              <a:spcAft>
-                <a:spcPts val="300"/>
-              </a:spcAft>
-              <a:defRPr sz="1300">
-                <a:solidFill>
-                  <a:srgbClr val="C9D1D9"/>
-                </a:solidFill>
-                <a:latin typeface="Consolas"/>
-              </a:defRPr>
-            </a:pPr>
-            <a:r>
-              <a:t>  4 energy × 2 dipole models = 8 combinations</a:t>
-            </a:r>
-          </a:p>
-          <a:p>
-            <a:pPr>
-              <a:spcAft>
-                <a:spcPts val="300"/>
-              </a:spcAft>
-              <a:defRPr sz="1300">
-                <a:solidFill>
-                  <a:srgbClr val="8B949E"/>
-                </a:solidFill>
-                <a:latin typeface="Consolas"/>
-              </a:defRPr>
-            </a:pPr>
-          </a:p>
-          <a:p>
-            <a:pPr>
-              <a:spcAft>
-                <a:spcPts val="300"/>
-              </a:spcAft>
-              <a:defRPr sz="1300">
-                <a:solidFill>
-                  <a:srgbClr val="58A6FF"/>
-                </a:solidFill>
-                <a:latin typeface="Consolas"/>
-              </a:defRPr>
-            </a:pPr>
-            <a:r>
-              <a:t># What we ran</a:t>
-            </a:r>
-          </a:p>
-          <a:p>
-            <a:pPr>
-              <a:spcAft>
-                <a:spcPts val="300"/>
-              </a:spcAft>
-              <a:defRPr sz="1300">
-                <a:solidFill>
-                  <a:srgbClr val="C9D1D9"/>
-                </a:solidFill>
-                <a:latin typeface="Consolas"/>
-              </a:defRPr>
-            </a:pPr>
-            <a:r>
-              <a:t>  Harmonic benchmark across 8 molecules</a:t>
-            </a:r>
-          </a:p>
-          <a:p>
-            <a:pPr>
-              <a:spcAft>
-                <a:spcPts val="300"/>
-              </a:spcAft>
-              <a:defRPr sz="1300">
-                <a:solidFill>
-                  <a:srgbClr val="8B949E"/>
-                </a:solidFill>
-                <a:latin typeface="Consolas"/>
-              </a:defRPr>
-            </a:pPr>
-            <a:r>
-              <a:t>  Water, aspirin, glycine, methane, ethane, NH₃, CO</a:t>
-            </a:r>
-          </a:p>
-          <a:p>
-            <a:pPr>
-              <a:spcAft>
-                <a:spcPts val="300"/>
-              </a:spcAft>
-              <a:defRPr sz="1300">
-                <a:solidFill>
-                  <a:srgbClr val="8B949E"/>
-                </a:solidFill>
-                <a:latin typeface="Consolas"/>
-              </a:defRPr>
-            </a:pPr>
-          </a:p>
-          <a:p>
-            <a:pPr>
-              <a:spcAft>
-                <a:spcPts val="300"/>
-              </a:spcAft>
-              <a:defRPr sz="1300">
-                <a:solidFill>
-                  <a:srgbClr val="58A6FF"/>
-                </a:solidFill>
-                <a:latin typeface="Consolas"/>
-              </a:defRPr>
-            </a:pPr>
-            <a:r>
-              <a:t># What we found</a:t>
-            </a:r>
-          </a:p>
-          <a:p>
-            <a:pPr>
-              <a:spcAft>
-                <a:spcPts val="300"/>
-              </a:spcAft>
-              <a:defRPr sz="1300">
-                <a:solidFill>
-                  <a:srgbClr val="3FB950"/>
-                </a:solidFill>
-                <a:latin typeface="Consolas"/>
-              </a:defRPr>
-            </a:pPr>
-            <a:r>
-              <a:t>  Frequencies: R² &gt; 0.999 across all combos ✓</a:t>
-            </a:r>
-          </a:p>
-          <a:p>
-            <a:pPr>
-              <a:spcAft>
-                <a:spcPts val="300"/>
-              </a:spcAft>
-              <a:defRPr sz="1300">
-                <a:solidFill>
-                  <a:srgbClr val="3FB950"/>
-                </a:solidFill>
-                <a:latin typeface="Consolas"/>
-              </a:defRPr>
-            </a:pPr>
-            <a:r>
-              <a:t>  Intensities: mace_ml &gt;&gt; espaloma (0.72 vs 0.52)</a:t>
-            </a:r>
-          </a:p>
-          <a:p>
-            <a:pPr>
-              <a:spcAft>
-                <a:spcPts val="300"/>
-              </a:spcAft>
-              <a:defRPr sz="1300">
-                <a:solidFill>
-                  <a:srgbClr val="3FB950"/>
-                </a:solidFill>
-                <a:latin typeface="Consolas"/>
-              </a:defRPr>
-            </a:pPr>
-            <a:r>
-              <a:t>  Speedup scales with molecule size (aspirin: ~18×)</a:t>
+              <a:t># Harmonic benchmark — aspirin (C₉H₈O₄, 51 modes)</a:t>
+            </a:r>
+          </a:p>
+          <a:p>
+            <a:pPr>
+              <a:spcAft>
+                <a:spcPts val="400"/>
+              </a:spcAft>
+              <a:defRPr sz="1400">
+                <a:solidFill>
+                  <a:srgbClr val="8B949E"/>
+                </a:solidFill>
+                <a:latin typeface="Consolas"/>
+              </a:defRPr>
+            </a:pPr>
+            <a:r>
+              <a:t>  Ref: B3LYP/6-31G(d,p)   |   sorted by MAE(freq) ascending</a:t>
+            </a:r>
+          </a:p>
+          <a:p>
+            <a:pPr>
+              <a:spcAft>
+                <a:spcPts val="400"/>
+              </a:spcAft>
+              <a:defRPr sz="1400">
+                <a:solidFill>
+                  <a:srgbClr val="8B949E"/>
+                </a:solidFill>
+                <a:latin typeface="Consolas"/>
+              </a:defRPr>
+            </a:pPr>
+          </a:p>
+          <a:p>
+            <a:pPr>
+              <a:spcAft>
+                <a:spcPts val="400"/>
+              </a:spcAft>
+              <a:defRPr sz="1400">
+                <a:solidFill>
+                  <a:srgbClr val="8B949E"/>
+                </a:solidFill>
+                <a:latin typeface="Consolas"/>
+              </a:defRPr>
+            </a:pPr>
+            <a:r>
+              <a:t>  Energy model    Dipole      MAE(freq)   R²(freq)    R²(intens)</a:t>
+            </a:r>
+          </a:p>
+          <a:p>
+            <a:pPr>
+              <a:spcAft>
+                <a:spcPts val="400"/>
+              </a:spcAft>
+              <a:defRPr sz="1400">
+                <a:solidFill>
+                  <a:srgbClr val="8B949E"/>
+                </a:solidFill>
+                <a:latin typeface="Consolas"/>
+              </a:defRPr>
+            </a:pPr>
+            <a:r>
+              <a:t>  ────────────────────────────────────────────────────────────</a:t>
+            </a:r>
+          </a:p>
+          <a:p>
+            <a:pPr>
+              <a:spcAft>
+                <a:spcPts val="400"/>
+              </a:spcAft>
+              <a:defRPr sz="1400">
+                <a:solidFill>
+                  <a:srgbClr val="C9D1D9"/>
+                </a:solidFill>
+                <a:latin typeface="Consolas"/>
+              </a:defRPr>
+            </a:pPr>
+            <a:r>
+              <a:t>  mace_omol       espaloma       8.8 cm⁻¹   0.9998492   0.25</a:t>
+            </a:r>
+          </a:p>
+          <a:p>
+            <a:pPr>
+              <a:spcAft>
+                <a:spcPts val="400"/>
+              </a:spcAft>
+              <a:defRPr sz="1400">
+                <a:solidFill>
+                  <a:srgbClr val="C9D1D9"/>
+                </a:solidFill>
+                <a:latin typeface="Consolas"/>
+              </a:defRPr>
+            </a:pPr>
+            <a:r>
+              <a:t>  mace_omol       mace_ml        8.8 cm⁻¹   0.9998492   0.46</a:t>
+            </a:r>
+          </a:p>
+          <a:p>
+            <a:pPr>
+              <a:spcAft>
+                <a:spcPts val="400"/>
+              </a:spcAft>
+              <a:defRPr sz="1400">
+                <a:solidFill>
+                  <a:srgbClr val="C9D1D9"/>
+                </a:solidFill>
+                <a:latin typeface="Consolas"/>
+              </a:defRPr>
+            </a:pPr>
+            <a:r>
+              <a:t>  mace_mp         mace_ml       97.8 cm⁻¹   0.9957866   0.29</a:t>
+            </a:r>
+          </a:p>
+          <a:p>
+            <a:pPr>
+              <a:spcAft>
+                <a:spcPts val="400"/>
+              </a:spcAft>
+              <a:defRPr sz="1400">
+                <a:solidFill>
+                  <a:srgbClr val="C9D1D9"/>
+                </a:solidFill>
+                <a:latin typeface="Consolas"/>
+              </a:defRPr>
+            </a:pPr>
+            <a:r>
+              <a:t>  mace_mp         espaloma      97.8 cm⁻¹   0.9957866   0.15</a:t>
+            </a:r>
+          </a:p>
+          <a:p>
+            <a:pPr>
+              <a:spcAft>
+                <a:spcPts val="400"/>
+              </a:spcAft>
+              <a:defRPr sz="1400">
+                <a:solidFill>
+                  <a:srgbClr val="8B949E"/>
+                </a:solidFill>
+                <a:latin typeface="Consolas"/>
+              </a:defRPr>
+            </a:pPr>
+          </a:p>
+          <a:p>
+            <a:pPr>
+              <a:spcAft>
+                <a:spcPts val="400"/>
+              </a:spcAft>
+              <a:defRPr sz="1400">
+                <a:solidFill>
+                  <a:srgbClr val="C9D1D9"/>
+                </a:solidFill>
+                <a:latin typeface="Consolas"/>
+              </a:defRPr>
+            </a:pPr>
+            <a:r>
+              <a:t>  → mace_omol: best accuracy (MAE &lt; 9 cm⁻¹, R² 0.9998)</a:t>
+            </a:r>
+          </a:p>
+          <a:p>
+            <a:pPr>
+              <a:spcAft>
+                <a:spcPts val="400"/>
+              </a:spcAft>
+              <a:defRPr sz="1400">
+                <a:solidFill>
+                  <a:srgbClr val="C9D1D9"/>
+                </a:solidFill>
+                <a:latin typeface="Consolas"/>
+              </a:defRPr>
+            </a:pPr>
+            <a:r>
+              <a:t>  → mace_mp: most speedup (~29×) but worse accuracy</a:t>
             </a:r>
           </a:p>
         </p:txBody>
@@ -4333,273 +4319,6 @@
       <p:sp>
         <p:nvSpPr>
           <p:cNvPr id="4" name="TextBox 3"/>
-          <p:cNvSpPr txBox="1"/>
-          <p:nvPr/>
-        </p:nvSpPr>
-        <p:spPr>
-          <a:xfrm>
-            <a:off x="4663440" y="1051560"/>
-            <a:ext cx="4023360" cy="4937760"/>
-          </a:xfrm>
-          <a:prstGeom prst="rect">
-            <a:avLst/>
-          </a:prstGeom>
-          <a:noFill/>
-        </p:spPr>
-        <p:txBody>
-          <a:bodyPr wrap="square">
-            <a:spAutoFit/>
-          </a:bodyPr>
-          <a:lstStyle/>
-          <a:p>
-            <a:pPr>
-              <a:spcAft>
-                <a:spcPts val="300"/>
-              </a:spcAft>
-              <a:defRPr sz="1300">
-                <a:solidFill>
-                  <a:srgbClr val="58A6FF"/>
-                </a:solidFill>
-                <a:latin typeface="Consolas"/>
-              </a:defRPr>
-            </a:pPr>
-            <a:r>
-              <a:t># Still open</a:t>
-            </a:r>
-          </a:p>
-          <a:p>
-            <a:pPr>
-              <a:spcAft>
-                <a:spcPts val="300"/>
-              </a:spcAft>
-              <a:defRPr sz="1300">
-                <a:solidFill>
-                  <a:srgbClr val="8B949E"/>
-                </a:solidFill>
-                <a:latin typeface="Consolas"/>
-              </a:defRPr>
-            </a:pPr>
-          </a:p>
-          <a:p>
-            <a:pPr>
-              <a:spcAft>
-                <a:spcPts val="300"/>
-              </a:spcAft>
-              <a:defRPr sz="1300">
-                <a:solidFill>
-                  <a:srgbClr val="C9D1D9"/>
-                </a:solidFill>
-                <a:latin typeface="Consolas"/>
-              </a:defRPr>
-            </a:pPr>
-            <a:r>
-              <a:t>  Anharmonic validation:</a:t>
-            </a:r>
-          </a:p>
-          <a:p>
-            <a:pPr>
-              <a:spcAft>
-                <a:spcPts val="300"/>
-              </a:spcAft>
-              <a:defRPr sz="1300">
-                <a:solidFill>
-                  <a:srgbClr val="8B949E"/>
-                </a:solidFill>
-                <a:latin typeface="Consolas"/>
-              </a:defRPr>
-            </a:pPr>
-            <a:r>
-              <a:t>  → VPT2 pipeline runs; accuracy TBD</a:t>
-            </a:r>
-          </a:p>
-          <a:p>
-            <a:pPr>
-              <a:spcAft>
-                <a:spcPts val="300"/>
-              </a:spcAft>
-              <a:defRPr sz="1300">
-                <a:solidFill>
-                  <a:srgbClr val="8B949E"/>
-                </a:solidFill>
-                <a:latin typeface="Consolas"/>
-              </a:defRPr>
-            </a:pPr>
-            <a:r>
-              <a:t>  → Overtones + combination bands</a:t>
-            </a:r>
-          </a:p>
-          <a:p>
-            <a:pPr>
-              <a:spcAft>
-                <a:spcPts val="300"/>
-              </a:spcAft>
-              <a:defRPr sz="1300">
-                <a:solidFill>
-                  <a:srgbClr val="8B949E"/>
-                </a:solidFill>
-                <a:latin typeface="Consolas"/>
-              </a:defRPr>
-            </a:pPr>
-          </a:p>
-          <a:p>
-            <a:pPr>
-              <a:spcAft>
-                <a:spcPts val="300"/>
-              </a:spcAft>
-              <a:defRPr sz="1300">
-                <a:solidFill>
-                  <a:srgbClr val="C9D1D9"/>
-                </a:solidFill>
-                <a:latin typeface="Consolas"/>
-              </a:defRPr>
-            </a:pPr>
-            <a:r>
-              <a:t>  25-molecule benchmark campaign:</a:t>
-            </a:r>
-          </a:p>
-          <a:p>
-            <a:pPr>
-              <a:spcAft>
-                <a:spcPts val="300"/>
-              </a:spcAft>
-              <a:defRPr sz="1300">
-                <a:solidFill>
-                  <a:srgbClr val="8B949E"/>
-                </a:solidFill>
-                <a:latin typeface="Consolas"/>
-              </a:defRPr>
-            </a:pPr>
-            <a:r>
-              <a:t>  → Systematic across functional groups</a:t>
-            </a:r>
-          </a:p>
-          <a:p>
-            <a:pPr>
-              <a:spcAft>
-                <a:spcPts val="300"/>
-              </a:spcAft>
-              <a:defRPr sz="1300">
-                <a:solidFill>
-                  <a:srgbClr val="8B949E"/>
-                </a:solidFill>
-                <a:latin typeface="Consolas"/>
-              </a:defRPr>
-            </a:pPr>
-            <a:r>
-              <a:t>  → Batch runner in progress</a:t>
-            </a:r>
-          </a:p>
-          <a:p>
-            <a:pPr>
-              <a:spcAft>
-                <a:spcPts val="300"/>
-              </a:spcAft>
-              <a:defRPr sz="1300">
-                <a:solidFill>
-                  <a:srgbClr val="8B949E"/>
-                </a:solidFill>
-                <a:latin typeface="Consolas"/>
-              </a:defRPr>
-            </a:pPr>
-          </a:p>
-          <a:p>
-            <a:pPr>
-              <a:spcAft>
-                <a:spcPts val="300"/>
-              </a:spcAft>
-              <a:defRPr sz="1300">
-                <a:solidFill>
-                  <a:srgbClr val="58A6FF"/>
-                </a:solidFill>
-                <a:latin typeface="Consolas"/>
-              </a:defRPr>
-            </a:pPr>
-            <a:r>
-              <a:t># Thesis question</a:t>
-            </a:r>
-          </a:p>
-          <a:p>
-            <a:pPr>
-              <a:spcAft>
-                <a:spcPts val="300"/>
-              </a:spcAft>
-              <a:defRPr sz="1300">
-                <a:solidFill>
-                  <a:srgbClr val="C9D1D9"/>
-                </a:solidFill>
-                <a:latin typeface="Consolas"/>
-              </a:defRPr>
-            </a:pPr>
-            <a:r>
-              <a:t>  Energy surface quality</a:t>
-            </a:r>
-          </a:p>
-          <a:p>
-            <a:pPr>
-              <a:spcAft>
-                <a:spcPts val="300"/>
-              </a:spcAft>
-              <a:defRPr sz="1300">
-                <a:solidFill>
-                  <a:srgbClr val="C9D1D9"/>
-                </a:solidFill>
-                <a:latin typeface="Consolas"/>
-              </a:defRPr>
-            </a:pPr>
-            <a:r>
-              <a:t>  vs dipole model quality —</a:t>
-            </a:r>
-          </a:p>
-          <a:p>
-            <a:pPr>
-              <a:spcAft>
-                <a:spcPts val="300"/>
-              </a:spcAft>
-              <a:defRPr sz="1300">
-                <a:solidFill>
-                  <a:srgbClr val="C9D1D9"/>
-                </a:solidFill>
-                <a:latin typeface="Consolas"/>
-              </a:defRPr>
-            </a:pPr>
-            <a:r>
-              <a:t>  which dominates IR accuracy?</a:t>
-            </a:r>
-          </a:p>
-          <a:p>
-            <a:pPr>
-              <a:spcAft>
-                <a:spcPts val="300"/>
-              </a:spcAft>
-              <a:defRPr sz="1300">
-                <a:solidFill>
-                  <a:srgbClr val="8B949E"/>
-                </a:solidFill>
-                <a:latin typeface="Consolas"/>
-              </a:defRPr>
-            </a:pPr>
-          </a:p>
-          <a:p>
-            <a:pPr>
-              <a:spcAft>
-                <a:spcPts val="300"/>
-              </a:spcAft>
-              <a:defRPr sz="1300">
-                <a:solidFill>
-                  <a:srgbClr val="3FB950"/>
-                </a:solidFill>
-                <a:latin typeface="Consolas"/>
-              </a:defRPr>
-            </a:pPr>
-            <a:r>
-              <a:t>  $ mace-gaussian run molecule.xyz</a:t>
-            </a:r>
-          </a:p>
-        </p:txBody>
-      </p:sp>
-      <p:sp>
-        <p:nvSpPr>
-          <p:cNvPr id="5" name="TextBox 4"/>
           <p:cNvSpPr txBox="1"/>
           <p:nvPr/>
         </p:nvSpPr>
@@ -4667,6 +4386,948 @@
         </p:nvSpPr>
         <p:spPr>
           <a:xfrm>
+            <a:off x="457200" y="320040"/>
+            <a:ext cx="8229600" cy="548640"/>
+          </a:xfrm>
+          <a:prstGeom prst="rect">
+            <a:avLst/>
+          </a:prstGeom>
+          <a:noFill/>
+        </p:spPr>
+        <p:txBody>
+          <a:bodyPr wrap="none">
+            <a:spAutoFit/>
+          </a:bodyPr>
+          <a:lstStyle/>
+          <a:p>
+            <a:pPr>
+              <a:defRPr sz="2800" b="1">
+                <a:solidFill>
+                  <a:srgbClr val="58A6FF"/>
+                </a:solidFill>
+                <a:latin typeface="Consolas"/>
+              </a:defRPr>
+            </a:pPr>
+            <a:r>
+              <a:t>$ python benchmark.py --scaling</a:t>
+            </a:r>
+          </a:p>
+        </p:txBody>
+      </p:sp>
+      <p:sp>
+        <p:nvSpPr>
+          <p:cNvPr id="3" name="TextBox 2"/>
+          <p:cNvSpPr txBox="1"/>
+          <p:nvPr/>
+        </p:nvSpPr>
+        <p:spPr>
+          <a:xfrm>
+            <a:off x="685800" y="1051560"/>
+            <a:ext cx="7772400" cy="4937760"/>
+          </a:xfrm>
+          <a:prstGeom prst="rect">
+            <a:avLst/>
+          </a:prstGeom>
+          <a:noFill/>
+        </p:spPr>
+        <p:txBody>
+          <a:bodyPr wrap="square">
+            <a:spAutoFit/>
+          </a:bodyPr>
+          <a:lstStyle/>
+          <a:p>
+            <a:pPr>
+              <a:spcAft>
+                <a:spcPts val="400"/>
+              </a:spcAft>
+              <a:defRPr sz="1400">
+                <a:solidFill>
+                  <a:srgbClr val="58A6FF"/>
+                </a:solidFill>
+                <a:latin typeface="Consolas"/>
+              </a:defRPr>
+            </a:pPr>
+            <a:r>
+              <a:t># ML speedup scales with molecule size</a:t>
+            </a:r>
+          </a:p>
+          <a:p>
+            <a:pPr>
+              <a:spcAft>
+                <a:spcPts val="400"/>
+              </a:spcAft>
+              <a:defRPr sz="1400">
+                <a:solidFill>
+                  <a:srgbClr val="8B949E"/>
+                </a:solidFill>
+                <a:latin typeface="Consolas"/>
+              </a:defRPr>
+            </a:pPr>
+            <a:r>
+              <a:t>  Dipole step: ML vs DFT (B3LYP/6-31G(d,p))</a:t>
+            </a:r>
+          </a:p>
+          <a:p>
+            <a:pPr>
+              <a:spcAft>
+                <a:spcPts val="400"/>
+              </a:spcAft>
+              <a:defRPr sz="1400">
+                <a:solidFill>
+                  <a:srgbClr val="8B949E"/>
+                </a:solidFill>
+                <a:latin typeface="Consolas"/>
+              </a:defRPr>
+            </a:pPr>
+          </a:p>
+          <a:p>
+            <a:pPr>
+              <a:spcAft>
+                <a:spcPts val="400"/>
+              </a:spcAft>
+              <a:defRPr sz="1400">
+                <a:solidFill>
+                  <a:srgbClr val="8B949E"/>
+                </a:solidFill>
+                <a:latin typeface="Consolas"/>
+              </a:defRPr>
+            </a:pPr>
+            <a:r>
+              <a:t>  molecule      atoms         speedup</a:t>
+            </a:r>
+          </a:p>
+          <a:p>
+            <a:pPr>
+              <a:spcAft>
+                <a:spcPts val="400"/>
+              </a:spcAft>
+              <a:defRPr sz="1400">
+                <a:solidFill>
+                  <a:srgbClr val="8B949E"/>
+                </a:solidFill>
+                <a:latin typeface="Consolas"/>
+              </a:defRPr>
+            </a:pPr>
+            <a:r>
+              <a:t>  ──────────────────────────────────────────────────</a:t>
+            </a:r>
+          </a:p>
+          <a:p>
+            <a:pPr>
+              <a:spcAft>
+                <a:spcPts val="400"/>
+              </a:spcAft>
+              <a:defRPr sz="1400">
+                <a:solidFill>
+                  <a:srgbClr val="C9D1D9"/>
+                </a:solidFill>
+                <a:latin typeface="Consolas"/>
+              </a:defRPr>
+            </a:pPr>
+            <a:r>
+              <a:t>  water       ( 3 atoms)  |=                   |  ~1×</a:t>
+            </a:r>
+          </a:p>
+          <a:p>
+            <a:pPr>
+              <a:spcAft>
+                <a:spcPts val="400"/>
+              </a:spcAft>
+              <a:defRPr sz="1400">
+                <a:solidFill>
+                  <a:srgbClr val="C9D1D9"/>
+                </a:solidFill>
+                <a:latin typeface="Consolas"/>
+              </a:defRPr>
+            </a:pPr>
+            <a:r>
+              <a:t>  glycine     (10 atoms)  |======              |  ~7–10×</a:t>
+            </a:r>
+          </a:p>
+          <a:p>
+            <a:pPr>
+              <a:spcAft>
+                <a:spcPts val="400"/>
+              </a:spcAft>
+              <a:defRPr sz="1400">
+                <a:solidFill>
+                  <a:srgbClr val="C9D1D9"/>
+                </a:solidFill>
+                <a:latin typeface="Consolas"/>
+              </a:defRPr>
+            </a:pPr>
+            <a:r>
+              <a:t>  aspirin     (21 atoms)  |====================|  ~18–29×</a:t>
+            </a:r>
+          </a:p>
+          <a:p>
+            <a:pPr>
+              <a:spcAft>
+                <a:spcPts val="400"/>
+              </a:spcAft>
+              <a:defRPr sz="1400">
+                <a:solidFill>
+                  <a:srgbClr val="8B949E"/>
+                </a:solidFill>
+                <a:latin typeface="Consolas"/>
+              </a:defRPr>
+            </a:pPr>
+          </a:p>
+          <a:p>
+            <a:pPr>
+              <a:spcAft>
+                <a:spcPts val="400"/>
+              </a:spcAft>
+              <a:defRPr sz="1400">
+                <a:solidFill>
+                  <a:srgbClr val="C9D1D9"/>
+                </a:solidFill>
+                <a:latin typeface="Consolas"/>
+              </a:defRPr>
+            </a:pPr>
+            <a:r>
+              <a:t>  → Water (3 atoms): ML overhead visible — no speedup at this scale</a:t>
+            </a:r>
+          </a:p>
+          <a:p>
+            <a:pPr>
+              <a:spcAft>
+                <a:spcPts val="400"/>
+              </a:spcAft>
+              <a:defRPr sz="1400">
+                <a:solidFill>
+                  <a:srgbClr val="C9D1D9"/>
+                </a:solidFill>
+                <a:latin typeface="Consolas"/>
+              </a:defRPr>
+            </a:pPr>
+            <a:r>
+              <a:t>  → Glycine (10 atoms): ~7–10× — target use case</a:t>
+            </a:r>
+          </a:p>
+          <a:p>
+            <a:pPr>
+              <a:spcAft>
+                <a:spcPts val="400"/>
+              </a:spcAft>
+              <a:defRPr sz="1400">
+                <a:solidFill>
+                  <a:srgbClr val="C9D1D9"/>
+                </a:solidFill>
+                <a:latin typeface="Consolas"/>
+              </a:defRPr>
+            </a:pPr>
+            <a:r>
+              <a:t>  → Aspirin (21 atoms): ~18–29× — strong benefit</a:t>
+            </a:r>
+          </a:p>
+          <a:p>
+            <a:pPr>
+              <a:spcAft>
+                <a:spcPts val="400"/>
+              </a:spcAft>
+              <a:defRPr sz="1400">
+                <a:solidFill>
+                  <a:srgbClr val="8B949E"/>
+                </a:solidFill>
+                <a:latin typeface="Consolas"/>
+              </a:defRPr>
+            </a:pPr>
+          </a:p>
+          <a:p>
+            <a:pPr>
+              <a:spcAft>
+                <a:spcPts val="400"/>
+              </a:spcAft>
+              <a:defRPr sz="1400">
+                <a:solidFill>
+                  <a:srgbClr val="8B949E"/>
+                </a:solidFill>
+                <a:latin typeface="Consolas"/>
+              </a:defRPr>
+            </a:pPr>
+            <a:r>
+              <a:t>  Speedup source: DFT dipoles O(N³); ML dipoles O(N)</a:t>
+            </a:r>
+          </a:p>
+          <a:p>
+            <a:pPr>
+              <a:spcAft>
+                <a:spcPts val="400"/>
+              </a:spcAft>
+              <a:defRPr sz="1400">
+                <a:solidFill>
+                  <a:srgbClr val="8B949E"/>
+                </a:solidFill>
+                <a:latin typeface="Consolas"/>
+              </a:defRPr>
+            </a:pPr>
+            <a:r>
+              <a:t>  (estimated ranges — not benchmarked to the second)</a:t>
+            </a:r>
+          </a:p>
+        </p:txBody>
+      </p:sp>
+      <p:sp>
+        <p:nvSpPr>
+          <p:cNvPr id="4" name="TextBox 3"/>
+          <p:cNvSpPr txBox="1"/>
+          <p:nvPr/>
+        </p:nvSpPr>
+        <p:spPr>
+          <a:xfrm>
+            <a:off x="914400" y="6263640"/>
+            <a:ext cx="7315200" cy="365760"/>
+          </a:xfrm>
+          <a:prstGeom prst="rect">
+            <a:avLst/>
+          </a:prstGeom>
+          <a:noFill/>
+        </p:spPr>
+        <p:txBody>
+          <a:bodyPr wrap="none">
+            <a:spAutoFit/>
+          </a:bodyPr>
+          <a:lstStyle/>
+          <a:p>
+            <a:pPr algn="ctr">
+              <a:defRPr sz="1100">
+                <a:solidFill>
+                  <a:srgbClr val="8B949E"/>
+                </a:solidFill>
+                <a:latin typeface="Consolas"/>
+              </a:defRPr>
+            </a:pPr>
+            <a:r>
+              <a:t>Manuel Ott · Hofer Lab · 2026-03-11</a:t>
+            </a:r>
+          </a:p>
+        </p:txBody>
+      </p:sp>
+    </p:spTree>
+  </p:cSld>
+  <p:clrMapOvr>
+    <a:masterClrMapping/>
+  </p:clrMapOvr>
+</p:sld>
+</file>
+
+<file path=ppt/slides/slide12.xml><?xml version="1.0" encoding="utf-8"?>
+<p:sld xmlns:a="http://schemas.openxmlformats.org/drawingml/2006/main" xmlns:p="http://schemas.openxmlformats.org/presentationml/2006/main" xmlns:r="http://schemas.openxmlformats.org/officeDocument/2006/relationships">
+  <p:cSld>
+    <p:bg>
+      <p:bgPr>
+        <a:solidFill>
+          <a:srgbClr val="0D1117"/>
+        </a:solidFill>
+        <a:effectLst/>
+      </p:bgPr>
+    </p:bg>
+    <p:spTree>
+      <p:nvGrpSpPr>
+        <p:cNvPr id="1" name=""/>
+        <p:cNvGrpSpPr/>
+        <p:nvPr/>
+      </p:nvGrpSpPr>
+      <p:grpSpPr/>
+      <p:sp>
+        <p:nvSpPr>
+          <p:cNvPr id="2" name="TextBox 1"/>
+          <p:cNvSpPr txBox="1"/>
+          <p:nvPr/>
+        </p:nvSpPr>
+        <p:spPr>
+          <a:xfrm>
+            <a:off x="457200" y="320040"/>
+            <a:ext cx="8229600" cy="548640"/>
+          </a:xfrm>
+          <a:prstGeom prst="rect">
+            <a:avLst/>
+          </a:prstGeom>
+          <a:noFill/>
+        </p:spPr>
+        <p:txBody>
+          <a:bodyPr wrap="none">
+            <a:spAutoFit/>
+          </a:bodyPr>
+          <a:lstStyle/>
+          <a:p>
+            <a:pPr>
+              <a:defRPr sz="2800" b="1">
+                <a:solidFill>
+                  <a:srgbClr val="58A6FF"/>
+                </a:solidFill>
+                <a:latin typeface="Consolas"/>
+              </a:defRPr>
+            </a:pPr>
+            <a:r>
+              <a:t>$ git log --oneline --graph</a:t>
+            </a:r>
+          </a:p>
+        </p:txBody>
+      </p:sp>
+      <p:sp>
+        <p:nvSpPr>
+          <p:cNvPr id="3" name="TextBox 2"/>
+          <p:cNvSpPr txBox="1"/>
+          <p:nvPr/>
+        </p:nvSpPr>
+        <p:spPr>
+          <a:xfrm>
+            <a:off x="457200" y="1051560"/>
+            <a:ext cx="4389120" cy="4937760"/>
+          </a:xfrm>
+          <a:prstGeom prst="rect">
+            <a:avLst/>
+          </a:prstGeom>
+          <a:noFill/>
+        </p:spPr>
+        <p:txBody>
+          <a:bodyPr wrap="square">
+            <a:spAutoFit/>
+          </a:bodyPr>
+          <a:lstStyle/>
+          <a:p>
+            <a:pPr>
+              <a:spcAft>
+                <a:spcPts val="300"/>
+              </a:spcAft>
+              <a:defRPr sz="1300">
+                <a:solidFill>
+                  <a:srgbClr val="58A6FF"/>
+                </a:solidFill>
+                <a:latin typeface="Consolas"/>
+              </a:defRPr>
+            </a:pPr>
+            <a:r>
+              <a:t># What we built</a:t>
+            </a:r>
+          </a:p>
+          <a:p>
+            <a:pPr>
+              <a:spcAft>
+                <a:spcPts val="300"/>
+              </a:spcAft>
+              <a:defRPr sz="1300">
+                <a:solidFill>
+                  <a:srgbClr val="C9D1D9"/>
+                </a:solidFill>
+                <a:latin typeface="Consolas"/>
+              </a:defRPr>
+            </a:pPr>
+            <a:r>
+              <a:t>  ZMQ bridge: ML dipoles → Gaussian VPT2</a:t>
+            </a:r>
+          </a:p>
+          <a:p>
+            <a:pPr>
+              <a:spcAft>
+                <a:spcPts val="300"/>
+              </a:spcAft>
+              <a:defRPr sz="1300">
+                <a:solidFill>
+                  <a:srgbClr val="8B949E"/>
+                </a:solidFill>
+                <a:latin typeface="Consolas"/>
+              </a:defRPr>
+            </a:pPr>
+            <a:r>
+              <a:t>  CLI: mace-gaussian run molecule.xyz</a:t>
+            </a:r>
+          </a:p>
+          <a:p>
+            <a:pPr>
+              <a:spcAft>
+                <a:spcPts val="300"/>
+              </a:spcAft>
+              <a:defRPr sz="1300">
+                <a:solidFill>
+                  <a:srgbClr val="C9D1D9"/>
+                </a:solidFill>
+                <a:latin typeface="Consolas"/>
+              </a:defRPr>
+            </a:pPr>
+            <a:r>
+              <a:t>  4 energy × 2 dipole models = 8 combinations</a:t>
+            </a:r>
+          </a:p>
+          <a:p>
+            <a:pPr>
+              <a:spcAft>
+                <a:spcPts val="300"/>
+              </a:spcAft>
+              <a:defRPr sz="1300">
+                <a:solidFill>
+                  <a:srgbClr val="8B949E"/>
+                </a:solidFill>
+                <a:latin typeface="Consolas"/>
+              </a:defRPr>
+            </a:pPr>
+          </a:p>
+          <a:p>
+            <a:pPr>
+              <a:spcAft>
+                <a:spcPts val="300"/>
+              </a:spcAft>
+              <a:defRPr sz="1300">
+                <a:solidFill>
+                  <a:srgbClr val="58A6FF"/>
+                </a:solidFill>
+                <a:latin typeface="Consolas"/>
+              </a:defRPr>
+            </a:pPr>
+            <a:r>
+              <a:t># What we ran</a:t>
+            </a:r>
+          </a:p>
+          <a:p>
+            <a:pPr>
+              <a:spcAft>
+                <a:spcPts val="300"/>
+              </a:spcAft>
+              <a:defRPr sz="1300">
+                <a:solidFill>
+                  <a:srgbClr val="C9D1D9"/>
+                </a:solidFill>
+                <a:latin typeface="Consolas"/>
+              </a:defRPr>
+            </a:pPr>
+            <a:r>
+              <a:t>  Harmonic benchmark across 8 molecules</a:t>
+            </a:r>
+          </a:p>
+          <a:p>
+            <a:pPr>
+              <a:spcAft>
+                <a:spcPts val="300"/>
+              </a:spcAft>
+              <a:defRPr sz="1300">
+                <a:solidFill>
+                  <a:srgbClr val="8B949E"/>
+                </a:solidFill>
+                <a:latin typeface="Consolas"/>
+              </a:defRPr>
+            </a:pPr>
+            <a:r>
+              <a:t>  Water, aspirin, glycine, methane, ethane, NH₃, CO</a:t>
+            </a:r>
+          </a:p>
+          <a:p>
+            <a:pPr>
+              <a:spcAft>
+                <a:spcPts val="300"/>
+              </a:spcAft>
+              <a:defRPr sz="1300">
+                <a:solidFill>
+                  <a:srgbClr val="8B949E"/>
+                </a:solidFill>
+                <a:latin typeface="Consolas"/>
+              </a:defRPr>
+            </a:pPr>
+          </a:p>
+          <a:p>
+            <a:pPr>
+              <a:spcAft>
+                <a:spcPts val="300"/>
+              </a:spcAft>
+              <a:defRPr sz="1300">
+                <a:solidFill>
+                  <a:srgbClr val="58A6FF"/>
+                </a:solidFill>
+                <a:latin typeface="Consolas"/>
+              </a:defRPr>
+            </a:pPr>
+            <a:r>
+              <a:t># What we found</a:t>
+            </a:r>
+          </a:p>
+          <a:p>
+            <a:pPr>
+              <a:spcAft>
+                <a:spcPts val="300"/>
+              </a:spcAft>
+              <a:defRPr sz="1300">
+                <a:solidFill>
+                  <a:srgbClr val="3FB950"/>
+                </a:solidFill>
+                <a:latin typeface="Consolas"/>
+              </a:defRPr>
+            </a:pPr>
+            <a:r>
+              <a:t>  Frequencies: R² &gt; 0.999 across all combos ✓</a:t>
+            </a:r>
+          </a:p>
+          <a:p>
+            <a:pPr>
+              <a:spcAft>
+                <a:spcPts val="300"/>
+              </a:spcAft>
+              <a:defRPr sz="1300">
+                <a:solidFill>
+                  <a:srgbClr val="3FB950"/>
+                </a:solidFill>
+                <a:latin typeface="Consolas"/>
+              </a:defRPr>
+            </a:pPr>
+            <a:r>
+              <a:t>  Intensities: mace_ml &gt;&gt; espaloma (0.72 vs 0.52)</a:t>
+            </a:r>
+          </a:p>
+          <a:p>
+            <a:pPr>
+              <a:spcAft>
+                <a:spcPts val="300"/>
+              </a:spcAft>
+              <a:defRPr sz="1300">
+                <a:solidFill>
+                  <a:srgbClr val="3FB950"/>
+                </a:solidFill>
+                <a:latin typeface="Consolas"/>
+              </a:defRPr>
+            </a:pPr>
+            <a:r>
+              <a:t>  Speedup scales with molecule size (aspirin: ~18×)</a:t>
+            </a:r>
+          </a:p>
+        </p:txBody>
+      </p:sp>
+      <p:sp>
+        <p:nvSpPr>
+          <p:cNvPr id="4" name="TextBox 3"/>
+          <p:cNvSpPr txBox="1"/>
+          <p:nvPr/>
+        </p:nvSpPr>
+        <p:spPr>
+          <a:xfrm>
+            <a:off x="4663440" y="1051560"/>
+            <a:ext cx="4023360" cy="4937760"/>
+          </a:xfrm>
+          <a:prstGeom prst="rect">
+            <a:avLst/>
+          </a:prstGeom>
+          <a:noFill/>
+        </p:spPr>
+        <p:txBody>
+          <a:bodyPr wrap="square">
+            <a:spAutoFit/>
+          </a:bodyPr>
+          <a:lstStyle/>
+          <a:p>
+            <a:pPr>
+              <a:spcAft>
+                <a:spcPts val="300"/>
+              </a:spcAft>
+              <a:defRPr sz="1300">
+                <a:solidFill>
+                  <a:srgbClr val="58A6FF"/>
+                </a:solidFill>
+                <a:latin typeface="Consolas"/>
+              </a:defRPr>
+            </a:pPr>
+            <a:r>
+              <a:t># Still open</a:t>
+            </a:r>
+          </a:p>
+          <a:p>
+            <a:pPr>
+              <a:spcAft>
+                <a:spcPts val="300"/>
+              </a:spcAft>
+              <a:defRPr sz="1300">
+                <a:solidFill>
+                  <a:srgbClr val="8B949E"/>
+                </a:solidFill>
+                <a:latin typeface="Consolas"/>
+              </a:defRPr>
+            </a:pPr>
+          </a:p>
+          <a:p>
+            <a:pPr>
+              <a:spcAft>
+                <a:spcPts val="300"/>
+              </a:spcAft>
+              <a:defRPr sz="1300">
+                <a:solidFill>
+                  <a:srgbClr val="C9D1D9"/>
+                </a:solidFill>
+                <a:latin typeface="Consolas"/>
+              </a:defRPr>
+            </a:pPr>
+            <a:r>
+              <a:t>  Anharmonic validation:</a:t>
+            </a:r>
+          </a:p>
+          <a:p>
+            <a:pPr>
+              <a:spcAft>
+                <a:spcPts val="300"/>
+              </a:spcAft>
+              <a:defRPr sz="1300">
+                <a:solidFill>
+                  <a:srgbClr val="8B949E"/>
+                </a:solidFill>
+                <a:latin typeface="Consolas"/>
+              </a:defRPr>
+            </a:pPr>
+            <a:r>
+              <a:t>  → VPT2 pipeline runs; accuracy TBD</a:t>
+            </a:r>
+          </a:p>
+          <a:p>
+            <a:pPr>
+              <a:spcAft>
+                <a:spcPts val="300"/>
+              </a:spcAft>
+              <a:defRPr sz="1300">
+                <a:solidFill>
+                  <a:srgbClr val="8B949E"/>
+                </a:solidFill>
+                <a:latin typeface="Consolas"/>
+              </a:defRPr>
+            </a:pPr>
+            <a:r>
+              <a:t>  → Overtones + combination bands</a:t>
+            </a:r>
+          </a:p>
+          <a:p>
+            <a:pPr>
+              <a:spcAft>
+                <a:spcPts val="300"/>
+              </a:spcAft>
+              <a:defRPr sz="1300">
+                <a:solidFill>
+                  <a:srgbClr val="8B949E"/>
+                </a:solidFill>
+                <a:latin typeface="Consolas"/>
+              </a:defRPr>
+            </a:pPr>
+          </a:p>
+          <a:p>
+            <a:pPr>
+              <a:spcAft>
+                <a:spcPts val="300"/>
+              </a:spcAft>
+              <a:defRPr sz="1300">
+                <a:solidFill>
+                  <a:srgbClr val="C9D1D9"/>
+                </a:solidFill>
+                <a:latin typeface="Consolas"/>
+              </a:defRPr>
+            </a:pPr>
+            <a:r>
+              <a:t>  25-molecule benchmark campaign:</a:t>
+            </a:r>
+          </a:p>
+          <a:p>
+            <a:pPr>
+              <a:spcAft>
+                <a:spcPts val="300"/>
+              </a:spcAft>
+              <a:defRPr sz="1300">
+                <a:solidFill>
+                  <a:srgbClr val="8B949E"/>
+                </a:solidFill>
+                <a:latin typeface="Consolas"/>
+              </a:defRPr>
+            </a:pPr>
+            <a:r>
+              <a:t>  → Systematic across functional groups</a:t>
+            </a:r>
+          </a:p>
+          <a:p>
+            <a:pPr>
+              <a:spcAft>
+                <a:spcPts val="300"/>
+              </a:spcAft>
+              <a:defRPr sz="1300">
+                <a:solidFill>
+                  <a:srgbClr val="8B949E"/>
+                </a:solidFill>
+                <a:latin typeface="Consolas"/>
+              </a:defRPr>
+            </a:pPr>
+            <a:r>
+              <a:t>  → Batch runner in progress</a:t>
+            </a:r>
+          </a:p>
+          <a:p>
+            <a:pPr>
+              <a:spcAft>
+                <a:spcPts val="300"/>
+              </a:spcAft>
+              <a:defRPr sz="1300">
+                <a:solidFill>
+                  <a:srgbClr val="8B949E"/>
+                </a:solidFill>
+                <a:latin typeface="Consolas"/>
+              </a:defRPr>
+            </a:pPr>
+          </a:p>
+          <a:p>
+            <a:pPr>
+              <a:spcAft>
+                <a:spcPts val="300"/>
+              </a:spcAft>
+              <a:defRPr sz="1300">
+                <a:solidFill>
+                  <a:srgbClr val="58A6FF"/>
+                </a:solidFill>
+                <a:latin typeface="Consolas"/>
+              </a:defRPr>
+            </a:pPr>
+            <a:r>
+              <a:t># Thesis question</a:t>
+            </a:r>
+          </a:p>
+          <a:p>
+            <a:pPr>
+              <a:spcAft>
+                <a:spcPts val="300"/>
+              </a:spcAft>
+              <a:defRPr sz="1300">
+                <a:solidFill>
+                  <a:srgbClr val="C9D1D9"/>
+                </a:solidFill>
+                <a:latin typeface="Consolas"/>
+              </a:defRPr>
+            </a:pPr>
+            <a:r>
+              <a:t>  Energy surface quality</a:t>
+            </a:r>
+          </a:p>
+          <a:p>
+            <a:pPr>
+              <a:spcAft>
+                <a:spcPts val="300"/>
+              </a:spcAft>
+              <a:defRPr sz="1300">
+                <a:solidFill>
+                  <a:srgbClr val="C9D1D9"/>
+                </a:solidFill>
+                <a:latin typeface="Consolas"/>
+              </a:defRPr>
+            </a:pPr>
+            <a:r>
+              <a:t>  vs dipole model quality —</a:t>
+            </a:r>
+          </a:p>
+          <a:p>
+            <a:pPr>
+              <a:spcAft>
+                <a:spcPts val="300"/>
+              </a:spcAft>
+              <a:defRPr sz="1300">
+                <a:solidFill>
+                  <a:srgbClr val="C9D1D9"/>
+                </a:solidFill>
+                <a:latin typeface="Consolas"/>
+              </a:defRPr>
+            </a:pPr>
+            <a:r>
+              <a:t>  which dominates IR accuracy?</a:t>
+            </a:r>
+          </a:p>
+          <a:p>
+            <a:pPr>
+              <a:spcAft>
+                <a:spcPts val="300"/>
+              </a:spcAft>
+              <a:defRPr sz="1300">
+                <a:solidFill>
+                  <a:srgbClr val="8B949E"/>
+                </a:solidFill>
+                <a:latin typeface="Consolas"/>
+              </a:defRPr>
+            </a:pPr>
+          </a:p>
+          <a:p>
+            <a:pPr>
+              <a:spcAft>
+                <a:spcPts val="300"/>
+              </a:spcAft>
+              <a:defRPr sz="1300">
+                <a:solidFill>
+                  <a:srgbClr val="3FB950"/>
+                </a:solidFill>
+                <a:latin typeface="Consolas"/>
+              </a:defRPr>
+            </a:pPr>
+            <a:r>
+              <a:t>  $ mace-gaussian run molecule.xyz</a:t>
+            </a:r>
+          </a:p>
+        </p:txBody>
+      </p:sp>
+      <p:sp>
+        <p:nvSpPr>
+          <p:cNvPr id="5" name="TextBox 4"/>
+          <p:cNvSpPr txBox="1"/>
+          <p:nvPr/>
+        </p:nvSpPr>
+        <p:spPr>
+          <a:xfrm>
+            <a:off x="914400" y="6263640"/>
+            <a:ext cx="7315200" cy="365760"/>
+          </a:xfrm>
+          <a:prstGeom prst="rect">
+            <a:avLst/>
+          </a:prstGeom>
+          <a:noFill/>
+        </p:spPr>
+        <p:txBody>
+          <a:bodyPr wrap="none">
+            <a:spAutoFit/>
+          </a:bodyPr>
+          <a:lstStyle/>
+          <a:p>
+            <a:pPr algn="ctr">
+              <a:defRPr sz="1100">
+                <a:solidFill>
+                  <a:srgbClr val="8B949E"/>
+                </a:solidFill>
+                <a:latin typeface="Consolas"/>
+              </a:defRPr>
+            </a:pPr>
+            <a:r>
+              <a:t>Manuel Ott · Hofer Lab · 2026-03-11</a:t>
+            </a:r>
+          </a:p>
+        </p:txBody>
+      </p:sp>
+    </p:spTree>
+  </p:cSld>
+  <p:clrMapOvr>
+    <a:masterClrMapping/>
+  </p:clrMapOvr>
+</p:sld>
+</file>
+
+<file path=ppt/slides/slide13.xml><?xml version="1.0" encoding="utf-8"?>
+<p:sld xmlns:a="http://schemas.openxmlformats.org/drawingml/2006/main" xmlns:p="http://schemas.openxmlformats.org/presentationml/2006/main" xmlns:r="http://schemas.openxmlformats.org/officeDocument/2006/relationships">
+  <p:cSld>
+    <p:bg>
+      <p:bgPr>
+        <a:solidFill>
+          <a:srgbClr val="0D1117"/>
+        </a:solidFill>
+        <a:effectLst/>
+      </p:bgPr>
+    </p:bg>
+    <p:spTree>
+      <p:nvGrpSpPr>
+        <p:cNvPr id="1" name=""/>
+        <p:cNvGrpSpPr/>
+        <p:nvPr/>
+      </p:nvGrpSpPr>
+      <p:grpSpPr/>
+      <p:sp>
+        <p:nvSpPr>
+          <p:cNvPr id="2" name="TextBox 1"/>
+          <p:cNvSpPr txBox="1"/>
+          <p:nvPr/>
+        </p:nvSpPr>
+        <p:spPr>
+          <a:xfrm>
             <a:off x="914400" y="2286000"/>
             <a:ext cx="7315200" cy="1828800"/>
           </a:xfrm>
@@ -5969,71 +6630,71 @@
               </a:defRPr>
             </a:pPr>
             <a:r>
-              <a:t>  │ gaussian_freq()             │   │ load_mace_calculator()      │</a:t>
-            </a:r>
-          </a:p>
-          <a:p>
-            <a:pPr>
-              <a:spcAft>
-                <a:spcPts val="400"/>
-              </a:spcAft>
-              <a:defRPr sz="1400">
-                <a:solidFill>
-                  <a:srgbClr val="8B949E"/>
-                </a:solidFill>
-                <a:latin typeface="Consolas"/>
-              </a:defRPr>
-            </a:pPr>
-            <a:r>
-              <a:t>  │ parse_gaussian()            │   │ get_dipole_calculator()     │</a:t>
-            </a:r>
-          </a:p>
-          <a:p>
-            <a:pPr>
-              <a:spcAft>
-                <a:spcPts val="400"/>
-              </a:spcAft>
-              <a:defRPr sz="1400">
-                <a:solidFill>
-                  <a:srgbClr val="8B949E"/>
-                </a:solidFill>
-                <a:latin typeface="Consolas"/>
-              </a:defRPr>
-            </a:pPr>
-            <a:r>
-              <a:t>  └──────────────┬──────────────┘   │ setup_zmq_server()          │</a:t>
-            </a:r>
-          </a:p>
-          <a:p>
-            <a:pPr>
-              <a:spcAft>
-                <a:spcPts val="400"/>
-              </a:spcAft>
-              <a:defRPr sz="1400">
-                <a:solidFill>
-                  <a:srgbClr val="8B949E"/>
-                </a:solidFill>
-                <a:latin typeface="Consolas"/>
-              </a:defRPr>
-            </a:pPr>
-            <a:r>
-              <a:t>                 │                  │ launch_gaussian()           │</a:t>
-            </a:r>
-          </a:p>
-          <a:p>
-            <a:pPr>
-              <a:spcAft>
-                <a:spcPts val="400"/>
-              </a:spcAft>
-              <a:defRPr sz="1400">
-                <a:solidFill>
-                  <a:srgbClr val="8B949E"/>
-                </a:solidFill>
-                <a:latin typeface="Consolas"/>
-              </a:defRPr>
-            </a:pPr>
-            <a:r>
-              <a:t>                 └──────────────────┤ zmq_dipole_loop()           │</a:t>
+              <a:t>  │ Gaussian 16                 │   │ MACE energy + forces        │</a:t>
+            </a:r>
+          </a:p>
+          <a:p>
+            <a:pPr>
+              <a:spcAft>
+                <a:spcPts val="400"/>
+              </a:spcAft>
+              <a:defRPr sz="1400">
+                <a:solidFill>
+                  <a:srgbClr val="8B949E"/>
+                </a:solidFill>
+                <a:latin typeface="Consolas"/>
+              </a:defRPr>
+            </a:pPr>
+            <a:r>
+              <a:t>  │ freq + dipoles              │   │ MACE dipole model           │</a:t>
+            </a:r>
+          </a:p>
+          <a:p>
+            <a:pPr>
+              <a:spcAft>
+                <a:spcPts val="400"/>
+              </a:spcAft>
+              <a:defRPr sz="1400">
+                <a:solidFill>
+                  <a:srgbClr val="8B949E"/>
+                </a:solidFill>
+                <a:latin typeface="Consolas"/>
+              </a:defRPr>
+            </a:pPr>
+            <a:r>
+              <a:t>  └──────────────┬──────────────┘   │ ZMQ bridge (zmq_server.py) │</a:t>
+            </a:r>
+          </a:p>
+          <a:p>
+            <a:pPr>
+              <a:spcAft>
+                <a:spcPts val="400"/>
+              </a:spcAft>
+              <a:defRPr sz="1400">
+                <a:solidFill>
+                  <a:srgbClr val="8B949E"/>
+                </a:solidFill>
+                <a:latin typeface="Consolas"/>
+              </a:defRPr>
+            </a:pPr>
+            <a:r>
+              <a:t>                 │                  │                             │</a:t>
+            </a:r>
+          </a:p>
+          <a:p>
+            <a:pPr>
+              <a:spcAft>
+                <a:spcPts val="400"/>
+              </a:spcAft>
+              <a:defRPr sz="1400">
+                <a:solidFill>
+                  <a:srgbClr val="8B949E"/>
+                </a:solidFill>
+                <a:latin typeface="Consolas"/>
+              </a:defRPr>
+            </a:pPr>
+            <a:r>
+              <a:t>                 └──────────────────┤ → fort.7 → Gaussian        │</a:t>
             </a:r>
           </a:p>
           <a:p>
@@ -6081,39 +6742,39 @@
               </a:defRPr>
             </a:pPr>
             <a:r>
-              <a:t>  ┌─────────────────────────────────────────────────────────────┐</a:t>
-            </a:r>
-          </a:p>
-          <a:p>
-            <a:pPr>
-              <a:spcAft>
-                <a:spcPts val="400"/>
-              </a:spcAft>
-              <a:defRPr sz="1400">
-                <a:solidFill>
-                  <a:srgbClr val="8B949E"/>
-                </a:solidFill>
-                <a:latin typeface="Consolas"/>
-              </a:defRPr>
-            </a:pPr>
-            <a:r>
-              <a:t>  │ ANALYSIS  eigenvector_match → kde_broaden → metrics → HTML │</a:t>
-            </a:r>
-          </a:p>
-          <a:p>
-            <a:pPr>
-              <a:spcAft>
-                <a:spcPts val="400"/>
-              </a:spcAft>
-              <a:defRPr sz="1400">
-                <a:solidFill>
-                  <a:srgbClr val="8B949E"/>
-                </a:solidFill>
-                <a:latin typeface="Consolas"/>
-              </a:defRPr>
-            </a:pPr>
-            <a:r>
-              <a:t>  └─────────────────────────────────────────────────────────────┘</a:t>
+              <a:t>  ┌──────────────────────────────────────────────────────────────┐</a:t>
+            </a:r>
+          </a:p>
+          <a:p>
+            <a:pPr>
+              <a:spcAft>
+                <a:spcPts val="400"/>
+              </a:spcAft>
+              <a:defRPr sz="1400">
+                <a:solidFill>
+                  <a:srgbClr val="8B949E"/>
+                </a:solidFill>
+                <a:latin typeface="Consolas"/>
+              </a:defRPr>
+            </a:pPr>
+            <a:r>
+              <a:t>  │ ANALYSIS  eigenvector matching → KDE broadening → HTML      │</a:t>
+            </a:r>
+          </a:p>
+          <a:p>
+            <a:pPr>
+              <a:spcAft>
+                <a:spcPts val="400"/>
+              </a:spcAft>
+              <a:defRPr sz="1400">
+                <a:solidFill>
+                  <a:srgbClr val="8B949E"/>
+                </a:solidFill>
+                <a:latin typeface="Consolas"/>
+              </a:defRPr>
+            </a:pPr>
+            <a:r>
+              <a:t>  └──────────────────────────────────────────────────────────────┘</a:t>
             </a:r>
           </a:p>
         </p:txBody>
@@ -6894,8 +7555,8 @@
         </p:nvSpPr>
         <p:spPr>
           <a:xfrm>
-            <a:off x="457200" y="1051560"/>
-            <a:ext cx="4389120" cy="4937760"/>
+            <a:off x="685800" y="1051560"/>
+            <a:ext cx="7772400" cy="4937760"/>
           </a:xfrm>
           <a:prstGeom prst="rect">
             <a:avLst/>
@@ -6910,9 +7571,9 @@
           <a:p>
             <a:pPr>
               <a:spcAft>
-                <a:spcPts val="300"/>
-              </a:spcAft>
-              <a:defRPr sz="1300">
+                <a:spcPts val="400"/>
+              </a:spcAft>
+              <a:defRPr sz="1400">
                 <a:solidFill>
                   <a:srgbClr val="58A6FF"/>
                 </a:solidFill>
@@ -6920,273 +7581,318 @@
               </a:defRPr>
             </a:pPr>
             <a:r>
-              <a:t># The bridge: how it works</a:t>
-            </a:r>
-          </a:p>
-          <a:p>
-            <a:pPr>
-              <a:spcAft>
-                <a:spcPts val="300"/>
-              </a:spcAft>
-              <a:defRPr sz="1300">
-                <a:solidFill>
-                  <a:srgbClr val="8B949E"/>
-                </a:solidFill>
-                <a:latin typeface="Consolas"/>
-              </a:defRPr>
-            </a:pPr>
-          </a:p>
-          <a:p>
-            <a:pPr>
-              <a:spcAft>
-                <a:spcPts val="300"/>
-              </a:spcAft>
-              <a:defRPr sz="1300">
-                <a:solidFill>
-                  <a:srgbClr val="C9D1D9"/>
-                </a:solidFill>
-                <a:latin typeface="Consolas"/>
-              </a:defRPr>
-            </a:pPr>
-            <a:r>
-              <a:t>  Gaussian 16: 'External' keyword</a:t>
-            </a:r>
-          </a:p>
-          <a:p>
-            <a:pPr>
-              <a:spcAft>
-                <a:spcPts val="300"/>
-              </a:spcAft>
-              <a:defRPr sz="1300">
-                <a:solidFill>
-                  <a:srgbClr val="C9D1D9"/>
-                </a:solidFill>
-                <a:latin typeface="Consolas"/>
-              </a:defRPr>
-            </a:pPr>
-            <a:r>
-              <a:t>  → calls a helper script for each</a:t>
-            </a:r>
-          </a:p>
-          <a:p>
-            <a:pPr>
-              <a:spcAft>
-                <a:spcPts val="300"/>
-              </a:spcAft>
-              <a:defRPr sz="1300">
-                <a:solidFill>
-                  <a:srgbClr val="C9D1D9"/>
-                </a:solidFill>
-                <a:latin typeface="Consolas"/>
-              </a:defRPr>
-            </a:pPr>
-            <a:r>
-              <a:t>     displaced geometry</a:t>
-            </a:r>
-          </a:p>
-          <a:p>
-            <a:pPr>
-              <a:spcAft>
-                <a:spcPts val="300"/>
-              </a:spcAft>
-              <a:defRPr sz="1300">
-                <a:solidFill>
-                  <a:srgbClr val="8B949E"/>
-                </a:solidFill>
-                <a:latin typeface="Consolas"/>
-              </a:defRPr>
-            </a:pPr>
-          </a:p>
-          <a:p>
-            <a:pPr>
-              <a:spcAft>
-                <a:spcPts val="300"/>
-              </a:spcAft>
-              <a:defRPr sz="1300">
-                <a:solidFill>
-                  <a:srgbClr val="8B949E"/>
-                </a:solidFill>
-                <a:latin typeface="Consolas"/>
-              </a:defRPr>
-            </a:pPr>
-            <a:r>
-              <a:t>  ┌──────────────────────────────┐</a:t>
-            </a:r>
-          </a:p>
-          <a:p>
-            <a:pPr>
-              <a:spcAft>
-                <a:spcPts val="300"/>
-              </a:spcAft>
-              <a:defRPr sz="1300">
-                <a:solidFill>
-                  <a:srgbClr val="8B949E"/>
-                </a:solidFill>
-                <a:latin typeface="Consolas"/>
-              </a:defRPr>
-            </a:pPr>
-            <a:r>
-              <a:t>  │  Gaussian (Fortran)          │</a:t>
-            </a:r>
-          </a:p>
-          <a:p>
-            <a:pPr>
-              <a:spcAft>
-                <a:spcPts val="300"/>
-              </a:spcAft>
-              <a:defRPr sz="1300">
-                <a:solidFill>
-                  <a:srgbClr val="8B949E"/>
-                </a:solidFill>
-                <a:latin typeface="Consolas"/>
-              </a:defRPr>
-            </a:pPr>
-            <a:r>
-              <a:t>  │  ↓  writes geometry file     │</a:t>
-            </a:r>
-          </a:p>
-          <a:p>
-            <a:pPr>
-              <a:spcAft>
-                <a:spcPts val="300"/>
-              </a:spcAft>
-              <a:defRPr sz="1300">
-                <a:solidFill>
-                  <a:srgbClr val="8B949E"/>
-                </a:solidFill>
-                <a:latin typeface="Consolas"/>
-              </a:defRPr>
-            </a:pPr>
-            <a:r>
-              <a:t>  │  ↓  calls gm_helper.py       │</a:t>
-            </a:r>
-          </a:p>
-          <a:p>
-            <a:pPr>
-              <a:spcAft>
-                <a:spcPts val="300"/>
-              </a:spcAft>
-              <a:defRPr sz="1300">
-                <a:solidFill>
-                  <a:srgbClr val="8B949E"/>
-                </a:solidFill>
-                <a:latin typeface="Consolas"/>
-              </a:defRPr>
-            </a:pPr>
-            <a:r>
-              <a:t>  └────────────┬─────────────────┘</a:t>
-            </a:r>
-          </a:p>
-          <a:p>
-            <a:pPr>
-              <a:spcAft>
-                <a:spcPts val="300"/>
-              </a:spcAft>
-              <a:defRPr sz="1300">
-                <a:solidFill>
-                  <a:srgbClr val="8B949E"/>
-                </a:solidFill>
-                <a:latin typeface="Consolas"/>
-              </a:defRPr>
-            </a:pPr>
-            <a:r>
-              <a:t>               │ ZMQ (IPC socket)</a:t>
-            </a:r>
-          </a:p>
-          <a:p>
-            <a:pPr>
-              <a:spcAft>
-                <a:spcPts val="300"/>
-              </a:spcAft>
-              <a:defRPr sz="1300">
-                <a:solidFill>
-                  <a:srgbClr val="8B949E"/>
-                </a:solidFill>
-                <a:latin typeface="Consolas"/>
-              </a:defRPr>
-            </a:pPr>
-            <a:r>
-              <a:t>  ┌────────────┴─────────────────┐</a:t>
-            </a:r>
-          </a:p>
-          <a:p>
-            <a:pPr>
-              <a:spcAft>
-                <a:spcPts val="300"/>
-              </a:spcAft>
-              <a:defRPr sz="1300">
-                <a:solidFill>
-                  <a:srgbClr val="8B949E"/>
-                </a:solidFill>
-                <a:latin typeface="Consolas"/>
-              </a:defRPr>
-            </a:pPr>
-            <a:r>
-              <a:t>  │  gm_main.py  (Python)        │</a:t>
-            </a:r>
-          </a:p>
-          <a:p>
-            <a:pPr>
-              <a:spcAft>
-                <a:spcPts val="300"/>
-              </a:spcAft>
-              <a:defRPr sz="1300">
-                <a:solidFill>
-                  <a:srgbClr val="8B949E"/>
-                </a:solidFill>
-                <a:latin typeface="Consolas"/>
-              </a:defRPr>
-            </a:pPr>
-            <a:r>
-              <a:t>  │  → MACE energy + forces      │</a:t>
-            </a:r>
-          </a:p>
-          <a:p>
-            <a:pPr>
-              <a:spcAft>
-                <a:spcPts val="300"/>
-              </a:spcAft>
-              <a:defRPr sz="1300">
-                <a:solidFill>
-                  <a:srgbClr val="8B949E"/>
-                </a:solidFill>
-                <a:latin typeface="Consolas"/>
-              </a:defRPr>
-            </a:pPr>
-            <a:r>
-              <a:t>  │  → dipole calculator         │</a:t>
-            </a:r>
-          </a:p>
-          <a:p>
-            <a:pPr>
-              <a:spcAft>
-                <a:spcPts val="300"/>
-              </a:spcAft>
-              <a:defRPr sz="1300">
-                <a:solidFill>
-                  <a:srgbClr val="8B949E"/>
-                </a:solidFill>
-                <a:latin typeface="Consolas"/>
-              </a:defRPr>
-            </a:pPr>
-            <a:r>
-              <a:t>  │  ← returns fort.7 format     │</a:t>
-            </a:r>
-          </a:p>
-          <a:p>
-            <a:pPr>
-              <a:spcAft>
-                <a:spcPts val="300"/>
-              </a:spcAft>
-              <a:defRPr sz="1300">
-                <a:solidFill>
-                  <a:srgbClr val="8B949E"/>
-                </a:solidFill>
-                <a:latin typeface="Consolas"/>
-              </a:defRPr>
-            </a:pPr>
-            <a:r>
-              <a:t>  └──────────────────────────────┘</a:t>
+              <a:t># Problem</a:t>
+            </a:r>
+          </a:p>
+          <a:p>
+            <a:pPr>
+              <a:spcAft>
+                <a:spcPts val="400"/>
+              </a:spcAft>
+              <a:defRPr sz="1400">
+                <a:solidFill>
+                  <a:srgbClr val="C9D1D9"/>
+                </a:solidFill>
+                <a:latin typeface="Consolas"/>
+              </a:defRPr>
+            </a:pPr>
+            <a:r>
+              <a:t>  Gaussian needs dipole derivatives for every displaced geometry</a:t>
+            </a:r>
+          </a:p>
+          <a:p>
+            <a:pPr>
+              <a:spcAft>
+                <a:spcPts val="400"/>
+              </a:spcAft>
+              <a:defRPr sz="1400">
+                <a:solidFill>
+                  <a:srgbClr val="C9D1D9"/>
+                </a:solidFill>
+                <a:latin typeface="Consolas"/>
+              </a:defRPr>
+            </a:pPr>
+            <a:r>
+              <a:t>  → DFT dipoles: expensive. This is the bottleneck.</a:t>
+            </a:r>
+          </a:p>
+          <a:p>
+            <a:pPr>
+              <a:spcAft>
+                <a:spcPts val="400"/>
+              </a:spcAft>
+              <a:defRPr sz="1400">
+                <a:solidFill>
+                  <a:srgbClr val="8B949E"/>
+                </a:solidFill>
+                <a:latin typeface="Consolas"/>
+              </a:defRPr>
+            </a:pPr>
+          </a:p>
+          <a:p>
+            <a:pPr>
+              <a:spcAft>
+                <a:spcPts val="400"/>
+              </a:spcAft>
+              <a:defRPr sz="1400">
+                <a:solidFill>
+                  <a:srgbClr val="58A6FF"/>
+                </a:solidFill>
+                <a:latin typeface="Consolas"/>
+              </a:defRPr>
+            </a:pPr>
+            <a:r>
+              <a:t># Solution: ZMQ bridge</a:t>
+            </a:r>
+          </a:p>
+          <a:p>
+            <a:pPr>
+              <a:spcAft>
+                <a:spcPts val="400"/>
+              </a:spcAft>
+              <a:defRPr sz="1400">
+                <a:solidFill>
+                  <a:srgbClr val="C9D1D9"/>
+                </a:solidFill>
+                <a:latin typeface="Consolas"/>
+              </a:defRPr>
+            </a:pPr>
+            <a:r>
+              <a:t>  Gaussian 'External' keyword calls gm_helper.py per geometry</a:t>
+            </a:r>
+          </a:p>
+          <a:p>
+            <a:pPr>
+              <a:spcAft>
+                <a:spcPts val="400"/>
+              </a:spcAft>
+              <a:defRPr sz="1400">
+                <a:solidFill>
+                  <a:srgbClr val="C9D1D9"/>
+                </a:solidFill>
+                <a:latin typeface="Consolas"/>
+              </a:defRPr>
+            </a:pPr>
+            <a:r>
+              <a:t>  → gm_helper.py sends geometry over ZMQ IPC socket</a:t>
+            </a:r>
+          </a:p>
+          <a:p>
+            <a:pPr>
+              <a:spcAft>
+                <a:spcPts val="400"/>
+              </a:spcAft>
+              <a:defRPr sz="1400">
+                <a:solidFill>
+                  <a:srgbClr val="C9D1D9"/>
+                </a:solidFill>
+                <a:latin typeface="Consolas"/>
+              </a:defRPr>
+            </a:pPr>
+            <a:r>
+              <a:t>  → zmq_server.py receives, queries ML, returns results</a:t>
+            </a:r>
+          </a:p>
+          <a:p>
+            <a:pPr>
+              <a:spcAft>
+                <a:spcPts val="400"/>
+              </a:spcAft>
+              <a:defRPr sz="1400">
+                <a:solidFill>
+                  <a:srgbClr val="8B949E"/>
+                </a:solidFill>
+                <a:latin typeface="Consolas"/>
+              </a:defRPr>
+            </a:pPr>
+          </a:p>
+          <a:p>
+            <a:pPr>
+              <a:spcAft>
+                <a:spcPts val="400"/>
+              </a:spcAft>
+              <a:defRPr sz="1400">
+                <a:solidFill>
+                  <a:srgbClr val="58A6FF"/>
+                </a:solidFill>
+                <a:latin typeface="Consolas"/>
+              </a:defRPr>
+            </a:pPr>
+            <a:r>
+              <a:t># How it works</a:t>
+            </a:r>
+          </a:p>
+          <a:p>
+            <a:pPr>
+              <a:spcAft>
+                <a:spcPts val="400"/>
+              </a:spcAft>
+              <a:defRPr sz="1400">
+                <a:solidFill>
+                  <a:srgbClr val="8B949E"/>
+                </a:solidFill>
+                <a:latin typeface="Consolas"/>
+              </a:defRPr>
+            </a:pPr>
+            <a:r>
+              <a:t>  [Gaussian]  → writes geometry → calls gm_helper.py</a:t>
+            </a:r>
+          </a:p>
+          <a:p>
+            <a:pPr>
+              <a:spcAft>
+                <a:spcPts val="400"/>
+              </a:spcAft>
+              <a:defRPr sz="1400">
+                <a:solidFill>
+                  <a:srgbClr val="8B949E"/>
+                </a:solidFill>
+                <a:latin typeface="Consolas"/>
+              </a:defRPr>
+            </a:pPr>
+            <a:r>
+              <a:t>                                        ↓  ZMQ (IPC)</a:t>
+            </a:r>
+          </a:p>
+          <a:p>
+            <a:pPr>
+              <a:spcAft>
+                <a:spcPts val="400"/>
+              </a:spcAft>
+              <a:defRPr sz="1400">
+                <a:solidFill>
+                  <a:srgbClr val="8B949E"/>
+                </a:solidFill>
+                <a:latin typeface="Consolas"/>
+              </a:defRPr>
+            </a:pPr>
+            <a:r>
+              <a:t>                                  zmq_server.py</a:t>
+            </a:r>
+          </a:p>
+          <a:p>
+            <a:pPr>
+              <a:spcAft>
+                <a:spcPts val="400"/>
+              </a:spcAft>
+              <a:defRPr sz="1400">
+                <a:solidFill>
+                  <a:srgbClr val="8B949E"/>
+                </a:solidFill>
+                <a:latin typeface="Consolas"/>
+              </a:defRPr>
+            </a:pPr>
+            <a:r>
+              <a:t>                                        ↓  MACE energy + forces</a:t>
+            </a:r>
+          </a:p>
+          <a:p>
+            <a:pPr>
+              <a:spcAft>
+                <a:spcPts val="400"/>
+              </a:spcAft>
+              <a:defRPr sz="1400">
+                <a:solidFill>
+                  <a:srgbClr val="8B949E"/>
+                </a:solidFill>
+                <a:latin typeface="Consolas"/>
+              </a:defRPr>
+            </a:pPr>
+            <a:r>
+              <a:t>                                        ↓  MACE dipole model</a:t>
+            </a:r>
+          </a:p>
+          <a:p>
+            <a:pPr>
+              <a:spcAft>
+                <a:spcPts val="400"/>
+              </a:spcAft>
+              <a:defRPr sz="1400">
+                <a:solidFill>
+                  <a:srgbClr val="8B949E"/>
+                </a:solidFill>
+                <a:latin typeface="Consolas"/>
+              </a:defRPr>
+            </a:pPr>
+            <a:r>
+              <a:t>  [Gaussian]  ← reads fort.7  ←         ↑  returns results</a:t>
+            </a:r>
+          </a:p>
+          <a:p>
+            <a:pPr>
+              <a:spcAft>
+                <a:spcPts val="400"/>
+              </a:spcAft>
+              <a:defRPr sz="1400">
+                <a:solidFill>
+                  <a:srgbClr val="8B949E"/>
+                </a:solidFill>
+                <a:latin typeface="Consolas"/>
+              </a:defRPr>
+            </a:pPr>
+          </a:p>
+          <a:p>
+            <a:pPr>
+              <a:spcAft>
+                <a:spcPts val="400"/>
+              </a:spcAft>
+              <a:defRPr sz="1400">
+                <a:solidFill>
+                  <a:srgbClr val="58A6FF"/>
+                </a:solidFill>
+                <a:latin typeface="Consolas"/>
+              </a:defRPr>
+            </a:pPr>
+            <a:r>
+              <a:t># Why it's non-trivial</a:t>
+            </a:r>
+          </a:p>
+          <a:p>
+            <a:pPr>
+              <a:spcAft>
+                <a:spcPts val="400"/>
+              </a:spcAft>
+              <a:defRPr sz="1400">
+                <a:solidFill>
+                  <a:srgbClr val="C9D1D9"/>
+                </a:solidFill>
+                <a:latin typeface="Consolas"/>
+              </a:defRPr>
+            </a:pPr>
+            <a:r>
+              <a:t>  Socket cleanup: LINGER=0 + SIGKILL timeout (no orphan processes)</a:t>
+            </a:r>
+          </a:p>
+          <a:p>
+            <a:pPr>
+              <a:spcAft>
+                <a:spcPts val="400"/>
+              </a:spcAft>
+              <a:defRPr sz="1400">
+                <a:solidFill>
+                  <a:srgbClr val="C9D1D9"/>
+                </a:solidFill>
+                <a:latin typeface="Consolas"/>
+              </a:defRPr>
+            </a:pPr>
+            <a:r>
+              <a:t>  Absolute paths: Gaussian needs full path resolved at CLI startup</a:t>
+            </a:r>
+          </a:p>
+          <a:p>
+            <a:pPr>
+              <a:spcAft>
+                <a:spcPts val="400"/>
+              </a:spcAft>
+              <a:defRPr sz="1400">
+                <a:solidFill>
+                  <a:srgbClr val="C9D1D9"/>
+                </a:solidFill>
+                <a:latin typeface="Consolas"/>
+              </a:defRPr>
+            </a:pPr>
+            <a:r>
+              <a:t>  Model loading: dipole class remapping via torch.load()</a:t>
             </a:r>
           </a:p>
         </p:txBody>
@@ -7194,292 +7900,6 @@
       <p:sp>
         <p:nvSpPr>
           <p:cNvPr id="4" name="TextBox 3"/>
-          <p:cNvSpPr txBox="1"/>
-          <p:nvPr/>
-        </p:nvSpPr>
-        <p:spPr>
-          <a:xfrm>
-            <a:off x="4663440" y="1051560"/>
-            <a:ext cx="4023360" cy="4937760"/>
-          </a:xfrm>
-          <a:prstGeom prst="rect">
-            <a:avLst/>
-          </a:prstGeom>
-          <a:noFill/>
-        </p:spPr>
-        <p:txBody>
-          <a:bodyPr wrap="square">
-            <a:spAutoFit/>
-          </a:bodyPr>
-          <a:lstStyle/>
-          <a:p>
-            <a:pPr>
-              <a:spcAft>
-                <a:spcPts val="300"/>
-              </a:spcAft>
-              <a:defRPr sz="1300">
-                <a:solidFill>
-                  <a:srgbClr val="58A6FF"/>
-                </a:solidFill>
-                <a:latin typeface="Consolas"/>
-              </a:defRPr>
-            </a:pPr>
-            <a:r>
-              <a:t># Key engineering challenges</a:t>
-            </a:r>
-          </a:p>
-          <a:p>
-            <a:pPr>
-              <a:spcAft>
-                <a:spcPts val="300"/>
-              </a:spcAft>
-              <a:defRPr sz="1300">
-                <a:solidFill>
-                  <a:srgbClr val="8B949E"/>
-                </a:solidFill>
-                <a:latin typeface="Consolas"/>
-              </a:defRPr>
-            </a:pPr>
-          </a:p>
-          <a:p>
-            <a:pPr>
-              <a:spcAft>
-                <a:spcPts val="300"/>
-              </a:spcAft>
-              <a:defRPr sz="1300">
-                <a:solidFill>
-                  <a:srgbClr val="C9D1D9"/>
-                </a:solidFill>
-                <a:latin typeface="Consolas"/>
-              </a:defRPr>
-            </a:pPr>
-            <a:r>
-              <a:t>  LINGER=0:</a:t>
-            </a:r>
-          </a:p>
-          <a:p>
-            <a:pPr>
-              <a:spcAft>
-                <a:spcPts val="300"/>
-              </a:spcAft>
-              <a:defRPr sz="1300">
-                <a:solidFill>
-                  <a:srgbClr val="C9D1D9"/>
-                </a:solidFill>
-                <a:latin typeface="Consolas"/>
-              </a:defRPr>
-            </a:pPr>
-            <a:r>
-              <a:t>  → ZMQ socket must close cleanly</a:t>
-            </a:r>
-          </a:p>
-          <a:p>
-            <a:pPr>
-              <a:spcAft>
-                <a:spcPts val="300"/>
-              </a:spcAft>
-              <a:defRPr sz="1300">
-                <a:solidFill>
-                  <a:srgbClr val="C9D1D9"/>
-                </a:solidFill>
-                <a:latin typeface="Consolas"/>
-              </a:defRPr>
-            </a:pPr>
-            <a:r>
-              <a:t>  → Fixed: explicit SIGKILL timeout</a:t>
-            </a:r>
-          </a:p>
-          <a:p>
-            <a:pPr>
-              <a:spcAft>
-                <a:spcPts val="300"/>
-              </a:spcAft>
-              <a:defRPr sz="1300">
-                <a:solidFill>
-                  <a:srgbClr val="8B949E"/>
-                </a:solidFill>
-                <a:latin typeface="Consolas"/>
-              </a:defRPr>
-            </a:pPr>
-          </a:p>
-          <a:p>
-            <a:pPr>
-              <a:spcAft>
-                <a:spcPts val="300"/>
-              </a:spcAft>
-              <a:defRPr sz="1300">
-                <a:solidFill>
-                  <a:srgbClr val="C9D1D9"/>
-                </a:solidFill>
-                <a:latin typeface="Consolas"/>
-              </a:defRPr>
-            </a:pPr>
-            <a:r>
-              <a:t>  Absolute paths:</a:t>
-            </a:r>
-          </a:p>
-          <a:p>
-            <a:pPr>
-              <a:spcAft>
-                <a:spcPts val="300"/>
-              </a:spcAft>
-              <a:defRPr sz="1300">
-                <a:solidFill>
-                  <a:srgbClr val="C9D1D9"/>
-                </a:solidFill>
-                <a:latin typeface="Consolas"/>
-              </a:defRPr>
-            </a:pPr>
-            <a:r>
-              <a:t>  → Gaussian needs full path to</a:t>
-            </a:r>
-          </a:p>
-          <a:p>
-            <a:pPr>
-              <a:spcAft>
-                <a:spcPts val="300"/>
-              </a:spcAft>
-              <a:defRPr sz="1300">
-                <a:solidFill>
-                  <a:srgbClr val="C9D1D9"/>
-                </a:solidFill>
-                <a:latin typeface="Consolas"/>
-              </a:defRPr>
-            </a:pPr>
-            <a:r>
-              <a:t>    helper script in .gjf files</a:t>
-            </a:r>
-          </a:p>
-          <a:p>
-            <a:pPr>
-              <a:spcAft>
-                <a:spcPts val="300"/>
-              </a:spcAft>
-              <a:defRPr sz="1300">
-                <a:solidFill>
-                  <a:srgbClr val="C9D1D9"/>
-                </a:solidFill>
-                <a:latin typeface="Consolas"/>
-              </a:defRPr>
-            </a:pPr>
-            <a:r>
-              <a:t>  → Resolved at CLI startup via</a:t>
-            </a:r>
-          </a:p>
-          <a:p>
-            <a:pPr>
-              <a:spcAft>
-                <a:spcPts val="300"/>
-              </a:spcAft>
-              <a:defRPr sz="1300">
-                <a:solidFill>
-                  <a:srgbClr val="C9D1D9"/>
-                </a:solidFill>
-                <a:latin typeface="Consolas"/>
-              </a:defRPr>
-            </a:pPr>
-            <a:r>
-              <a:t>    MACE_HELPER_SCRIPT_PATH env var</a:t>
-            </a:r>
-          </a:p>
-          <a:p>
-            <a:pPr>
-              <a:spcAft>
-                <a:spcPts val="300"/>
-              </a:spcAft>
-              <a:defRPr sz="1300">
-                <a:solidFill>
-                  <a:srgbClr val="8B949E"/>
-                </a:solidFill>
-                <a:latin typeface="Consolas"/>
-              </a:defRPr>
-            </a:pPr>
-          </a:p>
-          <a:p>
-            <a:pPr>
-              <a:spcAft>
-                <a:spcPts val="300"/>
-              </a:spcAft>
-              <a:defRPr sz="1300">
-                <a:solidFill>
-                  <a:srgbClr val="C9D1D9"/>
-                </a:solidFill>
-                <a:latin typeface="Consolas"/>
-              </a:defRPr>
-            </a:pPr>
-            <a:r>
-              <a:t>  MACE module loading:</a:t>
-            </a:r>
-          </a:p>
-          <a:p>
-            <a:pPr>
-              <a:spcAft>
-                <a:spcPts val="300"/>
-              </a:spcAft>
-              <a:defRPr sz="1300">
-                <a:solidFill>
-                  <a:srgbClr val="C9D1D9"/>
-                </a:solidFill>
-                <a:latin typeface="Consolas"/>
-              </a:defRPr>
-            </a:pPr>
-            <a:r>
-              <a:t>  → Dipole model saved with different</a:t>
-            </a:r>
-          </a:p>
-          <a:p>
-            <a:pPr>
-              <a:spcAft>
-                <a:spcPts val="300"/>
-              </a:spcAft>
-              <a:defRPr sz="1300">
-                <a:solidFill>
-                  <a:srgbClr val="C9D1D9"/>
-                </a:solidFill>
-                <a:latin typeface="Consolas"/>
-              </a:defRPr>
-            </a:pPr>
-            <a:r>
-              <a:t>    class paths than runtime</a:t>
-            </a:r>
-          </a:p>
-          <a:p>
-            <a:pPr>
-              <a:spcAft>
-                <a:spcPts val="300"/>
-              </a:spcAft>
-              <a:defRPr sz="1300">
-                <a:solidFill>
-                  <a:srgbClr val="C9D1D9"/>
-                </a:solidFill>
-                <a:latin typeface="Consolas"/>
-              </a:defRPr>
-            </a:pPr>
-            <a:r>
-              <a:t>  → mace_loader.py handles remapping</a:t>
-            </a:r>
-          </a:p>
-          <a:p>
-            <a:pPr>
-              <a:spcAft>
-                <a:spcPts val="300"/>
-              </a:spcAft>
-              <a:defRPr sz="1300">
-                <a:solidFill>
-                  <a:srgbClr val="C9D1D9"/>
-                </a:solidFill>
-                <a:latin typeface="Consolas"/>
-              </a:defRPr>
-            </a:pPr>
-            <a:r>
-              <a:t>    via torch.load(pickle_module=…)</a:t>
-            </a:r>
-          </a:p>
-        </p:txBody>
-      </p:sp>
-      <p:sp>
-        <p:nvSpPr>
-          <p:cNvPr id="5" name="TextBox 4"/>
           <p:cNvSpPr txBox="1"/>
           <p:nvPr/>
         </p:nvSpPr>
@@ -8029,7 +8449,7 @@
               </a:defRPr>
             </a:pPr>
             <a:r>
-              <a:t># HTML reports generated per molecule</a:t>
+              <a:t># Spectrum analysis reports</a:t>
             </a:r>
           </a:p>
           <a:p>
@@ -8058,6 +8478,83 @@
               </a:defRPr>
             </a:pPr>
             <a:r>
+              <a:t>       O                       O   OH</a:t>
+            </a:r>
+          </a:p>
+          <a:p>
+            <a:pPr>
+              <a:spcAft>
+                <a:spcPts val="400"/>
+              </a:spcAft>
+              <a:defRPr sz="1400">
+                <a:solidFill>
+                  <a:srgbClr val="3FB950"/>
+                </a:solidFill>
+                <a:latin typeface="Consolas"/>
+              </a:defRPr>
+            </a:pPr>
+            <a:r>
+              <a:t>      / \                      ‖   |</a:t>
+            </a:r>
+          </a:p>
+          <a:p>
+            <a:pPr>
+              <a:spcAft>
+                <a:spcPts val="400"/>
+              </a:spcAft>
+              <a:defRPr sz="1400">
+                <a:solidFill>
+                  <a:srgbClr val="3FB950"/>
+                </a:solidFill>
+                <a:latin typeface="Consolas"/>
+              </a:defRPr>
+            </a:pPr>
+            <a:r>
+              <a:t>     H   H   H₂O          CH₃-C-O-C₆H₄-COOH</a:t>
+            </a:r>
+          </a:p>
+          <a:p>
+            <a:pPr>
+              <a:spcAft>
+                <a:spcPts val="400"/>
+              </a:spcAft>
+              <a:defRPr sz="1400">
+                <a:solidFill>
+                  <a:srgbClr val="8B949E"/>
+                </a:solidFill>
+                <a:latin typeface="Consolas"/>
+              </a:defRPr>
+            </a:pPr>
+            <a:r>
+              <a:t>                               aspirin C₉H₈O₄</a:t>
+            </a:r>
+          </a:p>
+          <a:p>
+            <a:pPr>
+              <a:spcAft>
+                <a:spcPts val="400"/>
+              </a:spcAft>
+              <a:defRPr sz="1400">
+                <a:solidFill>
+                  <a:srgbClr val="8B949E"/>
+                </a:solidFill>
+                <a:latin typeface="Consolas"/>
+              </a:defRPr>
+            </a:pPr>
+          </a:p>
+          <a:p>
+            <a:pPr>
+              <a:spcAft>
+                <a:spcPts val="400"/>
+              </a:spcAft>
+              <a:defRPr sz="1400">
+                <a:solidFill>
+                  <a:srgbClr val="3FB950"/>
+                </a:solidFill>
+                <a:latin typeface="Consolas"/>
+              </a:defRPr>
+            </a:pPr>
+            <a:r>
               <a:t>  water/report.html       3 atoms  · 3 modes  · 8 combos</a:t>
             </a:r>
           </a:p>
@@ -8084,102 +8581,6 @@
               </a:spcAft>
               <a:defRPr sz="1400">
                 <a:solidFill>
-                  <a:srgbClr val="3FB950"/>
-                </a:solidFill>
-                <a:latin typeface="Consolas"/>
-              </a:defRPr>
-            </a:pPr>
-            <a:r>
-              <a:t>  gly/report.html        10 atoms  · 24 modes · 4 combos</a:t>
-            </a:r>
-          </a:p>
-          <a:p>
-            <a:pPr>
-              <a:spcAft>
-                <a:spcPts val="400"/>
-              </a:spcAft>
-              <a:defRPr sz="1400">
-                <a:solidFill>
-                  <a:srgbClr val="3FB950"/>
-                </a:solidFill>
-                <a:latin typeface="Consolas"/>
-              </a:defRPr>
-            </a:pPr>
-            <a:r>
-              <a:t>  ammonia/report.html     4 atoms  · 6 modes  · 4 combos</a:t>
-            </a:r>
-          </a:p>
-          <a:p>
-            <a:pPr>
-              <a:spcAft>
-                <a:spcPts val="400"/>
-              </a:spcAft>
-              <a:defRPr sz="1400">
-                <a:solidFill>
-                  <a:srgbClr val="3FB950"/>
-                </a:solidFill>
-                <a:latin typeface="Consolas"/>
-              </a:defRPr>
-            </a:pPr>
-            <a:r>
-              <a:t>  CH4_ase/report.html     5 atoms  · 9 modes  · 4 combos</a:t>
-            </a:r>
-          </a:p>
-          <a:p>
-            <a:pPr>
-              <a:spcAft>
-                <a:spcPts val="400"/>
-              </a:spcAft>
-              <a:defRPr sz="1400">
-                <a:solidFill>
-                  <a:srgbClr val="3FB950"/>
-                </a:solidFill>
-                <a:latin typeface="Consolas"/>
-              </a:defRPr>
-            </a:pPr>
-            <a:r>
-              <a:t>  C2H6_ase/report.html    8 atoms  · 18 modes · 4 combos</a:t>
-            </a:r>
-          </a:p>
-          <a:p>
-            <a:pPr>
-              <a:spcAft>
-                <a:spcPts val="400"/>
-              </a:spcAft>
-              <a:defRPr sz="1400">
-                <a:solidFill>
-                  <a:srgbClr val="8B949E"/>
-                </a:solidFill>
-                <a:latin typeface="Consolas"/>
-              </a:defRPr>
-            </a:pPr>
-            <a:r>
-              <a:t>  co/report.html          2 atoms  · 1 mode   · 4 combos</a:t>
-            </a:r>
-          </a:p>
-          <a:p>
-            <a:pPr>
-              <a:spcAft>
-                <a:spcPts val="400"/>
-              </a:spcAft>
-              <a:defRPr sz="1400">
-                <a:solidFill>
-                  <a:srgbClr val="8B949E"/>
-                </a:solidFill>
-                <a:latin typeface="Consolas"/>
-              </a:defRPr>
-            </a:pPr>
-            <a:r>
-              <a:t>  bh3_nh3/report.html     6 atoms  · 12 modes · 4 combos</a:t>
-            </a:r>
-          </a:p>
-          <a:p>
-            <a:pPr>
-              <a:spcAft>
-                <a:spcPts val="400"/>
-              </a:spcAft>
-              <a:defRPr sz="1400">
-                <a:solidFill>
                   <a:srgbClr val="8B949E"/>
                 </a:solidFill>
                 <a:latin typeface="Consolas"/>
@@ -8215,7 +8616,23 @@
               </a:defRPr>
             </a:pPr>
             <a:r>
-              <a:t>  Anharmonic reports also in analysis_results/</a:t>
+              <a:t>  Open: $ open analysis_results_harmonic/water/report.html</a:t>
+            </a:r>
+          </a:p>
+          <a:p>
+            <a:pPr>
+              <a:spcAft>
+                <a:spcPts val="400"/>
+              </a:spcAft>
+              <a:defRPr sz="1400">
+                <a:solidFill>
+                  <a:srgbClr val="8B949E"/>
+                </a:solidFill>
+                <a:latin typeface="Consolas"/>
+              </a:defRPr>
+            </a:pPr>
+            <a:r>
+              <a:t>         $ open analysis_results_harmonic/aspirin/report.html</a:t>
             </a:r>
           </a:p>
         </p:txBody>
@@ -8313,7 +8730,7 @@
               </a:defRPr>
             </a:pPr>
             <a:r>
-              <a:t>$ cat results/water/metrics_summary.json | sort-by-freq</a:t>
+              <a:t>$ cat analysis_results_harmonic/water/data/metrics_summary.json | sort-by-mae</a:t>
             </a:r>
           </a:p>
         </p:txBody>
@@ -8368,225 +8785,225 @@
               </a:defRPr>
             </a:pPr>
             <a:r>
-              <a:t>  Ref: B3LYP/6-31G(d,p)   |   sorted by frequency MAE</a:t>
-            </a:r>
-          </a:p>
-          <a:p>
-            <a:pPr>
-              <a:spcAft>
-                <a:spcPts val="400"/>
-              </a:spcAft>
-              <a:defRPr sz="1400">
-                <a:solidFill>
-                  <a:srgbClr val="8B949E"/>
-                </a:solidFill>
-                <a:latin typeface="Consolas"/>
-              </a:defRPr>
-            </a:pPr>
-          </a:p>
-          <a:p>
-            <a:pPr>
-              <a:spcAft>
-                <a:spcPts val="400"/>
-              </a:spcAft>
-              <a:defRPr sz="1400">
-                <a:solidFill>
-                  <a:srgbClr val="8B949E"/>
-                </a:solidFill>
-                <a:latin typeface="Consolas"/>
-              </a:defRPr>
-            </a:pPr>
-            <a:r>
-              <a:t>  Energy model   Dipole     MAE(freq)   R²(freq)   R²(intens)</a:t>
-            </a:r>
-          </a:p>
-          <a:p>
-            <a:pPr>
-              <a:spcAft>
-                <a:spcPts val="400"/>
-              </a:spcAft>
-              <a:defRPr sz="1400">
-                <a:solidFill>
-                  <a:srgbClr val="8B949E"/>
-                </a:solidFill>
-                <a:latin typeface="Consolas"/>
-              </a:defRPr>
-            </a:pPr>
-            <a:r>
-              <a:t>  ─  ─  ─  ─  ─  ─  ─  ─  ─  ─  ─  ─  ─  ─  ─  ─  ─  ─  ─  ─  ─  ─  ─  ─  ─  ─  ─  ─  ─  ─  ─  ─  ─  ─  ─  ─  ─  ─  ─  ─  ─  ─  ─  ─  ─  ─  ─  ─  ─  ─  ─  ─  ─  ─  ─  ─  ─</a:t>
-            </a:r>
-          </a:p>
-          <a:p>
-            <a:pPr>
-              <a:spcAft>
-                <a:spcPts val="400"/>
-              </a:spcAft>
-              <a:defRPr sz="1400">
-                <a:solidFill>
-                  <a:srgbClr val="3FB950"/>
-                </a:solidFill>
-                <a:latin typeface="Consolas"/>
-              </a:defRPr>
-            </a:pPr>
-            <a:r>
-              <a:t>  mace_anicc     mace_ml      19 cm⁻¹   0.999997     0.72  ✓</a:t>
-            </a:r>
-          </a:p>
-          <a:p>
-            <a:pPr>
-              <a:spcAft>
-                <a:spcPts val="400"/>
-              </a:spcAft>
-              <a:defRPr sz="1400">
-                <a:solidFill>
-                  <a:srgbClr val="C9D1D9"/>
-                </a:solidFill>
-                <a:latin typeface="Consolas"/>
-              </a:defRPr>
-            </a:pPr>
-            <a:r>
-              <a:t>  mace_anicc     espaloma     19 cm⁻¹   0.999997     0.52</a:t>
-            </a:r>
-          </a:p>
-          <a:p>
-            <a:pPr>
-              <a:spcAft>
-                <a:spcPts val="400"/>
-              </a:spcAft>
-              <a:defRPr sz="1400">
-                <a:solidFill>
-                  <a:srgbClr val="3FB950"/>
-                </a:solidFill>
-                <a:latin typeface="Consolas"/>
-              </a:defRPr>
-            </a:pPr>
-            <a:r>
-              <a:t>  mace_off       mace_ml      21 cm⁻¹   0.999934     0.72  ✓</a:t>
-            </a:r>
-          </a:p>
-          <a:p>
-            <a:pPr>
-              <a:spcAft>
-                <a:spcPts val="400"/>
-              </a:spcAft>
-              <a:defRPr sz="1400">
-                <a:solidFill>
-                  <a:srgbClr val="C9D1D9"/>
-                </a:solidFill>
-                <a:latin typeface="Consolas"/>
-              </a:defRPr>
-            </a:pPr>
-            <a:r>
-              <a:t>  mace_off       espaloma     21 cm⁻¹   0.999934     0.52</a:t>
-            </a:r>
-          </a:p>
-          <a:p>
-            <a:pPr>
-              <a:spcAft>
-                <a:spcPts val="400"/>
-              </a:spcAft>
-              <a:defRPr sz="1400">
-                <a:solidFill>
-                  <a:srgbClr val="3FB950"/>
-                </a:solidFill>
-                <a:latin typeface="Consolas"/>
-              </a:defRPr>
-            </a:pPr>
-            <a:r>
-              <a:t>  mace_omol      mace_ml      23 cm⁻¹   0.999963     0.72  ✓</a:t>
-            </a:r>
-          </a:p>
-          <a:p>
-            <a:pPr>
-              <a:spcAft>
-                <a:spcPts val="400"/>
-              </a:spcAft>
-              <a:defRPr sz="1400">
-                <a:solidFill>
-                  <a:srgbClr val="C9D1D9"/>
-                </a:solidFill>
-                <a:latin typeface="Consolas"/>
-              </a:defRPr>
-            </a:pPr>
-            <a:r>
-              <a:t>  mace_omol      espaloma     23 cm⁻¹   0.999963     0.52</a:t>
-            </a:r>
-          </a:p>
-          <a:p>
-            <a:pPr>
-              <a:spcAft>
-                <a:spcPts val="400"/>
-              </a:spcAft>
-              <a:defRPr sz="1400">
-                <a:solidFill>
-                  <a:srgbClr val="D29922"/>
-                </a:solidFill>
-                <a:latin typeface="Consolas"/>
-              </a:defRPr>
-            </a:pPr>
-            <a:r>
-              <a:t>  mace_mp        mace_ml     106 cm⁻¹   0.999998     0.72</a:t>
-            </a:r>
-          </a:p>
-          <a:p>
-            <a:pPr>
-              <a:spcAft>
-                <a:spcPts val="400"/>
-              </a:spcAft>
-              <a:defRPr sz="1400">
-                <a:solidFill>
-                  <a:srgbClr val="D29922"/>
-                </a:solidFill>
-                <a:latin typeface="Consolas"/>
-              </a:defRPr>
-            </a:pPr>
-            <a:r>
-              <a:t>  mace_mp        espaloma    106 cm⁻¹   0.999998     0.51</a:t>
-            </a:r>
-          </a:p>
-          <a:p>
-            <a:pPr>
-              <a:spcAft>
-                <a:spcPts val="400"/>
-              </a:spcAft>
-              <a:defRPr sz="1400">
-                <a:solidFill>
-                  <a:srgbClr val="8B949E"/>
-                </a:solidFill>
-                <a:latin typeface="Consolas"/>
-              </a:defRPr>
-            </a:pPr>
-          </a:p>
-          <a:p>
-            <a:pPr>
-              <a:spcAft>
-                <a:spcPts val="400"/>
-              </a:spcAft>
-              <a:defRPr sz="1400">
-                <a:solidFill>
-                  <a:srgbClr val="C9D1D9"/>
-                </a:solidFill>
-                <a:latin typeface="Consolas"/>
-              </a:defRPr>
-            </a:pPr>
-            <a:r>
-              <a:t>  → Frequencies: all combos excellent except mace_mp</a:t>
-            </a:r>
-          </a:p>
-          <a:p>
-            <a:pPr>
-              <a:spcAft>
-                <a:spcPts val="400"/>
-              </a:spcAft>
-              <a:defRPr sz="1400">
-                <a:solidFill>
-                  <a:srgbClr val="3FB950"/>
-                </a:solidFill>
-                <a:latin typeface="Consolas"/>
-              </a:defRPr>
-            </a:pPr>
-            <a:r>
-              <a:t>  → Intensities: mace_ml dipole consistently beats espaloma</a:t>
+              <a:t>  Ref: B3LYP/6-31G(d,p)   |   sorted by MAE(freq) ascending</a:t>
+            </a:r>
+          </a:p>
+          <a:p>
+            <a:pPr>
+              <a:spcAft>
+                <a:spcPts val="400"/>
+              </a:spcAft>
+              <a:defRPr sz="1400">
+                <a:solidFill>
+                  <a:srgbClr val="8B949E"/>
+                </a:solidFill>
+                <a:latin typeface="Consolas"/>
+              </a:defRPr>
+            </a:pPr>
+          </a:p>
+          <a:p>
+            <a:pPr>
+              <a:spcAft>
+                <a:spcPts val="400"/>
+              </a:spcAft>
+              <a:defRPr sz="1400">
+                <a:solidFill>
+                  <a:srgbClr val="8B949E"/>
+                </a:solidFill>
+                <a:latin typeface="Consolas"/>
+              </a:defRPr>
+            </a:pPr>
+            <a:r>
+              <a:t>  Energy model    Dipole      MAE(freq)   R²(freq)    R²(intens)</a:t>
+            </a:r>
+          </a:p>
+          <a:p>
+            <a:pPr>
+              <a:spcAft>
+                <a:spcPts val="400"/>
+              </a:spcAft>
+              <a:defRPr sz="1400">
+                <a:solidFill>
+                  <a:srgbClr val="8B949E"/>
+                </a:solidFill>
+                <a:latin typeface="Consolas"/>
+              </a:defRPr>
+            </a:pPr>
+            <a:r>
+              <a:t>  ────────────────────────────────────────────────────────────</a:t>
+            </a:r>
+          </a:p>
+          <a:p>
+            <a:pPr>
+              <a:spcAft>
+                <a:spcPts val="400"/>
+              </a:spcAft>
+              <a:defRPr sz="1400">
+                <a:solidFill>
+                  <a:srgbClr val="C9D1D9"/>
+                </a:solidFill>
+                <a:latin typeface="Consolas"/>
+              </a:defRPr>
+            </a:pPr>
+            <a:r>
+              <a:t>  mace_anicc      mace_ml       19.0 cm⁻¹   0.9999974   0.72</a:t>
+            </a:r>
+          </a:p>
+          <a:p>
+            <a:pPr>
+              <a:spcAft>
+                <a:spcPts val="400"/>
+              </a:spcAft>
+              <a:defRPr sz="1400">
+                <a:solidFill>
+                  <a:srgbClr val="C9D1D9"/>
+                </a:solidFill>
+                <a:latin typeface="Consolas"/>
+              </a:defRPr>
+            </a:pPr>
+            <a:r>
+              <a:t>  mace_anicc      espaloma      19.0 cm⁻¹   0.9999974   0.52</a:t>
+            </a:r>
+          </a:p>
+          <a:p>
+            <a:pPr>
+              <a:spcAft>
+                <a:spcPts val="400"/>
+              </a:spcAft>
+              <a:defRPr sz="1400">
+                <a:solidFill>
+                  <a:srgbClr val="C9D1D9"/>
+                </a:solidFill>
+                <a:latin typeface="Consolas"/>
+              </a:defRPr>
+            </a:pPr>
+            <a:r>
+              <a:t>  mace_off        espaloma      20.7 cm⁻¹   0.9999344   0.52</a:t>
+            </a:r>
+          </a:p>
+          <a:p>
+            <a:pPr>
+              <a:spcAft>
+                <a:spcPts val="400"/>
+              </a:spcAft>
+              <a:defRPr sz="1400">
+                <a:solidFill>
+                  <a:srgbClr val="C9D1D9"/>
+                </a:solidFill>
+                <a:latin typeface="Consolas"/>
+              </a:defRPr>
+            </a:pPr>
+            <a:r>
+              <a:t>  mace_off        mace_ml       20.7 cm⁻¹   0.9999344   0.72</a:t>
+            </a:r>
+          </a:p>
+          <a:p>
+            <a:pPr>
+              <a:spcAft>
+                <a:spcPts val="400"/>
+              </a:spcAft>
+              <a:defRPr sz="1400">
+                <a:solidFill>
+                  <a:srgbClr val="C9D1D9"/>
+                </a:solidFill>
+                <a:latin typeface="Consolas"/>
+              </a:defRPr>
+            </a:pPr>
+            <a:r>
+              <a:t>  mace_omol       espaloma      22.7 cm⁻¹   0.9999631   0.52</a:t>
+            </a:r>
+          </a:p>
+          <a:p>
+            <a:pPr>
+              <a:spcAft>
+                <a:spcPts val="400"/>
+              </a:spcAft>
+              <a:defRPr sz="1400">
+                <a:solidFill>
+                  <a:srgbClr val="C9D1D9"/>
+                </a:solidFill>
+                <a:latin typeface="Consolas"/>
+              </a:defRPr>
+            </a:pPr>
+            <a:r>
+              <a:t>  mace_omol       mace_ml       22.7 cm⁻¹   0.9999631   0.72</a:t>
+            </a:r>
+          </a:p>
+          <a:p>
+            <a:pPr>
+              <a:spcAft>
+                <a:spcPts val="400"/>
+              </a:spcAft>
+              <a:defRPr sz="1400">
+                <a:solidFill>
+                  <a:srgbClr val="C9D1D9"/>
+                </a:solidFill>
+                <a:latin typeface="Consolas"/>
+              </a:defRPr>
+            </a:pPr>
+            <a:r>
+              <a:t>  mace_mp         mace_ml      106.3 cm⁻¹   0.9999981   0.72</a:t>
+            </a:r>
+          </a:p>
+          <a:p>
+            <a:pPr>
+              <a:spcAft>
+                <a:spcPts val="400"/>
+              </a:spcAft>
+              <a:defRPr sz="1400">
+                <a:solidFill>
+                  <a:srgbClr val="C9D1D9"/>
+                </a:solidFill>
+                <a:latin typeface="Consolas"/>
+              </a:defRPr>
+            </a:pPr>
+            <a:r>
+              <a:t>  mace_mp         espaloma     106.3 cm⁻¹   0.9999981   0.51</a:t>
+            </a:r>
+          </a:p>
+          <a:p>
+            <a:pPr>
+              <a:spcAft>
+                <a:spcPts val="400"/>
+              </a:spcAft>
+              <a:defRPr sz="1400">
+                <a:solidFill>
+                  <a:srgbClr val="8B949E"/>
+                </a:solidFill>
+                <a:latin typeface="Consolas"/>
+              </a:defRPr>
+            </a:pPr>
+          </a:p>
+          <a:p>
+            <a:pPr>
+              <a:spcAft>
+                <a:spcPts val="400"/>
+              </a:spcAft>
+              <a:defRPr sz="1400">
+                <a:solidFill>
+                  <a:srgbClr val="C9D1D9"/>
+                </a:solidFill>
+                <a:latin typeface="Consolas"/>
+              </a:defRPr>
+            </a:pPr>
+            <a:r>
+              <a:t>  → Frequencies: all combos excellent (R² &gt; 0.9999)</a:t>
+            </a:r>
+          </a:p>
+          <a:p>
+            <a:pPr>
+              <a:spcAft>
+                <a:spcPts val="400"/>
+              </a:spcAft>
+              <a:defRPr sz="1400">
+                <a:solidFill>
+                  <a:srgbClr val="C9D1D9"/>
+                </a:solidFill>
+                <a:latin typeface="Consolas"/>
+              </a:defRPr>
+            </a:pPr>
+            <a:r>
+              <a:t>  → Intensities: mace_ml consistently beats espaloma</a:t>
             </a:r>
           </a:p>
         </p:txBody>

</xml_diff>

<commit_message>
feat(slides): motivation slide — v1 style with systematic benchmark line
Co-Authored-By: Claude Opus 4.6 <noreply@anthropic.com>
</commit_message>
<xml_diff>
--- a/presentation/presentation_v2.pptx
+++ b/presentation/presentation_v2.pptx
@@ -5518,39 +5518,39 @@
               </a:defRPr>
             </a:pPr>
             <a:r>
-              <a:t>  → DFT frequency calculations: slow (minutes to hours per molecule)</a:t>
-            </a:r>
-          </a:p>
-          <a:p>
-            <a:pPr>
-              <a:spcAft>
-                <a:spcPts val="400"/>
-              </a:spcAft>
-              <a:defRPr sz="1400">
-                <a:solidFill>
-                  <a:srgbClr val="C9D1D9"/>
-                </a:solidFill>
-                <a:latin typeface="Consolas"/>
-              </a:defRPr>
-            </a:pPr>
-            <a:r>
-              <a:t>  → Anharmonic VPT2: even more expensive — scales as O(N⁴)</a:t>
-            </a:r>
-          </a:p>
-          <a:p>
-            <a:pPr>
-              <a:spcAft>
-                <a:spcPts val="400"/>
-              </a:spcAft>
-              <a:defRPr sz="1400">
-                <a:solidFill>
-                  <a:srgbClr val="C9D1D9"/>
-                </a:solidFill>
-                <a:latin typeface="Consolas"/>
-              </a:defRPr>
-            </a:pPr>
-            <a:r>
-              <a:t>  → Bottleneck for any systematic benchmark campaign</a:t>
+              <a:t>  → DFT frequency calculations: slow</a:t>
+            </a:r>
+          </a:p>
+          <a:p>
+            <a:pPr>
+              <a:spcAft>
+                <a:spcPts val="400"/>
+              </a:spcAft>
+              <a:defRPr sz="1400">
+                <a:solidFill>
+                  <a:srgbClr val="C9D1D9"/>
+                </a:solidFill>
+                <a:latin typeface="Consolas"/>
+              </a:defRPr>
+            </a:pPr>
+            <a:r>
+              <a:t>  → Minutes to hours per molecule</a:t>
+            </a:r>
+          </a:p>
+          <a:p>
+            <a:pPr>
+              <a:spcAft>
+                <a:spcPts val="400"/>
+              </a:spcAft>
+              <a:defRPr sz="1400">
+                <a:solidFill>
+                  <a:srgbClr val="C9D1D9"/>
+                </a:solidFill>
+                <a:latin typeface="Consolas"/>
+              </a:defRPr>
+            </a:pPr>
+            <a:r>
+              <a:t>  → Bottleneck for systematic benchmark campaigns</a:t>
             </a:r>
           </a:p>
           <a:p>
@@ -5595,39 +5595,39 @@
               </a:defRPr>
             </a:pPr>
             <a:r>
-              <a:t>  → Hybrid ML-QM: ML computes dipole derivatives in real-time</a:t>
-            </a:r>
-          </a:p>
-          <a:p>
-            <a:pPr>
-              <a:spcAft>
-                <a:spcPts val="400"/>
-              </a:spcAft>
-              <a:defRPr sz="1400">
-                <a:solidFill>
-                  <a:srgbClr val="C9D1D9"/>
-                </a:solidFill>
-                <a:latin typeface="Consolas"/>
-              </a:defRPr>
-            </a:pPr>
-            <a:r>
-              <a:t>  → ZMQ bridge injects results into Gaussian — no modifications needed</a:t>
-            </a:r>
-          </a:p>
-          <a:p>
-            <a:pPr>
-              <a:spcAft>
-                <a:spcPts val="400"/>
-              </a:spcAft>
-              <a:defRPr sz="1400">
-                <a:solidFill>
-                  <a:srgbClr val="C9D1D9"/>
-                </a:solidFill>
-                <a:latin typeface="Consolas"/>
-              </a:defRPr>
-            </a:pPr>
-            <a:r>
-              <a:t>  → 10–100× faster than pure DFT for dipole-heavy steps</a:t>
+              <a:t>  → Hybrid ML-QM approach</a:t>
+            </a:r>
+          </a:p>
+          <a:p>
+            <a:pPr>
+              <a:spcAft>
+                <a:spcPts val="400"/>
+              </a:spcAft>
+              <a:defRPr sz="1400">
+                <a:solidFill>
+                  <a:srgbClr val="C9D1D9"/>
+                </a:solidFill>
+                <a:latin typeface="Consolas"/>
+              </a:defRPr>
+            </a:pPr>
+            <a:r>
+              <a:t>  → ML dipoles and energies</a:t>
+            </a:r>
+          </a:p>
+          <a:p>
+            <a:pPr>
+              <a:spcAft>
+                <a:spcPts val="400"/>
+              </a:spcAft>
+              <a:defRPr sz="1400">
+                <a:solidFill>
+                  <a:srgbClr val="C9D1D9"/>
+                </a:solidFill>
+                <a:latin typeface="Consolas"/>
+              </a:defRPr>
+            </a:pPr>
+            <a:r>
+              <a:t>  → Possibly 10–100× faster than pure DFT</a:t>
             </a:r>
           </a:p>
           <a:p>
@@ -5672,23 +5672,39 @@
               </a:defRPr>
             </a:pPr>
             <a:r>
-              <a:t>  → Rapid IR predictions across chemical space</a:t>
-            </a:r>
-          </a:p>
-          <a:p>
-            <a:pPr>
-              <a:spcAft>
-                <a:spcPts val="400"/>
-              </a:spcAft>
-              <a:defRPr sz="1400">
-                <a:solidFill>
-                  <a:srgbClr val="C9D1D9"/>
-                </a:solidFill>
-                <a:latin typeface="Consolas"/>
-              </a:defRPr>
-            </a:pPr>
-            <a:r>
-              <a:t>  → Thesis question: energy surface vs dipole model quality</a:t>
+              <a:t>  → Enable rapid IR spectral predictions</a:t>
+            </a:r>
+          </a:p>
+          <a:p>
+            <a:pPr>
+              <a:spcAft>
+                <a:spcPts val="400"/>
+              </a:spcAft>
+              <a:defRPr sz="1400">
+                <a:solidFill>
+                  <a:srgbClr val="C9D1D9"/>
+                </a:solidFill>
+                <a:latin typeface="Consolas"/>
+              </a:defRPr>
+            </a:pPr>
+            <a:r>
+              <a:t>  → Maintain DFT-level accuracy</a:t>
+            </a:r>
+          </a:p>
+          <a:p>
+            <a:pPr>
+              <a:spcAft>
+                <a:spcPts val="400"/>
+              </a:spcAft>
+              <a:defRPr sz="1400">
+                <a:solidFill>
+                  <a:srgbClr val="C9D1D9"/>
+                </a:solidFill>
+                <a:latin typeface="Consolas"/>
+              </a:defRPr>
+            </a:pPr>
+            <a:r>
+              <a:t>  → Systematic comparison: energy surface vs dipole model quality</a:t>
             </a:r>
           </a:p>
         </p:txBody>

</xml_diff>

<commit_message>
feat(slides): restore v1 architecture ASCII art with function names
Co-Authored-By: Claude Opus 4.6 <noreply@anthropic.com>
</commit_message>
<xml_diff>
--- a/presentation/presentation_v2.pptx
+++ b/presentation/presentation_v2.pptx
@@ -6502,295 +6502,471 @@
               </a:defRPr>
             </a:pPr>
             <a:r>
-              <a:t>  [molecule.xyz]</a:t>
-            </a:r>
-          </a:p>
-          <a:p>
-            <a:pPr>
-              <a:spcAft>
-                <a:spcPts val="400"/>
-              </a:spcAft>
-              <a:defRPr sz="1400">
-                <a:solidFill>
-                  <a:srgbClr val="8B949E"/>
-                </a:solidFill>
-                <a:latin typeface="Consolas"/>
-              </a:defRPr>
-            </a:pPr>
-            <a:r>
-              <a:t>       ↓</a:t>
-            </a:r>
-          </a:p>
-          <a:p>
-            <a:pPr>
-              <a:spcAft>
-                <a:spcPts val="400"/>
-              </a:spcAft>
-              <a:defRPr sz="1400">
-                <a:solidFill>
-                  <a:srgbClr val="8B949E"/>
-                </a:solidFill>
-                <a:latin typeface="Consolas"/>
-              </a:defRPr>
-            </a:pPr>
-            <a:r>
-              <a:t>  ┌─────────────────────────────────────────────────────┐</a:t>
-            </a:r>
-          </a:p>
-          <a:p>
-            <a:pPr>
-              <a:spcAft>
-                <a:spcPts val="400"/>
-              </a:spcAft>
-              <a:defRPr sz="1400">
-                <a:solidFill>
-                  <a:srgbClr val="8B949E"/>
-                </a:solidFill>
-                <a:latin typeface="Consolas"/>
-              </a:defRPr>
-            </a:pPr>
-            <a:r>
-              <a:t>  │  GEOMETRY OPTIMIZER  (MACE-OMOL-0 + ASE)           │</a:t>
-            </a:r>
-          </a:p>
-          <a:p>
-            <a:pPr>
-              <a:spcAft>
-                <a:spcPts val="400"/>
-              </a:spcAft>
-              <a:defRPr sz="1400">
-                <a:solidFill>
-                  <a:srgbClr val="8B949E"/>
-                </a:solidFill>
-                <a:latin typeface="Consolas"/>
-              </a:defRPr>
-            </a:pPr>
-            <a:r>
-              <a:t>  └──────────────┬──────────────────────────────────────┘</a:t>
-            </a:r>
-          </a:p>
-          <a:p>
-            <a:pPr>
-              <a:spcAft>
-                <a:spcPts val="400"/>
-              </a:spcAft>
-              <a:defRPr sz="1400">
-                <a:solidFill>
-                  <a:srgbClr val="8B949E"/>
-                </a:solidFill>
-                <a:latin typeface="Consolas"/>
-              </a:defRPr>
-            </a:pPr>
-            <a:r>
-              <a:t>                 ↓</a:t>
-            </a:r>
-          </a:p>
-          <a:p>
-            <a:pPr>
-              <a:spcAft>
-                <a:spcPts val="400"/>
-              </a:spcAft>
-              <a:defRPr sz="1400">
-                <a:solidFill>
-                  <a:srgbClr val="8B949E"/>
-                </a:solidFill>
-                <a:latin typeface="Consolas"/>
-              </a:defRPr>
-            </a:pPr>
-            <a:r>
-              <a:t>  ┌──────────────┴──────────────┐</a:t>
-            </a:r>
-          </a:p>
-          <a:p>
-            <a:pPr>
-              <a:spcAft>
-                <a:spcPts val="400"/>
-              </a:spcAft>
-              <a:defRPr sz="1400">
-                <a:solidFill>
-                  <a:srgbClr val="8B949E"/>
-                </a:solidFill>
-                <a:latin typeface="Consolas"/>
-              </a:defRPr>
-            </a:pPr>
-            <a:r>
-              <a:t>  │ DFT BASELINE                │   ┌─────────────────────────────┐</a:t>
-            </a:r>
-          </a:p>
-          <a:p>
-            <a:pPr>
-              <a:spcAft>
-                <a:spcPts val="400"/>
-              </a:spcAft>
-              <a:defRPr sz="1400">
-                <a:solidFill>
-                  <a:srgbClr val="8B949E"/>
-                </a:solidFill>
-                <a:latin typeface="Consolas"/>
-              </a:defRPr>
-            </a:pPr>
-            <a:r>
-              <a:t>  │ B3LYP/6-31G(d,p)           │   │ ML FREQ CALC                │</a:t>
-            </a:r>
-          </a:p>
-          <a:p>
-            <a:pPr>
-              <a:spcAft>
-                <a:spcPts val="400"/>
-              </a:spcAft>
-              <a:defRPr sz="1400">
-                <a:solidFill>
-                  <a:srgbClr val="8B949E"/>
-                </a:solidFill>
-                <a:latin typeface="Consolas"/>
-              </a:defRPr>
-            </a:pPr>
-            <a:r>
-              <a:t>  │ Gaussian 16                 │   │ MACE energy + forces        │</a:t>
-            </a:r>
-          </a:p>
-          <a:p>
-            <a:pPr>
-              <a:spcAft>
-                <a:spcPts val="400"/>
-              </a:spcAft>
-              <a:defRPr sz="1400">
-                <a:solidFill>
-                  <a:srgbClr val="8B949E"/>
-                </a:solidFill>
-                <a:latin typeface="Consolas"/>
-              </a:defRPr>
-            </a:pPr>
-            <a:r>
-              <a:t>  │ freq + dipoles              │   │ MACE dipole model           │</a:t>
-            </a:r>
-          </a:p>
-          <a:p>
-            <a:pPr>
-              <a:spcAft>
-                <a:spcPts val="400"/>
-              </a:spcAft>
-              <a:defRPr sz="1400">
-                <a:solidFill>
-                  <a:srgbClr val="8B949E"/>
-                </a:solidFill>
-                <a:latin typeface="Consolas"/>
-              </a:defRPr>
-            </a:pPr>
-            <a:r>
-              <a:t>  └──────────────┬──────────────┘   │ ZMQ bridge (zmq_server.py) │</a:t>
-            </a:r>
-          </a:p>
-          <a:p>
-            <a:pPr>
-              <a:spcAft>
-                <a:spcPts val="400"/>
-              </a:spcAft>
-              <a:defRPr sz="1400">
-                <a:solidFill>
-                  <a:srgbClr val="8B949E"/>
-                </a:solidFill>
-                <a:latin typeface="Consolas"/>
-              </a:defRPr>
-            </a:pPr>
-            <a:r>
-              <a:t>                 │                  │                             │</a:t>
-            </a:r>
-          </a:p>
-          <a:p>
-            <a:pPr>
-              <a:spcAft>
-                <a:spcPts val="400"/>
-              </a:spcAft>
-              <a:defRPr sz="1400">
-                <a:solidFill>
-                  <a:srgbClr val="8B949E"/>
-                </a:solidFill>
-                <a:latin typeface="Consolas"/>
-              </a:defRPr>
-            </a:pPr>
-            <a:r>
-              <a:t>                 └──────────────────┤ → fort.7 → Gaussian        │</a:t>
-            </a:r>
-          </a:p>
-          <a:p>
-            <a:pPr>
-              <a:spcAft>
-                <a:spcPts val="400"/>
-              </a:spcAft>
-              <a:defRPr sz="1400">
-                <a:solidFill>
-                  <a:srgbClr val="8B949E"/>
-                </a:solidFill>
-                <a:latin typeface="Consolas"/>
-              </a:defRPr>
-            </a:pPr>
-            <a:r>
-              <a:t>                                    └──────────────┬──────────────┘</a:t>
-            </a:r>
-          </a:p>
-          <a:p>
-            <a:pPr>
-              <a:spcAft>
-                <a:spcPts val="400"/>
-              </a:spcAft>
-              <a:defRPr sz="1400">
-                <a:solidFill>
-                  <a:srgbClr val="8B949E"/>
-                </a:solidFill>
-                <a:latin typeface="Consolas"/>
-              </a:defRPr>
-            </a:pPr>
-            <a:r>
-              <a:t>                                                   ↓</a:t>
-            </a:r>
-          </a:p>
-          <a:p>
-            <a:pPr>
-              <a:spcAft>
-                <a:spcPts val="400"/>
-              </a:spcAft>
-              <a:defRPr sz="1400">
-                <a:solidFill>
-                  <a:srgbClr val="8B949E"/>
-                </a:solidFill>
-                <a:latin typeface="Consolas"/>
-              </a:defRPr>
-            </a:pPr>
-            <a:r>
-              <a:t>  ┌──────────────────────────────────────────────────────────────┐</a:t>
-            </a:r>
-          </a:p>
-          <a:p>
-            <a:pPr>
-              <a:spcAft>
-                <a:spcPts val="400"/>
-              </a:spcAft>
-              <a:defRPr sz="1400">
-                <a:solidFill>
-                  <a:srgbClr val="8B949E"/>
-                </a:solidFill>
-                <a:latin typeface="Consolas"/>
-              </a:defRPr>
-            </a:pPr>
-            <a:r>
-              <a:t>  │ ANALYSIS  eigenvector matching → KDE broadening → HTML      │</a:t>
-            </a:r>
-          </a:p>
-          <a:p>
-            <a:pPr>
-              <a:spcAft>
-                <a:spcPts val="400"/>
-              </a:spcAft>
-              <a:defRPr sz="1400">
-                <a:solidFill>
-                  <a:srgbClr val="8B949E"/>
-                </a:solidFill>
-                <a:latin typeface="Consolas"/>
-              </a:defRPr>
-            </a:pPr>
-            <a:r>
-              <a:t>  └──────────────────────────────────────────────────────────────┘</a:t>
+              <a:t>                        [molecule.xyz]</a:t>
+            </a:r>
+          </a:p>
+          <a:p>
+            <a:pPr>
+              <a:spcAft>
+                <a:spcPts val="400"/>
+              </a:spcAft>
+              <a:defRPr sz="1400">
+                <a:solidFill>
+                  <a:srgbClr val="8B949E"/>
+                </a:solidFill>
+                <a:latin typeface="Consolas"/>
+              </a:defRPr>
+            </a:pPr>
+            <a:r>
+              <a:t>                             │</a:t>
+            </a:r>
+          </a:p>
+          <a:p>
+            <a:pPr>
+              <a:spcAft>
+                <a:spcPts val="400"/>
+              </a:spcAft>
+              <a:defRPr sz="1400">
+                <a:solidFill>
+                  <a:srgbClr val="8B949E"/>
+                </a:solidFill>
+                <a:latin typeface="Consolas"/>
+              </a:defRPr>
+            </a:pPr>
+            <a:r>
+              <a:t>                             ▼</a:t>
+            </a:r>
+          </a:p>
+          <a:p>
+            <a:pPr>
+              <a:spcAft>
+                <a:spcPts val="400"/>
+              </a:spcAft>
+              <a:defRPr sz="1400">
+                <a:solidFill>
+                  <a:srgbClr val="8B949E"/>
+                </a:solidFill>
+                <a:latin typeface="Consolas"/>
+              </a:defRPr>
+            </a:pPr>
+            <a:r>
+              <a:t>  ┌───────────────────────────────────────────────────────────┐</a:t>
+            </a:r>
+          </a:p>
+          <a:p>
+            <a:pPr>
+              <a:spcAft>
+                <a:spcPts val="400"/>
+              </a:spcAft>
+              <a:defRPr sz="1400">
+                <a:solidFill>
+                  <a:srgbClr val="58A6FF"/>
+                </a:solidFill>
+                <a:latin typeface="Consolas"/>
+              </a:defRPr>
+            </a:pPr>
+            <a:r>
+              <a:t>  │  GEOMETRY OPTIMIZER                                      │</a:t>
+            </a:r>
+          </a:p>
+          <a:p>
+            <a:pPr>
+              <a:spcAft>
+                <a:spcPts val="400"/>
+              </a:spcAft>
+              <a:defRPr sz="1400">
+                <a:solidFill>
+                  <a:srgbClr val="8B949E"/>
+                </a:solidFill>
+                <a:latin typeface="Consolas"/>
+              </a:defRPr>
+            </a:pPr>
+            <a:r>
+              <a:t>  │  • load_geometry()  • mace_omol.optimize()  • ase_to_gjf │</a:t>
+            </a:r>
+          </a:p>
+          <a:p>
+            <a:pPr>
+              <a:spcAft>
+                <a:spcPts val="400"/>
+              </a:spcAft>
+              <a:defRPr sz="1400">
+                <a:solidFill>
+                  <a:srgbClr val="8B949E"/>
+                </a:solidFill>
+                <a:latin typeface="Consolas"/>
+              </a:defRPr>
+            </a:pPr>
+            <a:r>
+              <a:t>  └──────────────┬────────────────────────┬──────────────────┘</a:t>
+            </a:r>
+          </a:p>
+          <a:p>
+            <a:pPr>
+              <a:spcAft>
+                <a:spcPts val="400"/>
+              </a:spcAft>
+              <a:defRPr sz="1400">
+                <a:solidFill>
+                  <a:srgbClr val="8B949E"/>
+                </a:solidFill>
+                <a:latin typeface="Consolas"/>
+              </a:defRPr>
+            </a:pPr>
+            <a:r>
+              <a:t>                 │                        │</a:t>
+            </a:r>
+          </a:p>
+          <a:p>
+            <a:pPr>
+              <a:spcAft>
+                <a:spcPts val="400"/>
+              </a:spcAft>
+              <a:defRPr sz="1400">
+                <a:solidFill>
+                  <a:srgbClr val="8B949E"/>
+                </a:solidFill>
+                <a:latin typeface="Consolas"/>
+              </a:defRPr>
+            </a:pPr>
+            <a:r>
+              <a:t>                 ▼                        ▼</a:t>
+            </a:r>
+          </a:p>
+          <a:p>
+            <a:pPr>
+              <a:spcAft>
+                <a:spcPts val="400"/>
+              </a:spcAft>
+              <a:defRPr sz="1400">
+                <a:solidFill>
+                  <a:srgbClr val="8B949E"/>
+                </a:solidFill>
+                <a:latin typeface="Consolas"/>
+              </a:defRPr>
+            </a:pPr>
+            <a:r>
+              <a:t>  ┌──────────────────────┐  ┌────────────────────────────────┐</a:t>
+            </a:r>
+          </a:p>
+          <a:p>
+            <a:pPr>
+              <a:spcAft>
+                <a:spcPts val="400"/>
+              </a:spcAft>
+              <a:defRPr sz="1400">
+                <a:solidFill>
+                  <a:srgbClr val="58A6FF"/>
+                </a:solidFill>
+                <a:latin typeface="Consolas"/>
+              </a:defRPr>
+            </a:pPr>
+            <a:r>
+              <a:t>  │  DFT BASELINE        │  │  ML FREQ CALC                  │</a:t>
+            </a:r>
+          </a:p>
+          <a:p>
+            <a:pPr>
+              <a:spcAft>
+                <a:spcPts val="400"/>
+              </a:spcAft>
+              <a:defRPr sz="1400">
+                <a:solidFill>
+                  <a:srgbClr val="8B949E"/>
+                </a:solidFill>
+                <a:latin typeface="Consolas"/>
+              </a:defRPr>
+            </a:pPr>
+            <a:r>
+              <a:t>  │                      │  │                                │</a:t>
+            </a:r>
+          </a:p>
+          <a:p>
+            <a:pPr>
+              <a:spcAft>
+                <a:spcPts val="400"/>
+              </a:spcAft>
+              <a:defRPr sz="1400">
+                <a:solidFill>
+                  <a:srgbClr val="8B949E"/>
+                </a:solidFill>
+                <a:latin typeface="Consolas"/>
+              </a:defRPr>
+            </a:pPr>
+            <a:r>
+              <a:t>  │  ┌────────────────┐  │  │  • load_mace_calculator()      │</a:t>
+            </a:r>
+          </a:p>
+          <a:p>
+            <a:pPr>
+              <a:spcAft>
+                <a:spcPts val="400"/>
+              </a:spcAft>
+              <a:defRPr sz="1400">
+                <a:solidFill>
+                  <a:srgbClr val="8B949E"/>
+                </a:solidFill>
+                <a:latin typeface="Consolas"/>
+              </a:defRPr>
+            </a:pPr>
+            <a:r>
+              <a:t>  │  │ Built-in opt   │  │  │    (MACE-MP / MACE-OMOL)       │</a:t>
+            </a:r>
+          </a:p>
+          <a:p>
+            <a:pPr>
+              <a:spcAft>
+                <a:spcPts val="400"/>
+              </a:spcAft>
+              <a:defRPr sz="1400">
+                <a:solidFill>
+                  <a:srgbClr val="8B949E"/>
+                </a:solidFill>
+                <a:latin typeface="Consolas"/>
+              </a:defRPr>
+            </a:pPr>
+            <a:r>
+              <a:t>  │  │ B3LYP/6-31G(d,p) │  │  • get_dipole_calculator()     │</a:t>
+            </a:r>
+          </a:p>
+          <a:p>
+            <a:pPr>
+              <a:spcAft>
+                <a:spcPts val="400"/>
+              </a:spcAft>
+              <a:defRPr sz="1400">
+                <a:solidFill>
+                  <a:srgbClr val="8B949E"/>
+                </a:solidFill>
+                <a:latin typeface="Consolas"/>
+              </a:defRPr>
+            </a:pPr>
+            <a:r>
+              <a:t>  │  └────────────────┘  │  │    (Espaloma / MACE_DIPOLE)    │</a:t>
+            </a:r>
+          </a:p>
+          <a:p>
+            <a:pPr>
+              <a:spcAft>
+                <a:spcPts val="400"/>
+              </a:spcAft>
+              <a:defRPr sz="1400">
+                <a:solidFill>
+                  <a:srgbClr val="8B949E"/>
+                </a:solidFill>
+                <a:latin typeface="Consolas"/>
+              </a:defRPr>
+            </a:pPr>
+            <a:r>
+              <a:t>  │                      │  │  • setup_zmq_server()          │</a:t>
+            </a:r>
+          </a:p>
+          <a:p>
+            <a:pPr>
+              <a:spcAft>
+                <a:spcPts val="400"/>
+              </a:spcAft>
+              <a:defRPr sz="1400">
+                <a:solidFill>
+                  <a:srgbClr val="8B949E"/>
+                </a:solidFill>
+                <a:latin typeface="Consolas"/>
+              </a:defRPr>
+            </a:pPr>
+            <a:r>
+              <a:t>  │  • gaussian_freq()   │  │  • launch_gaussian()           │</a:t>
+            </a:r>
+          </a:p>
+          <a:p>
+            <a:pPr>
+              <a:spcAft>
+                <a:spcPts val="400"/>
+              </a:spcAft>
+              <a:defRPr sz="1400">
+                <a:solidFill>
+                  <a:srgbClr val="8B949E"/>
+                </a:solidFill>
+                <a:latin typeface="Consolas"/>
+              </a:defRPr>
+            </a:pPr>
+            <a:r>
+              <a:t>  │  • gaussian_dipoles()│  │  • zmq_dipole_loop()           │</a:t>
+            </a:r>
+          </a:p>
+          <a:p>
+            <a:pPr>
+              <a:spcAft>
+                <a:spcPts val="400"/>
+              </a:spcAft>
+              <a:defRPr sz="1400">
+                <a:solidFill>
+                  <a:srgbClr val="8B949E"/>
+                </a:solidFill>
+                <a:latin typeface="Consolas"/>
+              </a:defRPr>
+            </a:pPr>
+            <a:r>
+              <a:t>  │  • parse_gaussian()  │  │                                │</a:t>
+            </a:r>
+          </a:p>
+          <a:p>
+            <a:pPr>
+              <a:spcAft>
+                <a:spcPts val="400"/>
+              </a:spcAft>
+              <a:defRPr sz="1400">
+                <a:solidFill>
+                  <a:srgbClr val="8B949E"/>
+                </a:solidFill>
+                <a:latin typeface="Consolas"/>
+              </a:defRPr>
+            </a:pPr>
+            <a:r>
+              <a:t>  └──────────┬───────────┘  └───────────────┬────────────────┘</a:t>
+            </a:r>
+          </a:p>
+          <a:p>
+            <a:pPr>
+              <a:spcAft>
+                <a:spcPts val="400"/>
+              </a:spcAft>
+              <a:defRPr sz="1400">
+                <a:solidFill>
+                  <a:srgbClr val="8B949E"/>
+                </a:solidFill>
+                <a:latin typeface="Consolas"/>
+              </a:defRPr>
+            </a:pPr>
+            <a:r>
+              <a:t>             │                              │</a:t>
+            </a:r>
+          </a:p>
+          <a:p>
+            <a:pPr>
+              <a:spcAft>
+                <a:spcPts val="400"/>
+              </a:spcAft>
+              <a:defRPr sz="1400">
+                <a:solidFill>
+                  <a:srgbClr val="8B949E"/>
+                </a:solidFill>
+                <a:latin typeface="Consolas"/>
+              </a:defRPr>
+            </a:pPr>
+            <a:r>
+              <a:t>             ▼                              ▼</a:t>
+            </a:r>
+          </a:p>
+          <a:p>
+            <a:pPr>
+              <a:spcAft>
+                <a:spcPts val="400"/>
+              </a:spcAft>
+              <a:defRPr sz="1400">
+                <a:solidFill>
+                  <a:srgbClr val="8B949E"/>
+                </a:solidFill>
+                <a:latin typeface="Consolas"/>
+              </a:defRPr>
+            </a:pPr>
+            <a:r>
+              <a:t>  ┌──────────────────────────────────────────────────────────┐</a:t>
+            </a:r>
+          </a:p>
+          <a:p>
+            <a:pPr>
+              <a:spcAft>
+                <a:spcPts val="400"/>
+              </a:spcAft>
+              <a:defRPr sz="1400">
+                <a:solidFill>
+                  <a:srgbClr val="58A6FF"/>
+                </a:solidFill>
+                <a:latin typeface="Consolas"/>
+              </a:defRPr>
+            </a:pPr>
+            <a:r>
+              <a:t>  │  ANALYSIS &amp; COMPARISON                                   │</a:t>
+            </a:r>
+          </a:p>
+          <a:p>
+            <a:pPr>
+              <a:spcAft>
+                <a:spcPts val="400"/>
+              </a:spcAft>
+              <a:defRPr sz="1400">
+                <a:solidFill>
+                  <a:srgbClr val="8B949E"/>
+                </a:solidFill>
+                <a:latin typeface="Consolas"/>
+              </a:defRPr>
+            </a:pPr>
+            <a:r>
+              <a:t>  │  load_results → find_dft_baseline → eigenvector_matching │</a:t>
+            </a:r>
+          </a:p>
+          <a:p>
+            <a:pPr>
+              <a:spcAft>
+                <a:spcPts val="400"/>
+              </a:spcAft>
+              <a:defRPr sz="1400">
+                <a:solidFill>
+                  <a:srgbClr val="8B949E"/>
+                </a:solidFill>
+                <a:latin typeface="Consolas"/>
+              </a:defRPr>
+            </a:pPr>
+            <a:r>
+              <a:t>  │  → kde_broaden → calculate_metrics → plot_regression     │</a:t>
+            </a:r>
+          </a:p>
+          <a:p>
+            <a:pPr>
+              <a:spcAft>
+                <a:spcPts val="400"/>
+              </a:spcAft>
+              <a:defRPr sz="1400">
+                <a:solidFill>
+                  <a:srgbClr val="8B949E"/>
+                </a:solidFill>
+                <a:latin typeface="Consolas"/>
+              </a:defRPr>
+            </a:pPr>
+            <a:r>
+              <a:t>  └─────────────────────────┬────────────────────────────────┘</a:t>
+            </a:r>
+          </a:p>
+          <a:p>
+            <a:pPr>
+              <a:spcAft>
+                <a:spcPts val="400"/>
+              </a:spcAft>
+              <a:defRPr sz="1400">
+                <a:solidFill>
+                  <a:srgbClr val="8B949E"/>
+                </a:solidFill>
+                <a:latin typeface="Consolas"/>
+              </a:defRPr>
+            </a:pPr>
+            <a:r>
+              <a:t>                            ▼</a:t>
+            </a:r>
+          </a:p>
+          <a:p>
+            <a:pPr>
+              <a:spcAft>
+                <a:spcPts val="400"/>
+              </a:spcAft>
+              <a:defRPr sz="1400">
+                <a:solidFill>
+                  <a:srgbClr val="3FB950"/>
+                </a:solidFill>
+                <a:latin typeface="Consolas"/>
+              </a:defRPr>
+            </a:pPr>
+            <a:r>
+              <a:t>                  generate_html_report()</a:t>
             </a:r>
           </a:p>
         </p:txBody>

</xml_diff>

<commit_message>
feat(slides): architecture — wider layout, fewer rows
Co-Authored-By: Claude Opus 4.6 <noreply@anthropic.com>
</commit_message>
<xml_diff>
--- a/presentation/presentation_v2.pptx
+++ b/presentation/presentation_v2.pptx
@@ -6502,55 +6502,39 @@
               </a:defRPr>
             </a:pPr>
             <a:r>
-              <a:t>                        [molecule.xyz]</a:t>
-            </a:r>
-          </a:p>
-          <a:p>
-            <a:pPr>
-              <a:spcAft>
-                <a:spcPts val="400"/>
-              </a:spcAft>
-              <a:defRPr sz="1400">
-                <a:solidFill>
-                  <a:srgbClr val="8B949E"/>
-                </a:solidFill>
-                <a:latin typeface="Consolas"/>
-              </a:defRPr>
-            </a:pPr>
-            <a:r>
-              <a:t>                             │</a:t>
-            </a:r>
-          </a:p>
-          <a:p>
-            <a:pPr>
-              <a:spcAft>
-                <a:spcPts val="400"/>
-              </a:spcAft>
-              <a:defRPr sz="1400">
-                <a:solidFill>
-                  <a:srgbClr val="8B949E"/>
-                </a:solidFill>
-                <a:latin typeface="Consolas"/>
-              </a:defRPr>
-            </a:pPr>
-            <a:r>
-              <a:t>                             ▼</a:t>
-            </a:r>
-          </a:p>
-          <a:p>
-            <a:pPr>
-              <a:spcAft>
-                <a:spcPts val="400"/>
-              </a:spcAft>
-              <a:defRPr sz="1400">
-                <a:solidFill>
-                  <a:srgbClr val="8B949E"/>
-                </a:solidFill>
-                <a:latin typeface="Consolas"/>
-              </a:defRPr>
-            </a:pPr>
-            <a:r>
-              <a:t>  ┌───────────────────────────────────────────────────────────┐</a:t>
+              <a:t>                              [molecule.xyz]</a:t>
+            </a:r>
+          </a:p>
+          <a:p>
+            <a:pPr>
+              <a:spcAft>
+                <a:spcPts val="400"/>
+              </a:spcAft>
+              <a:defRPr sz="1400">
+                <a:solidFill>
+                  <a:srgbClr val="8B949E"/>
+                </a:solidFill>
+                <a:latin typeface="Consolas"/>
+              </a:defRPr>
+            </a:pPr>
+            <a:r>
+              <a:t>                                    ▼</a:t>
+            </a:r>
+          </a:p>
+          <a:p>
+            <a:pPr>
+              <a:spcAft>
+                <a:spcPts val="400"/>
+              </a:spcAft>
+              <a:defRPr sz="1400">
+                <a:solidFill>
+                  <a:srgbClr val="8B949E"/>
+                </a:solidFill>
+                <a:latin typeface="Consolas"/>
+              </a:defRPr>
+            </a:pPr>
+            <a:r>
+              <a:t>  ┌────────────────────────────────────────────────────────────────────────┐</a:t>
             </a:r>
           </a:p>
           <a:p>
@@ -6566,87 +6550,71 @@
               </a:defRPr>
             </a:pPr>
             <a:r>
-              <a:t>  │  GEOMETRY OPTIMIZER                                      │</a:t>
-            </a:r>
-          </a:p>
-          <a:p>
-            <a:pPr>
-              <a:spcAft>
-                <a:spcPts val="400"/>
-              </a:spcAft>
-              <a:defRPr sz="1400">
-                <a:solidFill>
-                  <a:srgbClr val="8B949E"/>
-                </a:solidFill>
-                <a:latin typeface="Consolas"/>
-              </a:defRPr>
-            </a:pPr>
-            <a:r>
-              <a:t>  │  • load_geometry()  • mace_omol.optimize()  • ase_to_gjf │</a:t>
-            </a:r>
-          </a:p>
-          <a:p>
-            <a:pPr>
-              <a:spcAft>
-                <a:spcPts val="400"/>
-              </a:spcAft>
-              <a:defRPr sz="1400">
-                <a:solidFill>
-                  <a:srgbClr val="8B949E"/>
-                </a:solidFill>
-                <a:latin typeface="Consolas"/>
-              </a:defRPr>
-            </a:pPr>
-            <a:r>
-              <a:t>  └──────────────┬────────────────────────┬──────────────────┘</a:t>
-            </a:r>
-          </a:p>
-          <a:p>
-            <a:pPr>
-              <a:spcAft>
-                <a:spcPts val="400"/>
-              </a:spcAft>
-              <a:defRPr sz="1400">
-                <a:solidFill>
-                  <a:srgbClr val="8B949E"/>
-                </a:solidFill>
-                <a:latin typeface="Consolas"/>
-              </a:defRPr>
-            </a:pPr>
-            <a:r>
-              <a:t>                 │                        │</a:t>
-            </a:r>
-          </a:p>
-          <a:p>
-            <a:pPr>
-              <a:spcAft>
-                <a:spcPts val="400"/>
-              </a:spcAft>
-              <a:defRPr sz="1400">
-                <a:solidFill>
-                  <a:srgbClr val="8B949E"/>
-                </a:solidFill>
-                <a:latin typeface="Consolas"/>
-              </a:defRPr>
-            </a:pPr>
-            <a:r>
-              <a:t>                 ▼                        ▼</a:t>
-            </a:r>
-          </a:p>
-          <a:p>
-            <a:pPr>
-              <a:spcAft>
-                <a:spcPts val="400"/>
-              </a:spcAft>
-              <a:defRPr sz="1400">
-                <a:solidFill>
-                  <a:srgbClr val="8B949E"/>
-                </a:solidFill>
-                <a:latin typeface="Consolas"/>
-              </a:defRPr>
-            </a:pPr>
-            <a:r>
-              <a:t>  ┌──────────────────────┐  ┌────────────────────────────────┐</a:t>
+              <a:t>  │  GEOMETRY OPTIMIZER   • load_geometry()  • mace_omol.optimize()        │</a:t>
+            </a:r>
+          </a:p>
+          <a:p>
+            <a:pPr>
+              <a:spcAft>
+                <a:spcPts val="400"/>
+              </a:spcAft>
+              <a:defRPr sz="1400">
+                <a:solidFill>
+                  <a:srgbClr val="8B949E"/>
+                </a:solidFill>
+                <a:latin typeface="Consolas"/>
+              </a:defRPr>
+            </a:pPr>
+            <a:r>
+              <a:t>  └───────────────────────────────┬────────────────────────────────────────┘</a:t>
+            </a:r>
+          </a:p>
+          <a:p>
+            <a:pPr>
+              <a:spcAft>
+                <a:spcPts val="400"/>
+              </a:spcAft>
+              <a:defRPr sz="1400">
+                <a:solidFill>
+                  <a:srgbClr val="8B949E"/>
+                </a:solidFill>
+                <a:latin typeface="Consolas"/>
+              </a:defRPr>
+            </a:pPr>
+            <a:r>
+              <a:t>                 ┌────────────────┴─────────────────┐</a:t>
+            </a:r>
+          </a:p>
+          <a:p>
+            <a:pPr>
+              <a:spcAft>
+                <a:spcPts val="400"/>
+              </a:spcAft>
+              <a:defRPr sz="1400">
+                <a:solidFill>
+                  <a:srgbClr val="8B949E"/>
+                </a:solidFill>
+                <a:latin typeface="Consolas"/>
+              </a:defRPr>
+            </a:pPr>
+            <a:r>
+              <a:t>                 ▼                                  ▼</a:t>
+            </a:r>
+          </a:p>
+          <a:p>
+            <a:pPr>
+              <a:spcAft>
+                <a:spcPts val="400"/>
+              </a:spcAft>
+              <a:defRPr sz="1400">
+                <a:solidFill>
+                  <a:srgbClr val="8B949E"/>
+                </a:solidFill>
+                <a:latin typeface="Consolas"/>
+              </a:defRPr>
+            </a:pPr>
+            <a:r>
+              <a:t>  ┌────────────────────────────────┐  ┌────────────────────────────────────┐</a:t>
             </a:r>
           </a:p>
           <a:p>
@@ -6662,215 +6630,183 @@
               </a:defRPr>
             </a:pPr>
             <a:r>
-              <a:t>  │  DFT BASELINE        │  │  ML FREQ CALC                  │</a:t>
-            </a:r>
-          </a:p>
-          <a:p>
-            <a:pPr>
-              <a:spcAft>
-                <a:spcPts val="400"/>
-              </a:spcAft>
-              <a:defRPr sz="1400">
-                <a:solidFill>
-                  <a:srgbClr val="8B949E"/>
-                </a:solidFill>
-                <a:latin typeface="Consolas"/>
-              </a:defRPr>
-            </a:pPr>
-            <a:r>
-              <a:t>  │                      │  │                                │</a:t>
-            </a:r>
-          </a:p>
-          <a:p>
-            <a:pPr>
-              <a:spcAft>
-                <a:spcPts val="400"/>
-              </a:spcAft>
-              <a:defRPr sz="1400">
-                <a:solidFill>
-                  <a:srgbClr val="8B949E"/>
-                </a:solidFill>
-                <a:latin typeface="Consolas"/>
-              </a:defRPr>
-            </a:pPr>
-            <a:r>
-              <a:t>  │  ┌────────────────┐  │  │  • load_mace_calculator()      │</a:t>
-            </a:r>
-          </a:p>
-          <a:p>
-            <a:pPr>
-              <a:spcAft>
-                <a:spcPts val="400"/>
-              </a:spcAft>
-              <a:defRPr sz="1400">
-                <a:solidFill>
-                  <a:srgbClr val="8B949E"/>
-                </a:solidFill>
-                <a:latin typeface="Consolas"/>
-              </a:defRPr>
-            </a:pPr>
-            <a:r>
-              <a:t>  │  │ Built-in opt   │  │  │    (MACE-MP / MACE-OMOL)       │</a:t>
-            </a:r>
-          </a:p>
-          <a:p>
-            <a:pPr>
-              <a:spcAft>
-                <a:spcPts val="400"/>
-              </a:spcAft>
-              <a:defRPr sz="1400">
-                <a:solidFill>
-                  <a:srgbClr val="8B949E"/>
-                </a:solidFill>
-                <a:latin typeface="Consolas"/>
-              </a:defRPr>
-            </a:pPr>
-            <a:r>
-              <a:t>  │  │ B3LYP/6-31G(d,p) │  │  • get_dipole_calculator()     │</a:t>
-            </a:r>
-          </a:p>
-          <a:p>
-            <a:pPr>
-              <a:spcAft>
-                <a:spcPts val="400"/>
-              </a:spcAft>
-              <a:defRPr sz="1400">
-                <a:solidFill>
-                  <a:srgbClr val="8B949E"/>
-                </a:solidFill>
-                <a:latin typeface="Consolas"/>
-              </a:defRPr>
-            </a:pPr>
-            <a:r>
-              <a:t>  │  └────────────────┘  │  │    (Espaloma / MACE_DIPOLE)    │</a:t>
-            </a:r>
-          </a:p>
-          <a:p>
-            <a:pPr>
-              <a:spcAft>
-                <a:spcPts val="400"/>
-              </a:spcAft>
-              <a:defRPr sz="1400">
-                <a:solidFill>
-                  <a:srgbClr val="8B949E"/>
-                </a:solidFill>
-                <a:latin typeface="Consolas"/>
-              </a:defRPr>
-            </a:pPr>
-            <a:r>
-              <a:t>  │                      │  │  • setup_zmq_server()          │</a:t>
-            </a:r>
-          </a:p>
-          <a:p>
-            <a:pPr>
-              <a:spcAft>
-                <a:spcPts val="400"/>
-              </a:spcAft>
-              <a:defRPr sz="1400">
-                <a:solidFill>
-                  <a:srgbClr val="8B949E"/>
-                </a:solidFill>
-                <a:latin typeface="Consolas"/>
-              </a:defRPr>
-            </a:pPr>
-            <a:r>
-              <a:t>  │  • gaussian_freq()   │  │  • launch_gaussian()           │</a:t>
-            </a:r>
-          </a:p>
-          <a:p>
-            <a:pPr>
-              <a:spcAft>
-                <a:spcPts val="400"/>
-              </a:spcAft>
-              <a:defRPr sz="1400">
-                <a:solidFill>
-                  <a:srgbClr val="8B949E"/>
-                </a:solidFill>
-                <a:latin typeface="Consolas"/>
-              </a:defRPr>
-            </a:pPr>
-            <a:r>
-              <a:t>  │  • gaussian_dipoles()│  │  • zmq_dipole_loop()           │</a:t>
-            </a:r>
-          </a:p>
-          <a:p>
-            <a:pPr>
-              <a:spcAft>
-                <a:spcPts val="400"/>
-              </a:spcAft>
-              <a:defRPr sz="1400">
-                <a:solidFill>
-                  <a:srgbClr val="8B949E"/>
-                </a:solidFill>
-                <a:latin typeface="Consolas"/>
-              </a:defRPr>
-            </a:pPr>
-            <a:r>
-              <a:t>  │  • parse_gaussian()  │  │                                │</a:t>
-            </a:r>
-          </a:p>
-          <a:p>
-            <a:pPr>
-              <a:spcAft>
-                <a:spcPts val="400"/>
-              </a:spcAft>
-              <a:defRPr sz="1400">
-                <a:solidFill>
-                  <a:srgbClr val="8B949E"/>
-                </a:solidFill>
-                <a:latin typeface="Consolas"/>
-              </a:defRPr>
-            </a:pPr>
-            <a:r>
-              <a:t>  └──────────┬───────────┘  └───────────────┬────────────────┘</a:t>
-            </a:r>
-          </a:p>
-          <a:p>
-            <a:pPr>
-              <a:spcAft>
-                <a:spcPts val="400"/>
-              </a:spcAft>
-              <a:defRPr sz="1400">
-                <a:solidFill>
-                  <a:srgbClr val="8B949E"/>
-                </a:solidFill>
-                <a:latin typeface="Consolas"/>
-              </a:defRPr>
-            </a:pPr>
-            <a:r>
-              <a:t>             │                              │</a:t>
-            </a:r>
-          </a:p>
-          <a:p>
-            <a:pPr>
-              <a:spcAft>
-                <a:spcPts val="400"/>
-              </a:spcAft>
-              <a:defRPr sz="1400">
-                <a:solidFill>
-                  <a:srgbClr val="8B949E"/>
-                </a:solidFill>
-                <a:latin typeface="Consolas"/>
-              </a:defRPr>
-            </a:pPr>
-            <a:r>
-              <a:t>             ▼                              ▼</a:t>
-            </a:r>
-          </a:p>
-          <a:p>
-            <a:pPr>
-              <a:spcAft>
-                <a:spcPts val="400"/>
-              </a:spcAft>
-              <a:defRPr sz="1400">
-                <a:solidFill>
-                  <a:srgbClr val="8B949E"/>
-                </a:solidFill>
-                <a:latin typeface="Consolas"/>
-              </a:defRPr>
-            </a:pPr>
-            <a:r>
-              <a:t>  ┌──────────────────────────────────────────────────────────┐</a:t>
+              <a:t>  │  DFT BASELINE                  │  │  ML FREQ CALC                      │</a:t>
+            </a:r>
+          </a:p>
+          <a:p>
+            <a:pPr>
+              <a:spcAft>
+                <a:spcPts val="400"/>
+              </a:spcAft>
+              <a:defRPr sz="1400">
+                <a:solidFill>
+                  <a:srgbClr val="8B949E"/>
+                </a:solidFill>
+                <a:latin typeface="Consolas"/>
+              </a:defRPr>
+            </a:pPr>
+            <a:r>
+              <a:t>  │  ┌──────────────────┐          │  │  • load_mace_calculator()           │</a:t>
+            </a:r>
+          </a:p>
+          <a:p>
+            <a:pPr>
+              <a:spcAft>
+                <a:spcPts val="400"/>
+              </a:spcAft>
+              <a:defRPr sz="1400">
+                <a:solidFill>
+                  <a:srgbClr val="8B949E"/>
+                </a:solidFill>
+                <a:latin typeface="Consolas"/>
+              </a:defRPr>
+            </a:pPr>
+            <a:r>
+              <a:t>  │  │ Built-in opt     │          │  │    (MACE-MP / MACE-OMOL)            │</a:t>
+            </a:r>
+          </a:p>
+          <a:p>
+            <a:pPr>
+              <a:spcAft>
+                <a:spcPts val="400"/>
+              </a:spcAft>
+              <a:defRPr sz="1400">
+                <a:solidFill>
+                  <a:srgbClr val="8B949E"/>
+                </a:solidFill>
+                <a:latin typeface="Consolas"/>
+              </a:defRPr>
+            </a:pPr>
+            <a:r>
+              <a:t>  │  │ B3LYP/6-31G(d,p)│          │  │  • get_dipole_calculator()           │</a:t>
+            </a:r>
+          </a:p>
+          <a:p>
+            <a:pPr>
+              <a:spcAft>
+                <a:spcPts val="400"/>
+              </a:spcAft>
+              <a:defRPr sz="1400">
+                <a:solidFill>
+                  <a:srgbClr val="8B949E"/>
+                </a:solidFill>
+                <a:latin typeface="Consolas"/>
+              </a:defRPr>
+            </a:pPr>
+            <a:r>
+              <a:t>  │  └──────────────────┘          │  │    (Espaloma / MACE_DIPOLE)          │</a:t>
+            </a:r>
+          </a:p>
+          <a:p>
+            <a:pPr>
+              <a:spcAft>
+                <a:spcPts val="400"/>
+              </a:spcAft>
+              <a:defRPr sz="1400">
+                <a:solidFill>
+                  <a:srgbClr val="8B949E"/>
+                </a:solidFill>
+                <a:latin typeface="Consolas"/>
+              </a:defRPr>
+            </a:pPr>
+            <a:r>
+              <a:t>  │  • gaussian_freq()             │  │  • setup_zmq_server()               │</a:t>
+            </a:r>
+          </a:p>
+          <a:p>
+            <a:pPr>
+              <a:spcAft>
+                <a:spcPts val="400"/>
+              </a:spcAft>
+              <a:defRPr sz="1400">
+                <a:solidFill>
+                  <a:srgbClr val="8B949E"/>
+                </a:solidFill>
+                <a:latin typeface="Consolas"/>
+              </a:defRPr>
+            </a:pPr>
+            <a:r>
+              <a:t>  │  • gaussian_dipoles()          │  │  • launch_gaussian()                │</a:t>
+            </a:r>
+          </a:p>
+          <a:p>
+            <a:pPr>
+              <a:spcAft>
+                <a:spcPts val="400"/>
+              </a:spcAft>
+              <a:defRPr sz="1400">
+                <a:solidFill>
+                  <a:srgbClr val="8B949E"/>
+                </a:solidFill>
+                <a:latin typeface="Consolas"/>
+              </a:defRPr>
+            </a:pPr>
+            <a:r>
+              <a:t>  │  • parse_gaussian()            │  │  • zmq_dipole_loop()                │</a:t>
+            </a:r>
+          </a:p>
+          <a:p>
+            <a:pPr>
+              <a:spcAft>
+                <a:spcPts val="400"/>
+              </a:spcAft>
+              <a:defRPr sz="1400">
+                <a:solidFill>
+                  <a:srgbClr val="8B949E"/>
+                </a:solidFill>
+                <a:latin typeface="Consolas"/>
+              </a:defRPr>
+            </a:pPr>
+            <a:r>
+              <a:t>  └──────────────┬─────────────────┘  └──────────────────┬─────────────────┘</a:t>
+            </a:r>
+          </a:p>
+          <a:p>
+            <a:pPr>
+              <a:spcAft>
+                <a:spcPts val="400"/>
+              </a:spcAft>
+              <a:defRPr sz="1400">
+                <a:solidFill>
+                  <a:srgbClr val="8B949E"/>
+                </a:solidFill>
+                <a:latin typeface="Consolas"/>
+              </a:defRPr>
+            </a:pPr>
+            <a:r>
+              <a:t>                 └────────────────┬─────────────────────┘</a:t>
+            </a:r>
+          </a:p>
+          <a:p>
+            <a:pPr>
+              <a:spcAft>
+                <a:spcPts val="400"/>
+              </a:spcAft>
+              <a:defRPr sz="1400">
+                <a:solidFill>
+                  <a:srgbClr val="8B949E"/>
+                </a:solidFill>
+                <a:latin typeface="Consolas"/>
+              </a:defRPr>
+            </a:pPr>
+            <a:r>
+              <a:t>                                  ▼</a:t>
+            </a:r>
+          </a:p>
+          <a:p>
+            <a:pPr>
+              <a:spcAft>
+                <a:spcPts val="400"/>
+              </a:spcAft>
+              <a:defRPr sz="1400">
+                <a:solidFill>
+                  <a:srgbClr val="8B949E"/>
+                </a:solidFill>
+                <a:latin typeface="Consolas"/>
+              </a:defRPr>
+            </a:pPr>
+            <a:r>
+              <a:t>  ┌────────────────────────────────────────────────────────────────────────┐</a:t>
             </a:r>
           </a:p>
           <a:p>
@@ -6886,71 +6822,39 @@
               </a:defRPr>
             </a:pPr>
             <a:r>
-              <a:t>  │  ANALYSIS &amp; COMPARISON                                   │</a:t>
-            </a:r>
-          </a:p>
-          <a:p>
-            <a:pPr>
-              <a:spcAft>
-                <a:spcPts val="400"/>
-              </a:spcAft>
-              <a:defRPr sz="1400">
-                <a:solidFill>
-                  <a:srgbClr val="8B949E"/>
-                </a:solidFill>
-                <a:latin typeface="Consolas"/>
-              </a:defRPr>
-            </a:pPr>
-            <a:r>
-              <a:t>  │  load_results → find_dft_baseline → eigenvector_matching │</a:t>
-            </a:r>
-          </a:p>
-          <a:p>
-            <a:pPr>
-              <a:spcAft>
-                <a:spcPts val="400"/>
-              </a:spcAft>
-              <a:defRPr sz="1400">
-                <a:solidFill>
-                  <a:srgbClr val="8B949E"/>
-                </a:solidFill>
-                <a:latin typeface="Consolas"/>
-              </a:defRPr>
-            </a:pPr>
-            <a:r>
-              <a:t>  │  → kde_broaden → calculate_metrics → plot_regression     │</a:t>
-            </a:r>
-          </a:p>
-          <a:p>
-            <a:pPr>
-              <a:spcAft>
-                <a:spcPts val="400"/>
-              </a:spcAft>
-              <a:defRPr sz="1400">
-                <a:solidFill>
-                  <a:srgbClr val="8B949E"/>
-                </a:solidFill>
-                <a:latin typeface="Consolas"/>
-              </a:defRPr>
-            </a:pPr>
-            <a:r>
-              <a:t>  └─────────────────────────┬────────────────────────────────┘</a:t>
-            </a:r>
-          </a:p>
-          <a:p>
-            <a:pPr>
-              <a:spcAft>
-                <a:spcPts val="400"/>
-              </a:spcAft>
-              <a:defRPr sz="1400">
-                <a:solidFill>
-                  <a:srgbClr val="8B949E"/>
-                </a:solidFill>
-                <a:latin typeface="Consolas"/>
-              </a:defRPr>
-            </a:pPr>
-            <a:r>
-              <a:t>                            ▼</a:t>
+              <a:t>  │  ANALYSIS   load_results → eigenvector_matching → kde → metrics → plot │</a:t>
+            </a:r>
+          </a:p>
+          <a:p>
+            <a:pPr>
+              <a:spcAft>
+                <a:spcPts val="400"/>
+              </a:spcAft>
+              <a:defRPr sz="1400">
+                <a:solidFill>
+                  <a:srgbClr val="8B949E"/>
+                </a:solidFill>
+                <a:latin typeface="Consolas"/>
+              </a:defRPr>
+            </a:pPr>
+            <a:r>
+              <a:t>  └───────────────────────────────┬────────────────────────────────────────┘</a:t>
+            </a:r>
+          </a:p>
+          <a:p>
+            <a:pPr>
+              <a:spcAft>
+                <a:spcPts val="400"/>
+              </a:spcAft>
+              <a:defRPr sz="1400">
+                <a:solidFill>
+                  <a:srgbClr val="8B949E"/>
+                </a:solidFill>
+                <a:latin typeface="Consolas"/>
+              </a:defRPr>
+            </a:pPr>
+            <a:r>
+              <a:t>                                  ▼</a:t>
             </a:r>
           </a:p>
           <a:p>
@@ -6966,7 +6870,7 @@
               </a:defRPr>
             </a:pPr>
             <a:r>
-              <a:t>                  generate_html_report()</a:t>
+              <a:t>                        generate_html_report()</a:t>
             </a:r>
           </a:p>
         </p:txBody>

</xml_diff>

<commit_message>
feat(slides): replace neofetch title with style 9 block font banner
Co-Authored-By: Claude Opus 4.6 <noreply@anthropic.com>
</commit_message>
<xml_diff>
--- a/presentation/presentation_v2.pptx
+++ b/presentation/presentation_v2.pptx
@@ -3116,8 +3116,8 @@
         </p:nvSpPr>
         <p:spPr>
           <a:xfrm>
-            <a:off x="365760" y="914400"/>
-            <a:ext cx="4023360" cy="5120640"/>
+            <a:off x="548640" y="1463040"/>
+            <a:ext cx="8412480" cy="2743200"/>
           </a:xfrm>
           <a:prstGeom prst="rect">
             <a:avLst/>
@@ -3130,11 +3130,91 @@
           </a:bodyPr>
           <a:lstStyle/>
           <a:p>
-            <a:pPr>
+            <a:pPr algn="ctr">
               <a:spcAft>
                 <a:spcPts val="0"/>
               </a:spcAft>
-              <a:defRPr sz="1500">
+              <a:defRPr sz="1600">
+                <a:solidFill>
+                  <a:srgbClr val="58A6FF"/>
+                </a:solidFill>
+                <a:latin typeface="Consolas"/>
+              </a:defRPr>
+            </a:pPr>
+            <a:r>
+              <a:t>_|      _|    _|_|      _|_|_|  _|_|_|_|  </a:t>
+            </a:r>
+          </a:p>
+          <a:p>
+            <a:pPr algn="ctr">
+              <a:spcAft>
+                <a:spcPts val="0"/>
+              </a:spcAft>
+              <a:defRPr sz="1600">
+                <a:solidFill>
+                  <a:srgbClr val="58A6FF"/>
+                </a:solidFill>
+                <a:latin typeface="Consolas"/>
+              </a:defRPr>
+            </a:pPr>
+            <a:r>
+              <a:t>_|_|  _|_|  _|    _|  _|        _|        </a:t>
+            </a:r>
+          </a:p>
+          <a:p>
+            <a:pPr algn="ctr">
+              <a:spcAft>
+                <a:spcPts val="0"/>
+              </a:spcAft>
+              <a:defRPr sz="1600">
+                <a:solidFill>
+                  <a:srgbClr val="58A6FF"/>
+                </a:solidFill>
+                <a:latin typeface="Consolas"/>
+              </a:defRPr>
+            </a:pPr>
+            <a:r>
+              <a:t>_|  _|  _|  _|_|_|_|  _|        _|_|_|    </a:t>
+            </a:r>
+          </a:p>
+          <a:p>
+            <a:pPr algn="ctr">
+              <a:spcAft>
+                <a:spcPts val="0"/>
+              </a:spcAft>
+              <a:defRPr sz="1600">
+                <a:solidFill>
+                  <a:srgbClr val="58A6FF"/>
+                </a:solidFill>
+                <a:latin typeface="Consolas"/>
+              </a:defRPr>
+            </a:pPr>
+            <a:r>
+              <a:t>_|      _|  _|    _|  _|        _|        </a:t>
+            </a:r>
+          </a:p>
+          <a:p>
+            <a:pPr algn="ctr">
+              <a:spcAft>
+                <a:spcPts val="0"/>
+              </a:spcAft>
+              <a:defRPr sz="1600">
+                <a:solidFill>
+                  <a:srgbClr val="58A6FF"/>
+                </a:solidFill>
+                <a:latin typeface="Consolas"/>
+              </a:defRPr>
+            </a:pPr>
+            <a:r>
+              <a:t>_|      _|  _|    _|    _|_|_|  _|_|_|_|  </a:t>
+            </a:r>
+          </a:p>
+          <a:p>
+            <a:pPr algn="ctr">
+              <a:spcAft>
+                <a:spcPts val="0"/>
+              </a:spcAft>
+              <a:defRPr sz="1600">
                 <a:solidFill>
                   <a:srgbClr val="3FB950"/>
                 </a:solidFill>
@@ -3142,263 +3222,7 @@
               </a:defRPr>
             </a:pPr>
             <a:r>
-              <a:t>  __  __   _   ___ ___    </a:t>
-            </a:r>
-          </a:p>
-          <a:p>
-            <a:pPr>
-              <a:spcAft>
-                <a:spcPts val="0"/>
-              </a:spcAft>
-              <a:defRPr sz="1500">
-                <a:solidFill>
-                  <a:srgbClr val="3FB950"/>
-                </a:solidFill>
-                <a:latin typeface="Consolas"/>
-              </a:defRPr>
-            </a:pPr>
-            <a:r>
-              <a:t> |  \/  | /_\ / __| __|   </a:t>
-            </a:r>
-          </a:p>
-          <a:p>
-            <a:pPr>
-              <a:spcAft>
-                <a:spcPts val="0"/>
-              </a:spcAft>
-              <a:defRPr sz="1500">
-                <a:solidFill>
-                  <a:srgbClr val="3FB950"/>
-                </a:solidFill>
-                <a:latin typeface="Consolas"/>
-              </a:defRPr>
-            </a:pPr>
-            <a:r>
-              <a:t> | |\/| |/ _ \ (__| _|    </a:t>
-            </a:r>
-          </a:p>
-          <a:p>
-            <a:pPr>
-              <a:spcAft>
-                <a:spcPts val="0"/>
-              </a:spcAft>
-              <a:defRPr sz="1500">
-                <a:solidFill>
-                  <a:srgbClr val="3FB950"/>
-                </a:solidFill>
-                <a:latin typeface="Consolas"/>
-              </a:defRPr>
-            </a:pPr>
-            <a:r>
-              <a:t> |_|  |_/_/ \_\___|___|   </a:t>
-            </a:r>
-          </a:p>
-          <a:p>
-            <a:pPr>
-              <a:spcAft>
-                <a:spcPts val="0"/>
-              </a:spcAft>
-              <a:defRPr sz="1500">
-                <a:solidFill>
-                  <a:srgbClr val="3FB950"/>
-                </a:solidFill>
-                <a:latin typeface="Consolas"/>
-              </a:defRPr>
-            </a:pPr>
-            <a:r>
-              <a:t>       GAUSSIAN            </a:t>
-            </a:r>
-          </a:p>
-          <a:p>
-            <a:pPr>
-              <a:spcAft>
-                <a:spcPts val="0"/>
-              </a:spcAft>
-              <a:defRPr sz="1500">
-                <a:solidFill>
-                  <a:srgbClr val="8B949E"/>
-                </a:solidFill>
-                <a:latin typeface="Consolas"/>
-              </a:defRPr>
-            </a:pPr>
-            <a:r>
-              <a:t>                           </a:t>
-            </a:r>
-          </a:p>
-          <a:p>
-            <a:pPr>
-              <a:spcAft>
-                <a:spcPts val="0"/>
-              </a:spcAft>
-              <a:defRPr sz="1500">
-                <a:solidFill>
-                  <a:srgbClr val="8B949E"/>
-                </a:solidFill>
-                <a:latin typeface="Consolas"/>
-              </a:defRPr>
-            </a:pPr>
-            <a:r>
-              <a:t>  // ML-accelerated        </a:t>
-            </a:r>
-          </a:p>
-          <a:p>
-            <a:pPr>
-              <a:spcAft>
-                <a:spcPts val="0"/>
-              </a:spcAft>
-              <a:defRPr sz="1500">
-                <a:solidFill>
-                  <a:srgbClr val="8B949E"/>
-                </a:solidFill>
-                <a:latin typeface="Consolas"/>
-              </a:defRPr>
-            </a:pPr>
-            <a:r>
-              <a:t>  // IR spectroscopy       </a:t>
-            </a:r>
-          </a:p>
-          <a:p>
-            <a:pPr>
-              <a:spcAft>
-                <a:spcPts val="0"/>
-              </a:spcAft>
-              <a:defRPr sz="1500">
-                <a:solidFill>
-                  <a:srgbClr val="8B949E"/>
-                </a:solidFill>
-                <a:latin typeface="Consolas"/>
-              </a:defRPr>
-            </a:pPr>
-            <a:r>
-              <a:t>                           </a:t>
-            </a:r>
-          </a:p>
-          <a:p>
-            <a:pPr>
-              <a:spcAft>
-                <a:spcPts val="0"/>
-              </a:spcAft>
-              <a:defRPr sz="1500">
-                <a:solidFill>
-                  <a:srgbClr val="58A6FF"/>
-                </a:solidFill>
-                <a:latin typeface="Consolas"/>
-              </a:defRPr>
-            </a:pPr>
-            <a:r>
-              <a:t>     O                     </a:t>
-            </a:r>
-          </a:p>
-          <a:p>
-            <a:pPr>
-              <a:spcAft>
-                <a:spcPts val="0"/>
-              </a:spcAft>
-              <a:defRPr sz="1500">
-                <a:solidFill>
-                  <a:srgbClr val="58A6FF"/>
-                </a:solidFill>
-                <a:latin typeface="Consolas"/>
-              </a:defRPr>
-            </a:pPr>
-            <a:r>
-              <a:t>    / \                    </a:t>
-            </a:r>
-          </a:p>
-          <a:p>
-            <a:pPr>
-              <a:spcAft>
-                <a:spcPts val="0"/>
-              </a:spcAft>
-              <a:defRPr sz="1500">
-                <a:solidFill>
-                  <a:srgbClr val="58A6FF"/>
-                </a:solidFill>
-                <a:latin typeface="Consolas"/>
-              </a:defRPr>
-            </a:pPr>
-            <a:r>
-              <a:t>   H   H   H₂O             </a:t>
-            </a:r>
-          </a:p>
-          <a:p>
-            <a:pPr>
-              <a:spcAft>
-                <a:spcPts val="0"/>
-              </a:spcAft>
-              <a:defRPr sz="1500">
-                <a:solidFill>
-                  <a:srgbClr val="58A6FF"/>
-                </a:solidFill>
-                <a:latin typeface="Consolas"/>
-              </a:defRPr>
-            </a:pPr>
-            <a:r>
-              <a:t>                           </a:t>
-            </a:r>
-          </a:p>
-          <a:p>
-            <a:pPr>
-              <a:spcAft>
-                <a:spcPts val="0"/>
-              </a:spcAft>
-              <a:defRPr sz="1500">
-                <a:solidFill>
-                  <a:srgbClr val="58A6FF"/>
-                </a:solidFill>
-                <a:latin typeface="Consolas"/>
-              </a:defRPr>
-            </a:pPr>
-            <a:r>
-              <a:t>     O   OH                </a:t>
-            </a:r>
-          </a:p>
-          <a:p>
-            <a:pPr>
-              <a:spcAft>
-                <a:spcPts val="0"/>
-              </a:spcAft>
-              <a:defRPr sz="1500">
-                <a:solidFill>
-                  <a:srgbClr val="58A6FF"/>
-                </a:solidFill>
-                <a:latin typeface="Consolas"/>
-              </a:defRPr>
-            </a:pPr>
-            <a:r>
-              <a:t>     ‖   |                 </a:t>
-            </a:r>
-          </a:p>
-          <a:p>
-            <a:pPr>
-              <a:spcAft>
-                <a:spcPts val="0"/>
-              </a:spcAft>
-              <a:defRPr sz="1500">
-                <a:solidFill>
-                  <a:srgbClr val="58A6FF"/>
-                </a:solidFill>
-                <a:latin typeface="Consolas"/>
-              </a:defRPr>
-            </a:pPr>
-            <a:r>
-              <a:t> CH₃-C-O-C₆H₄-COOH        </a:t>
-            </a:r>
-          </a:p>
-          <a:p>
-            <a:pPr>
-              <a:spcAft>
-                <a:spcPts val="0"/>
-              </a:spcAft>
-              <a:defRPr sz="1500">
-                <a:solidFill>
-                  <a:srgbClr val="58A6FF"/>
-                </a:solidFill>
-                <a:latin typeface="Consolas"/>
-              </a:defRPr>
-            </a:pPr>
-            <a:r>
-              <a:t>   aspirin C₉H₈O₄          </a:t>
+              <a:t>              GAUSSIAN</a:t>
             </a:r>
           </a:p>
         </p:txBody>
@@ -3411,8 +3235,8 @@
         </p:nvSpPr>
         <p:spPr>
           <a:xfrm>
-            <a:off x="4480560" y="914400"/>
-            <a:ext cx="91440" cy="5120640"/>
+            <a:off x="731520" y="4572000"/>
+            <a:ext cx="7680960" cy="548640"/>
           </a:xfrm>
           <a:prstGeom prst="rect">
             <a:avLst/>
@@ -3425,275 +3249,16 @@
           </a:bodyPr>
           <a:lstStyle/>
           <a:p>
-            <a:pPr>
-              <a:spcAft>
-                <a:spcPts val="0"/>
-              </a:spcAft>
-              <a:defRPr sz="1500">
-                <a:solidFill>
-                  <a:srgbClr val="8B949E"/>
-                </a:solidFill>
-                <a:latin typeface="Consolas"/>
-              </a:defRPr>
-            </a:pPr>
-            <a:r>
-              <a:t>│</a:t>
-            </a:r>
-          </a:p>
-          <a:p>
-            <a:pPr>
-              <a:spcAft>
-                <a:spcPts val="0"/>
-              </a:spcAft>
-              <a:defRPr sz="1500">
-                <a:solidFill>
-                  <a:srgbClr val="8B949E"/>
-                </a:solidFill>
-                <a:latin typeface="Consolas"/>
-              </a:defRPr>
-            </a:pPr>
-            <a:r>
-              <a:t>│</a:t>
-            </a:r>
-          </a:p>
-          <a:p>
-            <a:pPr>
-              <a:spcAft>
-                <a:spcPts val="0"/>
-              </a:spcAft>
-              <a:defRPr sz="1500">
-                <a:solidFill>
-                  <a:srgbClr val="8B949E"/>
-                </a:solidFill>
-                <a:latin typeface="Consolas"/>
-              </a:defRPr>
-            </a:pPr>
-            <a:r>
-              <a:t>│</a:t>
-            </a:r>
-          </a:p>
-          <a:p>
-            <a:pPr>
-              <a:spcAft>
-                <a:spcPts val="0"/>
-              </a:spcAft>
-              <a:defRPr sz="1500">
-                <a:solidFill>
-                  <a:srgbClr val="8B949E"/>
-                </a:solidFill>
-                <a:latin typeface="Consolas"/>
-              </a:defRPr>
-            </a:pPr>
-            <a:r>
-              <a:t>│</a:t>
-            </a:r>
-          </a:p>
-          <a:p>
-            <a:pPr>
-              <a:spcAft>
-                <a:spcPts val="0"/>
-              </a:spcAft>
-              <a:defRPr sz="1500">
-                <a:solidFill>
-                  <a:srgbClr val="8B949E"/>
-                </a:solidFill>
-                <a:latin typeface="Consolas"/>
-              </a:defRPr>
-            </a:pPr>
-            <a:r>
-              <a:t>│</a:t>
-            </a:r>
-          </a:p>
-          <a:p>
-            <a:pPr>
-              <a:spcAft>
-                <a:spcPts val="0"/>
-              </a:spcAft>
-              <a:defRPr sz="1500">
-                <a:solidFill>
-                  <a:srgbClr val="8B949E"/>
-                </a:solidFill>
-                <a:latin typeface="Consolas"/>
-              </a:defRPr>
-            </a:pPr>
-            <a:r>
-              <a:t>│</a:t>
-            </a:r>
-          </a:p>
-          <a:p>
-            <a:pPr>
-              <a:spcAft>
-                <a:spcPts val="0"/>
-              </a:spcAft>
-              <a:defRPr sz="1500">
-                <a:solidFill>
-                  <a:srgbClr val="8B949E"/>
-                </a:solidFill>
-                <a:latin typeface="Consolas"/>
-              </a:defRPr>
-            </a:pPr>
-            <a:r>
-              <a:t>│</a:t>
-            </a:r>
-          </a:p>
-          <a:p>
-            <a:pPr>
-              <a:spcAft>
-                <a:spcPts val="0"/>
-              </a:spcAft>
-              <a:defRPr sz="1500">
-                <a:solidFill>
-                  <a:srgbClr val="8B949E"/>
-                </a:solidFill>
-                <a:latin typeface="Consolas"/>
-              </a:defRPr>
-            </a:pPr>
-            <a:r>
-              <a:t>│</a:t>
-            </a:r>
-          </a:p>
-          <a:p>
-            <a:pPr>
-              <a:spcAft>
-                <a:spcPts val="0"/>
-              </a:spcAft>
-              <a:defRPr sz="1500">
-                <a:solidFill>
-                  <a:srgbClr val="8B949E"/>
-                </a:solidFill>
-                <a:latin typeface="Consolas"/>
-              </a:defRPr>
-            </a:pPr>
-            <a:r>
-              <a:t>│</a:t>
-            </a:r>
-          </a:p>
-          <a:p>
-            <a:pPr>
-              <a:spcAft>
-                <a:spcPts val="0"/>
-              </a:spcAft>
-              <a:defRPr sz="1500">
-                <a:solidFill>
-                  <a:srgbClr val="8B949E"/>
-                </a:solidFill>
-                <a:latin typeface="Consolas"/>
-              </a:defRPr>
-            </a:pPr>
-            <a:r>
-              <a:t>│</a:t>
-            </a:r>
-          </a:p>
-          <a:p>
-            <a:pPr>
-              <a:spcAft>
-                <a:spcPts val="0"/>
-              </a:spcAft>
-              <a:defRPr sz="1500">
-                <a:solidFill>
-                  <a:srgbClr val="8B949E"/>
-                </a:solidFill>
-                <a:latin typeface="Consolas"/>
-              </a:defRPr>
-            </a:pPr>
-            <a:r>
-              <a:t>│</a:t>
-            </a:r>
-          </a:p>
-          <a:p>
-            <a:pPr>
-              <a:spcAft>
-                <a:spcPts val="0"/>
-              </a:spcAft>
-              <a:defRPr sz="1500">
-                <a:solidFill>
-                  <a:srgbClr val="8B949E"/>
-                </a:solidFill>
-                <a:latin typeface="Consolas"/>
-              </a:defRPr>
-            </a:pPr>
-            <a:r>
-              <a:t>│</a:t>
-            </a:r>
-          </a:p>
-          <a:p>
-            <a:pPr>
-              <a:spcAft>
-                <a:spcPts val="0"/>
-              </a:spcAft>
-              <a:defRPr sz="1500">
-                <a:solidFill>
-                  <a:srgbClr val="8B949E"/>
-                </a:solidFill>
-                <a:latin typeface="Consolas"/>
-              </a:defRPr>
-            </a:pPr>
-            <a:r>
-              <a:t>│</a:t>
-            </a:r>
-          </a:p>
-          <a:p>
-            <a:pPr>
-              <a:spcAft>
-                <a:spcPts val="0"/>
-              </a:spcAft>
-              <a:defRPr sz="1500">
-                <a:solidFill>
-                  <a:srgbClr val="8B949E"/>
-                </a:solidFill>
-                <a:latin typeface="Consolas"/>
-              </a:defRPr>
-            </a:pPr>
-            <a:r>
-              <a:t>│</a:t>
-            </a:r>
-          </a:p>
-          <a:p>
-            <a:pPr>
-              <a:spcAft>
-                <a:spcPts val="0"/>
-              </a:spcAft>
-              <a:defRPr sz="1500">
-                <a:solidFill>
-                  <a:srgbClr val="8B949E"/>
-                </a:solidFill>
-                <a:latin typeface="Consolas"/>
-              </a:defRPr>
-            </a:pPr>
-            <a:r>
-              <a:t>│</a:t>
-            </a:r>
-          </a:p>
-          <a:p>
-            <a:pPr>
-              <a:spcAft>
-                <a:spcPts val="0"/>
-              </a:spcAft>
-              <a:defRPr sz="1500">
-                <a:solidFill>
-                  <a:srgbClr val="8B949E"/>
-                </a:solidFill>
-                <a:latin typeface="Consolas"/>
-              </a:defRPr>
-            </a:pPr>
-            <a:r>
-              <a:t>│</a:t>
-            </a:r>
-          </a:p>
-          <a:p>
-            <a:pPr>
-              <a:spcAft>
-                <a:spcPts val="0"/>
-              </a:spcAft>
-              <a:defRPr sz="1500">
-                <a:solidFill>
-                  <a:srgbClr val="8B949E"/>
-                </a:solidFill>
-                <a:latin typeface="Consolas"/>
-              </a:defRPr>
-            </a:pPr>
-            <a:r>
-              <a:t>│</a:t>
+            <a:pPr algn="ctr">
+              <a:defRPr sz="1600">
+                <a:solidFill>
+                  <a:srgbClr val="8B949E"/>
+                </a:solidFill>
+                <a:latin typeface="Consolas"/>
+              </a:defRPr>
+            </a:pPr>
+            <a:r>
+              <a:t>// ML-accelerated IR spectrum calculations</a:t>
             </a:r>
           </a:p>
         </p:txBody>
@@ -3701,317 +3266,6 @@
       <p:sp>
         <p:nvSpPr>
           <p:cNvPr id="4" name="TextBox 3"/>
-          <p:cNvSpPr txBox="1"/>
-          <p:nvPr/>
-        </p:nvSpPr>
-        <p:spPr>
-          <a:xfrm>
-            <a:off x="4663440" y="914400"/>
-            <a:ext cx="4206240" cy="5120640"/>
-          </a:xfrm>
-          <a:prstGeom prst="rect">
-            <a:avLst/>
-          </a:prstGeom>
-          <a:noFill/>
-        </p:spPr>
-        <p:txBody>
-          <a:bodyPr wrap="none">
-            <a:spAutoFit/>
-          </a:bodyPr>
-          <a:lstStyle/>
-          <a:p>
-            <a:pPr>
-              <a:spcAft>
-                <a:spcPts val="100"/>
-              </a:spcAft>
-              <a:defRPr sz="1400">
-                <a:solidFill>
-                  <a:srgbClr val="58A6FF"/>
-                </a:solidFill>
-                <a:latin typeface="Consolas"/>
-              </a:defRPr>
-            </a:pPr>
-            <a:r>
-              <a:t>mot@hofer-hpc</a:t>
-            </a:r>
-          </a:p>
-          <a:p>
-            <a:pPr>
-              <a:spcAft>
-                <a:spcPts val="100"/>
-              </a:spcAft>
-              <a:defRPr sz="1400">
-                <a:solidFill>
-                  <a:srgbClr val="8B949E"/>
-                </a:solidFill>
-                <a:latin typeface="Consolas"/>
-              </a:defRPr>
-            </a:pPr>
-            <a:r>
-              <a:t>────────────────────────────</a:t>
-            </a:r>
-          </a:p>
-          <a:p>
-            <a:pPr>
-              <a:spcAft>
-                <a:spcPts val="100"/>
-              </a:spcAft>
-              <a:defRPr sz="1400">
-                <a:solidFill>
-                  <a:srgbClr val="C9D1D9"/>
-                </a:solidFill>
-                <a:latin typeface="Consolas"/>
-              </a:defRPr>
-            </a:pPr>
-            <a:r>
-              <a:t>OS       Hofer Lab · TU München</a:t>
-            </a:r>
-          </a:p>
-          <a:p>
-            <a:pPr>
-              <a:spcAft>
-                <a:spcPts val="100"/>
-              </a:spcAft>
-              <a:defRPr sz="1400">
-                <a:solidFill>
-                  <a:srgbClr val="C9D1D9"/>
-                </a:solidFill>
-                <a:latin typeface="Consolas"/>
-              </a:defRPr>
-            </a:pPr>
-            <a:r>
-              <a:t>Shell    zsh + oh-my-zsh</a:t>
-            </a:r>
-          </a:p>
-          <a:p>
-            <a:pPr>
-              <a:spcAft>
-                <a:spcPts val="100"/>
-              </a:spcAft>
-              <a:defRPr sz="1400">
-                <a:solidFill>
-                  <a:srgbClr val="8B949E"/>
-                </a:solidFill>
-                <a:latin typeface="Consolas"/>
-              </a:defRPr>
-            </a:pPr>
-            <a:r>
-              <a:t>────────────────────────────</a:t>
-            </a:r>
-          </a:p>
-          <a:p>
-            <a:pPr>
-              <a:spcAft>
-                <a:spcPts val="100"/>
-              </a:spcAft>
-              <a:defRPr sz="1400">
-                <a:solidFill>
-                  <a:srgbClr val="3FB950"/>
-                </a:solidFill>
-                <a:latin typeface="Consolas"/>
-              </a:defRPr>
-            </a:pPr>
-            <a:r>
-              <a:t>Project  mace-gaussian v1.1</a:t>
-            </a:r>
-          </a:p>
-          <a:p>
-            <a:pPr>
-              <a:spcAft>
-                <a:spcPts val="100"/>
-              </a:spcAft>
-              <a:defRPr sz="1400">
-                <a:solidFill>
-                  <a:srgbClr val="C9D1D9"/>
-                </a:solidFill>
-                <a:latin typeface="Consolas"/>
-              </a:defRPr>
-            </a:pPr>
-            <a:r>
-              <a:t>Method   VPT2 + ML Dipoles</a:t>
-            </a:r>
-          </a:p>
-          <a:p>
-            <a:pPr>
-              <a:spcAft>
-                <a:spcPts val="100"/>
-              </a:spcAft>
-              <a:defRPr sz="1400">
-                <a:solidFill>
-                  <a:srgbClr val="C9D1D9"/>
-                </a:solidFill>
-                <a:latin typeface="Consolas"/>
-              </a:defRPr>
-            </a:pPr>
-            <a:r>
-              <a:t>Engine   Gaussian 16</a:t>
-            </a:r>
-          </a:p>
-          <a:p>
-            <a:pPr>
-              <a:spcAft>
-                <a:spcPts val="100"/>
-              </a:spcAft>
-              <a:defRPr sz="1400">
-                <a:solidFill>
-                  <a:srgbClr val="C9D1D9"/>
-                </a:solidFill>
-                <a:latin typeface="Consolas"/>
-              </a:defRPr>
-            </a:pPr>
-            <a:r>
-              <a:t>Bridge   ZMQ (IPC socket)</a:t>
-            </a:r>
-          </a:p>
-          <a:p>
-            <a:pPr>
-              <a:spcAft>
-                <a:spcPts val="100"/>
-              </a:spcAft>
-              <a:defRPr sz="1400">
-                <a:solidFill>
-                  <a:srgbClr val="8B949E"/>
-                </a:solidFill>
-                <a:latin typeface="Consolas"/>
-              </a:defRPr>
-            </a:pPr>
-            <a:r>
-              <a:t>────────────────────────────</a:t>
-            </a:r>
-          </a:p>
-          <a:p>
-            <a:pPr>
-              <a:spcAft>
-                <a:spcPts val="100"/>
-              </a:spcAft>
-              <a:defRPr sz="1400">
-                <a:solidFill>
-                  <a:srgbClr val="C9D1D9"/>
-                </a:solidFill>
-                <a:latin typeface="Consolas"/>
-              </a:defRPr>
-            </a:pPr>
-            <a:r>
-              <a:t>ML       MACE-OMOL-0, MACE-MP</a:t>
-            </a:r>
-          </a:p>
-          <a:p>
-            <a:pPr>
-              <a:spcAft>
-                <a:spcPts val="100"/>
-              </a:spcAft>
-              <a:defRPr sz="1400">
-                <a:solidFill>
-                  <a:srgbClr val="C9D1D9"/>
-                </a:solidFill>
-                <a:latin typeface="Consolas"/>
-              </a:defRPr>
-            </a:pPr>
-            <a:r>
-              <a:t>Dipoles  MACE4IR / Espaloma</a:t>
-            </a:r>
-          </a:p>
-          <a:p>
-            <a:pPr>
-              <a:spcAft>
-                <a:spcPts val="100"/>
-              </a:spcAft>
-              <a:defRPr sz="1400">
-                <a:solidFill>
-                  <a:srgbClr val="C9D1D9"/>
-                </a:solidFill>
-                <a:latin typeface="Consolas"/>
-              </a:defRPr>
-            </a:pPr>
-            <a:r>
-              <a:t>Combos   4 energy × 2 dipole</a:t>
-            </a:r>
-          </a:p>
-          <a:p>
-            <a:pPr>
-              <a:spcAft>
-                <a:spcPts val="100"/>
-              </a:spcAft>
-              <a:defRPr sz="1400">
-                <a:solidFill>
-                  <a:srgbClr val="8B949E"/>
-                </a:solidFill>
-                <a:latin typeface="Consolas"/>
-              </a:defRPr>
-            </a:pPr>
-            <a:r>
-              <a:t>────────────────────────────</a:t>
-            </a:r>
-          </a:p>
-          <a:p>
-            <a:pPr>
-              <a:spcAft>
-                <a:spcPts val="100"/>
-              </a:spcAft>
-              <a:defRPr sz="1400">
-                <a:solidFill>
-                  <a:srgbClr val="3FB950"/>
-                </a:solidFill>
-                <a:latin typeface="Consolas"/>
-              </a:defRPr>
-            </a:pPr>
-            <a:r>
-              <a:t>Tests    131 passing ✓</a:t>
-            </a:r>
-          </a:p>
-          <a:p>
-            <a:pPr>
-              <a:spcAft>
-                <a:spcPts val="100"/>
-              </a:spcAft>
-              <a:defRPr sz="1400">
-                <a:solidFill>
-                  <a:srgbClr val="3FB950"/>
-                </a:solidFill>
-                <a:latin typeface="Consolas"/>
-              </a:defRPr>
-            </a:pPr>
-            <a:r>
-              <a:t>CI       GitHub Actions ✓</a:t>
-            </a:r>
-          </a:p>
-          <a:p>
-            <a:pPr>
-              <a:spcAft>
-                <a:spcPts val="100"/>
-              </a:spcAft>
-              <a:defRPr sz="1400">
-                <a:solidFill>
-                  <a:srgbClr val="8B949E"/>
-                </a:solidFill>
-                <a:latin typeface="Consolas"/>
-              </a:defRPr>
-            </a:pPr>
-            <a:r>
-              <a:t>────────────────────────────</a:t>
-            </a:r>
-          </a:p>
-          <a:p>
-            <a:pPr>
-              <a:spcAft>
-                <a:spcPts val="100"/>
-              </a:spcAft>
-              <a:defRPr sz="1400">
-                <a:solidFill>
-                  <a:srgbClr val="58A6FF"/>
-                </a:solidFill>
-                <a:latin typeface="Consolas"/>
-              </a:defRPr>
-            </a:pPr>
-            <a:r>
-              <a:t>▓▓▓▓▓▓▓▓▓▓▓▓▓▓▓▓▓▓▓▓▓▓▓▓▓▓▓▓</a:t>
-            </a:r>
-          </a:p>
-        </p:txBody>
-      </p:sp>
-      <p:sp>
-        <p:nvSpPr>
-          <p:cNvPr id="5" name="TextBox 4"/>
           <p:cNvSpPr txBox="1"/>
           <p:nvPr/>
         </p:nvSpPr>

</xml_diff>

<commit_message>
feat(slides): architecture 10pt, remove '# system architecture' from header
Co-Authored-By: Claude Opus 4.6 <noreply@anthropic.com>
</commit_message>
<xml_diff>
--- a/presentation/presentation_v2.pptx
+++ b/presentation/presentation_v2.pptx
@@ -5717,7 +5717,7 @@
               </a:defRPr>
             </a:pPr>
             <a:r>
-              <a:t>$ python3 main.py  # system architecture</a:t>
+              <a:t>$ python3 main.py</a:t>
             </a:r>
           </a:p>
         </p:txBody>
@@ -5730,8 +5730,8 @@
         </p:nvSpPr>
         <p:spPr>
           <a:xfrm>
-            <a:off x="685800" y="1051560"/>
-            <a:ext cx="7772400" cy="4937760"/>
+            <a:off x="274320" y="1051560"/>
+            <a:ext cx="8595360" cy="4937760"/>
           </a:xfrm>
           <a:prstGeom prst="rect">
             <a:avLst/>
@@ -5739,16 +5739,16 @@
           <a:noFill/>
         </p:spPr>
         <p:txBody>
-          <a:bodyPr wrap="square">
+          <a:bodyPr wrap="none">
             <a:spAutoFit/>
           </a:bodyPr>
           <a:lstStyle/>
           <a:p>
             <a:pPr>
               <a:spcAft>
-                <a:spcPts val="400"/>
-              </a:spcAft>
-              <a:defRPr sz="1400">
+                <a:spcPts val="0"/>
+              </a:spcAft>
+              <a:defRPr sz="1000">
                 <a:solidFill>
                   <a:srgbClr val="3FB950"/>
                 </a:solidFill>
@@ -5762,9 +5762,9 @@
           <a:p>
             <a:pPr>
               <a:spcAft>
-                <a:spcPts val="400"/>
-              </a:spcAft>
-              <a:defRPr sz="1400">
+                <a:spcPts val="0"/>
+              </a:spcAft>
+              <a:defRPr sz="1000">
                 <a:solidFill>
                   <a:srgbClr val="8B949E"/>
                 </a:solidFill>
@@ -5778,9 +5778,9 @@
           <a:p>
             <a:pPr>
               <a:spcAft>
-                <a:spcPts val="400"/>
-              </a:spcAft>
-              <a:defRPr sz="1400">
+                <a:spcPts val="0"/>
+              </a:spcAft>
+              <a:defRPr sz="1000">
                 <a:solidFill>
                   <a:srgbClr val="8B949E"/>
                 </a:solidFill>
@@ -5794,9 +5794,9 @@
           <a:p>
             <a:pPr>
               <a:spcAft>
-                <a:spcPts val="400"/>
-              </a:spcAft>
-              <a:defRPr sz="1400">
+                <a:spcPts val="0"/>
+              </a:spcAft>
+              <a:defRPr sz="1000">
                 <a:solidFill>
                   <a:srgbClr val="58A6FF"/>
                 </a:solidFill>
@@ -5810,9 +5810,9 @@
           <a:p>
             <a:pPr>
               <a:spcAft>
-                <a:spcPts val="400"/>
-              </a:spcAft>
-              <a:defRPr sz="1400">
+                <a:spcPts val="0"/>
+              </a:spcAft>
+              <a:defRPr sz="1000">
                 <a:solidFill>
                   <a:srgbClr val="8B949E"/>
                 </a:solidFill>
@@ -5826,9 +5826,9 @@
           <a:p>
             <a:pPr>
               <a:spcAft>
-                <a:spcPts val="400"/>
-              </a:spcAft>
-              <a:defRPr sz="1400">
+                <a:spcPts val="0"/>
+              </a:spcAft>
+              <a:defRPr sz="1000">
                 <a:solidFill>
                   <a:srgbClr val="8B949E"/>
                 </a:solidFill>
@@ -5842,9 +5842,9 @@
           <a:p>
             <a:pPr>
               <a:spcAft>
-                <a:spcPts val="400"/>
-              </a:spcAft>
-              <a:defRPr sz="1400">
+                <a:spcPts val="0"/>
+              </a:spcAft>
+              <a:defRPr sz="1000">
                 <a:solidFill>
                   <a:srgbClr val="8B949E"/>
                 </a:solidFill>
@@ -5858,9 +5858,9 @@
           <a:p>
             <a:pPr>
               <a:spcAft>
-                <a:spcPts val="400"/>
-              </a:spcAft>
-              <a:defRPr sz="1400">
+                <a:spcPts val="0"/>
+              </a:spcAft>
+              <a:defRPr sz="1000">
                 <a:solidFill>
                   <a:srgbClr val="8B949E"/>
                 </a:solidFill>
@@ -5874,9 +5874,9 @@
           <a:p>
             <a:pPr>
               <a:spcAft>
-                <a:spcPts val="400"/>
-              </a:spcAft>
-              <a:defRPr sz="1400">
+                <a:spcPts val="0"/>
+              </a:spcAft>
+              <a:defRPr sz="1000">
                 <a:solidFill>
                   <a:srgbClr val="58A6FF"/>
                 </a:solidFill>
@@ -5890,9 +5890,9 @@
           <a:p>
             <a:pPr>
               <a:spcAft>
-                <a:spcPts val="400"/>
-              </a:spcAft>
-              <a:defRPr sz="1400">
+                <a:spcPts val="0"/>
+              </a:spcAft>
+              <a:defRPr sz="1000">
                 <a:solidFill>
                   <a:srgbClr val="8B949E"/>
                 </a:solidFill>
@@ -5906,9 +5906,9 @@
           <a:p>
             <a:pPr>
               <a:spcAft>
-                <a:spcPts val="400"/>
-              </a:spcAft>
-              <a:defRPr sz="1400">
+                <a:spcPts val="0"/>
+              </a:spcAft>
+              <a:defRPr sz="1000">
                 <a:solidFill>
                   <a:srgbClr val="8B949E"/>
                 </a:solidFill>
@@ -5922,9 +5922,9 @@
           <a:p>
             <a:pPr>
               <a:spcAft>
-                <a:spcPts val="400"/>
-              </a:spcAft>
-              <a:defRPr sz="1400">
+                <a:spcPts val="0"/>
+              </a:spcAft>
+              <a:defRPr sz="1000">
                 <a:solidFill>
                   <a:srgbClr val="8B949E"/>
                 </a:solidFill>
@@ -5938,9 +5938,9 @@
           <a:p>
             <a:pPr>
               <a:spcAft>
-                <a:spcPts val="400"/>
-              </a:spcAft>
-              <a:defRPr sz="1400">
+                <a:spcPts val="0"/>
+              </a:spcAft>
+              <a:defRPr sz="1000">
                 <a:solidFill>
                   <a:srgbClr val="8B949E"/>
                 </a:solidFill>
@@ -5954,9 +5954,9 @@
           <a:p>
             <a:pPr>
               <a:spcAft>
-                <a:spcPts val="400"/>
-              </a:spcAft>
-              <a:defRPr sz="1400">
+                <a:spcPts val="0"/>
+              </a:spcAft>
+              <a:defRPr sz="1000">
                 <a:solidFill>
                   <a:srgbClr val="8B949E"/>
                 </a:solidFill>
@@ -5970,9 +5970,9 @@
           <a:p>
             <a:pPr>
               <a:spcAft>
-                <a:spcPts val="400"/>
-              </a:spcAft>
-              <a:defRPr sz="1400">
+                <a:spcPts val="0"/>
+              </a:spcAft>
+              <a:defRPr sz="1000">
                 <a:solidFill>
                   <a:srgbClr val="8B949E"/>
                 </a:solidFill>
@@ -5986,9 +5986,9 @@
           <a:p>
             <a:pPr>
               <a:spcAft>
-                <a:spcPts val="400"/>
-              </a:spcAft>
-              <a:defRPr sz="1400">
+                <a:spcPts val="0"/>
+              </a:spcAft>
+              <a:defRPr sz="1000">
                 <a:solidFill>
                   <a:srgbClr val="8B949E"/>
                 </a:solidFill>
@@ -6002,9 +6002,9 @@
           <a:p>
             <a:pPr>
               <a:spcAft>
-                <a:spcPts val="400"/>
-              </a:spcAft>
-              <a:defRPr sz="1400">
+                <a:spcPts val="0"/>
+              </a:spcAft>
+              <a:defRPr sz="1000">
                 <a:solidFill>
                   <a:srgbClr val="8B949E"/>
                 </a:solidFill>
@@ -6018,9 +6018,9 @@
           <a:p>
             <a:pPr>
               <a:spcAft>
-                <a:spcPts val="400"/>
-              </a:spcAft>
-              <a:defRPr sz="1400">
+                <a:spcPts val="0"/>
+              </a:spcAft>
+              <a:defRPr sz="1000">
                 <a:solidFill>
                   <a:srgbClr val="8B949E"/>
                 </a:solidFill>
@@ -6034,9 +6034,9 @@
           <a:p>
             <a:pPr>
               <a:spcAft>
-                <a:spcPts val="400"/>
-              </a:spcAft>
-              <a:defRPr sz="1400">
+                <a:spcPts val="0"/>
+              </a:spcAft>
+              <a:defRPr sz="1000">
                 <a:solidFill>
                   <a:srgbClr val="8B949E"/>
                 </a:solidFill>
@@ -6050,9 +6050,9 @@
           <a:p>
             <a:pPr>
               <a:spcAft>
-                <a:spcPts val="400"/>
-              </a:spcAft>
-              <a:defRPr sz="1400">
+                <a:spcPts val="0"/>
+              </a:spcAft>
+              <a:defRPr sz="1000">
                 <a:solidFill>
                   <a:srgbClr val="8B949E"/>
                 </a:solidFill>
@@ -6066,9 +6066,9 @@
           <a:p>
             <a:pPr>
               <a:spcAft>
-                <a:spcPts val="400"/>
-              </a:spcAft>
-              <a:defRPr sz="1400">
+                <a:spcPts val="0"/>
+              </a:spcAft>
+              <a:defRPr sz="1000">
                 <a:solidFill>
                   <a:srgbClr val="58A6FF"/>
                 </a:solidFill>
@@ -6082,9 +6082,9 @@
           <a:p>
             <a:pPr>
               <a:spcAft>
-                <a:spcPts val="400"/>
-              </a:spcAft>
-              <a:defRPr sz="1400">
+                <a:spcPts val="0"/>
+              </a:spcAft>
+              <a:defRPr sz="1000">
                 <a:solidFill>
                   <a:srgbClr val="8B949E"/>
                 </a:solidFill>
@@ -6098,9 +6098,9 @@
           <a:p>
             <a:pPr>
               <a:spcAft>
-                <a:spcPts val="400"/>
-              </a:spcAft>
-              <a:defRPr sz="1400">
+                <a:spcPts val="0"/>
+              </a:spcAft>
+              <a:defRPr sz="1000">
                 <a:solidFill>
                   <a:srgbClr val="8B949E"/>
                 </a:solidFill>
@@ -6114,9 +6114,9 @@
           <a:p>
             <a:pPr>
               <a:spcAft>
-                <a:spcPts val="400"/>
-              </a:spcAft>
-              <a:defRPr sz="1400">
+                <a:spcPts val="0"/>
+              </a:spcAft>
+              <a:defRPr sz="1000">
                 <a:solidFill>
                   <a:srgbClr val="3FB950"/>
                 </a:solidFill>

</xml_diff>

<commit_message>
feat(slides): IR theory — narrative bridge explaining displacements, dipoles, intensities
Co-Authored-By: Claude Opus 4.6 <noreply@anthropic.com>
</commit_message>
<xml_diff>
--- a/presentation/presentation_v2.pptx
+++ b/presentation/presentation_v2.pptx
@@ -5056,7 +5056,7 @@
               </a:defRPr>
             </a:pPr>
             <a:r>
-              <a:t>$ man ir_spectroscopy</a:t>
+              <a:t>$ cat ir_spectroscopy.md</a:t>
             </a:r>
           </a:p>
         </p:txBody>
@@ -5069,8 +5069,8 @@
         </p:nvSpPr>
         <p:spPr>
           <a:xfrm>
-            <a:off x="457200" y="1051560"/>
-            <a:ext cx="4297680" cy="4937760"/>
+            <a:off x="685800" y="1051560"/>
+            <a:ext cx="7772400" cy="4937760"/>
           </a:xfrm>
           <a:prstGeom prst="rect">
             <a:avLst/>
@@ -5085,9 +5085,9 @@
           <a:p>
             <a:pPr>
               <a:spcAft>
-                <a:spcPts val="300"/>
-              </a:spcAft>
-              <a:defRPr sz="1300">
+                <a:spcPts val="400"/>
+              </a:spcAft>
+              <a:defRPr sz="1400">
                 <a:solidFill>
                   <a:srgbClr val="58A6FF"/>
                 </a:solidFill>
@@ -5095,211 +5095,108 @@
               </a:defRPr>
             </a:pPr>
             <a:r>
-              <a:t># What the software computes</a:t>
-            </a:r>
-          </a:p>
-          <a:p>
-            <a:pPr>
-              <a:spcAft>
-                <a:spcPts val="300"/>
-              </a:spcAft>
-              <a:defRPr sz="1300">
-                <a:solidFill>
-                  <a:srgbClr val="8B949E"/>
-                </a:solidFill>
-                <a:latin typeface="Consolas"/>
-              </a:defRPr>
-            </a:pPr>
-          </a:p>
-          <a:p>
-            <a:pPr>
-              <a:spcAft>
-                <a:spcPts val="300"/>
-              </a:spcAft>
-              <a:defRPr sz="1300">
-                <a:solidFill>
-                  <a:srgbClr val="C9D1D9"/>
-                </a:solidFill>
-                <a:latin typeface="Consolas"/>
-              </a:defRPr>
-            </a:pPr>
-            <a:r>
-              <a:t>  Harmonic approximation:</a:t>
-            </a:r>
-          </a:p>
-          <a:p>
-            <a:pPr>
-              <a:spcAft>
-                <a:spcPts val="300"/>
-              </a:spcAft>
-              <a:defRPr sz="1300">
-                <a:solidFill>
-                  <a:srgbClr val="C9D1D9"/>
-                </a:solidFill>
-                <a:latin typeface="Consolas"/>
-              </a:defRPr>
-            </a:pPr>
-            <a:r>
-              <a:t>  V(x) ≈ V₀ + ½k·x²</a:t>
-            </a:r>
-          </a:p>
-          <a:p>
-            <a:pPr>
-              <a:spcAft>
-                <a:spcPts val="300"/>
-              </a:spcAft>
-              <a:defRPr sz="1300">
-                <a:solidFill>
-                  <a:srgbClr val="8B949E"/>
-                </a:solidFill>
-                <a:latin typeface="Consolas"/>
-              </a:defRPr>
-            </a:pPr>
-          </a:p>
-          <a:p>
-            <a:pPr>
-              <a:spcAft>
-                <a:spcPts val="300"/>
-              </a:spcAft>
-              <a:defRPr sz="1300">
-                <a:solidFill>
-                  <a:srgbClr val="C9D1D9"/>
-                </a:solidFill>
-                <a:latin typeface="Consolas"/>
-              </a:defRPr>
-            </a:pPr>
-            <a:r>
-              <a:t>  → Diagonalise Hessian → normal modes</a:t>
-            </a:r>
-          </a:p>
-          <a:p>
-            <a:pPr>
-              <a:spcAft>
-                <a:spcPts val="300"/>
-              </a:spcAft>
-              <a:defRPr sz="1300">
-                <a:solidFill>
-                  <a:srgbClr val="C9D1D9"/>
-                </a:solidFill>
-                <a:latin typeface="Consolas"/>
-              </a:defRPr>
-            </a:pPr>
-            <a:r>
-              <a:t>  → 3N−6 frequencies ωᵢ</a:t>
-            </a:r>
-          </a:p>
-          <a:p>
-            <a:pPr>
-              <a:spcAft>
-                <a:spcPts val="300"/>
-              </a:spcAft>
-              <a:defRPr sz="1300">
-                <a:solidFill>
-                  <a:srgbClr val="C9D1D9"/>
-                </a:solidFill>
-                <a:latin typeface="Consolas"/>
-              </a:defRPr>
-            </a:pPr>
-            <a:r>
-              <a:t>  → Intensities ∝ |Δμ/ΔQ|²</a:t>
-            </a:r>
-          </a:p>
-          <a:p>
-            <a:pPr>
-              <a:spcAft>
-                <a:spcPts val="300"/>
-              </a:spcAft>
-              <a:defRPr sz="1300">
-                <a:solidFill>
-                  <a:srgbClr val="8B949E"/>
-                </a:solidFill>
-                <a:latin typeface="Consolas"/>
-              </a:defRPr>
-            </a:pPr>
-          </a:p>
-          <a:p>
-            <a:pPr>
-              <a:spcAft>
-                <a:spcPts val="300"/>
-              </a:spcAft>
-              <a:defRPr sz="1300">
-                <a:solidFill>
-                  <a:srgbClr val="C9D1D9"/>
-                </a:solidFill>
-                <a:latin typeface="Consolas"/>
-              </a:defRPr>
-            </a:pPr>
-            <a:r>
-              <a:t>  For each displaced geometry:</a:t>
-            </a:r>
-          </a:p>
-          <a:p>
-            <a:pPr>
-              <a:spcAft>
-                <a:spcPts val="300"/>
-              </a:spcAft>
-              <a:defRPr sz="1300">
-                <a:solidFill>
-                  <a:srgbClr val="C9D1D9"/>
-                </a:solidFill>
-                <a:latin typeface="Consolas"/>
-              </a:defRPr>
-            </a:pPr>
-            <a:r>
-              <a:t>  → energy (forces → Hessian)</a:t>
-            </a:r>
-          </a:p>
-          <a:p>
-            <a:pPr>
-              <a:spcAft>
-                <a:spcPts val="300"/>
-              </a:spcAft>
-              <a:defRPr sz="1300">
-                <a:solidFill>
-                  <a:srgbClr val="C9D1D9"/>
-                </a:solidFill>
-                <a:latin typeface="Consolas"/>
-              </a:defRPr>
-            </a:pPr>
-            <a:r>
-              <a:t>  → dipole μ⃗ (intensity)</a:t>
-            </a:r>
-          </a:p>
-          <a:p>
-            <a:pPr>
-              <a:spcAft>
-                <a:spcPts val="300"/>
-              </a:spcAft>
-              <a:defRPr sz="1300">
-                <a:solidFill>
-                  <a:srgbClr val="C9D1D9"/>
-                </a:solidFill>
-                <a:latin typeface="Consolas"/>
-              </a:defRPr>
-            </a:pPr>
-            <a:r>
-              <a:t>  → Gaussian displaces ~hundreds of times</a:t>
-            </a:r>
-          </a:p>
-          <a:p>
-            <a:pPr>
-              <a:spcAft>
-                <a:spcPts val="300"/>
-              </a:spcAft>
-              <a:defRPr sz="1300">
-                <a:solidFill>
-                  <a:srgbClr val="8B949E"/>
-                </a:solidFill>
-                <a:latin typeface="Consolas"/>
-              </a:defRPr>
-            </a:pPr>
-          </a:p>
-          <a:p>
-            <a:pPr>
-              <a:spcAft>
-                <a:spcPts val="300"/>
-              </a:spcAft>
-              <a:defRPr sz="1300">
+              <a:t># How IR spectra are computed</a:t>
+            </a:r>
+          </a:p>
+          <a:p>
+            <a:pPr>
+              <a:spcAft>
+                <a:spcPts val="400"/>
+              </a:spcAft>
+              <a:defRPr sz="1400">
+                <a:solidFill>
+                  <a:srgbClr val="C9D1D9"/>
+                </a:solidFill>
+                <a:latin typeface="Consolas"/>
+              </a:defRPr>
+            </a:pPr>
+            <a:r>
+              <a:t>  → Displace each atom in x, y, z  (small nudges around equilibrium)</a:t>
+            </a:r>
+          </a:p>
+          <a:p>
+            <a:pPr>
+              <a:spcAft>
+                <a:spcPts val="400"/>
+              </a:spcAft>
+              <a:defRPr sz="1400">
+                <a:solidFill>
+                  <a:srgbClr val="C9D1D9"/>
+                </a:solidFill>
+                <a:latin typeface="Consolas"/>
+              </a:defRPr>
+            </a:pPr>
+            <a:r>
+              <a:t>  → For each displacement, compute energy + forces</a:t>
+            </a:r>
+          </a:p>
+          <a:p>
+            <a:pPr>
+              <a:spcAft>
+                <a:spcPts val="400"/>
+              </a:spcAft>
+              <a:defRPr sz="1400">
+                <a:solidFill>
+                  <a:srgbClr val="C9D1D9"/>
+                </a:solidFill>
+                <a:latin typeface="Consolas"/>
+              </a:defRPr>
+            </a:pPr>
+            <a:r>
+              <a:t>  → Build Hessian (matrix of force constants) → diagonalise</a:t>
+            </a:r>
+          </a:p>
+          <a:p>
+            <a:pPr>
+              <a:spcAft>
+                <a:spcPts val="400"/>
+              </a:spcAft>
+              <a:defRPr sz="1400">
+                <a:solidFill>
+                  <a:srgbClr val="C9D1D9"/>
+                </a:solidFill>
+                <a:latin typeface="Consolas"/>
+              </a:defRPr>
+            </a:pPr>
+            <a:r>
+              <a:t>  → Eigenvalues = frequencies, eigenvectors = normal modes</a:t>
+            </a:r>
+          </a:p>
+          <a:p>
+            <a:pPr>
+              <a:spcAft>
+                <a:spcPts val="400"/>
+              </a:spcAft>
+              <a:defRPr sz="1400">
+                <a:solidFill>
+                  <a:srgbClr val="C9D1D9"/>
+                </a:solidFill>
+                <a:latin typeface="Consolas"/>
+              </a:defRPr>
+            </a:pPr>
+            <a:r>
+              <a:t>  → 3N−6 modes for N atoms  (e.g. water: 3 modes)</a:t>
+            </a:r>
+          </a:p>
+          <a:p>
+            <a:pPr>
+              <a:spcAft>
+                <a:spcPts val="400"/>
+              </a:spcAft>
+              <a:defRPr sz="1400">
+                <a:solidFill>
+                  <a:srgbClr val="8B949E"/>
+                </a:solidFill>
+                <a:latin typeface="Consolas"/>
+              </a:defRPr>
+            </a:pPr>
+          </a:p>
+          <a:p>
+            <a:pPr>
+              <a:spcAft>
+                <a:spcPts val="400"/>
+              </a:spcAft>
+              <a:defRPr sz="1400">
                 <a:solidFill>
                   <a:srgbClr val="58A6FF"/>
                 </a:solidFill>
@@ -5307,39 +5204,164 @@
               </a:defRPr>
             </a:pPr>
             <a:r>
-              <a:t># Anharmonic (VPT2): ongoing work</a:t>
-            </a:r>
-          </a:p>
-          <a:p>
-            <a:pPr>
-              <a:spcAft>
-                <a:spcPts val="300"/>
-              </a:spcAft>
-              <a:defRPr sz="1300">
-                <a:solidFill>
-                  <a:srgbClr val="C9D1D9"/>
-                </a:solidFill>
-                <a:latin typeface="Consolas"/>
-              </a:defRPr>
-            </a:pPr>
-            <a:r>
-              <a:t>  → Already running. Overtones + combination bands.</a:t>
-            </a:r>
-          </a:p>
-          <a:p>
-            <a:pPr>
-              <a:spcAft>
-                <a:spcPts val="300"/>
-              </a:spcAft>
-              <a:defRPr sz="1300">
-                <a:solidFill>
-                  <a:srgbClr val="8B949E"/>
-                </a:solidFill>
-                <a:latin typeface="Consolas"/>
-              </a:defRPr>
-            </a:pPr>
-            <a:r>
-              <a:t>  → Results pending full validation — next direction.</a:t>
+              <a:t># Where do intensities come from?</a:t>
+            </a:r>
+          </a:p>
+          <a:p>
+            <a:pPr>
+              <a:spcAft>
+                <a:spcPts val="400"/>
+              </a:spcAft>
+              <a:defRPr sz="1400">
+                <a:solidFill>
+                  <a:srgbClr val="C9D1D9"/>
+                </a:solidFill>
+                <a:latin typeface="Consolas"/>
+              </a:defRPr>
+            </a:pPr>
+            <a:r>
+              <a:t>  → Dipole μ⃗ = charge distribution of the molecule</a:t>
+            </a:r>
+          </a:p>
+          <a:p>
+            <a:pPr>
+              <a:spcAft>
+                <a:spcPts val="400"/>
+              </a:spcAft>
+              <a:defRPr sz="1400">
+                <a:solidFill>
+                  <a:srgbClr val="C9D1D9"/>
+                </a:solidFill>
+                <a:latin typeface="Consolas"/>
+              </a:defRPr>
+            </a:pPr>
+            <a:r>
+              <a:t>  → When atoms vibrate, μ⃗ changes → molecule absorbs IR light</a:t>
+            </a:r>
+          </a:p>
+          <a:p>
+            <a:pPr>
+              <a:spcAft>
+                <a:spcPts val="400"/>
+              </a:spcAft>
+              <a:defRPr sz="1400">
+                <a:solidFill>
+                  <a:srgbClr val="C9D1D9"/>
+                </a:solidFill>
+                <a:latin typeface="Consolas"/>
+              </a:defRPr>
+            </a:pPr>
+            <a:r>
+              <a:t>  → Intensity ∝ |∂μ/∂Q|²  (how much dipole changes per mode)</a:t>
+            </a:r>
+          </a:p>
+          <a:p>
+            <a:pPr>
+              <a:spcAft>
+                <a:spcPts val="400"/>
+              </a:spcAft>
+              <a:defRPr sz="1400">
+                <a:solidFill>
+                  <a:srgbClr val="C9D1D9"/>
+                </a:solidFill>
+                <a:latin typeface="Consolas"/>
+              </a:defRPr>
+            </a:pPr>
+            <a:r>
+              <a:t>  → So we also need μ⃗ at every displaced geometry</a:t>
+            </a:r>
+          </a:p>
+          <a:p>
+            <a:pPr>
+              <a:spcAft>
+                <a:spcPts val="400"/>
+              </a:spcAft>
+              <a:defRPr sz="1400">
+                <a:solidFill>
+                  <a:srgbClr val="8B949E"/>
+                </a:solidFill>
+                <a:latin typeface="Consolas"/>
+              </a:defRPr>
+            </a:pPr>
+          </a:p>
+          <a:p>
+            <a:pPr>
+              <a:spcAft>
+                <a:spcPts val="400"/>
+              </a:spcAft>
+              <a:defRPr sz="1400">
+                <a:solidFill>
+                  <a:srgbClr val="58A6FF"/>
+                </a:solidFill>
+                <a:latin typeface="Consolas"/>
+              </a:defRPr>
+            </a:pPr>
+            <a:r>
+              <a:t># The bottleneck</a:t>
+            </a:r>
+          </a:p>
+          <a:p>
+            <a:pPr>
+              <a:spcAft>
+                <a:spcPts val="400"/>
+              </a:spcAft>
+              <a:defRPr sz="1400">
+                <a:solidFill>
+                  <a:srgbClr val="C9D1D9"/>
+                </a:solidFill>
+                <a:latin typeface="Consolas"/>
+              </a:defRPr>
+            </a:pPr>
+            <a:r>
+              <a:t>  → Gaussian displaces the molecule hundreds of times</a:t>
+            </a:r>
+          </a:p>
+          <a:p>
+            <a:pPr>
+              <a:spcAft>
+                <a:spcPts val="400"/>
+              </a:spcAft>
+              <a:defRPr sz="1400">
+                <a:solidFill>
+                  <a:srgbClr val="C9D1D9"/>
+                </a:solidFill>
+                <a:latin typeface="Consolas"/>
+              </a:defRPr>
+            </a:pPr>
+            <a:r>
+              <a:t>  → Each time: needs energy E, forces F, and dipole μ⃗</a:t>
+            </a:r>
+          </a:p>
+          <a:p>
+            <a:pPr>
+              <a:spcAft>
+                <a:spcPts val="400"/>
+              </a:spcAft>
+              <a:defRPr sz="1400">
+                <a:solidFill>
+                  <a:srgbClr val="C9D1D9"/>
+                </a:solidFill>
+                <a:latin typeface="Consolas"/>
+              </a:defRPr>
+            </a:pPr>
+            <a:r>
+              <a:t>  → With DFT: minutes to hours per molecule</a:t>
+            </a:r>
+          </a:p>
+          <a:p>
+            <a:pPr>
+              <a:spcAft>
+                <a:spcPts val="400"/>
+              </a:spcAft>
+              <a:defRPr sz="1400">
+                <a:solidFill>
+                  <a:srgbClr val="3FB950"/>
+                </a:solidFill>
+                <a:latin typeface="Consolas"/>
+              </a:defRPr>
+            </a:pPr>
+            <a:r>
+              <a:t>  → With ML:  seconds  ← this is what we replace</a:t>
             </a:r>
           </a:p>
         </p:txBody>
@@ -5347,286 +5369,6 @@
       <p:sp>
         <p:nvSpPr>
           <p:cNvPr id="4" name="TextBox 3"/>
-          <p:cNvSpPr txBox="1"/>
-          <p:nvPr/>
-        </p:nvSpPr>
-        <p:spPr>
-          <a:xfrm>
-            <a:off x="4572000" y="1051560"/>
-            <a:ext cx="4114800" cy="4937760"/>
-          </a:xfrm>
-          <a:prstGeom prst="rect">
-            <a:avLst/>
-          </a:prstGeom>
-          <a:noFill/>
-        </p:spPr>
-        <p:txBody>
-          <a:bodyPr wrap="square">
-            <a:spAutoFit/>
-          </a:bodyPr>
-          <a:lstStyle/>
-          <a:p>
-            <a:pPr>
-              <a:spcAft>
-                <a:spcPts val="300"/>
-              </a:spcAft>
-              <a:defRPr sz="1300">
-                <a:solidFill>
-                  <a:srgbClr val="58A6FF"/>
-                </a:solidFill>
-                <a:latin typeface="Consolas"/>
-              </a:defRPr>
-            </a:pPr>
-            <a:r>
-              <a:t># What ML provides</a:t>
-            </a:r>
-          </a:p>
-          <a:p>
-            <a:pPr>
-              <a:spcAft>
-                <a:spcPts val="300"/>
-              </a:spcAft>
-              <a:defRPr sz="1300">
-                <a:solidFill>
-                  <a:srgbClr val="8B949E"/>
-                </a:solidFill>
-                <a:latin typeface="Consolas"/>
-              </a:defRPr>
-            </a:pPr>
-          </a:p>
-          <a:p>
-            <a:pPr>
-              <a:spcAft>
-                <a:spcPts val="300"/>
-              </a:spcAft>
-              <a:defRPr sz="1300">
-                <a:solidFill>
-                  <a:srgbClr val="C9D1D9"/>
-                </a:solidFill>
-                <a:latin typeface="Consolas"/>
-              </a:defRPr>
-            </a:pPr>
-            <a:r>
-              <a:t>  Each displaced geometry → ML query:</a:t>
-            </a:r>
-          </a:p>
-          <a:p>
-            <a:pPr>
-              <a:spcAft>
-                <a:spcPts val="300"/>
-              </a:spcAft>
-              <a:defRPr sz="1300">
-                <a:solidFill>
-                  <a:srgbClr val="8B949E"/>
-                </a:solidFill>
-                <a:latin typeface="Consolas"/>
-              </a:defRPr>
-            </a:pPr>
-          </a:p>
-          <a:p>
-            <a:pPr>
-              <a:spcAft>
-                <a:spcPts val="300"/>
-              </a:spcAft>
-              <a:defRPr sz="1300">
-                <a:solidFill>
-                  <a:srgbClr val="3FB950"/>
-                </a:solidFill>
-                <a:latin typeface="Consolas"/>
-              </a:defRPr>
-            </a:pPr>
-            <a:r>
-              <a:t>  [geometry]</a:t>
-            </a:r>
-          </a:p>
-          <a:p>
-            <a:pPr>
-              <a:spcAft>
-                <a:spcPts val="300"/>
-              </a:spcAft>
-              <a:defRPr sz="1300">
-                <a:solidFill>
-                  <a:srgbClr val="C9D1D9"/>
-                </a:solidFill>
-                <a:latin typeface="Consolas"/>
-              </a:defRPr>
-            </a:pPr>
-            <a:r>
-              <a:t>      ↓  MACE energy model</a:t>
-            </a:r>
-          </a:p>
-          <a:p>
-            <a:pPr>
-              <a:spcAft>
-                <a:spcPts val="300"/>
-              </a:spcAft>
-              <a:defRPr sz="1300">
-                <a:solidFill>
-                  <a:srgbClr val="8B949E"/>
-                </a:solidFill>
-                <a:latin typeface="Consolas"/>
-              </a:defRPr>
-            </a:pPr>
-            <a:r>
-              <a:t>  E, F, Hessian contribution</a:t>
-            </a:r>
-          </a:p>
-          <a:p>
-            <a:pPr>
-              <a:spcAft>
-                <a:spcPts val="300"/>
-              </a:spcAft>
-              <a:defRPr sz="1300">
-                <a:solidFill>
-                  <a:srgbClr val="8B949E"/>
-                </a:solidFill>
-                <a:latin typeface="Consolas"/>
-              </a:defRPr>
-            </a:pPr>
-          </a:p>
-          <a:p>
-            <a:pPr>
-              <a:spcAft>
-                <a:spcPts val="300"/>
-              </a:spcAft>
-              <a:defRPr sz="1300">
-                <a:solidFill>
-                  <a:srgbClr val="3FB950"/>
-                </a:solidFill>
-                <a:latin typeface="Consolas"/>
-              </a:defRPr>
-            </a:pPr>
-            <a:r>
-              <a:t>  [geometry]</a:t>
-            </a:r>
-          </a:p>
-          <a:p>
-            <a:pPr>
-              <a:spcAft>
-                <a:spcPts val="300"/>
-              </a:spcAft>
-              <a:defRPr sz="1300">
-                <a:solidFill>
-                  <a:srgbClr val="C9D1D9"/>
-                </a:solidFill>
-                <a:latin typeface="Consolas"/>
-              </a:defRPr>
-            </a:pPr>
-            <a:r>
-              <a:t>      ↓  MACE dipole model</a:t>
-            </a:r>
-          </a:p>
-          <a:p>
-            <a:pPr>
-              <a:spcAft>
-                <a:spcPts val="300"/>
-              </a:spcAft>
-              <a:defRPr sz="1300">
-                <a:solidFill>
-                  <a:srgbClr val="8B949E"/>
-                </a:solidFill>
-                <a:latin typeface="Consolas"/>
-              </a:defRPr>
-            </a:pPr>
-            <a:r>
-              <a:t>  μ⃗ = (μ_x, μ_y, μ_z)</a:t>
-            </a:r>
-          </a:p>
-          <a:p>
-            <a:pPr>
-              <a:spcAft>
-                <a:spcPts val="300"/>
-              </a:spcAft>
-              <a:defRPr sz="1300">
-                <a:solidFill>
-                  <a:srgbClr val="8B949E"/>
-                </a:solidFill>
-                <a:latin typeface="Consolas"/>
-              </a:defRPr>
-            </a:pPr>
-          </a:p>
-          <a:p>
-            <a:pPr>
-              <a:spcAft>
-                <a:spcPts val="300"/>
-              </a:spcAft>
-              <a:defRPr sz="1300">
-                <a:solidFill>
-                  <a:srgbClr val="C9D1D9"/>
-                </a:solidFill>
-                <a:latin typeface="Consolas"/>
-              </a:defRPr>
-            </a:pPr>
-            <a:r>
-              <a:t>  Both injected into Gaussian</a:t>
-            </a:r>
-          </a:p>
-          <a:p>
-            <a:pPr>
-              <a:spcAft>
-                <a:spcPts val="300"/>
-              </a:spcAft>
-              <a:defRPr sz="1300">
-                <a:solidFill>
-                  <a:srgbClr val="C9D1D9"/>
-                </a:solidFill>
-                <a:latin typeface="Consolas"/>
-              </a:defRPr>
-            </a:pPr>
-            <a:r>
-              <a:t>  via ZMQ bridge — next slide.</a:t>
-            </a:r>
-          </a:p>
-          <a:p>
-            <a:pPr>
-              <a:spcAft>
-                <a:spcPts val="300"/>
-              </a:spcAft>
-              <a:defRPr sz="1300">
-                <a:solidFill>
-                  <a:srgbClr val="8B949E"/>
-                </a:solidFill>
-                <a:latin typeface="Consolas"/>
-              </a:defRPr>
-            </a:pPr>
-          </a:p>
-          <a:p>
-            <a:pPr>
-              <a:spcAft>
-                <a:spcPts val="300"/>
-              </a:spcAft>
-              <a:defRPr sz="1300">
-                <a:solidFill>
-                  <a:srgbClr val="8B949E"/>
-                </a:solidFill>
-                <a:latin typeface="Consolas"/>
-              </a:defRPr>
-            </a:pPr>
-            <a:r>
-              <a:t>  IR range: 400–4000 cm⁻¹</a:t>
-            </a:r>
-          </a:p>
-          <a:p>
-            <a:pPr>
-              <a:spcAft>
-                <a:spcPts val="300"/>
-              </a:spcAft>
-              <a:defRPr sz="1300">
-                <a:solidFill>
-                  <a:srgbClr val="8B949E"/>
-                </a:solidFill>
-                <a:latin typeface="Consolas"/>
-              </a:defRPr>
-            </a:pPr>
-            <a:r>
-              <a:t>  1 cm⁻¹ ≈ 0.124 meV</a:t>
-            </a:r>
-          </a:p>
-        </p:txBody>
-      </p:sp>
-      <p:sp>
-        <p:nvSpPr>
-          <p:cNvPr id="5" name="TextBox 4"/>
           <p:cNvSpPr txBox="1"/>
           <p:nvPr/>
         </p:nvSpPr>

</xml_diff>

<commit_message>
feat(slides): architecture 11pt + workflow.py header, calculators with MACE-ANI-CC, IR diagram idea slide
Co-Authored-By: Claude Opus 4.6 <noreply@anthropic.com>
</commit_message>
<xml_diff>
--- a/presentation/presentation_v2.pptx
+++ b/presentation/presentation_v2.pptx
@@ -18,6 +18,7 @@
     <p:sldId id="266" r:id="rId17"/>
     <p:sldId id="267" r:id="rId18"/>
     <p:sldId id="268" r:id="rId19"/>
+    <p:sldId id="269" r:id="rId20"/>
   </p:sldIdLst>
   <p:sldSz cx="9144000" cy="6858000" type="screen4x3"/>
   <p:notesSz cx="6858000" cy="9144000"/>
@@ -4668,6 +4669,406 @@
 </p:sld>
 </file>
 
+<file path=ppt/slides/slide14.xml><?xml version="1.0" encoding="utf-8"?>
+<p:sld xmlns:a="http://schemas.openxmlformats.org/drawingml/2006/main" xmlns:p="http://schemas.openxmlformats.org/presentationml/2006/main" xmlns:r="http://schemas.openxmlformats.org/officeDocument/2006/relationships">
+  <p:cSld>
+    <p:bg>
+      <p:bgPr>
+        <a:solidFill>
+          <a:srgbClr val="0D1117"/>
+        </a:solidFill>
+        <a:effectLst/>
+      </p:bgPr>
+    </p:bg>
+    <p:spTree>
+      <p:nvGrpSpPr>
+        <p:cNvPr id="1" name=""/>
+        <p:cNvGrpSpPr/>
+        <p:nvPr/>
+      </p:nvGrpSpPr>
+      <p:grpSpPr/>
+      <p:sp>
+        <p:nvSpPr>
+          <p:cNvPr id="2" name="TextBox 1"/>
+          <p:cNvSpPr txBox="1"/>
+          <p:nvPr/>
+        </p:nvSpPr>
+        <p:spPr>
+          <a:xfrm>
+            <a:off x="457200" y="320040"/>
+            <a:ext cx="8229600" cy="548640"/>
+          </a:xfrm>
+          <a:prstGeom prst="rect">
+            <a:avLst/>
+          </a:prstGeom>
+          <a:noFill/>
+        </p:spPr>
+        <p:txBody>
+          <a:bodyPr wrap="none">
+            <a:spAutoFit/>
+          </a:bodyPr>
+          <a:lstStyle/>
+          <a:p>
+            <a:pPr>
+              <a:defRPr sz="2800" b="1">
+                <a:solidFill>
+                  <a:srgbClr val="58A6FF"/>
+                </a:solidFill>
+                <a:latin typeface="Consolas"/>
+              </a:defRPr>
+            </a:pPr>
+            <a:r>
+              <a:t>$ cat ir_intensity.md  # idea — for IR theory slide?</a:t>
+            </a:r>
+          </a:p>
+        </p:txBody>
+      </p:sp>
+      <p:sp>
+        <p:nvSpPr>
+          <p:cNvPr id="3" name="TextBox 2"/>
+          <p:cNvSpPr txBox="1"/>
+          <p:nvPr/>
+        </p:nvSpPr>
+        <p:spPr>
+          <a:xfrm>
+            <a:off x="685800" y="1051560"/>
+            <a:ext cx="7772400" cy="4937760"/>
+          </a:xfrm>
+          <a:prstGeom prst="rect">
+            <a:avLst/>
+          </a:prstGeom>
+          <a:noFill/>
+        </p:spPr>
+        <p:txBody>
+          <a:bodyPr wrap="square">
+            <a:spAutoFit/>
+          </a:bodyPr>
+          <a:lstStyle/>
+          <a:p>
+            <a:pPr>
+              <a:spcAft>
+                <a:spcPts val="400"/>
+              </a:spcAft>
+              <a:defRPr sz="1400">
+                <a:solidFill>
+                  <a:srgbClr val="58A6FF"/>
+                </a:solidFill>
+                <a:latin typeface="Consolas"/>
+              </a:defRPr>
+            </a:pPr>
+            <a:r>
+              <a:t>  Intensity ∝ |∂μ/∂Q|²</a:t>
+            </a:r>
+          </a:p>
+          <a:p>
+            <a:pPr>
+              <a:spcAft>
+                <a:spcPts val="400"/>
+              </a:spcAft>
+              <a:defRPr sz="1400">
+                <a:solidFill>
+                  <a:srgbClr val="8B949E"/>
+                </a:solidFill>
+                <a:latin typeface="Consolas"/>
+              </a:defRPr>
+            </a:pPr>
+          </a:p>
+          <a:p>
+            <a:pPr>
+              <a:spcAft>
+                <a:spcPts val="400"/>
+              </a:spcAft>
+              <a:defRPr sz="1400">
+                <a:solidFill>
+                  <a:srgbClr val="C9D1D9"/>
+                </a:solidFill>
+                <a:latin typeface="Consolas"/>
+              </a:defRPr>
+            </a:pPr>
+            <a:r>
+              <a:t>  │                                large ∂μ/∂Q</a:t>
+            </a:r>
+          </a:p>
+          <a:p>
+            <a:pPr>
+              <a:spcAft>
+                <a:spcPts val="400"/>
+              </a:spcAft>
+              <a:defRPr sz="1400">
+                <a:solidFill>
+                  <a:srgbClr val="58A6FF"/>
+                </a:solidFill>
+                <a:latin typeface="Consolas"/>
+              </a:defRPr>
+            </a:pPr>
+            <a:r>
+              <a:t>  │                                ║</a:t>
+            </a:r>
+          </a:p>
+          <a:p>
+            <a:pPr>
+              <a:spcAft>
+                <a:spcPts val="400"/>
+              </a:spcAft>
+              <a:defRPr sz="1400">
+                <a:solidFill>
+                  <a:srgbClr val="C9D1D9"/>
+                </a:solidFill>
+                <a:latin typeface="Consolas"/>
+              </a:defRPr>
+            </a:pPr>
+            <a:r>
+              <a:t>  │          medium                ║</a:t>
+            </a:r>
+          </a:p>
+          <a:p>
+            <a:pPr>
+              <a:spcAft>
+                <a:spcPts val="400"/>
+              </a:spcAft>
+              <a:defRPr sz="1400">
+                <a:solidFill>
+                  <a:srgbClr val="58A6FF"/>
+                </a:solidFill>
+                <a:latin typeface="Consolas"/>
+              </a:defRPr>
+            </a:pPr>
+            <a:r>
+              <a:t>  │          ║                     ║</a:t>
+            </a:r>
+          </a:p>
+          <a:p>
+            <a:pPr>
+              <a:spcAft>
+                <a:spcPts val="400"/>
+              </a:spcAft>
+              <a:defRPr sz="1400">
+                <a:solidFill>
+                  <a:srgbClr val="58A6FF"/>
+                </a:solidFill>
+                <a:latin typeface="Consolas"/>
+              </a:defRPr>
+            </a:pPr>
+            <a:r>
+              <a:t>  │          ║                     ║</a:t>
+            </a:r>
+          </a:p>
+          <a:p>
+            <a:pPr>
+              <a:spcAft>
+                <a:spcPts val="400"/>
+              </a:spcAft>
+              <a:defRPr sz="1400">
+                <a:solidFill>
+                  <a:srgbClr val="C9D1D9"/>
+                </a:solidFill>
+                <a:latin typeface="Consolas"/>
+              </a:defRPr>
+            </a:pPr>
+            <a:r>
+              <a:t>  │  small   ║                     ║</a:t>
+            </a:r>
+          </a:p>
+          <a:p>
+            <a:pPr>
+              <a:spcAft>
+                <a:spcPts val="400"/>
+              </a:spcAft>
+              <a:defRPr sz="1400">
+                <a:solidFill>
+                  <a:srgbClr val="58A6FF"/>
+                </a:solidFill>
+                <a:latin typeface="Consolas"/>
+              </a:defRPr>
+            </a:pPr>
+            <a:r>
+              <a:t>  │  ║       ║                     ║</a:t>
+            </a:r>
+          </a:p>
+          <a:p>
+            <a:pPr>
+              <a:spcAft>
+                <a:spcPts val="400"/>
+              </a:spcAft>
+              <a:defRPr sz="1400">
+                <a:solidFill>
+                  <a:srgbClr val="8B949E"/>
+                </a:solidFill>
+                <a:latin typeface="Consolas"/>
+              </a:defRPr>
+            </a:pPr>
+            <a:r>
+              <a:t>  ──────────────────────────────────────── cm⁻¹</a:t>
+            </a:r>
+          </a:p>
+          <a:p>
+            <a:pPr>
+              <a:spcAft>
+                <a:spcPts val="400"/>
+              </a:spcAft>
+              <a:defRPr sz="1400">
+                <a:solidFill>
+                  <a:srgbClr val="8B949E"/>
+                </a:solidFill>
+                <a:latin typeface="Consolas"/>
+              </a:defRPr>
+            </a:pPr>
+            <a:r>
+              <a:t>     ν₁      ν₂                   ν₃</a:t>
+            </a:r>
+          </a:p>
+          <a:p>
+            <a:pPr>
+              <a:spcAft>
+                <a:spcPts val="400"/>
+              </a:spcAft>
+              <a:defRPr sz="1400">
+                <a:solidFill>
+                  <a:srgbClr val="8B949E"/>
+                </a:solidFill>
+                <a:latin typeface="Consolas"/>
+              </a:defRPr>
+            </a:pPr>
+            <a:r>
+              <a:t>     bend    sym. stretch      asym. stretch</a:t>
+            </a:r>
+          </a:p>
+          <a:p>
+            <a:pPr>
+              <a:spcAft>
+                <a:spcPts val="400"/>
+              </a:spcAft>
+              <a:defRPr sz="1400">
+                <a:solidFill>
+                  <a:srgbClr val="8B949E"/>
+                </a:solidFill>
+                <a:latin typeface="Consolas"/>
+              </a:defRPr>
+            </a:pPr>
+          </a:p>
+          <a:p>
+            <a:pPr>
+              <a:spcAft>
+                <a:spcPts val="400"/>
+              </a:spcAft>
+              <a:defRPr sz="1400">
+                <a:solidFill>
+                  <a:srgbClr val="C9D1D9"/>
+                </a:solidFill>
+                <a:latin typeface="Consolas"/>
+              </a:defRPr>
+            </a:pPr>
+            <a:r>
+              <a:t>  → Same molecule, same frequencies</a:t>
+            </a:r>
+          </a:p>
+          <a:p>
+            <a:pPr>
+              <a:spcAft>
+                <a:spcPts val="400"/>
+              </a:spcAft>
+              <a:defRPr sz="1400">
+                <a:solidFill>
+                  <a:srgbClr val="C9D1D9"/>
+                </a:solidFill>
+                <a:latin typeface="Consolas"/>
+              </a:defRPr>
+            </a:pPr>
+            <a:r>
+              <a:t>  → Different peak heights because ∂μ/∂Q differs per mode</a:t>
+            </a:r>
+          </a:p>
+          <a:p>
+            <a:pPr>
+              <a:spcAft>
+                <a:spcPts val="400"/>
+              </a:spcAft>
+              <a:defRPr sz="1400">
+                <a:solidFill>
+                  <a:srgbClr val="C9D1D9"/>
+                </a:solidFill>
+                <a:latin typeface="Consolas"/>
+              </a:defRPr>
+            </a:pPr>
+            <a:r>
+              <a:t>  → Asymmetric stretch changes dipole most → tallest peak</a:t>
+            </a:r>
+          </a:p>
+          <a:p>
+            <a:pPr>
+              <a:spcAft>
+                <a:spcPts val="400"/>
+              </a:spcAft>
+              <a:defRPr sz="1400">
+                <a:solidFill>
+                  <a:srgbClr val="8B949E"/>
+                </a:solidFill>
+                <a:latin typeface="Consolas"/>
+              </a:defRPr>
+            </a:pPr>
+          </a:p>
+          <a:p>
+            <a:pPr>
+              <a:spcAft>
+                <a:spcPts val="400"/>
+              </a:spcAft>
+              <a:defRPr sz="1400">
+                <a:solidFill>
+                  <a:srgbClr val="3FB950"/>
+                </a:solidFill>
+                <a:latin typeface="Consolas"/>
+              </a:defRPr>
+            </a:pPr>
+            <a:r>
+              <a:t>  // this is what ML replaces: μ⃗ at every displaced geometry</a:t>
+            </a:r>
+          </a:p>
+        </p:txBody>
+      </p:sp>
+      <p:sp>
+        <p:nvSpPr>
+          <p:cNvPr id="4" name="TextBox 3"/>
+          <p:cNvSpPr txBox="1"/>
+          <p:nvPr/>
+        </p:nvSpPr>
+        <p:spPr>
+          <a:xfrm>
+            <a:off x="914400" y="6263640"/>
+            <a:ext cx="7315200" cy="365760"/>
+          </a:xfrm>
+          <a:prstGeom prst="rect">
+            <a:avLst/>
+          </a:prstGeom>
+          <a:noFill/>
+        </p:spPr>
+        <p:txBody>
+          <a:bodyPr wrap="none">
+            <a:spAutoFit/>
+          </a:bodyPr>
+          <a:lstStyle/>
+          <a:p>
+            <a:pPr algn="ctr">
+              <a:defRPr sz="1100">
+                <a:solidFill>
+                  <a:srgbClr val="8B949E"/>
+                </a:solidFill>
+                <a:latin typeface="Consolas"/>
+              </a:defRPr>
+            </a:pPr>
+            <a:r>
+              <a:t>Manuel Ott · Hofer Lab · 2026-03-11</a:t>
+            </a:r>
+          </a:p>
+        </p:txBody>
+      </p:sp>
+    </p:spTree>
+  </p:cSld>
+  <p:clrMapOvr>
+    <a:masterClrMapping/>
+  </p:clrMapOvr>
+</p:sld>
+</file>
+
 <file path=ppt/slides/slide2.xml><?xml version="1.0" encoding="utf-8"?>
 <p:sld xmlns:a="http://schemas.openxmlformats.org/drawingml/2006/main" xmlns:p="http://schemas.openxmlformats.org/presentationml/2006/main" xmlns:r="http://schemas.openxmlformats.org/officeDocument/2006/relationships">
   <p:cSld>
@@ -5459,7 +5860,7 @@
               </a:defRPr>
             </a:pPr>
             <a:r>
-              <a:t>$ python3 main.py</a:t>
+              <a:t>$ python3 workflow.py</a:t>
             </a:r>
           </a:p>
         </p:txBody>
@@ -5490,7 +5891,7 @@
               <a:spcAft>
                 <a:spcPts val="0"/>
               </a:spcAft>
-              <a:defRPr sz="1000">
+              <a:defRPr sz="1100">
                 <a:solidFill>
                   <a:srgbClr val="3FB950"/>
                 </a:solidFill>
@@ -5506,7 +5907,7 @@
               <a:spcAft>
                 <a:spcPts val="0"/>
               </a:spcAft>
-              <a:defRPr sz="1000">
+              <a:defRPr sz="1100">
                 <a:solidFill>
                   <a:srgbClr val="8B949E"/>
                 </a:solidFill>
@@ -5522,7 +5923,7 @@
               <a:spcAft>
                 <a:spcPts val="0"/>
               </a:spcAft>
-              <a:defRPr sz="1000">
+              <a:defRPr sz="1100">
                 <a:solidFill>
                   <a:srgbClr val="8B949E"/>
                 </a:solidFill>
@@ -5538,7 +5939,7 @@
               <a:spcAft>
                 <a:spcPts val="0"/>
               </a:spcAft>
-              <a:defRPr sz="1000">
+              <a:defRPr sz="1100">
                 <a:solidFill>
                   <a:srgbClr val="58A6FF"/>
                 </a:solidFill>
@@ -5554,7 +5955,7 @@
               <a:spcAft>
                 <a:spcPts val="0"/>
               </a:spcAft>
-              <a:defRPr sz="1000">
+              <a:defRPr sz="1100">
                 <a:solidFill>
                   <a:srgbClr val="8B949E"/>
                 </a:solidFill>
@@ -5570,7 +5971,7 @@
               <a:spcAft>
                 <a:spcPts val="0"/>
               </a:spcAft>
-              <a:defRPr sz="1000">
+              <a:defRPr sz="1100">
                 <a:solidFill>
                   <a:srgbClr val="8B949E"/>
                 </a:solidFill>
@@ -5586,7 +5987,7 @@
               <a:spcAft>
                 <a:spcPts val="0"/>
               </a:spcAft>
-              <a:defRPr sz="1000">
+              <a:defRPr sz="1100">
                 <a:solidFill>
                   <a:srgbClr val="8B949E"/>
                 </a:solidFill>
@@ -5602,7 +6003,7 @@
               <a:spcAft>
                 <a:spcPts val="0"/>
               </a:spcAft>
-              <a:defRPr sz="1000">
+              <a:defRPr sz="1100">
                 <a:solidFill>
                   <a:srgbClr val="8B949E"/>
                 </a:solidFill>
@@ -5618,7 +6019,7 @@
               <a:spcAft>
                 <a:spcPts val="0"/>
               </a:spcAft>
-              <a:defRPr sz="1000">
+              <a:defRPr sz="1100">
                 <a:solidFill>
                   <a:srgbClr val="58A6FF"/>
                 </a:solidFill>
@@ -5634,7 +6035,7 @@
               <a:spcAft>
                 <a:spcPts val="0"/>
               </a:spcAft>
-              <a:defRPr sz="1000">
+              <a:defRPr sz="1100">
                 <a:solidFill>
                   <a:srgbClr val="8B949E"/>
                 </a:solidFill>
@@ -5650,7 +6051,7 @@
               <a:spcAft>
                 <a:spcPts val="0"/>
               </a:spcAft>
-              <a:defRPr sz="1000">
+              <a:defRPr sz="1100">
                 <a:solidFill>
                   <a:srgbClr val="8B949E"/>
                 </a:solidFill>
@@ -5666,7 +6067,7 @@
               <a:spcAft>
                 <a:spcPts val="0"/>
               </a:spcAft>
-              <a:defRPr sz="1000">
+              <a:defRPr sz="1100">
                 <a:solidFill>
                   <a:srgbClr val="8B949E"/>
                 </a:solidFill>
@@ -5682,7 +6083,7 @@
               <a:spcAft>
                 <a:spcPts val="0"/>
               </a:spcAft>
-              <a:defRPr sz="1000">
+              <a:defRPr sz="1100">
                 <a:solidFill>
                   <a:srgbClr val="8B949E"/>
                 </a:solidFill>
@@ -5698,7 +6099,7 @@
               <a:spcAft>
                 <a:spcPts val="0"/>
               </a:spcAft>
-              <a:defRPr sz="1000">
+              <a:defRPr sz="1100">
                 <a:solidFill>
                   <a:srgbClr val="8B949E"/>
                 </a:solidFill>
@@ -5714,7 +6115,7 @@
               <a:spcAft>
                 <a:spcPts val="0"/>
               </a:spcAft>
-              <a:defRPr sz="1000">
+              <a:defRPr sz="1100">
                 <a:solidFill>
                   <a:srgbClr val="8B949E"/>
                 </a:solidFill>
@@ -5730,7 +6131,7 @@
               <a:spcAft>
                 <a:spcPts val="0"/>
               </a:spcAft>
-              <a:defRPr sz="1000">
+              <a:defRPr sz="1100">
                 <a:solidFill>
                   <a:srgbClr val="8B949E"/>
                 </a:solidFill>
@@ -5746,7 +6147,7 @@
               <a:spcAft>
                 <a:spcPts val="0"/>
               </a:spcAft>
-              <a:defRPr sz="1000">
+              <a:defRPr sz="1100">
                 <a:solidFill>
                   <a:srgbClr val="8B949E"/>
                 </a:solidFill>
@@ -5762,7 +6163,7 @@
               <a:spcAft>
                 <a:spcPts val="0"/>
               </a:spcAft>
-              <a:defRPr sz="1000">
+              <a:defRPr sz="1100">
                 <a:solidFill>
                   <a:srgbClr val="8B949E"/>
                 </a:solidFill>
@@ -5778,7 +6179,7 @@
               <a:spcAft>
                 <a:spcPts val="0"/>
               </a:spcAft>
-              <a:defRPr sz="1000">
+              <a:defRPr sz="1100">
                 <a:solidFill>
                   <a:srgbClr val="8B949E"/>
                 </a:solidFill>
@@ -5794,7 +6195,7 @@
               <a:spcAft>
                 <a:spcPts val="0"/>
               </a:spcAft>
-              <a:defRPr sz="1000">
+              <a:defRPr sz="1100">
                 <a:solidFill>
                   <a:srgbClr val="8B949E"/>
                 </a:solidFill>
@@ -5810,7 +6211,7 @@
               <a:spcAft>
                 <a:spcPts val="0"/>
               </a:spcAft>
-              <a:defRPr sz="1000">
+              <a:defRPr sz="1100">
                 <a:solidFill>
                   <a:srgbClr val="58A6FF"/>
                 </a:solidFill>
@@ -5826,7 +6227,7 @@
               <a:spcAft>
                 <a:spcPts val="0"/>
               </a:spcAft>
-              <a:defRPr sz="1000">
+              <a:defRPr sz="1100">
                 <a:solidFill>
                   <a:srgbClr val="8B949E"/>
                 </a:solidFill>
@@ -5842,7 +6243,7 @@
               <a:spcAft>
                 <a:spcPts val="0"/>
               </a:spcAft>
-              <a:defRPr sz="1000">
+              <a:defRPr sz="1100">
                 <a:solidFill>
                   <a:srgbClr val="8B949E"/>
                 </a:solidFill>
@@ -5858,7 +6259,7 @@
               <a:spcAft>
                 <a:spcPts val="0"/>
               </a:spcAft>
-              <a:defRPr sz="1000">
+              <a:defRPr sz="1100">
                 <a:solidFill>
                   <a:srgbClr val="3FB950"/>
                 </a:solidFill>
@@ -5964,7 +6365,7 @@
               </a:defRPr>
             </a:pPr>
             <a:r>
-              <a:t>$ cat dipole_methods.md</a:t>
+              <a:t>$ ls -l calculators/</a:t>
             </a:r>
           </a:p>
         </p:txBody>
@@ -6472,7 +6873,7 @@
               </a:defRPr>
             </a:pPr>
             <a:r>
-              <a:t># Energy calculators</a:t>
+              <a:t># Energy calculators (PES)</a:t>
             </a:r>
           </a:p>
           <a:p>
@@ -6482,14 +6883,11 @@
               </a:spcAft>
               <a:defRPr sz="1300">
                 <a:solidFill>
-                  <a:srgbClr val="C9D1D9"/>
-                </a:solidFill>
-                <a:latin typeface="Consolas"/>
-              </a:defRPr>
-            </a:pPr>
-            <a:r>
-              <a:t>  MACE-OMOL-0  molecules, default</a:t>
-            </a:r>
+                  <a:srgbClr val="8B949E"/>
+                </a:solidFill>
+                <a:latin typeface="Consolas"/>
+              </a:defRPr>
+            </a:pPr>
           </a:p>
           <a:p>
             <a:pPr>
@@ -6498,13 +6896,13 @@
               </a:spcAft>
               <a:defRPr sz="1300">
                 <a:solidFill>
-                  <a:srgbClr val="C9D1D9"/>
-                </a:solidFill>
-                <a:latin typeface="Consolas"/>
-              </a:defRPr>
-            </a:pPr>
-            <a:r>
-              <a:t>  MACE-MP-0    universal (130 el.)</a:t>
+                  <a:srgbClr val="3FB950"/>
+                </a:solidFill>
+                <a:latin typeface="Consolas"/>
+              </a:defRPr>
+            </a:pPr>
+            <a:r>
+              <a:t>  MACE-OMOL-0   molecules, default</a:t>
             </a:r>
           </a:p>
           <a:p>
@@ -6514,13 +6912,13 @@
               </a:spcAft>
               <a:defRPr sz="1300">
                 <a:solidFill>
-                  <a:srgbClr val="C9D1D9"/>
-                </a:solidFill>
-                <a:latin typeface="Consolas"/>
-              </a:defRPr>
-            </a:pPr>
-            <a:r>
-              <a:t>  MACE-OFF     organic molecules</a:t>
+                  <a:srgbClr val="3FB950"/>
+                </a:solidFill>
+                <a:latin typeface="Consolas"/>
+              </a:defRPr>
+            </a:pPr>
+            <a:r>
+              <a:t>  MACE-MP-0     universal (130 el.)</a:t>
             </a:r>
           </a:p>
           <a:p>
@@ -6530,13 +6928,58 @@
               </a:spcAft>
               <a:defRPr sz="1300">
                 <a:solidFill>
-                  <a:srgbClr val="C9D1D9"/>
-                </a:solidFill>
-                <a:latin typeface="Consolas"/>
-              </a:defRPr>
-            </a:pPr>
-            <a:r>
-              <a:t>  MACE-ANI     organic H,C,N,O,S,F</a:t>
+                  <a:srgbClr val="3FB950"/>
+                </a:solidFill>
+                <a:latin typeface="Consolas"/>
+              </a:defRPr>
+            </a:pPr>
+            <a:r>
+              <a:t>  MACE-OFF      organic molecules</a:t>
+            </a:r>
+          </a:p>
+          <a:p>
+            <a:pPr>
+              <a:spcAft>
+                <a:spcPts val="300"/>
+              </a:spcAft>
+              <a:defRPr sz="1300">
+                <a:solidFill>
+                  <a:srgbClr val="3FB950"/>
+                </a:solidFill>
+                <a:latin typeface="Consolas"/>
+              </a:defRPr>
+            </a:pPr>
+            <a:r>
+              <a:t>  MACE-ANI-CC   organic (CC training data)</a:t>
+            </a:r>
+          </a:p>
+          <a:p>
+            <a:pPr>
+              <a:spcAft>
+                <a:spcPts val="300"/>
+              </a:spcAft>
+              <a:defRPr sz="1300">
+                <a:solidFill>
+                  <a:srgbClr val="8B949E"/>
+                </a:solidFill>
+                <a:latin typeface="Consolas"/>
+              </a:defRPr>
+            </a:pPr>
+          </a:p>
+          <a:p>
+            <a:pPr>
+              <a:spcAft>
+                <a:spcPts val="300"/>
+              </a:spcAft>
+              <a:defRPr sz="1300">
+                <a:solidFill>
+                  <a:srgbClr val="C9D1D9"/>
+                </a:solidFill>
+                <a:latin typeface="Consolas"/>
+              </a:defRPr>
+            </a:pPr>
+            <a:r>
+              <a:t>  → 4 energy × 2 dipole = 8 combos</a:t>
             </a:r>
           </a:p>
         </p:txBody>

</xml_diff>

<commit_message>
feat(slides): architecture 14pt centered, remove bonus IR diagram slide
Co-Authored-By: Claude Opus 4.6 <noreply@anthropic.com>
</commit_message>
<xml_diff>
--- a/presentation/presentation_v2.pptx
+++ b/presentation/presentation_v2.pptx
@@ -18,7 +18,6 @@
     <p:sldId id="266" r:id="rId17"/>
     <p:sldId id="267" r:id="rId18"/>
     <p:sldId id="268" r:id="rId19"/>
-    <p:sldId id="269" r:id="rId20"/>
   </p:sldIdLst>
   <p:sldSz cx="9144000" cy="6858000" type="screen4x3"/>
   <p:notesSz cx="6858000" cy="9144000"/>
@@ -4669,406 +4668,6 @@
 </p:sld>
 </file>
 
-<file path=ppt/slides/slide14.xml><?xml version="1.0" encoding="utf-8"?>
-<p:sld xmlns:a="http://schemas.openxmlformats.org/drawingml/2006/main" xmlns:p="http://schemas.openxmlformats.org/presentationml/2006/main" xmlns:r="http://schemas.openxmlformats.org/officeDocument/2006/relationships">
-  <p:cSld>
-    <p:bg>
-      <p:bgPr>
-        <a:solidFill>
-          <a:srgbClr val="0D1117"/>
-        </a:solidFill>
-        <a:effectLst/>
-      </p:bgPr>
-    </p:bg>
-    <p:spTree>
-      <p:nvGrpSpPr>
-        <p:cNvPr id="1" name=""/>
-        <p:cNvGrpSpPr/>
-        <p:nvPr/>
-      </p:nvGrpSpPr>
-      <p:grpSpPr/>
-      <p:sp>
-        <p:nvSpPr>
-          <p:cNvPr id="2" name="TextBox 1"/>
-          <p:cNvSpPr txBox="1"/>
-          <p:nvPr/>
-        </p:nvSpPr>
-        <p:spPr>
-          <a:xfrm>
-            <a:off x="457200" y="320040"/>
-            <a:ext cx="8229600" cy="548640"/>
-          </a:xfrm>
-          <a:prstGeom prst="rect">
-            <a:avLst/>
-          </a:prstGeom>
-          <a:noFill/>
-        </p:spPr>
-        <p:txBody>
-          <a:bodyPr wrap="none">
-            <a:spAutoFit/>
-          </a:bodyPr>
-          <a:lstStyle/>
-          <a:p>
-            <a:pPr>
-              <a:defRPr sz="2800" b="1">
-                <a:solidFill>
-                  <a:srgbClr val="58A6FF"/>
-                </a:solidFill>
-                <a:latin typeface="Consolas"/>
-              </a:defRPr>
-            </a:pPr>
-            <a:r>
-              <a:t>$ cat ir_intensity.md  # idea — for IR theory slide?</a:t>
-            </a:r>
-          </a:p>
-        </p:txBody>
-      </p:sp>
-      <p:sp>
-        <p:nvSpPr>
-          <p:cNvPr id="3" name="TextBox 2"/>
-          <p:cNvSpPr txBox="1"/>
-          <p:nvPr/>
-        </p:nvSpPr>
-        <p:spPr>
-          <a:xfrm>
-            <a:off x="685800" y="1051560"/>
-            <a:ext cx="7772400" cy="4937760"/>
-          </a:xfrm>
-          <a:prstGeom prst="rect">
-            <a:avLst/>
-          </a:prstGeom>
-          <a:noFill/>
-        </p:spPr>
-        <p:txBody>
-          <a:bodyPr wrap="square">
-            <a:spAutoFit/>
-          </a:bodyPr>
-          <a:lstStyle/>
-          <a:p>
-            <a:pPr>
-              <a:spcAft>
-                <a:spcPts val="400"/>
-              </a:spcAft>
-              <a:defRPr sz="1400">
-                <a:solidFill>
-                  <a:srgbClr val="58A6FF"/>
-                </a:solidFill>
-                <a:latin typeface="Consolas"/>
-              </a:defRPr>
-            </a:pPr>
-            <a:r>
-              <a:t>  Intensity ∝ |∂μ/∂Q|²</a:t>
-            </a:r>
-          </a:p>
-          <a:p>
-            <a:pPr>
-              <a:spcAft>
-                <a:spcPts val="400"/>
-              </a:spcAft>
-              <a:defRPr sz="1400">
-                <a:solidFill>
-                  <a:srgbClr val="8B949E"/>
-                </a:solidFill>
-                <a:latin typeface="Consolas"/>
-              </a:defRPr>
-            </a:pPr>
-          </a:p>
-          <a:p>
-            <a:pPr>
-              <a:spcAft>
-                <a:spcPts val="400"/>
-              </a:spcAft>
-              <a:defRPr sz="1400">
-                <a:solidFill>
-                  <a:srgbClr val="C9D1D9"/>
-                </a:solidFill>
-                <a:latin typeface="Consolas"/>
-              </a:defRPr>
-            </a:pPr>
-            <a:r>
-              <a:t>  │                                large ∂μ/∂Q</a:t>
-            </a:r>
-          </a:p>
-          <a:p>
-            <a:pPr>
-              <a:spcAft>
-                <a:spcPts val="400"/>
-              </a:spcAft>
-              <a:defRPr sz="1400">
-                <a:solidFill>
-                  <a:srgbClr val="58A6FF"/>
-                </a:solidFill>
-                <a:latin typeface="Consolas"/>
-              </a:defRPr>
-            </a:pPr>
-            <a:r>
-              <a:t>  │                                ║</a:t>
-            </a:r>
-          </a:p>
-          <a:p>
-            <a:pPr>
-              <a:spcAft>
-                <a:spcPts val="400"/>
-              </a:spcAft>
-              <a:defRPr sz="1400">
-                <a:solidFill>
-                  <a:srgbClr val="C9D1D9"/>
-                </a:solidFill>
-                <a:latin typeface="Consolas"/>
-              </a:defRPr>
-            </a:pPr>
-            <a:r>
-              <a:t>  │          medium                ║</a:t>
-            </a:r>
-          </a:p>
-          <a:p>
-            <a:pPr>
-              <a:spcAft>
-                <a:spcPts val="400"/>
-              </a:spcAft>
-              <a:defRPr sz="1400">
-                <a:solidFill>
-                  <a:srgbClr val="58A6FF"/>
-                </a:solidFill>
-                <a:latin typeface="Consolas"/>
-              </a:defRPr>
-            </a:pPr>
-            <a:r>
-              <a:t>  │          ║                     ║</a:t>
-            </a:r>
-          </a:p>
-          <a:p>
-            <a:pPr>
-              <a:spcAft>
-                <a:spcPts val="400"/>
-              </a:spcAft>
-              <a:defRPr sz="1400">
-                <a:solidFill>
-                  <a:srgbClr val="58A6FF"/>
-                </a:solidFill>
-                <a:latin typeface="Consolas"/>
-              </a:defRPr>
-            </a:pPr>
-            <a:r>
-              <a:t>  │          ║                     ║</a:t>
-            </a:r>
-          </a:p>
-          <a:p>
-            <a:pPr>
-              <a:spcAft>
-                <a:spcPts val="400"/>
-              </a:spcAft>
-              <a:defRPr sz="1400">
-                <a:solidFill>
-                  <a:srgbClr val="C9D1D9"/>
-                </a:solidFill>
-                <a:latin typeface="Consolas"/>
-              </a:defRPr>
-            </a:pPr>
-            <a:r>
-              <a:t>  │  small   ║                     ║</a:t>
-            </a:r>
-          </a:p>
-          <a:p>
-            <a:pPr>
-              <a:spcAft>
-                <a:spcPts val="400"/>
-              </a:spcAft>
-              <a:defRPr sz="1400">
-                <a:solidFill>
-                  <a:srgbClr val="58A6FF"/>
-                </a:solidFill>
-                <a:latin typeface="Consolas"/>
-              </a:defRPr>
-            </a:pPr>
-            <a:r>
-              <a:t>  │  ║       ║                     ║</a:t>
-            </a:r>
-          </a:p>
-          <a:p>
-            <a:pPr>
-              <a:spcAft>
-                <a:spcPts val="400"/>
-              </a:spcAft>
-              <a:defRPr sz="1400">
-                <a:solidFill>
-                  <a:srgbClr val="8B949E"/>
-                </a:solidFill>
-                <a:latin typeface="Consolas"/>
-              </a:defRPr>
-            </a:pPr>
-            <a:r>
-              <a:t>  ──────────────────────────────────────── cm⁻¹</a:t>
-            </a:r>
-          </a:p>
-          <a:p>
-            <a:pPr>
-              <a:spcAft>
-                <a:spcPts val="400"/>
-              </a:spcAft>
-              <a:defRPr sz="1400">
-                <a:solidFill>
-                  <a:srgbClr val="8B949E"/>
-                </a:solidFill>
-                <a:latin typeface="Consolas"/>
-              </a:defRPr>
-            </a:pPr>
-            <a:r>
-              <a:t>     ν₁      ν₂                   ν₃</a:t>
-            </a:r>
-          </a:p>
-          <a:p>
-            <a:pPr>
-              <a:spcAft>
-                <a:spcPts val="400"/>
-              </a:spcAft>
-              <a:defRPr sz="1400">
-                <a:solidFill>
-                  <a:srgbClr val="8B949E"/>
-                </a:solidFill>
-                <a:latin typeface="Consolas"/>
-              </a:defRPr>
-            </a:pPr>
-            <a:r>
-              <a:t>     bend    sym. stretch      asym. stretch</a:t>
-            </a:r>
-          </a:p>
-          <a:p>
-            <a:pPr>
-              <a:spcAft>
-                <a:spcPts val="400"/>
-              </a:spcAft>
-              <a:defRPr sz="1400">
-                <a:solidFill>
-                  <a:srgbClr val="8B949E"/>
-                </a:solidFill>
-                <a:latin typeface="Consolas"/>
-              </a:defRPr>
-            </a:pPr>
-          </a:p>
-          <a:p>
-            <a:pPr>
-              <a:spcAft>
-                <a:spcPts val="400"/>
-              </a:spcAft>
-              <a:defRPr sz="1400">
-                <a:solidFill>
-                  <a:srgbClr val="C9D1D9"/>
-                </a:solidFill>
-                <a:latin typeface="Consolas"/>
-              </a:defRPr>
-            </a:pPr>
-            <a:r>
-              <a:t>  → Same molecule, same frequencies</a:t>
-            </a:r>
-          </a:p>
-          <a:p>
-            <a:pPr>
-              <a:spcAft>
-                <a:spcPts val="400"/>
-              </a:spcAft>
-              <a:defRPr sz="1400">
-                <a:solidFill>
-                  <a:srgbClr val="C9D1D9"/>
-                </a:solidFill>
-                <a:latin typeface="Consolas"/>
-              </a:defRPr>
-            </a:pPr>
-            <a:r>
-              <a:t>  → Different peak heights because ∂μ/∂Q differs per mode</a:t>
-            </a:r>
-          </a:p>
-          <a:p>
-            <a:pPr>
-              <a:spcAft>
-                <a:spcPts val="400"/>
-              </a:spcAft>
-              <a:defRPr sz="1400">
-                <a:solidFill>
-                  <a:srgbClr val="C9D1D9"/>
-                </a:solidFill>
-                <a:latin typeface="Consolas"/>
-              </a:defRPr>
-            </a:pPr>
-            <a:r>
-              <a:t>  → Asymmetric stretch changes dipole most → tallest peak</a:t>
-            </a:r>
-          </a:p>
-          <a:p>
-            <a:pPr>
-              <a:spcAft>
-                <a:spcPts val="400"/>
-              </a:spcAft>
-              <a:defRPr sz="1400">
-                <a:solidFill>
-                  <a:srgbClr val="8B949E"/>
-                </a:solidFill>
-                <a:latin typeface="Consolas"/>
-              </a:defRPr>
-            </a:pPr>
-          </a:p>
-          <a:p>
-            <a:pPr>
-              <a:spcAft>
-                <a:spcPts val="400"/>
-              </a:spcAft>
-              <a:defRPr sz="1400">
-                <a:solidFill>
-                  <a:srgbClr val="3FB950"/>
-                </a:solidFill>
-                <a:latin typeface="Consolas"/>
-              </a:defRPr>
-            </a:pPr>
-            <a:r>
-              <a:t>  // this is what ML replaces: μ⃗ at every displaced geometry</a:t>
-            </a:r>
-          </a:p>
-        </p:txBody>
-      </p:sp>
-      <p:sp>
-        <p:nvSpPr>
-          <p:cNvPr id="4" name="TextBox 3"/>
-          <p:cNvSpPr txBox="1"/>
-          <p:nvPr/>
-        </p:nvSpPr>
-        <p:spPr>
-          <a:xfrm>
-            <a:off x="914400" y="6263640"/>
-            <a:ext cx="7315200" cy="365760"/>
-          </a:xfrm>
-          <a:prstGeom prst="rect">
-            <a:avLst/>
-          </a:prstGeom>
-          <a:noFill/>
-        </p:spPr>
-        <p:txBody>
-          <a:bodyPr wrap="none">
-            <a:spAutoFit/>
-          </a:bodyPr>
-          <a:lstStyle/>
-          <a:p>
-            <a:pPr algn="ctr">
-              <a:defRPr sz="1100">
-                <a:solidFill>
-                  <a:srgbClr val="8B949E"/>
-                </a:solidFill>
-                <a:latin typeface="Consolas"/>
-              </a:defRPr>
-            </a:pPr>
-            <a:r>
-              <a:t>Manuel Ott · Hofer Lab · 2026-03-11</a:t>
-            </a:r>
-          </a:p>
-        </p:txBody>
-      </p:sp>
-    </p:spTree>
-  </p:cSld>
-  <p:clrMapOvr>
-    <a:masterClrMapping/>
-  </p:clrMapOvr>
-</p:sld>
-</file>
-
 <file path=ppt/slides/slide2.xml><?xml version="1.0" encoding="utf-8"?>
 <p:sld xmlns:a="http://schemas.openxmlformats.org/drawingml/2006/main" xmlns:p="http://schemas.openxmlformats.org/presentationml/2006/main" xmlns:r="http://schemas.openxmlformats.org/officeDocument/2006/relationships">
   <p:cSld>
@@ -5873,8 +5472,8 @@
         </p:nvSpPr>
         <p:spPr>
           <a:xfrm>
-            <a:off x="274320" y="1051560"/>
-            <a:ext cx="8595360" cy="4937760"/>
+            <a:off x="91440" y="1051560"/>
+            <a:ext cx="8961120" cy="4937760"/>
           </a:xfrm>
           <a:prstGeom prst="rect">
             <a:avLst/>
@@ -5887,11 +5486,11 @@
           </a:bodyPr>
           <a:lstStyle/>
           <a:p>
-            <a:pPr>
+            <a:pPr algn="ctr">
               <a:spcAft>
                 <a:spcPts val="0"/>
               </a:spcAft>
-              <a:defRPr sz="1100">
+              <a:defRPr sz="1400">
                 <a:solidFill>
                   <a:srgbClr val="3FB950"/>
                 </a:solidFill>
@@ -5903,11 +5502,11 @@
             </a:r>
           </a:p>
           <a:p>
-            <a:pPr>
+            <a:pPr algn="ctr">
               <a:spcAft>
                 <a:spcPts val="0"/>
               </a:spcAft>
-              <a:defRPr sz="1100">
+              <a:defRPr sz="1400">
                 <a:solidFill>
                   <a:srgbClr val="8B949E"/>
                 </a:solidFill>
@@ -5919,11 +5518,11 @@
             </a:r>
           </a:p>
           <a:p>
-            <a:pPr>
+            <a:pPr algn="ctr">
               <a:spcAft>
                 <a:spcPts val="0"/>
               </a:spcAft>
-              <a:defRPr sz="1100">
+              <a:defRPr sz="1400">
                 <a:solidFill>
                   <a:srgbClr val="8B949E"/>
                 </a:solidFill>
@@ -5935,11 +5534,11 @@
             </a:r>
           </a:p>
           <a:p>
-            <a:pPr>
+            <a:pPr algn="ctr">
               <a:spcAft>
                 <a:spcPts val="0"/>
               </a:spcAft>
-              <a:defRPr sz="1100">
+              <a:defRPr sz="1400">
                 <a:solidFill>
                   <a:srgbClr val="58A6FF"/>
                 </a:solidFill>
@@ -5951,11 +5550,11 @@
             </a:r>
           </a:p>
           <a:p>
-            <a:pPr>
+            <a:pPr algn="ctr">
               <a:spcAft>
                 <a:spcPts val="0"/>
               </a:spcAft>
-              <a:defRPr sz="1100">
+              <a:defRPr sz="1400">
                 <a:solidFill>
                   <a:srgbClr val="8B949E"/>
                 </a:solidFill>
@@ -5967,11 +5566,11 @@
             </a:r>
           </a:p>
           <a:p>
-            <a:pPr>
+            <a:pPr algn="ctr">
               <a:spcAft>
                 <a:spcPts val="0"/>
               </a:spcAft>
-              <a:defRPr sz="1100">
+              <a:defRPr sz="1400">
                 <a:solidFill>
                   <a:srgbClr val="8B949E"/>
                 </a:solidFill>
@@ -5983,11 +5582,11 @@
             </a:r>
           </a:p>
           <a:p>
-            <a:pPr>
+            <a:pPr algn="ctr">
               <a:spcAft>
                 <a:spcPts val="0"/>
               </a:spcAft>
-              <a:defRPr sz="1100">
+              <a:defRPr sz="1400">
                 <a:solidFill>
                   <a:srgbClr val="8B949E"/>
                 </a:solidFill>
@@ -5999,11 +5598,11 @@
             </a:r>
           </a:p>
           <a:p>
-            <a:pPr>
+            <a:pPr algn="ctr">
               <a:spcAft>
                 <a:spcPts val="0"/>
               </a:spcAft>
-              <a:defRPr sz="1100">
+              <a:defRPr sz="1400">
                 <a:solidFill>
                   <a:srgbClr val="8B949E"/>
                 </a:solidFill>
@@ -6015,11 +5614,11 @@
             </a:r>
           </a:p>
           <a:p>
-            <a:pPr>
+            <a:pPr algn="ctr">
               <a:spcAft>
                 <a:spcPts val="0"/>
               </a:spcAft>
-              <a:defRPr sz="1100">
+              <a:defRPr sz="1400">
                 <a:solidFill>
                   <a:srgbClr val="58A6FF"/>
                 </a:solidFill>
@@ -6031,11 +5630,11 @@
             </a:r>
           </a:p>
           <a:p>
-            <a:pPr>
+            <a:pPr algn="ctr">
               <a:spcAft>
                 <a:spcPts val="0"/>
               </a:spcAft>
-              <a:defRPr sz="1100">
+              <a:defRPr sz="1400">
                 <a:solidFill>
                   <a:srgbClr val="8B949E"/>
                 </a:solidFill>
@@ -6047,11 +5646,11 @@
             </a:r>
           </a:p>
           <a:p>
-            <a:pPr>
+            <a:pPr algn="ctr">
               <a:spcAft>
                 <a:spcPts val="0"/>
               </a:spcAft>
-              <a:defRPr sz="1100">
+              <a:defRPr sz="1400">
                 <a:solidFill>
                   <a:srgbClr val="8B949E"/>
                 </a:solidFill>
@@ -6063,11 +5662,11 @@
             </a:r>
           </a:p>
           <a:p>
-            <a:pPr>
+            <a:pPr algn="ctr">
               <a:spcAft>
                 <a:spcPts val="0"/>
               </a:spcAft>
-              <a:defRPr sz="1100">
+              <a:defRPr sz="1400">
                 <a:solidFill>
                   <a:srgbClr val="8B949E"/>
                 </a:solidFill>
@@ -6079,11 +5678,11 @@
             </a:r>
           </a:p>
           <a:p>
-            <a:pPr>
+            <a:pPr algn="ctr">
               <a:spcAft>
                 <a:spcPts val="0"/>
               </a:spcAft>
-              <a:defRPr sz="1100">
+              <a:defRPr sz="1400">
                 <a:solidFill>
                   <a:srgbClr val="8B949E"/>
                 </a:solidFill>
@@ -6095,11 +5694,11 @@
             </a:r>
           </a:p>
           <a:p>
-            <a:pPr>
+            <a:pPr algn="ctr">
               <a:spcAft>
                 <a:spcPts val="0"/>
               </a:spcAft>
-              <a:defRPr sz="1100">
+              <a:defRPr sz="1400">
                 <a:solidFill>
                   <a:srgbClr val="8B949E"/>
                 </a:solidFill>
@@ -6111,11 +5710,11 @@
             </a:r>
           </a:p>
           <a:p>
-            <a:pPr>
+            <a:pPr algn="ctr">
               <a:spcAft>
                 <a:spcPts val="0"/>
               </a:spcAft>
-              <a:defRPr sz="1100">
+              <a:defRPr sz="1400">
                 <a:solidFill>
                   <a:srgbClr val="8B949E"/>
                 </a:solidFill>
@@ -6127,11 +5726,11 @@
             </a:r>
           </a:p>
           <a:p>
-            <a:pPr>
+            <a:pPr algn="ctr">
               <a:spcAft>
                 <a:spcPts val="0"/>
               </a:spcAft>
-              <a:defRPr sz="1100">
+              <a:defRPr sz="1400">
                 <a:solidFill>
                   <a:srgbClr val="8B949E"/>
                 </a:solidFill>
@@ -6143,11 +5742,11 @@
             </a:r>
           </a:p>
           <a:p>
-            <a:pPr>
+            <a:pPr algn="ctr">
               <a:spcAft>
                 <a:spcPts val="0"/>
               </a:spcAft>
-              <a:defRPr sz="1100">
+              <a:defRPr sz="1400">
                 <a:solidFill>
                   <a:srgbClr val="8B949E"/>
                 </a:solidFill>
@@ -6159,11 +5758,11 @@
             </a:r>
           </a:p>
           <a:p>
-            <a:pPr>
+            <a:pPr algn="ctr">
               <a:spcAft>
                 <a:spcPts val="0"/>
               </a:spcAft>
-              <a:defRPr sz="1100">
+              <a:defRPr sz="1400">
                 <a:solidFill>
                   <a:srgbClr val="8B949E"/>
                 </a:solidFill>
@@ -6175,11 +5774,11 @@
             </a:r>
           </a:p>
           <a:p>
-            <a:pPr>
+            <a:pPr algn="ctr">
               <a:spcAft>
                 <a:spcPts val="0"/>
               </a:spcAft>
-              <a:defRPr sz="1100">
+              <a:defRPr sz="1400">
                 <a:solidFill>
                   <a:srgbClr val="8B949E"/>
                 </a:solidFill>
@@ -6191,11 +5790,11 @@
             </a:r>
           </a:p>
           <a:p>
-            <a:pPr>
+            <a:pPr algn="ctr">
               <a:spcAft>
                 <a:spcPts val="0"/>
               </a:spcAft>
-              <a:defRPr sz="1100">
+              <a:defRPr sz="1400">
                 <a:solidFill>
                   <a:srgbClr val="8B949E"/>
                 </a:solidFill>
@@ -6207,11 +5806,11 @@
             </a:r>
           </a:p>
           <a:p>
-            <a:pPr>
+            <a:pPr algn="ctr">
               <a:spcAft>
                 <a:spcPts val="0"/>
               </a:spcAft>
-              <a:defRPr sz="1100">
+              <a:defRPr sz="1400">
                 <a:solidFill>
                   <a:srgbClr val="58A6FF"/>
                 </a:solidFill>
@@ -6223,11 +5822,11 @@
             </a:r>
           </a:p>
           <a:p>
-            <a:pPr>
+            <a:pPr algn="ctr">
               <a:spcAft>
                 <a:spcPts val="0"/>
               </a:spcAft>
-              <a:defRPr sz="1100">
+              <a:defRPr sz="1400">
                 <a:solidFill>
                   <a:srgbClr val="8B949E"/>
                 </a:solidFill>
@@ -6239,11 +5838,11 @@
             </a:r>
           </a:p>
           <a:p>
-            <a:pPr>
+            <a:pPr algn="ctr">
               <a:spcAft>
                 <a:spcPts val="0"/>
               </a:spcAft>
-              <a:defRPr sz="1100">
+              <a:defRPr sz="1400">
                 <a:solidFill>
                   <a:srgbClr val="8B949E"/>
                 </a:solidFill>
@@ -6255,11 +5854,11 @@
             </a:r>
           </a:p>
           <a:p>
-            <a:pPr>
+            <a:pPr algn="ctr">
               <a:spcAft>
                 <a:spcPts val="0"/>
               </a:spcAft>
-              <a:defRPr sz="1100">
+              <a:defRPr sz="1400">
                 <a:solidFill>
                   <a:srgbClr val="3FB950"/>
                 </a:solidFill>

</xml_diff>

<commit_message>
feat(slides): ZMQ bridge — ASCII box diagram with External keyword explanation
Co-Authored-By: Claude Opus 4.6 <noreply@anthropic.com>
</commit_message>
<xml_diff>
--- a/presentation/presentation_v2.pptx
+++ b/presentation/presentation_v2.pptx
@@ -6689,8 +6689,8 @@
         </p:nvSpPr>
         <p:spPr>
           <a:xfrm>
-            <a:off x="685800" y="1051560"/>
-            <a:ext cx="7772400" cy="4937760"/>
+            <a:off x="457200" y="1051560"/>
+            <a:ext cx="8229600" cy="1097280"/>
           </a:xfrm>
           <a:prstGeom prst="rect">
             <a:avLst/>
@@ -6705,9 +6705,9 @@
           <a:p>
             <a:pPr>
               <a:spcAft>
-                <a:spcPts val="400"/>
-              </a:spcAft>
-              <a:defRPr sz="1400">
+                <a:spcPts val="200"/>
+              </a:spcAft>
+              <a:defRPr sz="1300">
                 <a:solidFill>
                   <a:srgbClr val="58A6FF"/>
                 </a:solidFill>
@@ -6715,15 +6715,15 @@
               </a:defRPr>
             </a:pPr>
             <a:r>
-              <a:t># Problem</a:t>
-            </a:r>
-          </a:p>
-          <a:p>
-            <a:pPr>
-              <a:spcAft>
-                <a:spcPts val="400"/>
-              </a:spcAft>
-              <a:defRPr sz="1400">
+              <a:t># Gaussian needs E, F, μ⃗ at every displaced geometry — how do we inject ML?</a:t>
+            </a:r>
+          </a:p>
+          <a:p>
+            <a:pPr>
+              <a:spcAft>
+                <a:spcPts val="200"/>
+              </a:spcAft>
+              <a:defRPr sz="1300">
                 <a:solidFill>
                   <a:srgbClr val="C9D1D9"/>
                 </a:solidFill>
@@ -6731,15 +6731,15 @@
               </a:defRPr>
             </a:pPr>
             <a:r>
-              <a:t>  Gaussian needs dipole derivatives for every displaced geometry</a:t>
-            </a:r>
-          </a:p>
-          <a:p>
-            <a:pPr>
-              <a:spcAft>
-                <a:spcPts val="400"/>
-              </a:spcAft>
-              <a:defRPr sz="1400">
+              <a:t>  → Gaussian 'External' keyword: calls an external script per displacement</a:t>
+            </a:r>
+          </a:p>
+          <a:p>
+            <a:pPr>
+              <a:spcAft>
+                <a:spcPts val="200"/>
+              </a:spcAft>
+              <a:defRPr sz="1300">
                 <a:solidFill>
                   <a:srgbClr val="C9D1D9"/>
                 </a:solidFill>
@@ -6747,28 +6747,70 @@
               </a:defRPr>
             </a:pPr>
             <a:r>
-              <a:t>  → DFT dipoles: expensive. This is the bottleneck.</a:t>
-            </a:r>
-          </a:p>
-          <a:p>
-            <a:pPr>
-              <a:spcAft>
-                <a:spcPts val="400"/>
-              </a:spcAft>
-              <a:defRPr sz="1400">
-                <a:solidFill>
-                  <a:srgbClr val="8B949E"/>
-                </a:solidFill>
-                <a:latin typeface="Consolas"/>
-              </a:defRPr>
-            </a:pPr>
-          </a:p>
-          <a:p>
-            <a:pPr>
-              <a:spcAft>
-                <a:spcPts val="400"/>
-              </a:spcAft>
-              <a:defRPr sz="1400">
+              <a:t>  → We intercept this with a ZMQ bridge — no Gaussian modifications needed</a:t>
+            </a:r>
+          </a:p>
+        </p:txBody>
+      </p:sp>
+      <p:sp>
+        <p:nvSpPr>
+          <p:cNvPr id="4" name="TextBox 3"/>
+          <p:cNvSpPr txBox="1"/>
+          <p:nvPr/>
+        </p:nvSpPr>
+        <p:spPr>
+          <a:xfrm>
+            <a:off x="91440" y="2560320"/>
+            <a:ext cx="8961120" cy="3657600"/>
+          </a:xfrm>
+          <a:prstGeom prst="rect">
+            <a:avLst/>
+          </a:prstGeom>
+          <a:noFill/>
+        </p:spPr>
+        <p:txBody>
+          <a:bodyPr wrap="none">
+            <a:spAutoFit/>
+          </a:bodyPr>
+          <a:lstStyle/>
+          <a:p>
+            <a:pPr algn="ctr">
+              <a:spcAft>
+                <a:spcPts val="0"/>
+              </a:spcAft>
+              <a:defRPr sz="1100">
+                <a:solidFill>
+                  <a:srgbClr val="8B949E"/>
+                </a:solidFill>
+                <a:latin typeface="Consolas"/>
+              </a:defRPr>
+            </a:pPr>
+            <a:r>
+              <a:t>  ┌─────────────────────┐                    ┌─────────────────────────────┐</a:t>
+            </a:r>
+          </a:p>
+          <a:p>
+            <a:pPr algn="ctr">
+              <a:spcAft>
+                <a:spcPts val="0"/>
+              </a:spcAft>
+              <a:defRPr sz="1100">
+                <a:solidFill>
+                  <a:srgbClr val="8B949E"/>
+                </a:solidFill>
+                <a:latin typeface="Consolas"/>
+              </a:defRPr>
+            </a:pPr>
+            <a:r>
+              <a:t>  │                     │   displacement #n  │                             │</a:t>
+            </a:r>
+          </a:p>
+          <a:p>
+            <a:pPr algn="ctr">
+              <a:spcAft>
+                <a:spcPts val="0"/>
+              </a:spcAft>
+              <a:defRPr sz="1100">
                 <a:solidFill>
                   <a:srgbClr val="58A6FF"/>
                 </a:solidFill>
@@ -6776,15 +6818,204 @@
               </a:defRPr>
             </a:pPr>
             <a:r>
-              <a:t># Solution: ZMQ bridge</a:t>
-            </a:r>
-          </a:p>
-          <a:p>
-            <a:pPr>
-              <a:spcAft>
-                <a:spcPts val="400"/>
-              </a:spcAft>
-              <a:defRPr sz="1400">
+              <a:t>  │    GAUSSIAN 16      │ ──────────────────→│     gm_helper.py            │</a:t>
+            </a:r>
+          </a:p>
+          <a:p>
+            <a:pPr algn="ctr">
+              <a:spcAft>
+                <a:spcPts val="0"/>
+              </a:spcAft>
+              <a:defRPr sz="1100">
+                <a:solidFill>
+                  <a:srgbClr val="8B949E"/>
+                </a:solidFill>
+                <a:latin typeface="Consolas"/>
+              </a:defRPr>
+            </a:pPr>
+            <a:r>
+              <a:t>  │                     │                    │     (External script)        │</a:t>
+            </a:r>
+          </a:p>
+          <a:p>
+            <a:pPr algn="ctr">
+              <a:spcAft>
+                <a:spcPts val="0"/>
+              </a:spcAft>
+              <a:defRPr sz="1100">
+                <a:solidFill>
+                  <a:srgbClr val="8B949E"/>
+                </a:solidFill>
+                <a:latin typeface="Consolas"/>
+              </a:defRPr>
+            </a:pPr>
+            <a:r>
+              <a:t>  │    freq=anharmonic  │                    └──────────────┬──────────────┘</a:t>
+            </a:r>
+          </a:p>
+          <a:p>
+            <a:pPr algn="ctr">
+              <a:spcAft>
+                <a:spcPts val="0"/>
+              </a:spcAft>
+              <a:defRPr sz="1100">
+                <a:solidFill>
+                  <a:srgbClr val="8B949E"/>
+                </a:solidFill>
+                <a:latin typeface="Consolas"/>
+              </a:defRPr>
+            </a:pPr>
+            <a:r>
+              <a:t>  │    external='...'   │                                   │ ZMQ IPC</a:t>
+            </a:r>
+          </a:p>
+          <a:p>
+            <a:pPr algn="ctr">
+              <a:spcAft>
+                <a:spcPts val="0"/>
+              </a:spcAft>
+              <a:defRPr sz="1100">
+                <a:solidFill>
+                  <a:srgbClr val="8B949E"/>
+                </a:solidFill>
+                <a:latin typeface="Consolas"/>
+              </a:defRPr>
+            </a:pPr>
+            <a:r>
+              <a:t>  │                     │                                   ▼</a:t>
+            </a:r>
+          </a:p>
+          <a:p>
+            <a:pPr algn="ctr">
+              <a:spcAft>
+                <a:spcPts val="0"/>
+              </a:spcAft>
+              <a:defRPr sz="1100">
+                <a:solidFill>
+                  <a:srgbClr val="8B949E"/>
+                </a:solidFill>
+                <a:latin typeface="Consolas"/>
+              </a:defRPr>
+            </a:pPr>
+            <a:r>
+              <a:t>  │                     │                    ┌─────────────────────────────┐</a:t>
+            </a:r>
+          </a:p>
+          <a:p>
+            <a:pPr algn="ctr">
+              <a:spcAft>
+                <a:spcPts val="0"/>
+              </a:spcAft>
+              <a:defRPr sz="1100">
+                <a:solidFill>
+                  <a:srgbClr val="58A6FF"/>
+                </a:solidFill>
+                <a:latin typeface="Consolas"/>
+              </a:defRPr>
+            </a:pPr>
+            <a:r>
+              <a:t>  │                     │                    │     zmq_server.py           │</a:t>
+            </a:r>
+          </a:p>
+          <a:p>
+            <a:pPr algn="ctr">
+              <a:spcAft>
+                <a:spcPts val="0"/>
+              </a:spcAft>
+              <a:defRPr sz="1100">
+                <a:solidFill>
+                  <a:srgbClr val="8B949E"/>
+                </a:solidFill>
+                <a:latin typeface="Consolas"/>
+              </a:defRPr>
+            </a:pPr>
+            <a:r>
+              <a:t>  │                     │                    │                             │</a:t>
+            </a:r>
+          </a:p>
+          <a:p>
+            <a:pPr algn="ctr">
+              <a:spcAft>
+                <a:spcPts val="0"/>
+              </a:spcAft>
+              <a:defRPr sz="1100">
+                <a:solidFill>
+                  <a:srgbClr val="3FB950"/>
+                </a:solidFill>
+                <a:latin typeface="Consolas"/>
+              </a:defRPr>
+            </a:pPr>
+            <a:r>
+              <a:t>  │                     │     fort.7         │  ┌─ MACE energy → E, F     │</a:t>
+            </a:r>
+          </a:p>
+          <a:p>
+            <a:pPr algn="ctr">
+              <a:spcAft>
+                <a:spcPts val="0"/>
+              </a:spcAft>
+              <a:defRPr sz="1100">
+                <a:solidFill>
+                  <a:srgbClr val="3FB950"/>
+                </a:solidFill>
+                <a:latin typeface="Consolas"/>
+              </a:defRPr>
+            </a:pPr>
+            <a:r>
+              <a:t>  │                     │ ←──────────────────│  └─ MACE dipole → μ⃗        │</a:t>
+            </a:r>
+          </a:p>
+          <a:p>
+            <a:pPr algn="ctr">
+              <a:spcAft>
+                <a:spcPts val="0"/>
+              </a:spcAft>
+              <a:defRPr sz="1100">
+                <a:solidFill>
+                  <a:srgbClr val="8B949E"/>
+                </a:solidFill>
+                <a:latin typeface="Consolas"/>
+              </a:defRPr>
+            </a:pPr>
+            <a:r>
+              <a:t>  │                     │   E, F, μ⃗          │                             │</a:t>
+            </a:r>
+          </a:p>
+          <a:p>
+            <a:pPr algn="ctr">
+              <a:spcAft>
+                <a:spcPts val="0"/>
+              </a:spcAft>
+              <a:defRPr sz="1100">
+                <a:solidFill>
+                  <a:srgbClr val="8B949E"/>
+                </a:solidFill>
+                <a:latin typeface="Consolas"/>
+              </a:defRPr>
+            </a:pPr>
+            <a:r>
+              <a:t>  └─────────────────────┘                    └─────────────────────────────┘</a:t>
+            </a:r>
+          </a:p>
+          <a:p>
+            <a:pPr algn="ctr">
+              <a:spcAft>
+                <a:spcPts val="0"/>
+              </a:spcAft>
+              <a:defRPr sz="1100">
+                <a:solidFill>
+                  <a:srgbClr val="8B949E"/>
+                </a:solidFill>
+                <a:latin typeface="Consolas"/>
+              </a:defRPr>
+            </a:pPr>
+          </a:p>
+          <a:p>
+            <a:pPr algn="ctr">
+              <a:spcAft>
+                <a:spcPts val="0"/>
+              </a:spcAft>
+              <a:defRPr sz="1100">
                 <a:solidFill>
                   <a:srgbClr val="C9D1D9"/>
                 </a:solidFill>
@@ -6792,248 +7023,14 @@
               </a:defRPr>
             </a:pPr>
             <a:r>
-              <a:t>  Gaussian 'External' keyword calls gm_helper.py per geometry</a:t>
-            </a:r>
-          </a:p>
-          <a:p>
-            <a:pPr>
-              <a:spcAft>
-                <a:spcPts val="400"/>
-              </a:spcAft>
-              <a:defRPr sz="1400">
-                <a:solidFill>
-                  <a:srgbClr val="C9D1D9"/>
-                </a:solidFill>
-                <a:latin typeface="Consolas"/>
-              </a:defRPr>
-            </a:pPr>
-            <a:r>
-              <a:t>  → gm_helper.py sends geometry over ZMQ IPC socket</a:t>
-            </a:r>
-          </a:p>
-          <a:p>
-            <a:pPr>
-              <a:spcAft>
-                <a:spcPts val="400"/>
-              </a:spcAft>
-              <a:defRPr sz="1400">
-                <a:solidFill>
-                  <a:srgbClr val="C9D1D9"/>
-                </a:solidFill>
-                <a:latin typeface="Consolas"/>
-              </a:defRPr>
-            </a:pPr>
-            <a:r>
-              <a:t>  → zmq_server.py receives, queries ML, returns results</a:t>
-            </a:r>
-          </a:p>
-          <a:p>
-            <a:pPr>
-              <a:spcAft>
-                <a:spcPts val="400"/>
-              </a:spcAft>
-              <a:defRPr sz="1400">
-                <a:solidFill>
-                  <a:srgbClr val="8B949E"/>
-                </a:solidFill>
-                <a:latin typeface="Consolas"/>
-              </a:defRPr>
-            </a:pPr>
-          </a:p>
-          <a:p>
-            <a:pPr>
-              <a:spcAft>
-                <a:spcPts val="400"/>
-              </a:spcAft>
-              <a:defRPr sz="1400">
-                <a:solidFill>
-                  <a:srgbClr val="58A6FF"/>
-                </a:solidFill>
-                <a:latin typeface="Consolas"/>
-              </a:defRPr>
-            </a:pPr>
-            <a:r>
-              <a:t># How it works</a:t>
-            </a:r>
-          </a:p>
-          <a:p>
-            <a:pPr>
-              <a:spcAft>
-                <a:spcPts val="400"/>
-              </a:spcAft>
-              <a:defRPr sz="1400">
-                <a:solidFill>
-                  <a:srgbClr val="8B949E"/>
-                </a:solidFill>
-                <a:latin typeface="Consolas"/>
-              </a:defRPr>
-            </a:pPr>
-            <a:r>
-              <a:t>  [Gaussian]  → writes geometry → calls gm_helper.py</a:t>
-            </a:r>
-          </a:p>
-          <a:p>
-            <a:pPr>
-              <a:spcAft>
-                <a:spcPts val="400"/>
-              </a:spcAft>
-              <a:defRPr sz="1400">
-                <a:solidFill>
-                  <a:srgbClr val="8B949E"/>
-                </a:solidFill>
-                <a:latin typeface="Consolas"/>
-              </a:defRPr>
-            </a:pPr>
-            <a:r>
-              <a:t>                                        ↓  ZMQ (IPC)</a:t>
-            </a:r>
-          </a:p>
-          <a:p>
-            <a:pPr>
-              <a:spcAft>
-                <a:spcPts val="400"/>
-              </a:spcAft>
-              <a:defRPr sz="1400">
-                <a:solidFill>
-                  <a:srgbClr val="8B949E"/>
-                </a:solidFill>
-                <a:latin typeface="Consolas"/>
-              </a:defRPr>
-            </a:pPr>
-            <a:r>
-              <a:t>                                  zmq_server.py</a:t>
-            </a:r>
-          </a:p>
-          <a:p>
-            <a:pPr>
-              <a:spcAft>
-                <a:spcPts val="400"/>
-              </a:spcAft>
-              <a:defRPr sz="1400">
-                <a:solidFill>
-                  <a:srgbClr val="8B949E"/>
-                </a:solidFill>
-                <a:latin typeface="Consolas"/>
-              </a:defRPr>
-            </a:pPr>
-            <a:r>
-              <a:t>                                        ↓  MACE energy + forces</a:t>
-            </a:r>
-          </a:p>
-          <a:p>
-            <a:pPr>
-              <a:spcAft>
-                <a:spcPts val="400"/>
-              </a:spcAft>
-              <a:defRPr sz="1400">
-                <a:solidFill>
-                  <a:srgbClr val="8B949E"/>
-                </a:solidFill>
-                <a:latin typeface="Consolas"/>
-              </a:defRPr>
-            </a:pPr>
-            <a:r>
-              <a:t>                                        ↓  MACE dipole model</a:t>
-            </a:r>
-          </a:p>
-          <a:p>
-            <a:pPr>
-              <a:spcAft>
-                <a:spcPts val="400"/>
-              </a:spcAft>
-              <a:defRPr sz="1400">
-                <a:solidFill>
-                  <a:srgbClr val="8B949E"/>
-                </a:solidFill>
-                <a:latin typeface="Consolas"/>
-              </a:defRPr>
-            </a:pPr>
-            <a:r>
-              <a:t>  [Gaussian]  ← reads fort.7  ←         ↑  returns results</a:t>
-            </a:r>
-          </a:p>
-          <a:p>
-            <a:pPr>
-              <a:spcAft>
-                <a:spcPts val="400"/>
-              </a:spcAft>
-              <a:defRPr sz="1400">
-                <a:solidFill>
-                  <a:srgbClr val="8B949E"/>
-                </a:solidFill>
-                <a:latin typeface="Consolas"/>
-              </a:defRPr>
-            </a:pPr>
-          </a:p>
-          <a:p>
-            <a:pPr>
-              <a:spcAft>
-                <a:spcPts val="400"/>
-              </a:spcAft>
-              <a:defRPr sz="1400">
-                <a:solidFill>
-                  <a:srgbClr val="58A6FF"/>
-                </a:solidFill>
-                <a:latin typeface="Consolas"/>
-              </a:defRPr>
-            </a:pPr>
-            <a:r>
-              <a:t># Why it's non-trivial</a:t>
-            </a:r>
-          </a:p>
-          <a:p>
-            <a:pPr>
-              <a:spcAft>
-                <a:spcPts val="400"/>
-              </a:spcAft>
-              <a:defRPr sz="1400">
-                <a:solidFill>
-                  <a:srgbClr val="C9D1D9"/>
-                </a:solidFill>
-                <a:latin typeface="Consolas"/>
-              </a:defRPr>
-            </a:pPr>
-            <a:r>
-              <a:t>  Socket cleanup: LINGER=0 + SIGKILL timeout (no orphan processes)</a:t>
-            </a:r>
-          </a:p>
-          <a:p>
-            <a:pPr>
-              <a:spcAft>
-                <a:spcPts val="400"/>
-              </a:spcAft>
-              <a:defRPr sz="1400">
-                <a:solidFill>
-                  <a:srgbClr val="C9D1D9"/>
-                </a:solidFill>
-                <a:latin typeface="Consolas"/>
-              </a:defRPr>
-            </a:pPr>
-            <a:r>
-              <a:t>  Absolute paths: Gaussian needs full path resolved at CLI startup</a:t>
-            </a:r>
-          </a:p>
-          <a:p>
-            <a:pPr>
-              <a:spcAft>
-                <a:spcPts val="400"/>
-              </a:spcAft>
-              <a:defRPr sz="1400">
-                <a:solidFill>
-                  <a:srgbClr val="C9D1D9"/>
-                </a:solidFill>
-                <a:latin typeface="Consolas"/>
-              </a:defRPr>
-            </a:pPr>
-            <a:r>
-              <a:t>  Model loading: dipole class remapping via torch.load()</a:t>
-            </a:r>
-          </a:p>
-        </p:txBody>
-      </p:sp>
-      <p:sp>
-        <p:nvSpPr>
-          <p:cNvPr id="4" name="TextBox 3"/>
+              <a:t>  ↻ repeats for every displacement (hundreds per molecule)</a:t>
+            </a:r>
+          </a:p>
+        </p:txBody>
+      </p:sp>
+      <p:sp>
+        <p:nvSpPr>
+          <p:cNvPr id="5" name="TextBox 4"/>
           <p:cNvSpPr txBox="1"/>
           <p:nvPr/>
         </p:nvSpPr>

</xml_diff>

<commit_message>
fix(slides): left-align ASCII art in architecture + ZMQ slides to fix alignment
Co-Authored-By: Claude Opus 4.6 <noreply@anthropic.com>
</commit_message>
<xml_diff>
--- a/presentation/presentation_v2.pptx
+++ b/presentation/presentation_v2.pptx
@@ -5472,8 +5472,8 @@
         </p:nvSpPr>
         <p:spPr>
           <a:xfrm>
-            <a:off x="91440" y="1051560"/>
-            <a:ext cx="8961120" cy="4937760"/>
+            <a:off x="685800" y="1051560"/>
+            <a:ext cx="7772400" cy="4937760"/>
           </a:xfrm>
           <a:prstGeom prst="rect">
             <a:avLst/>
@@ -5486,7 +5486,7 @@
           </a:bodyPr>
           <a:lstStyle/>
           <a:p>
-            <a:pPr algn="ctr">
+            <a:pPr>
               <a:spcAft>
                 <a:spcPts val="0"/>
               </a:spcAft>
@@ -5502,7 +5502,7 @@
             </a:r>
           </a:p>
           <a:p>
-            <a:pPr algn="ctr">
+            <a:pPr>
               <a:spcAft>
                 <a:spcPts val="0"/>
               </a:spcAft>
@@ -5518,7 +5518,7 @@
             </a:r>
           </a:p>
           <a:p>
-            <a:pPr algn="ctr">
+            <a:pPr>
               <a:spcAft>
                 <a:spcPts val="0"/>
               </a:spcAft>
@@ -5534,7 +5534,7 @@
             </a:r>
           </a:p>
           <a:p>
-            <a:pPr algn="ctr">
+            <a:pPr>
               <a:spcAft>
                 <a:spcPts val="0"/>
               </a:spcAft>
@@ -5550,7 +5550,7 @@
             </a:r>
           </a:p>
           <a:p>
-            <a:pPr algn="ctr">
+            <a:pPr>
               <a:spcAft>
                 <a:spcPts val="0"/>
               </a:spcAft>
@@ -5566,7 +5566,7 @@
             </a:r>
           </a:p>
           <a:p>
-            <a:pPr algn="ctr">
+            <a:pPr>
               <a:spcAft>
                 <a:spcPts val="0"/>
               </a:spcAft>
@@ -5582,7 +5582,7 @@
             </a:r>
           </a:p>
           <a:p>
-            <a:pPr algn="ctr">
+            <a:pPr>
               <a:spcAft>
                 <a:spcPts val="0"/>
               </a:spcAft>
@@ -5598,7 +5598,7 @@
             </a:r>
           </a:p>
           <a:p>
-            <a:pPr algn="ctr">
+            <a:pPr>
               <a:spcAft>
                 <a:spcPts val="0"/>
               </a:spcAft>
@@ -5614,7 +5614,7 @@
             </a:r>
           </a:p>
           <a:p>
-            <a:pPr algn="ctr">
+            <a:pPr>
               <a:spcAft>
                 <a:spcPts val="0"/>
               </a:spcAft>
@@ -5630,7 +5630,7 @@
             </a:r>
           </a:p>
           <a:p>
-            <a:pPr algn="ctr">
+            <a:pPr>
               <a:spcAft>
                 <a:spcPts val="0"/>
               </a:spcAft>
@@ -5646,7 +5646,7 @@
             </a:r>
           </a:p>
           <a:p>
-            <a:pPr algn="ctr">
+            <a:pPr>
               <a:spcAft>
                 <a:spcPts val="0"/>
               </a:spcAft>
@@ -5662,7 +5662,7 @@
             </a:r>
           </a:p>
           <a:p>
-            <a:pPr algn="ctr">
+            <a:pPr>
               <a:spcAft>
                 <a:spcPts val="0"/>
               </a:spcAft>
@@ -5678,7 +5678,7 @@
             </a:r>
           </a:p>
           <a:p>
-            <a:pPr algn="ctr">
+            <a:pPr>
               <a:spcAft>
                 <a:spcPts val="0"/>
               </a:spcAft>
@@ -5694,7 +5694,7 @@
             </a:r>
           </a:p>
           <a:p>
-            <a:pPr algn="ctr">
+            <a:pPr>
               <a:spcAft>
                 <a:spcPts val="0"/>
               </a:spcAft>
@@ -5710,7 +5710,7 @@
             </a:r>
           </a:p>
           <a:p>
-            <a:pPr algn="ctr">
+            <a:pPr>
               <a:spcAft>
                 <a:spcPts val="0"/>
               </a:spcAft>
@@ -5726,7 +5726,7 @@
             </a:r>
           </a:p>
           <a:p>
-            <a:pPr algn="ctr">
+            <a:pPr>
               <a:spcAft>
                 <a:spcPts val="0"/>
               </a:spcAft>
@@ -5742,7 +5742,7 @@
             </a:r>
           </a:p>
           <a:p>
-            <a:pPr algn="ctr">
+            <a:pPr>
               <a:spcAft>
                 <a:spcPts val="0"/>
               </a:spcAft>
@@ -5758,7 +5758,7 @@
             </a:r>
           </a:p>
           <a:p>
-            <a:pPr algn="ctr">
+            <a:pPr>
               <a:spcAft>
                 <a:spcPts val="0"/>
               </a:spcAft>
@@ -5774,7 +5774,7 @@
             </a:r>
           </a:p>
           <a:p>
-            <a:pPr algn="ctr">
+            <a:pPr>
               <a:spcAft>
                 <a:spcPts val="0"/>
               </a:spcAft>
@@ -5790,7 +5790,7 @@
             </a:r>
           </a:p>
           <a:p>
-            <a:pPr algn="ctr">
+            <a:pPr>
               <a:spcAft>
                 <a:spcPts val="0"/>
               </a:spcAft>
@@ -5806,7 +5806,7 @@
             </a:r>
           </a:p>
           <a:p>
-            <a:pPr algn="ctr">
+            <a:pPr>
               <a:spcAft>
                 <a:spcPts val="0"/>
               </a:spcAft>
@@ -5822,7 +5822,7 @@
             </a:r>
           </a:p>
           <a:p>
-            <a:pPr algn="ctr">
+            <a:pPr>
               <a:spcAft>
                 <a:spcPts val="0"/>
               </a:spcAft>
@@ -5838,7 +5838,7 @@
             </a:r>
           </a:p>
           <a:p>
-            <a:pPr algn="ctr">
+            <a:pPr>
               <a:spcAft>
                 <a:spcPts val="0"/>
               </a:spcAft>
@@ -5854,7 +5854,7 @@
             </a:r>
           </a:p>
           <a:p>
-            <a:pPr algn="ctr">
+            <a:pPr>
               <a:spcAft>
                 <a:spcPts val="0"/>
               </a:spcAft>
@@ -6760,8 +6760,8 @@
         </p:nvSpPr>
         <p:spPr>
           <a:xfrm>
-            <a:off x="91440" y="2560320"/>
-            <a:ext cx="8961120" cy="3657600"/>
+            <a:off x="685800" y="2560320"/>
+            <a:ext cx="7772400" cy="3657600"/>
           </a:xfrm>
           <a:prstGeom prst="rect">
             <a:avLst/>
@@ -6774,7 +6774,7 @@
           </a:bodyPr>
           <a:lstStyle/>
           <a:p>
-            <a:pPr algn="ctr">
+            <a:pPr>
               <a:spcAft>
                 <a:spcPts val="0"/>
               </a:spcAft>
@@ -6790,7 +6790,7 @@
             </a:r>
           </a:p>
           <a:p>
-            <a:pPr algn="ctr">
+            <a:pPr>
               <a:spcAft>
                 <a:spcPts val="0"/>
               </a:spcAft>
@@ -6806,7 +6806,7 @@
             </a:r>
           </a:p>
           <a:p>
-            <a:pPr algn="ctr">
+            <a:pPr>
               <a:spcAft>
                 <a:spcPts val="0"/>
               </a:spcAft>
@@ -6822,7 +6822,7 @@
             </a:r>
           </a:p>
           <a:p>
-            <a:pPr algn="ctr">
+            <a:pPr>
               <a:spcAft>
                 <a:spcPts val="0"/>
               </a:spcAft>
@@ -6838,7 +6838,7 @@
             </a:r>
           </a:p>
           <a:p>
-            <a:pPr algn="ctr">
+            <a:pPr>
               <a:spcAft>
                 <a:spcPts val="0"/>
               </a:spcAft>
@@ -6854,7 +6854,7 @@
             </a:r>
           </a:p>
           <a:p>
-            <a:pPr algn="ctr">
+            <a:pPr>
               <a:spcAft>
                 <a:spcPts val="0"/>
               </a:spcAft>
@@ -6870,7 +6870,7 @@
             </a:r>
           </a:p>
           <a:p>
-            <a:pPr algn="ctr">
+            <a:pPr>
               <a:spcAft>
                 <a:spcPts val="0"/>
               </a:spcAft>
@@ -6886,7 +6886,7 @@
             </a:r>
           </a:p>
           <a:p>
-            <a:pPr algn="ctr">
+            <a:pPr>
               <a:spcAft>
                 <a:spcPts val="0"/>
               </a:spcAft>
@@ -6902,7 +6902,7 @@
             </a:r>
           </a:p>
           <a:p>
-            <a:pPr algn="ctr">
+            <a:pPr>
               <a:spcAft>
                 <a:spcPts val="0"/>
               </a:spcAft>
@@ -6918,7 +6918,7 @@
             </a:r>
           </a:p>
           <a:p>
-            <a:pPr algn="ctr">
+            <a:pPr>
               <a:spcAft>
                 <a:spcPts val="0"/>
               </a:spcAft>
@@ -6934,7 +6934,7 @@
             </a:r>
           </a:p>
           <a:p>
-            <a:pPr algn="ctr">
+            <a:pPr>
               <a:spcAft>
                 <a:spcPts val="0"/>
               </a:spcAft>
@@ -6950,7 +6950,7 @@
             </a:r>
           </a:p>
           <a:p>
-            <a:pPr algn="ctr">
+            <a:pPr>
               <a:spcAft>
                 <a:spcPts val="0"/>
               </a:spcAft>
@@ -6966,7 +6966,7 @@
             </a:r>
           </a:p>
           <a:p>
-            <a:pPr algn="ctr">
+            <a:pPr>
               <a:spcAft>
                 <a:spcPts val="0"/>
               </a:spcAft>
@@ -6982,7 +6982,7 @@
             </a:r>
           </a:p>
           <a:p>
-            <a:pPr algn="ctr">
+            <a:pPr>
               <a:spcAft>
                 <a:spcPts val="0"/>
               </a:spcAft>
@@ -6998,7 +6998,7 @@
             </a:r>
           </a:p>
           <a:p>
-            <a:pPr algn="ctr">
+            <a:pPr>
               <a:spcAft>
                 <a:spcPts val="0"/>
               </a:spcAft>
@@ -7011,7 +7011,7 @@
             </a:pPr>
           </a:p>
           <a:p>
-            <a:pPr algn="ctr">
+            <a:pPr>
               <a:spcAft>
                 <a:spcPts val="0"/>
               </a:spcAft>

</xml_diff>

<commit_message>
feat(slides): ZMQ diagram 14pt
Co-Authored-By: Claude Opus 4.6 <noreply@anthropic.com>
</commit_message>
<xml_diff>
--- a/presentation/presentation_v2.pptx
+++ b/presentation/presentation_v2.pptx
@@ -6778,7 +6778,7 @@
               <a:spcAft>
                 <a:spcPts val="0"/>
               </a:spcAft>
-              <a:defRPr sz="1100">
+              <a:defRPr sz="1400">
                 <a:solidFill>
                   <a:srgbClr val="8B949E"/>
                 </a:solidFill>
@@ -6794,7 +6794,7 @@
               <a:spcAft>
                 <a:spcPts val="0"/>
               </a:spcAft>
-              <a:defRPr sz="1100">
+              <a:defRPr sz="1400">
                 <a:solidFill>
                   <a:srgbClr val="8B949E"/>
                 </a:solidFill>
@@ -6810,7 +6810,7 @@
               <a:spcAft>
                 <a:spcPts val="0"/>
               </a:spcAft>
-              <a:defRPr sz="1100">
+              <a:defRPr sz="1400">
                 <a:solidFill>
                   <a:srgbClr val="58A6FF"/>
                 </a:solidFill>
@@ -6826,7 +6826,7 @@
               <a:spcAft>
                 <a:spcPts val="0"/>
               </a:spcAft>
-              <a:defRPr sz="1100">
+              <a:defRPr sz="1400">
                 <a:solidFill>
                   <a:srgbClr val="8B949E"/>
                 </a:solidFill>
@@ -6842,7 +6842,7 @@
               <a:spcAft>
                 <a:spcPts val="0"/>
               </a:spcAft>
-              <a:defRPr sz="1100">
+              <a:defRPr sz="1400">
                 <a:solidFill>
                   <a:srgbClr val="8B949E"/>
                 </a:solidFill>
@@ -6858,7 +6858,7 @@
               <a:spcAft>
                 <a:spcPts val="0"/>
               </a:spcAft>
-              <a:defRPr sz="1100">
+              <a:defRPr sz="1400">
                 <a:solidFill>
                   <a:srgbClr val="8B949E"/>
                 </a:solidFill>
@@ -6874,7 +6874,7 @@
               <a:spcAft>
                 <a:spcPts val="0"/>
               </a:spcAft>
-              <a:defRPr sz="1100">
+              <a:defRPr sz="1400">
                 <a:solidFill>
                   <a:srgbClr val="8B949E"/>
                 </a:solidFill>
@@ -6890,7 +6890,7 @@
               <a:spcAft>
                 <a:spcPts val="0"/>
               </a:spcAft>
-              <a:defRPr sz="1100">
+              <a:defRPr sz="1400">
                 <a:solidFill>
                   <a:srgbClr val="8B949E"/>
                 </a:solidFill>
@@ -6906,7 +6906,7 @@
               <a:spcAft>
                 <a:spcPts val="0"/>
               </a:spcAft>
-              <a:defRPr sz="1100">
+              <a:defRPr sz="1400">
                 <a:solidFill>
                   <a:srgbClr val="58A6FF"/>
                 </a:solidFill>
@@ -6922,7 +6922,7 @@
               <a:spcAft>
                 <a:spcPts val="0"/>
               </a:spcAft>
-              <a:defRPr sz="1100">
+              <a:defRPr sz="1400">
                 <a:solidFill>
                   <a:srgbClr val="8B949E"/>
                 </a:solidFill>
@@ -6938,7 +6938,7 @@
               <a:spcAft>
                 <a:spcPts val="0"/>
               </a:spcAft>
-              <a:defRPr sz="1100">
+              <a:defRPr sz="1400">
                 <a:solidFill>
                   <a:srgbClr val="3FB950"/>
                 </a:solidFill>
@@ -6954,7 +6954,7 @@
               <a:spcAft>
                 <a:spcPts val="0"/>
               </a:spcAft>
-              <a:defRPr sz="1100">
+              <a:defRPr sz="1400">
                 <a:solidFill>
                   <a:srgbClr val="3FB950"/>
                 </a:solidFill>
@@ -6970,7 +6970,7 @@
               <a:spcAft>
                 <a:spcPts val="0"/>
               </a:spcAft>
-              <a:defRPr sz="1100">
+              <a:defRPr sz="1400">
                 <a:solidFill>
                   <a:srgbClr val="8B949E"/>
                 </a:solidFill>
@@ -6986,7 +6986,7 @@
               <a:spcAft>
                 <a:spcPts val="0"/>
               </a:spcAft>
-              <a:defRPr sz="1100">
+              <a:defRPr sz="1400">
                 <a:solidFill>
                   <a:srgbClr val="8B949E"/>
                 </a:solidFill>
@@ -7002,7 +7002,7 @@
               <a:spcAft>
                 <a:spcPts val="0"/>
               </a:spcAft>
-              <a:defRPr sz="1100">
+              <a:defRPr sz="1400">
                 <a:solidFill>
                   <a:srgbClr val="8B949E"/>
                 </a:solidFill>
@@ -7015,7 +7015,7 @@
               <a:spcAft>
                 <a:spcPts val="0"/>
               </a:spcAft>
-              <a:defRPr sz="1100">
+              <a:defRPr sz="1400">
                 <a:solidFill>
                   <a:srgbClr val="C9D1D9"/>
                 </a:solidFill>

</xml_diff>

<commit_message>
feat(slides): mode matching — realistic example with close frequencies swapped
Co-Authored-By: Claude Opus 4.6 <noreply@anthropic.com>
</commit_message>
<xml_diff>
--- a/presentation/presentation_v2.pptx
+++ b/presentation/presentation_v2.pptx
@@ -7189,7 +7189,7 @@
               </a:defRPr>
             </a:pPr>
             <a:r>
-              <a:t>  DFT:  [500, 1200, 1500, 2900, 3100] cm⁻¹</a:t>
+              <a:t>  DFT:  [1595, 1610, 2900, 3050, 3100] cm⁻¹</a:t>
             </a:r>
           </a:p>
           <a:p>
@@ -7205,7 +7205,7 @@
               </a:defRPr>
             </a:pPr>
             <a:r>
-              <a:t>  ML:   [498, 3095, 1205, 2895, 1498] cm⁻¹   ← different order!</a:t>
+              <a:t>  ML:   [1608, 1590, 3045, 3098, 2895] cm⁻¹   ← swapped + reordered!</a:t>
             </a:r>
           </a:p>
           <a:p>
@@ -7234,7 +7234,23 @@
               </a:defRPr>
             </a:pPr>
             <a:r>
-              <a:t>  → Cannot compare by index. Need to identify which mode is which.</a:t>
+              <a:t>  → Modes 1 &amp; 2 are close (1595 vs 1610) but physically different</a:t>
+            </a:r>
+          </a:p>
+          <a:p>
+            <a:pPr>
+              <a:spcAft>
+                <a:spcPts val="400"/>
+              </a:spcAft>
+              <a:defRPr sz="1400">
+                <a:solidFill>
+                  <a:srgbClr val="C9D1D9"/>
+                </a:solidFill>
+                <a:latin typeface="Consolas"/>
+              </a:defRPr>
+            </a:pPr>
+            <a:r>
+              <a:t>  → Cannot compare by index — need to identify which mode is which</a:t>
             </a:r>
           </a:p>
           <a:p>
@@ -7411,7 +7427,7 @@
               </a:defRPr>
             </a:pPr>
             <a:r>
-              <a:t># Example (water)</a:t>
+              <a:t># Example</a:t>
             </a:r>
           </a:p>
           <a:p>
@@ -7427,7 +7443,7 @@
               </a:defRPr>
             </a:pPr>
             <a:r>
-              <a:t>  ML 3095 cm⁻¹ → DFT 1200 cm⁻¹  [overlap: 0.027]   ✗ wrong match</a:t>
+              <a:t>  ML 1608 cm⁻¹ → DFT 1595 cm⁻¹  [overlap: 0.12]   ✗ closest freq, wrong mode</a:t>
             </a:r>
           </a:p>
           <a:p>
@@ -7443,7 +7459,7 @@
               </a:defRPr>
             </a:pPr>
             <a:r>
-              <a:t>  ML 3095 cm⁻¹ → DFT 3100 cm⁻¹  [overlap: 0.989]   ✓ correct</a:t>
+              <a:t>  ML 1608 cm⁻¹ → DFT 1610 cm⁻¹  [overlap: 0.97]   ✓ correct — same motion</a:t>
             </a:r>
           </a:p>
         </p:txBody>

</xml_diff>

<commit_message>
feat(slides): mode matching — single swap, shorter text to fit slide
Co-Authored-By: Claude Opus 4.6 <noreply@anthropic.com>
</commit_message>
<xml_diff>
--- a/presentation/presentation_v2.pptx
+++ b/presentation/presentation_v2.pptx
@@ -7160,7 +7160,7 @@
               </a:defRPr>
             </a:pPr>
             <a:r>
-              <a:t># Problem: ML and DFT don't output modes in the same order</a:t>
+              <a:t># Problem: ML and DFT modes can be in different order</a:t>
             </a:r>
           </a:p>
           <a:p>
@@ -7205,7 +7205,7 @@
               </a:defRPr>
             </a:pPr>
             <a:r>
-              <a:t>  ML:   [1608, 1590, 3045, 3098, 2895] cm⁻¹   ← swapped + reordered!</a:t>
+              <a:t>  ML:   [1608, 1590, 2905, 3048, 3102] cm⁻¹   ← modes 1 &amp; 2 swapped!</a:t>
             </a:r>
           </a:p>
           <a:p>
@@ -7234,7 +7234,36 @@
               </a:defRPr>
             </a:pPr>
             <a:r>
-              <a:t>  → Modes 1 &amp; 2 are close (1595 vs 1610) but physically different</a:t>
+              <a:t>  → 1595 and 1610 are close but physically different modes</a:t>
+            </a:r>
+          </a:p>
+          <a:p>
+            <a:pPr>
+              <a:spcAft>
+                <a:spcPts val="400"/>
+              </a:spcAft>
+              <a:defRPr sz="1400">
+                <a:solidFill>
+                  <a:srgbClr val="8B949E"/>
+                </a:solidFill>
+                <a:latin typeface="Consolas"/>
+              </a:defRPr>
+            </a:pPr>
+          </a:p>
+          <a:p>
+            <a:pPr>
+              <a:spcAft>
+                <a:spcPts val="400"/>
+              </a:spcAft>
+              <a:defRPr sz="1400">
+                <a:solidFill>
+                  <a:srgbClr val="58A6FF"/>
+                </a:solidFill>
+                <a:latin typeface="Consolas"/>
+              </a:defRPr>
+            </a:pPr>
+            <a:r>
+              <a:t># Solution: Eigenvector dot product</a:t>
             </a:r>
           </a:p>
           <a:p>
@@ -7250,50 +7279,8 @@
               </a:defRPr>
             </a:pPr>
             <a:r>
-              <a:t>  → Cannot compare by index — need to identify which mode is which</a:t>
-            </a:r>
-          </a:p>
-          <a:p>
-            <a:pPr>
-              <a:spcAft>
-                <a:spcPts val="400"/>
-              </a:spcAft>
-              <a:defRPr sz="1400">
-                <a:solidFill>
-                  <a:srgbClr val="8B949E"/>
-                </a:solidFill>
-                <a:latin typeface="Consolas"/>
-              </a:defRPr>
-            </a:pPr>
-          </a:p>
-          <a:p>
-            <a:pPr>
-              <a:spcAft>
-                <a:spcPts val="400"/>
-              </a:spcAft>
-              <a:defRPr sz="1400">
-                <a:solidFill>
-                  <a:srgbClr val="58A6FF"/>
-                </a:solidFill>
-                <a:latin typeface="Consolas"/>
-              </a:defRPr>
-            </a:pPr>
-            <a:r>
-              <a:t># Solution: Eigenvector dot product</a:t>
-            </a:r>
-          </a:p>
-          <a:p>
-            <a:pPr>
-              <a:spcAft>
-                <a:spcPts val="400"/>
-              </a:spcAft>
-              <a:defRPr sz="1400">
-                <a:solidFill>
-                  <a:srgbClr val="8B949E"/>
-                </a:solidFill>
-                <a:latin typeface="Consolas"/>
-              </a:defRPr>
-            </a:pPr>
+              <a:t>  Each mode = eigenvector (3N-dim displacement pattern)</a:t>
+            </a:r>
           </a:p>
           <a:p>
             <a:pPr>
@@ -7308,7 +7295,7 @@
               </a:defRPr>
             </a:pPr>
             <a:r>
-              <a:t>  Each normal mode has an eigenvector: 3N-dimensional displacement pattern.</a:t>
+              <a:t>  Same physical motion → parallel eigenvectors</a:t>
             </a:r>
           </a:p>
           <a:p>
@@ -7324,7 +7311,7 @@
               </a:defRPr>
             </a:pPr>
             <a:r>
-              <a:t>  Modes with the same physical motion will have parallel eigenvectors.</a:t>
+              <a:t>  similarity(i, j) = |v_ML[i] · v_DFT[j]|     (0 = orthogonal, 1 = same)</a:t>
             </a:r>
           </a:p>
           <a:p>
@@ -7353,52 +7340,7 @@
               </a:defRPr>
             </a:pPr>
             <a:r>
-              <a:t>  similarity(i, j) = |v_ML[i] · v_DFT[j]|        (0 = orthogonal, 1 = same)</a:t>
-            </a:r>
-          </a:p>
-          <a:p>
-            <a:pPr>
-              <a:spcAft>
-                <a:spcPts val="400"/>
-              </a:spcAft>
-              <a:defRPr sz="1400">
-                <a:solidFill>
-                  <a:srgbClr val="8B949E"/>
-                </a:solidFill>
-                <a:latin typeface="Consolas"/>
-              </a:defRPr>
-            </a:pPr>
-          </a:p>
-          <a:p>
-            <a:pPr>
-              <a:spcAft>
-                <a:spcPts val="400"/>
-              </a:spcAft>
-              <a:defRPr sz="1400">
-                <a:solidFill>
-                  <a:srgbClr val="C9D1D9"/>
-                </a:solidFill>
-                <a:latin typeface="Consolas"/>
-              </a:defRPr>
-            </a:pPr>
-            <a:r>
-              <a:t>  → Assign each ML mode to its best-matching DFT mode</a:t>
-            </a:r>
-          </a:p>
-          <a:p>
-            <a:pPr>
-              <a:spcAft>
-                <a:spcPts val="400"/>
-              </a:spcAft>
-              <a:defRPr sz="1400">
-                <a:solidFill>
-                  <a:srgbClr val="C9D1D9"/>
-                </a:solidFill>
-                <a:latin typeface="Consolas"/>
-              </a:defRPr>
-            </a:pPr>
-            <a:r>
-              <a:t>  → Robust to reordering, robust to small frequency errors</a:t>
+              <a:t>  → Match by motion, not by frequency</a:t>
             </a:r>
           </a:p>
           <a:p>

</xml_diff>

<commit_message>
feat(slides): mode matching yellow equation, results overview with corrected aspirin structure
Co-Authored-By: Claude Opus 4.6 <noreply@anthropic.com>
</commit_message>
<xml_diff>
--- a/presentation/presentation_v2.pptx
+++ b/presentation/presentation_v2.pptx
@@ -7305,42 +7305,71 @@
               </a:spcAft>
               <a:defRPr sz="1400">
                 <a:solidFill>
+                  <a:srgbClr val="8B949E"/>
+                </a:solidFill>
+                <a:latin typeface="Consolas"/>
+              </a:defRPr>
+            </a:pPr>
+          </a:p>
+          <a:p>
+            <a:pPr>
+              <a:spcAft>
+                <a:spcPts val="400"/>
+              </a:spcAft>
+              <a:defRPr sz="1400">
+                <a:solidFill>
+                  <a:srgbClr val="D29922"/>
+                </a:solidFill>
+                <a:latin typeface="Consolas"/>
+              </a:defRPr>
+            </a:pPr>
+            <a:r>
+              <a:t>              similarity(i, j) = |v_ML[i] · v_DFT[j]|</a:t>
+            </a:r>
+          </a:p>
+          <a:p>
+            <a:pPr>
+              <a:spcAft>
+                <a:spcPts val="400"/>
+              </a:spcAft>
+              <a:defRPr sz="1400">
+                <a:solidFill>
+                  <a:srgbClr val="8B949E"/>
+                </a:solidFill>
+                <a:latin typeface="Consolas"/>
+              </a:defRPr>
+            </a:pPr>
+            <a:r>
+              <a:t>              (0 = orthogonal, 1 = identical motion)</a:t>
+            </a:r>
+          </a:p>
+          <a:p>
+            <a:pPr>
+              <a:spcAft>
+                <a:spcPts val="400"/>
+              </a:spcAft>
+              <a:defRPr sz="1400">
+                <a:solidFill>
+                  <a:srgbClr val="8B949E"/>
+                </a:solidFill>
+                <a:latin typeface="Consolas"/>
+              </a:defRPr>
+            </a:pPr>
+          </a:p>
+          <a:p>
+            <a:pPr>
+              <a:spcAft>
+                <a:spcPts val="400"/>
+              </a:spcAft>
+              <a:defRPr sz="1400">
+                <a:solidFill>
                   <a:srgbClr val="C9D1D9"/>
                 </a:solidFill>
                 <a:latin typeface="Consolas"/>
               </a:defRPr>
             </a:pPr>
             <a:r>
-              <a:t>  similarity(i, j) = |v_ML[i] · v_DFT[j]|     (0 = orthogonal, 1 = same)</a:t>
-            </a:r>
-          </a:p>
-          <a:p>
-            <a:pPr>
-              <a:spcAft>
-                <a:spcPts val="400"/>
-              </a:spcAft>
-              <a:defRPr sz="1400">
-                <a:solidFill>
-                  <a:srgbClr val="8B949E"/>
-                </a:solidFill>
-                <a:latin typeface="Consolas"/>
-              </a:defRPr>
-            </a:pPr>
-          </a:p>
-          <a:p>
-            <a:pPr>
-              <a:spcAft>
-                <a:spcPts val="400"/>
-              </a:spcAft>
-              <a:defRPr sz="1400">
-                <a:solidFill>
-                  <a:srgbClr val="C9D1D9"/>
-                </a:solidFill>
-                <a:latin typeface="Consolas"/>
-              </a:defRPr>
-            </a:pPr>
-            <a:r>
-              <a:t>  → Match by motion, not by frequency</a:t>
+              <a:t>  → Match by motion, not by frequency or index</a:t>
             </a:r>
           </a:p>
           <a:p>
@@ -7532,196 +7561,296 @@
               </a:spcAft>
               <a:defRPr sz="1400">
                 <a:solidFill>
+                  <a:srgbClr val="8B949E"/>
+                </a:solidFill>
+                <a:latin typeface="Consolas"/>
+              </a:defRPr>
+            </a:pPr>
+          </a:p>
+          <a:p>
+            <a:pPr>
+              <a:spcAft>
+                <a:spcPts val="400"/>
+              </a:spcAft>
+              <a:defRPr sz="1400">
+                <a:solidFill>
+                  <a:srgbClr val="3FB950"/>
+                </a:solidFill>
+                <a:latin typeface="Consolas"/>
+              </a:defRPr>
+            </a:pPr>
+            <a:r>
+              <a:t>         O</a:t>
+            </a:r>
+          </a:p>
+          <a:p>
+            <a:pPr>
+              <a:spcAft>
+                <a:spcPts val="400"/>
+              </a:spcAft>
+              <a:defRPr sz="1400">
+                <a:solidFill>
+                  <a:srgbClr val="3FB950"/>
+                </a:solidFill>
+                <a:latin typeface="Consolas"/>
+              </a:defRPr>
+            </a:pPr>
+            <a:r>
+              <a:t>        / \</a:t>
+            </a:r>
+          </a:p>
+          <a:p>
+            <a:pPr>
+              <a:spcAft>
+                <a:spcPts val="400"/>
+              </a:spcAft>
+              <a:defRPr sz="1400">
+                <a:solidFill>
+                  <a:srgbClr val="3FB950"/>
+                </a:solidFill>
+                <a:latin typeface="Consolas"/>
+              </a:defRPr>
+            </a:pPr>
+            <a:r>
+              <a:t>       H   H</a:t>
+            </a:r>
+          </a:p>
+          <a:p>
+            <a:pPr>
+              <a:spcAft>
+                <a:spcPts val="400"/>
+              </a:spcAft>
+              <a:defRPr sz="1400">
+                <a:solidFill>
+                  <a:srgbClr val="8B949E"/>
+                </a:solidFill>
+                <a:latin typeface="Consolas"/>
+              </a:defRPr>
+            </a:pPr>
+          </a:p>
+          <a:p>
+            <a:pPr>
+              <a:spcAft>
+                <a:spcPts val="400"/>
+              </a:spcAft>
+              <a:defRPr sz="1400">
+                <a:solidFill>
+                  <a:srgbClr val="C9D1D9"/>
+                </a:solidFill>
+                <a:latin typeface="Consolas"/>
+              </a:defRPr>
+            </a:pPr>
+            <a:r>
+              <a:t>       H₂O  (3 atoms, 3 modes)</a:t>
+            </a:r>
+          </a:p>
+          <a:p>
+            <a:pPr>
+              <a:spcAft>
+                <a:spcPts val="400"/>
+              </a:spcAft>
+              <a:defRPr sz="1400">
+                <a:solidFill>
+                  <a:srgbClr val="8B949E"/>
+                </a:solidFill>
+                <a:latin typeface="Consolas"/>
+              </a:defRPr>
+            </a:pPr>
+          </a:p>
+          <a:p>
+            <a:pPr>
+              <a:spcAft>
+                <a:spcPts val="400"/>
+              </a:spcAft>
+              <a:defRPr sz="1400">
+                <a:solidFill>
+                  <a:srgbClr val="8B949E"/>
+                </a:solidFill>
+                <a:latin typeface="Consolas"/>
+              </a:defRPr>
+            </a:pPr>
+          </a:p>
+          <a:p>
+            <a:pPr>
+              <a:spcAft>
+                <a:spcPts val="400"/>
+              </a:spcAft>
+              <a:defRPr sz="1400">
+                <a:solidFill>
+                  <a:srgbClr val="3FB950"/>
+                </a:solidFill>
+                <a:latin typeface="Consolas"/>
+              </a:defRPr>
+            </a:pPr>
+            <a:r>
+              <a:t>       COOH</a:t>
+            </a:r>
+          </a:p>
+          <a:p>
+            <a:pPr>
+              <a:spcAft>
+                <a:spcPts val="400"/>
+              </a:spcAft>
+              <a:defRPr sz="1400">
+                <a:solidFill>
+                  <a:srgbClr val="3FB950"/>
+                </a:solidFill>
+                <a:latin typeface="Consolas"/>
+              </a:defRPr>
+            </a:pPr>
+            <a:r>
+              <a:t>        |</a:t>
+            </a:r>
+          </a:p>
+          <a:p>
+            <a:pPr>
+              <a:spcAft>
+                <a:spcPts val="400"/>
+              </a:spcAft>
+              <a:defRPr sz="1400">
+                <a:solidFill>
+                  <a:srgbClr val="3FB950"/>
+                </a:solidFill>
+                <a:latin typeface="Consolas"/>
+              </a:defRPr>
+            </a:pPr>
+            <a:r>
+              <a:t>    /--( )--\</a:t>
+            </a:r>
+          </a:p>
+          <a:p>
+            <a:pPr>
+              <a:spcAft>
+                <a:spcPts val="400"/>
+              </a:spcAft>
+              <a:defRPr sz="1400">
+                <a:solidFill>
+                  <a:srgbClr val="3FB950"/>
+                </a:solidFill>
+                <a:latin typeface="Consolas"/>
+              </a:defRPr>
+            </a:pPr>
+            <a:r>
+              <a:t>    |       |     O</a:t>
+            </a:r>
+          </a:p>
+          <a:p>
+            <a:pPr>
+              <a:spcAft>
+                <a:spcPts val="400"/>
+              </a:spcAft>
+              <a:defRPr sz="1400">
+                <a:solidFill>
+                  <a:srgbClr val="3FB950"/>
+                </a:solidFill>
+                <a:latin typeface="Consolas"/>
+              </a:defRPr>
+            </a:pPr>
+            <a:r>
+              <a:t>    \--( )--/     ‖</a:t>
+            </a:r>
+          </a:p>
+          <a:p>
+            <a:pPr>
+              <a:spcAft>
+                <a:spcPts val="400"/>
+              </a:spcAft>
+              <a:defRPr sz="1400">
+                <a:solidFill>
+                  <a:srgbClr val="3FB950"/>
+                </a:solidFill>
+                <a:latin typeface="Consolas"/>
+              </a:defRPr>
+            </a:pPr>
+            <a:r>
+              <a:t>        |    O---C-CH₃</a:t>
+            </a:r>
+          </a:p>
+          <a:p>
+            <a:pPr>
+              <a:spcAft>
+                <a:spcPts val="400"/>
+              </a:spcAft>
+              <a:defRPr sz="1400">
+                <a:solidFill>
+                  <a:srgbClr val="8B949E"/>
+                </a:solidFill>
+                <a:latin typeface="Consolas"/>
+              </a:defRPr>
+            </a:pPr>
+          </a:p>
+          <a:p>
+            <a:pPr>
+              <a:spcAft>
+                <a:spcPts val="400"/>
+              </a:spcAft>
+              <a:defRPr sz="1400">
+                <a:solidFill>
+                  <a:srgbClr val="C9D1D9"/>
+                </a:solidFill>
+                <a:latin typeface="Consolas"/>
+              </a:defRPr>
+            </a:pPr>
+            <a:r>
+              <a:t>       aspirin  C₉H₈O₄  (21 atoms, 57 modes)</a:t>
+            </a:r>
+          </a:p>
+          <a:p>
+            <a:pPr>
+              <a:spcAft>
+                <a:spcPts val="400"/>
+              </a:spcAft>
+              <a:defRPr sz="1400">
+                <a:solidFill>
+                  <a:srgbClr val="8B949E"/>
+                </a:solidFill>
+                <a:latin typeface="Consolas"/>
+              </a:defRPr>
+            </a:pPr>
+          </a:p>
+          <a:p>
+            <a:pPr>
+              <a:spcAft>
+                <a:spcPts val="400"/>
+              </a:spcAft>
+              <a:defRPr sz="1400">
+                <a:solidFill>
+                  <a:srgbClr val="8B949E"/>
+                </a:solidFill>
+                <a:latin typeface="Consolas"/>
+              </a:defRPr>
+            </a:pPr>
+          </a:p>
+          <a:p>
+            <a:pPr>
+              <a:spcAft>
+                <a:spcPts val="400"/>
+              </a:spcAft>
+              <a:defRPr sz="1400">
+                <a:solidFill>
                   <a:srgbClr val="58A6FF"/>
                 </a:solidFill>
                 <a:latin typeface="Consolas"/>
               </a:defRPr>
             </a:pPr>
             <a:r>
-              <a:t># Spectrum analysis reports</a:t>
-            </a:r>
-          </a:p>
-          <a:p>
-            <a:pPr>
-              <a:spcAft>
-                <a:spcPts val="400"/>
-              </a:spcAft>
-              <a:defRPr sz="1400">
-                <a:solidFill>
-                  <a:srgbClr val="8B949E"/>
-                </a:solidFill>
-                <a:latin typeface="Consolas"/>
-              </a:defRPr>
-            </a:pPr>
-          </a:p>
-          <a:p>
-            <a:pPr>
-              <a:spcAft>
-                <a:spcPts val="400"/>
-              </a:spcAft>
-              <a:defRPr sz="1400">
-                <a:solidFill>
-                  <a:srgbClr val="3FB950"/>
-                </a:solidFill>
-                <a:latin typeface="Consolas"/>
-              </a:defRPr>
-            </a:pPr>
-            <a:r>
-              <a:t>       O                       O   OH</a:t>
-            </a:r>
-          </a:p>
-          <a:p>
-            <a:pPr>
-              <a:spcAft>
-                <a:spcPts val="400"/>
-              </a:spcAft>
-              <a:defRPr sz="1400">
-                <a:solidFill>
-                  <a:srgbClr val="3FB950"/>
-                </a:solidFill>
-                <a:latin typeface="Consolas"/>
-              </a:defRPr>
-            </a:pPr>
-            <a:r>
-              <a:t>      / \                      ‖   |</a:t>
-            </a:r>
-          </a:p>
-          <a:p>
-            <a:pPr>
-              <a:spcAft>
-                <a:spcPts val="400"/>
-              </a:spcAft>
-              <a:defRPr sz="1400">
-                <a:solidFill>
-                  <a:srgbClr val="3FB950"/>
-                </a:solidFill>
-                <a:latin typeface="Consolas"/>
-              </a:defRPr>
-            </a:pPr>
-            <a:r>
-              <a:t>     H   H   H₂O          CH₃-C-O-C₆H₄-COOH</a:t>
-            </a:r>
-          </a:p>
-          <a:p>
-            <a:pPr>
-              <a:spcAft>
-                <a:spcPts val="400"/>
-              </a:spcAft>
-              <a:defRPr sz="1400">
-                <a:solidFill>
-                  <a:srgbClr val="8B949E"/>
-                </a:solidFill>
-                <a:latin typeface="Consolas"/>
-              </a:defRPr>
-            </a:pPr>
-            <a:r>
-              <a:t>                               aspirin C₉H₈O₄</a:t>
-            </a:r>
-          </a:p>
-          <a:p>
-            <a:pPr>
-              <a:spcAft>
-                <a:spcPts val="400"/>
-              </a:spcAft>
-              <a:defRPr sz="1400">
-                <a:solidFill>
-                  <a:srgbClr val="8B949E"/>
-                </a:solidFill>
-                <a:latin typeface="Consolas"/>
-              </a:defRPr>
-            </a:pPr>
-          </a:p>
-          <a:p>
-            <a:pPr>
-              <a:spcAft>
-                <a:spcPts val="400"/>
-              </a:spcAft>
-              <a:defRPr sz="1400">
-                <a:solidFill>
-                  <a:srgbClr val="3FB950"/>
-                </a:solidFill>
-                <a:latin typeface="Consolas"/>
-              </a:defRPr>
-            </a:pPr>
-            <a:r>
-              <a:t>  water/report.html       3 atoms  · 3 modes  · 8 combos</a:t>
-            </a:r>
-          </a:p>
-          <a:p>
-            <a:pPr>
-              <a:spcAft>
-                <a:spcPts val="400"/>
-              </a:spcAft>
-              <a:defRPr sz="1400">
-                <a:solidFill>
-                  <a:srgbClr val="3FB950"/>
-                </a:solidFill>
-                <a:latin typeface="Consolas"/>
-              </a:defRPr>
-            </a:pPr>
-            <a:r>
-              <a:t>  aspirin/report.html    19 atoms  · 51 modes · 4 combos</a:t>
-            </a:r>
-          </a:p>
-          <a:p>
-            <a:pPr>
-              <a:spcAft>
-                <a:spcPts val="400"/>
-              </a:spcAft>
-              <a:defRPr sz="1400">
-                <a:solidFill>
-                  <a:srgbClr val="8B949E"/>
-                </a:solidFill>
-                <a:latin typeface="Consolas"/>
-              </a:defRPr>
-            </a:pPr>
-          </a:p>
-          <a:p>
-            <a:pPr>
-              <a:spcAft>
-                <a:spcPts val="400"/>
-              </a:spcAft>
-              <a:defRPr sz="1400">
-                <a:solidFill>
-                  <a:srgbClr val="C9D1D9"/>
-                </a:solidFill>
-                <a:latin typeface="Consolas"/>
-              </a:defRPr>
-            </a:pPr>
-            <a:r>
-              <a:t>  Each report: regression plots · KDE spectra · mode matching</a:t>
-            </a:r>
-          </a:p>
-          <a:p>
-            <a:pPr>
-              <a:spcAft>
-                <a:spcPts val="400"/>
-              </a:spcAft>
-              <a:defRPr sz="1400">
-                <a:solidFill>
-                  <a:srgbClr val="8B949E"/>
-                </a:solidFill>
-                <a:latin typeface="Consolas"/>
-              </a:defRPr>
-            </a:pPr>
-            <a:r>
-              <a:t>  Open: $ open analysis_results_harmonic/water/report.html</a:t>
-            </a:r>
-          </a:p>
-          <a:p>
-            <a:pPr>
-              <a:spcAft>
-                <a:spcPts val="400"/>
-              </a:spcAft>
-              <a:defRPr sz="1400">
-                <a:solidFill>
-                  <a:srgbClr val="8B949E"/>
-                </a:solidFill>
-                <a:latin typeface="Consolas"/>
-              </a:defRPr>
-            </a:pPr>
-            <a:r>
-              <a:t>         $ open analysis_results_harmonic/aspirin/report.html</a:t>
+              <a:t>  → water/report.html</a:t>
+            </a:r>
+          </a:p>
+          <a:p>
+            <a:pPr>
+              <a:spcAft>
+                <a:spcPts val="400"/>
+              </a:spcAft>
+              <a:defRPr sz="1400">
+                <a:solidFill>
+                  <a:srgbClr val="58A6FF"/>
+                </a:solidFill>
+                <a:latin typeface="Consolas"/>
+              </a:defRPr>
+            </a:pPr>
+            <a:r>
+              <a:t>  → aspirin/report.html</a:t>
             </a:r>
           </a:p>
         </p:txBody>

</xml_diff>

<commit_message>
feat(slides): results overview — condensed formula, molecule then link
Co-Authored-By: Claude Opus 4.6 <noreply@anthropic.com>
</commit_message>
<xml_diff>
--- a/presentation/presentation_v2.pptx
+++ b/presentation/presentation_v2.pptx
@@ -7580,7 +7580,7 @@
               </a:defRPr>
             </a:pPr>
             <a:r>
-              <a:t>         O</a:t>
+              <a:t>       O</a:t>
             </a:r>
           </a:p>
           <a:p>
@@ -7596,7 +7596,7 @@
               </a:defRPr>
             </a:pPr>
             <a:r>
-              <a:t>        / \</a:t>
+              <a:t>      / \</a:t>
             </a:r>
           </a:p>
           <a:p>
@@ -7612,36 +7612,36 @@
               </a:defRPr>
             </a:pPr>
             <a:r>
-              <a:t>       H   H</a:t>
-            </a:r>
-          </a:p>
-          <a:p>
-            <a:pPr>
-              <a:spcAft>
-                <a:spcPts val="400"/>
-              </a:spcAft>
-              <a:defRPr sz="1400">
-                <a:solidFill>
-                  <a:srgbClr val="8B949E"/>
-                </a:solidFill>
-                <a:latin typeface="Consolas"/>
-              </a:defRPr>
-            </a:pPr>
-          </a:p>
-          <a:p>
-            <a:pPr>
-              <a:spcAft>
-                <a:spcPts val="400"/>
-              </a:spcAft>
-              <a:defRPr sz="1400">
-                <a:solidFill>
-                  <a:srgbClr val="C9D1D9"/>
-                </a:solidFill>
-                <a:latin typeface="Consolas"/>
-              </a:defRPr>
-            </a:pPr>
-            <a:r>
-              <a:t>       H₂O  (3 atoms, 3 modes)</a:t>
+              <a:t>     H   H   H₂O</a:t>
+            </a:r>
+          </a:p>
+          <a:p>
+            <a:pPr>
+              <a:spcAft>
+                <a:spcPts val="400"/>
+              </a:spcAft>
+              <a:defRPr sz="1400">
+                <a:solidFill>
+                  <a:srgbClr val="8B949E"/>
+                </a:solidFill>
+                <a:latin typeface="Consolas"/>
+              </a:defRPr>
+            </a:pPr>
+          </a:p>
+          <a:p>
+            <a:pPr>
+              <a:spcAft>
+                <a:spcPts val="400"/>
+              </a:spcAft>
+              <a:defRPr sz="1400">
+                <a:solidFill>
+                  <a:srgbClr val="58A6FF"/>
+                </a:solidFill>
+                <a:latin typeface="Consolas"/>
+              </a:defRPr>
+            </a:pPr>
+            <a:r>
+              <a:t>  → water/report.html</a:t>
             </a:r>
           </a:p>
           <a:p>
@@ -7683,7 +7683,7 @@
               </a:defRPr>
             </a:pPr>
             <a:r>
-              <a:t>       COOH</a:t>
+              <a:t>     O   OH</a:t>
             </a:r>
           </a:p>
           <a:p>
@@ -7699,7 +7699,7 @@
               </a:defRPr>
             </a:pPr>
             <a:r>
-              <a:t>        |</a:t>
+              <a:t>     ‖   |</a:t>
             </a:r>
           </a:p>
           <a:p>
@@ -7715,7 +7715,7 @@
               </a:defRPr>
             </a:pPr>
             <a:r>
-              <a:t>    /--( )--\</a:t>
+              <a:t>     C-O-C₆H₄-COOH   aspirin C₉H₈O₄</a:t>
             </a:r>
           </a:p>
           <a:p>
@@ -7731,7 +7731,7 @@
               </a:defRPr>
             </a:pPr>
             <a:r>
-              <a:t>    |       |     O</a:t>
+              <a:t>     |</a:t>
             </a:r>
           </a:p>
           <a:p>
@@ -7747,95 +7747,21 @@
               </a:defRPr>
             </a:pPr>
             <a:r>
-              <a:t>    \--( )--/     ‖</a:t>
-            </a:r>
-          </a:p>
-          <a:p>
-            <a:pPr>
-              <a:spcAft>
-                <a:spcPts val="400"/>
-              </a:spcAft>
-              <a:defRPr sz="1400">
-                <a:solidFill>
-                  <a:srgbClr val="3FB950"/>
-                </a:solidFill>
-                <a:latin typeface="Consolas"/>
-              </a:defRPr>
-            </a:pPr>
-            <a:r>
-              <a:t>        |    O---C-CH₃</a:t>
-            </a:r>
-          </a:p>
-          <a:p>
-            <a:pPr>
-              <a:spcAft>
-                <a:spcPts val="400"/>
-              </a:spcAft>
-              <a:defRPr sz="1400">
-                <a:solidFill>
-                  <a:srgbClr val="8B949E"/>
-                </a:solidFill>
-                <a:latin typeface="Consolas"/>
-              </a:defRPr>
-            </a:pPr>
-          </a:p>
-          <a:p>
-            <a:pPr>
-              <a:spcAft>
-                <a:spcPts val="400"/>
-              </a:spcAft>
-              <a:defRPr sz="1400">
-                <a:solidFill>
-                  <a:srgbClr val="C9D1D9"/>
-                </a:solidFill>
-                <a:latin typeface="Consolas"/>
-              </a:defRPr>
-            </a:pPr>
-            <a:r>
-              <a:t>       aspirin  C₉H₈O₄  (21 atoms, 57 modes)</a:t>
-            </a:r>
-          </a:p>
-          <a:p>
-            <a:pPr>
-              <a:spcAft>
-                <a:spcPts val="400"/>
-              </a:spcAft>
-              <a:defRPr sz="1400">
-                <a:solidFill>
-                  <a:srgbClr val="8B949E"/>
-                </a:solidFill>
-                <a:latin typeface="Consolas"/>
-              </a:defRPr>
-            </a:pPr>
-          </a:p>
-          <a:p>
-            <a:pPr>
-              <a:spcAft>
-                <a:spcPts val="400"/>
-              </a:spcAft>
-              <a:defRPr sz="1400">
-                <a:solidFill>
-                  <a:srgbClr val="8B949E"/>
-                </a:solidFill>
-                <a:latin typeface="Consolas"/>
-              </a:defRPr>
-            </a:pPr>
-          </a:p>
-          <a:p>
-            <a:pPr>
-              <a:spcAft>
-                <a:spcPts val="400"/>
-              </a:spcAft>
-              <a:defRPr sz="1400">
-                <a:solidFill>
-                  <a:srgbClr val="58A6FF"/>
-                </a:solidFill>
-                <a:latin typeface="Consolas"/>
-              </a:defRPr>
-            </a:pPr>
-            <a:r>
-              <a:t>  → water/report.html</a:t>
-            </a:r>
+              <a:t>     CH₃</a:t>
+            </a:r>
+          </a:p>
+          <a:p>
+            <a:pPr>
+              <a:spcAft>
+                <a:spcPts val="400"/>
+              </a:spcAft>
+              <a:defRPr sz="1400">
+                <a:solidFill>
+                  <a:srgbClr val="8B949E"/>
+                </a:solidFill>
+                <a:latin typeface="Consolas"/>
+              </a:defRPr>
+            </a:pPr>
           </a:p>
           <a:p>
             <a:pPr>

</xml_diff>

<commit_message>
fix(slides): remove incorrect OH from aspirin — it's an ester, not salicylic acid
Co-Authored-By: Claude Opus 4.6 <noreply@anthropic.com>
</commit_message>
<xml_diff>
--- a/presentation/presentation_v2.pptx
+++ b/presentation/presentation_v2.pptx
@@ -7683,7 +7683,7 @@
               </a:defRPr>
             </a:pPr>
             <a:r>
-              <a:t>     O   OH</a:t>
+              <a:t>     O</a:t>
             </a:r>
           </a:p>
           <a:p>
@@ -7699,7 +7699,7 @@
               </a:defRPr>
             </a:pPr>
             <a:r>
-              <a:t>     ‖   |</a:t>
+              <a:t>     ‖</a:t>
             </a:r>
           </a:p>
           <a:p>

</xml_diff>

<commit_message>
feat(slides): results tables — green highlight, R² warning for water, speedup for aspirin
Co-Authored-By: Claude Opus 4.6 <noreply@anthropic.com>
</commit_message>
<xml_diff>
--- a/presentation/presentation_v2.pptx
+++ b/presentation/presentation_v2.pptx
@@ -3356,7 +3356,7 @@
               </a:defRPr>
             </a:pPr>
             <a:r>
-              <a:t>$ cat analysis_results_harmonic/aspirin/data/metrics_summary.json | sort-by-mae</a:t>
+              <a:t>$ cat metrics.json | sort-by-mae  # aspirin</a:t>
             </a:r>
           </a:p>
         </p:txBody>
@@ -3395,68 +3395,100 @@
               </a:defRPr>
             </a:pPr>
             <a:r>
-              <a:t># Harmonic benchmark — aspirin (C₉H₈O₄, 51 modes)</a:t>
-            </a:r>
-          </a:p>
-          <a:p>
-            <a:pPr>
-              <a:spcAft>
-                <a:spcPts val="400"/>
-              </a:spcAft>
-              <a:defRPr sz="1400">
-                <a:solidFill>
-                  <a:srgbClr val="8B949E"/>
-                </a:solidFill>
-                <a:latin typeface="Consolas"/>
-              </a:defRPr>
-            </a:pPr>
-            <a:r>
-              <a:t>  Ref: B3LYP/6-31G(d,p)   |   sorted by MAE(freq) ascending</a:t>
-            </a:r>
-          </a:p>
-          <a:p>
-            <a:pPr>
-              <a:spcAft>
-                <a:spcPts val="400"/>
-              </a:spcAft>
-              <a:defRPr sz="1400">
-                <a:solidFill>
-                  <a:srgbClr val="8B949E"/>
-                </a:solidFill>
-                <a:latin typeface="Consolas"/>
-              </a:defRPr>
-            </a:pPr>
-          </a:p>
-          <a:p>
-            <a:pPr>
-              <a:spcAft>
-                <a:spcPts val="400"/>
-              </a:spcAft>
-              <a:defRPr sz="1400">
-                <a:solidFill>
-                  <a:srgbClr val="8B949E"/>
-                </a:solidFill>
-                <a:latin typeface="Consolas"/>
-              </a:defRPr>
-            </a:pPr>
-            <a:r>
-              <a:t>  Energy model    Dipole      MAE(freq)   R²(freq)    R²(intens)</a:t>
-            </a:r>
-          </a:p>
-          <a:p>
-            <a:pPr>
-              <a:spcAft>
-                <a:spcPts val="400"/>
-              </a:spcAft>
-              <a:defRPr sz="1400">
-                <a:solidFill>
-                  <a:srgbClr val="8B949E"/>
-                </a:solidFill>
-                <a:latin typeface="Consolas"/>
-              </a:defRPr>
-            </a:pPr>
-            <a:r>
-              <a:t>  ────────────────────────────────────────────────────────────</a:t>
+              <a:t># Harmonic benchmark — aspirin (C₉H₈O₄, 57 modes)</a:t>
+            </a:r>
+          </a:p>
+          <a:p>
+            <a:pPr>
+              <a:spcAft>
+                <a:spcPts val="400"/>
+              </a:spcAft>
+              <a:defRPr sz="1400">
+                <a:solidFill>
+                  <a:srgbClr val="8B949E"/>
+                </a:solidFill>
+                <a:latin typeface="Consolas"/>
+              </a:defRPr>
+            </a:pPr>
+            <a:r>
+              <a:t>  Ref: B3LYP/6-31G(d,p)   |   sorted by MAE ascending</a:t>
+            </a:r>
+          </a:p>
+          <a:p>
+            <a:pPr>
+              <a:spcAft>
+                <a:spcPts val="400"/>
+              </a:spcAft>
+              <a:defRPr sz="1400">
+                <a:solidFill>
+                  <a:srgbClr val="8B949E"/>
+                </a:solidFill>
+                <a:latin typeface="Consolas"/>
+              </a:defRPr>
+            </a:pPr>
+          </a:p>
+          <a:p>
+            <a:pPr>
+              <a:spcAft>
+                <a:spcPts val="400"/>
+              </a:spcAft>
+              <a:defRPr sz="1400">
+                <a:solidFill>
+                  <a:srgbClr val="8B949E"/>
+                </a:solidFill>
+                <a:latin typeface="Consolas"/>
+              </a:defRPr>
+            </a:pPr>
+            <a:r>
+              <a:t>  Energy        Dipole      MAE(freq)   R²(freq)  R²(int)  Speedup</a:t>
+            </a:r>
+          </a:p>
+          <a:p>
+            <a:pPr>
+              <a:spcAft>
+                <a:spcPts val="400"/>
+              </a:spcAft>
+              <a:defRPr sz="1400">
+                <a:solidFill>
+                  <a:srgbClr val="8B949E"/>
+                </a:solidFill>
+                <a:latin typeface="Consolas"/>
+              </a:defRPr>
+            </a:pPr>
+            <a:r>
+              <a:t>  ────────────────────────────────────────────────────────────────────</a:t>
+            </a:r>
+          </a:p>
+          <a:p>
+            <a:pPr>
+              <a:spcAft>
+                <a:spcPts val="400"/>
+              </a:spcAft>
+              <a:defRPr sz="1400">
+                <a:solidFill>
+                  <a:srgbClr val="3FB950"/>
+                </a:solidFill>
+                <a:latin typeface="Consolas"/>
+              </a:defRPr>
+            </a:pPr>
+            <a:r>
+              <a:t>  mace_anicc      mace_ml        7.6 cm⁻¹   0.9999   0.94     35.8×</a:t>
+            </a:r>
+          </a:p>
+          <a:p>
+            <a:pPr>
+              <a:spcAft>
+                <a:spcPts val="400"/>
+              </a:spcAft>
+              <a:defRPr sz="1400">
+                <a:solidFill>
+                  <a:srgbClr val="3FB950"/>
+                </a:solidFill>
+                <a:latin typeface="Consolas"/>
+              </a:defRPr>
+            </a:pPr>
+            <a:r>
+              <a:t>  mace_anicc      espaloma       7.6 cm⁻¹   0.9999   0.25     39.4×</a:t>
             </a:r>
           </a:p>
           <a:p>
@@ -3472,7 +3504,7 @@
               </a:defRPr>
             </a:pPr>
             <a:r>
-              <a:t>  mace_omol       espaloma       8.8 cm⁻¹   0.9998492   0.25</a:t>
+              <a:t>  mace_omol       espaloma       8.8 cm⁻¹   0.9998   0.25     21.6×</a:t>
             </a:r>
           </a:p>
           <a:p>
@@ -3488,7 +3520,7 @@
               </a:defRPr>
             </a:pPr>
             <a:r>
-              <a:t>  mace_omol       mace_ml        8.8 cm⁻¹   0.9998492   0.46</a:t>
+              <a:t>  mace_omol       mace_ml        8.8 cm⁻¹   0.9998   0.96     20.5×</a:t>
             </a:r>
           </a:p>
           <a:p>
@@ -3504,7 +3536,7 @@
               </a:defRPr>
             </a:pPr>
             <a:r>
-              <a:t>  mace_mp         mace_ml       97.8 cm⁻¹   0.9957866   0.29</a:t>
+              <a:t>  mace_off        espaloma      11.8 cm⁻¹   0.9998   0.26     19.8×</a:t>
             </a:r>
           </a:p>
           <a:p>
@@ -3520,21 +3552,8 @@
               </a:defRPr>
             </a:pPr>
             <a:r>
-              <a:t>  mace_mp         espaloma      97.8 cm⁻¹   0.9957866   0.15</a:t>
-            </a:r>
-          </a:p>
-          <a:p>
-            <a:pPr>
-              <a:spcAft>
-                <a:spcPts val="400"/>
-              </a:spcAft>
-              <a:defRPr sz="1400">
-                <a:solidFill>
-                  <a:srgbClr val="8B949E"/>
-                </a:solidFill>
-                <a:latin typeface="Consolas"/>
-              </a:defRPr>
-            </a:pPr>
+              <a:t>  mace_off        mace_ml       11.8 cm⁻¹   0.9998   0.95     18.8×</a:t>
+            </a:r>
           </a:p>
           <a:p>
             <a:pPr>
@@ -3549,7 +3568,7 @@
               </a:defRPr>
             </a:pPr>
             <a:r>
-              <a:t>  → mace_omol: best accuracy (MAE &lt; 9 cm⁻¹, R² 0.9998)</a:t>
+              <a:t>  mace_mp         mace_ml       97.8 cm⁻¹   0.9958   0.56     32.1×</a:t>
             </a:r>
           </a:p>
           <a:p>
@@ -3565,7 +3584,68 @@
               </a:defRPr>
             </a:pPr>
             <a:r>
-              <a:t>  → mace_mp: most speedup (~29×) but worse accuracy</a:t>
+              <a:t>  mace_mp         espaloma      97.8 cm⁻¹   0.9958   0.15     34.9×</a:t>
+            </a:r>
+          </a:p>
+          <a:p>
+            <a:pPr>
+              <a:spcAft>
+                <a:spcPts val="400"/>
+              </a:spcAft>
+              <a:defRPr sz="1400">
+                <a:solidFill>
+                  <a:srgbClr val="8B949E"/>
+                </a:solidFill>
+                <a:latin typeface="Consolas"/>
+              </a:defRPr>
+            </a:pPr>
+          </a:p>
+          <a:p>
+            <a:pPr>
+              <a:spcAft>
+                <a:spcPts val="400"/>
+              </a:spcAft>
+              <a:defRPr sz="1400">
+                <a:solidFill>
+                  <a:srgbClr val="C9D1D9"/>
+                </a:solidFill>
+                <a:latin typeface="Consolas"/>
+              </a:defRPr>
+            </a:pPr>
+            <a:r>
+              <a:t>  → 57 modes: R² now meaningful — MACE-MP drops to 0.9958</a:t>
+            </a:r>
+          </a:p>
+          <a:p>
+            <a:pPr>
+              <a:spcAft>
+                <a:spcPts val="400"/>
+              </a:spcAft>
+              <a:defRPr sz="1400">
+                <a:solidFill>
+                  <a:srgbClr val="C9D1D9"/>
+                </a:solidFill>
+                <a:latin typeface="Consolas"/>
+              </a:defRPr>
+            </a:pPr>
+            <a:r>
+              <a:t>  → MACE-ANI-CC: best accuracy (7.6 cm⁻¹), trained on coupled cluster</a:t>
+            </a:r>
+          </a:p>
+          <a:p>
+            <a:pPr>
+              <a:spcAft>
+                <a:spcPts val="400"/>
+              </a:spcAft>
+              <a:defRPr sz="1400">
+                <a:solidFill>
+                  <a:srgbClr val="C9D1D9"/>
+                </a:solidFill>
+                <a:latin typeface="Consolas"/>
+              </a:defRPr>
+            </a:pPr>
+            <a:r>
+              <a:t>  → mace_ml dipole: R²(int) 0.94–0.96 vs espaloma 0.15–0.26</a:t>
             </a:r>
           </a:p>
         </p:txBody>
@@ -7874,7 +7954,7 @@
               </a:defRPr>
             </a:pPr>
             <a:r>
-              <a:t>$ cat analysis_results_harmonic/water/data/metrics_summary.json | sort-by-mae</a:t>
+              <a:t>$ cat metrics.json | sort-by-mae  # water</a:t>
             </a:r>
           </a:p>
         </p:txBody>
@@ -7929,52 +8009,84 @@
               </a:defRPr>
             </a:pPr>
             <a:r>
-              <a:t>  Ref: B3LYP/6-31G(d,p)   |   sorted by MAE(freq) ascending</a:t>
-            </a:r>
-          </a:p>
-          <a:p>
-            <a:pPr>
-              <a:spcAft>
-                <a:spcPts val="400"/>
-              </a:spcAft>
-              <a:defRPr sz="1400">
-                <a:solidFill>
-                  <a:srgbClr val="8B949E"/>
-                </a:solidFill>
-                <a:latin typeface="Consolas"/>
-              </a:defRPr>
-            </a:pPr>
-          </a:p>
-          <a:p>
-            <a:pPr>
-              <a:spcAft>
-                <a:spcPts val="400"/>
-              </a:spcAft>
-              <a:defRPr sz="1400">
-                <a:solidFill>
-                  <a:srgbClr val="8B949E"/>
-                </a:solidFill>
-                <a:latin typeface="Consolas"/>
-              </a:defRPr>
-            </a:pPr>
-            <a:r>
-              <a:t>  Energy model    Dipole      MAE(freq)   R²(freq)    R²(intens)</a:t>
-            </a:r>
-          </a:p>
-          <a:p>
-            <a:pPr>
-              <a:spcAft>
-                <a:spcPts val="400"/>
-              </a:spcAft>
-              <a:defRPr sz="1400">
-                <a:solidFill>
-                  <a:srgbClr val="8B949E"/>
-                </a:solidFill>
-                <a:latin typeface="Consolas"/>
-              </a:defRPr>
-            </a:pPr>
-            <a:r>
-              <a:t>  ────────────────────────────────────────────────────────────</a:t>
+              <a:t>  Ref: B3LYP/6-31G(d,p)   |   sorted by MAE ascending</a:t>
+            </a:r>
+          </a:p>
+          <a:p>
+            <a:pPr>
+              <a:spcAft>
+                <a:spcPts val="400"/>
+              </a:spcAft>
+              <a:defRPr sz="1400">
+                <a:solidFill>
+                  <a:srgbClr val="8B949E"/>
+                </a:solidFill>
+                <a:latin typeface="Consolas"/>
+              </a:defRPr>
+            </a:pPr>
+          </a:p>
+          <a:p>
+            <a:pPr>
+              <a:spcAft>
+                <a:spcPts val="400"/>
+              </a:spcAft>
+              <a:defRPr sz="1400">
+                <a:solidFill>
+                  <a:srgbClr val="8B949E"/>
+                </a:solidFill>
+                <a:latin typeface="Consolas"/>
+              </a:defRPr>
+            </a:pPr>
+            <a:r>
+              <a:t>  Energy        Dipole      MAE(freq)   R²(freq)  R²(int)</a:t>
+            </a:r>
+          </a:p>
+          <a:p>
+            <a:pPr>
+              <a:spcAft>
+                <a:spcPts val="400"/>
+              </a:spcAft>
+              <a:defRPr sz="1400">
+                <a:solidFill>
+                  <a:srgbClr val="8B949E"/>
+                </a:solidFill>
+                <a:latin typeface="Consolas"/>
+              </a:defRPr>
+            </a:pPr>
+            <a:r>
+              <a:t>  ──────────────────────────────────────────────────────────</a:t>
+            </a:r>
+          </a:p>
+          <a:p>
+            <a:pPr>
+              <a:spcAft>
+                <a:spcPts val="400"/>
+              </a:spcAft>
+              <a:defRPr sz="1400">
+                <a:solidFill>
+                  <a:srgbClr val="3FB950"/>
+                </a:solidFill>
+                <a:latin typeface="Consolas"/>
+              </a:defRPr>
+            </a:pPr>
+            <a:r>
+              <a:t>  mace_anicc      mace_ml       19.0 cm⁻¹   1.0000   0.72</a:t>
+            </a:r>
+          </a:p>
+          <a:p>
+            <a:pPr>
+              <a:spcAft>
+                <a:spcPts val="400"/>
+              </a:spcAft>
+              <a:defRPr sz="1400">
+                <a:solidFill>
+                  <a:srgbClr val="3FB950"/>
+                </a:solidFill>
+                <a:latin typeface="Consolas"/>
+              </a:defRPr>
+            </a:pPr>
+            <a:r>
+              <a:t>  mace_anicc      espaloma      19.0 cm⁻¹   1.0000   0.52</a:t>
             </a:r>
           </a:p>
           <a:p>
@@ -7990,7 +8102,7 @@
               </a:defRPr>
             </a:pPr>
             <a:r>
-              <a:t>  mace_anicc      mace_ml       19.0 cm⁻¹   0.9999974   0.72</a:t>
+              <a:t>  mace_off        espaloma      20.7 cm⁻¹   0.9999   0.52</a:t>
             </a:r>
           </a:p>
           <a:p>
@@ -8006,7 +8118,7 @@
               </a:defRPr>
             </a:pPr>
             <a:r>
-              <a:t>  mace_anicc      espaloma      19.0 cm⁻¹   0.9999974   0.52</a:t>
+              <a:t>  mace_off        mace_ml       20.7 cm⁻¹   0.9999   0.72</a:t>
             </a:r>
           </a:p>
           <a:p>
@@ -8022,7 +8134,7 @@
               </a:defRPr>
             </a:pPr>
             <a:r>
-              <a:t>  mace_off        espaloma      20.7 cm⁻¹   0.9999344   0.52</a:t>
+              <a:t>  mace_omol       espaloma      22.7 cm⁻¹   1.0000   0.52</a:t>
             </a:r>
           </a:p>
           <a:p>
@@ -8038,7 +8150,7 @@
               </a:defRPr>
             </a:pPr>
             <a:r>
-              <a:t>  mace_off        mace_ml       20.7 cm⁻¹   0.9999344   0.72</a:t>
+              <a:t>  mace_omol       mace_ml       22.7 cm⁻¹   1.0000   0.72</a:t>
             </a:r>
           </a:p>
           <a:p>
@@ -8054,7 +8166,7 @@
               </a:defRPr>
             </a:pPr>
             <a:r>
-              <a:t>  mace_omol       espaloma      22.7 cm⁻¹   0.9999631   0.52</a:t>
+              <a:t>  mace_mp         mace_ml      106.3 cm⁻¹   1.0000   0.72</a:t>
             </a:r>
           </a:p>
           <a:p>
@@ -8070,7 +8182,52 @@
               </a:defRPr>
             </a:pPr>
             <a:r>
-              <a:t>  mace_omol       mace_ml       22.7 cm⁻¹   0.9999631   0.72</a:t>
+              <a:t>  mace_mp         espaloma     106.3 cm⁻¹   1.0000   0.51</a:t>
+            </a:r>
+          </a:p>
+          <a:p>
+            <a:pPr>
+              <a:spcAft>
+                <a:spcPts val="400"/>
+              </a:spcAft>
+              <a:defRPr sz="1400">
+                <a:solidFill>
+                  <a:srgbClr val="8B949E"/>
+                </a:solidFill>
+                <a:latin typeface="Consolas"/>
+              </a:defRPr>
+            </a:pPr>
+          </a:p>
+          <a:p>
+            <a:pPr>
+              <a:spcAft>
+                <a:spcPts val="400"/>
+              </a:spcAft>
+              <a:defRPr sz="1400">
+                <a:solidFill>
+                  <a:srgbClr val="D29922"/>
+                </a:solidFill>
+                <a:latin typeface="Consolas"/>
+              </a:defRPr>
+            </a:pPr>
+            <a:r>
+              <a:t>  ⚠ R²(freq) misleading: only 3 data points — any line fits well</a:t>
+            </a:r>
+          </a:p>
+          <a:p>
+            <a:pPr>
+              <a:spcAft>
+                <a:spcPts val="400"/>
+              </a:spcAft>
+              <a:defRPr sz="1400">
+                <a:solidFill>
+                  <a:srgbClr val="D29922"/>
+                </a:solidFill>
+                <a:latin typeface="Consolas"/>
+              </a:defRPr>
+            </a:pPr>
+            <a:r>
+              <a:t>    MACE-MP has best R² despite 106 cm⁻¹ MAE (systematic shift)</a:t>
             </a:r>
           </a:p>
           <a:p>
@@ -8086,7 +8243,7 @@
               </a:defRPr>
             </a:pPr>
             <a:r>
-              <a:t>  mace_mp         mace_ml      106.3 cm⁻¹   0.9999981   0.72</a:t>
+              <a:t>  → MAE is the reliable metric here</a:t>
             </a:r>
           </a:p>
           <a:p>
@@ -8102,52 +8259,7 @@
               </a:defRPr>
             </a:pPr>
             <a:r>
-              <a:t>  mace_mp         espaloma     106.3 cm⁻¹   0.9999981   0.51</a:t>
-            </a:r>
-          </a:p>
-          <a:p>
-            <a:pPr>
-              <a:spcAft>
-                <a:spcPts val="400"/>
-              </a:spcAft>
-              <a:defRPr sz="1400">
-                <a:solidFill>
-                  <a:srgbClr val="8B949E"/>
-                </a:solidFill>
-                <a:latin typeface="Consolas"/>
-              </a:defRPr>
-            </a:pPr>
-          </a:p>
-          <a:p>
-            <a:pPr>
-              <a:spcAft>
-                <a:spcPts val="400"/>
-              </a:spcAft>
-              <a:defRPr sz="1400">
-                <a:solidFill>
-                  <a:srgbClr val="C9D1D9"/>
-                </a:solidFill>
-                <a:latin typeface="Consolas"/>
-              </a:defRPr>
-            </a:pPr>
-            <a:r>
-              <a:t>  → Frequencies: all combos excellent (R² &gt; 0.9999)</a:t>
-            </a:r>
-          </a:p>
-          <a:p>
-            <a:pPr>
-              <a:spcAft>
-                <a:spcPts val="400"/>
-              </a:spcAft>
-              <a:defRPr sz="1400">
-                <a:solidFill>
-                  <a:srgbClr val="C9D1D9"/>
-                </a:solidFill>
-                <a:latin typeface="Consolas"/>
-              </a:defRPr>
-            </a:pPr>
-            <a:r>
-              <a:t>  → Intensities: mace_ml consistently beats espaloma</a:t>
+              <a:t>  → mace_ml consistently beats espaloma on intensities</a:t>
             </a:r>
           </a:p>
         </p:txBody>

</xml_diff>

<commit_message>
feat(slides): scaling — best-accuracy combo speedup, water vs aspirin, anharmonic note
Co-Authored-By: Claude Opus 4.6 <noreply@anthropic.com>
</commit_message>
<xml_diff>
--- a/presentation/presentation_v2.pptx
+++ b/presentation/presentation_v2.pptx
@@ -3782,68 +3782,68 @@
               </a:defRPr>
             </a:pPr>
             <a:r>
-              <a:t># ML speedup scales with molecule size</a:t>
-            </a:r>
-          </a:p>
-          <a:p>
-            <a:pPr>
-              <a:spcAft>
-                <a:spcPts val="400"/>
-              </a:spcAft>
-              <a:defRPr sz="1400">
-                <a:solidFill>
-                  <a:srgbClr val="8B949E"/>
-                </a:solidFill>
-                <a:latin typeface="Consolas"/>
-              </a:defRPr>
-            </a:pPr>
-            <a:r>
-              <a:t>  Dipole step: ML vs DFT (B3LYP/6-31G(d,p))</a:t>
-            </a:r>
-          </a:p>
-          <a:p>
-            <a:pPr>
-              <a:spcAft>
-                <a:spcPts val="400"/>
-              </a:spcAft>
-              <a:defRPr sz="1400">
-                <a:solidFill>
-                  <a:srgbClr val="8B949E"/>
-                </a:solidFill>
-                <a:latin typeface="Consolas"/>
-              </a:defRPr>
-            </a:pPr>
-          </a:p>
-          <a:p>
-            <a:pPr>
-              <a:spcAft>
-                <a:spcPts val="400"/>
-              </a:spcAft>
-              <a:defRPr sz="1400">
-                <a:solidFill>
-                  <a:srgbClr val="8B949E"/>
-                </a:solidFill>
-                <a:latin typeface="Consolas"/>
-              </a:defRPr>
-            </a:pPr>
-            <a:r>
-              <a:t>  molecule      atoms         speedup</a:t>
-            </a:r>
-          </a:p>
-          <a:p>
-            <a:pPr>
-              <a:spcAft>
-                <a:spcPts val="400"/>
-              </a:spcAft>
-              <a:defRPr sz="1400">
-                <a:solidFill>
-                  <a:srgbClr val="8B949E"/>
-                </a:solidFill>
-                <a:latin typeface="Consolas"/>
-              </a:defRPr>
-            </a:pPr>
-            <a:r>
-              <a:t>  ──────────────────────────────────────────────────</a:t>
+              <a:t># ML speedup — best-accuracy combo per molecule</a:t>
+            </a:r>
+          </a:p>
+          <a:p>
+            <a:pPr>
+              <a:spcAft>
+                <a:spcPts val="400"/>
+              </a:spcAft>
+              <a:defRPr sz="1400">
+                <a:solidFill>
+                  <a:srgbClr val="8B949E"/>
+                </a:solidFill>
+                <a:latin typeface="Consolas"/>
+              </a:defRPr>
+            </a:pPr>
+            <a:r>
+              <a:t>  Includes full anharmonic VPT2 calculation</a:t>
+            </a:r>
+          </a:p>
+          <a:p>
+            <a:pPr>
+              <a:spcAft>
+                <a:spcPts val="400"/>
+              </a:spcAft>
+              <a:defRPr sz="1400">
+                <a:solidFill>
+                  <a:srgbClr val="8B949E"/>
+                </a:solidFill>
+                <a:latin typeface="Consolas"/>
+              </a:defRPr>
+            </a:pPr>
+          </a:p>
+          <a:p>
+            <a:pPr>
+              <a:spcAft>
+                <a:spcPts val="400"/>
+              </a:spcAft>
+              <a:defRPr sz="1400">
+                <a:solidFill>
+                  <a:srgbClr val="8B949E"/>
+                </a:solidFill>
+                <a:latin typeface="Consolas"/>
+              </a:defRPr>
+            </a:pPr>
+            <a:r>
+              <a:t>  molecule    atoms    best combo                  speedup</a:t>
+            </a:r>
+          </a:p>
+          <a:p>
+            <a:pPr>
+              <a:spcAft>
+                <a:spcPts val="400"/>
+              </a:spcAft>
+              <a:defRPr sz="1400">
+                <a:solidFill>
+                  <a:srgbClr val="8B949E"/>
+                </a:solidFill>
+                <a:latin typeface="Consolas"/>
+              </a:defRPr>
+            </a:pPr>
+            <a:r>
+              <a:t>  ──────────────────────────────────────────────────────────────</a:t>
             </a:r>
           </a:p>
           <a:p>
@@ -3859,8 +3859,95 @@
               </a:defRPr>
             </a:pPr>
             <a:r>
-              <a:t>  water       ( 3 atoms)  |=                   |  ~1×</a:t>
-            </a:r>
+              <a:t>  water        3      mace_anicc / mace_ml           1.2×</a:t>
+            </a:r>
+          </a:p>
+          <a:p>
+            <a:pPr>
+              <a:spcAft>
+                <a:spcPts val="400"/>
+              </a:spcAft>
+              <a:defRPr sz="1400">
+                <a:solidFill>
+                  <a:srgbClr val="58A6FF"/>
+                </a:solidFill>
+                <a:latin typeface="Consolas"/>
+              </a:defRPr>
+            </a:pPr>
+            <a:r>
+              <a:t>               |=                             |</a:t>
+            </a:r>
+          </a:p>
+          <a:p>
+            <a:pPr>
+              <a:spcAft>
+                <a:spcPts val="400"/>
+              </a:spcAft>
+              <a:defRPr sz="1400">
+                <a:solidFill>
+                  <a:srgbClr val="8B949E"/>
+                </a:solidFill>
+                <a:latin typeface="Consolas"/>
+              </a:defRPr>
+            </a:pPr>
+          </a:p>
+          <a:p>
+            <a:pPr>
+              <a:spcAft>
+                <a:spcPts val="400"/>
+              </a:spcAft>
+              <a:defRPr sz="1400">
+                <a:solidFill>
+                  <a:srgbClr val="3FB950"/>
+                </a:solidFill>
+                <a:latin typeface="Consolas"/>
+              </a:defRPr>
+            </a:pPr>
+            <a:r>
+              <a:t>  aspirin     21      mace_anicc / mace_ml          35.8×</a:t>
+            </a:r>
+          </a:p>
+          <a:p>
+            <a:pPr>
+              <a:spcAft>
+                <a:spcPts val="400"/>
+              </a:spcAft>
+              <a:defRPr sz="1400">
+                <a:solidFill>
+                  <a:srgbClr val="3FB950"/>
+                </a:solidFill>
+                <a:latin typeface="Consolas"/>
+              </a:defRPr>
+            </a:pPr>
+            <a:r>
+              <a:t>               |==============================|</a:t>
+            </a:r>
+          </a:p>
+          <a:p>
+            <a:pPr>
+              <a:spcAft>
+                <a:spcPts val="400"/>
+              </a:spcAft>
+              <a:defRPr sz="1400">
+                <a:solidFill>
+                  <a:srgbClr val="8B949E"/>
+                </a:solidFill>
+                <a:latin typeface="Consolas"/>
+              </a:defRPr>
+            </a:pPr>
+          </a:p>
+          <a:p>
+            <a:pPr>
+              <a:spcAft>
+                <a:spcPts val="400"/>
+              </a:spcAft>
+              <a:defRPr sz="1400">
+                <a:solidFill>
+                  <a:srgbClr val="8B949E"/>
+                </a:solidFill>
+                <a:latin typeface="Consolas"/>
+              </a:defRPr>
+            </a:pPr>
           </a:p>
           <a:p>
             <a:pPr>
@@ -3875,7 +3962,7 @@
               </a:defRPr>
             </a:pPr>
             <a:r>
-              <a:t>  glycine     (10 atoms)  |======              |  ~7–10×</a:t>
+              <a:t>  → Water too small for ML to outpace DFT overhead</a:t>
             </a:r>
           </a:p>
           <a:p>
@@ -3891,21 +3978,8 @@
               </a:defRPr>
             </a:pPr>
             <a:r>
-              <a:t>  aspirin     (21 atoms)  |====================|  ~18–29×</a:t>
-            </a:r>
-          </a:p>
-          <a:p>
-            <a:pPr>
-              <a:spcAft>
-                <a:spcPts val="400"/>
-              </a:spcAft>
-              <a:defRPr sz="1400">
-                <a:solidFill>
-                  <a:srgbClr val="8B949E"/>
-                </a:solidFill>
-                <a:latin typeface="Consolas"/>
-              </a:defRPr>
-            </a:pPr>
+              <a:t>  → Aspirin: 21 atoms × 3 dirs × 2 = 126 displacements → ML wins</a:t>
+            </a:r>
           </a:p>
           <a:p>
             <a:pPr>
@@ -3920,84 +3994,36 @@
               </a:defRPr>
             </a:pPr>
             <a:r>
-              <a:t>  → Water (3 atoms): ML overhead visible — no speedup at this scale</a:t>
-            </a:r>
-          </a:p>
-          <a:p>
-            <a:pPr>
-              <a:spcAft>
-                <a:spcPts val="400"/>
-              </a:spcAft>
-              <a:defRPr sz="1400">
-                <a:solidFill>
-                  <a:srgbClr val="C9D1D9"/>
-                </a:solidFill>
-                <a:latin typeface="Consolas"/>
-              </a:defRPr>
-            </a:pPr>
-            <a:r>
-              <a:t>  → Glycine (10 atoms): ~7–10× — target use case</a:t>
-            </a:r>
-          </a:p>
-          <a:p>
-            <a:pPr>
-              <a:spcAft>
-                <a:spcPts val="400"/>
-              </a:spcAft>
-              <a:defRPr sz="1400">
-                <a:solidFill>
-                  <a:srgbClr val="C9D1D9"/>
-                </a:solidFill>
-                <a:latin typeface="Consolas"/>
-              </a:defRPr>
-            </a:pPr>
-            <a:r>
-              <a:t>  → Aspirin (21 atoms): ~18–29× — strong benefit</a:t>
-            </a:r>
-          </a:p>
-          <a:p>
-            <a:pPr>
-              <a:spcAft>
-                <a:spcPts val="400"/>
-              </a:spcAft>
-              <a:defRPr sz="1400">
-                <a:solidFill>
-                  <a:srgbClr val="8B949E"/>
-                </a:solidFill>
-                <a:latin typeface="Consolas"/>
-              </a:defRPr>
-            </a:pPr>
-          </a:p>
-          <a:p>
-            <a:pPr>
-              <a:spcAft>
-                <a:spcPts val="400"/>
-              </a:spcAft>
-              <a:defRPr sz="1400">
-                <a:solidFill>
-                  <a:srgbClr val="8B949E"/>
-                </a:solidFill>
-                <a:latin typeface="Consolas"/>
-              </a:defRPr>
-            </a:pPr>
-            <a:r>
-              <a:t>  Speedup source: DFT dipoles O(N³); ML dipoles O(N)</a:t>
-            </a:r>
-          </a:p>
-          <a:p>
-            <a:pPr>
-              <a:spcAft>
-                <a:spcPts val="400"/>
-              </a:spcAft>
-              <a:defRPr sz="1400">
-                <a:solidFill>
-                  <a:srgbClr val="8B949E"/>
-                </a:solidFill>
-                <a:latin typeface="Consolas"/>
-              </a:defRPr>
-            </a:pPr>
-            <a:r>
-              <a:t>  (estimated ranges — not benchmarked to the second)</a:t>
+              <a:t>  → Harmonic-only would be even faster (less Gaussian overhead)</a:t>
+            </a:r>
+          </a:p>
+          <a:p>
+            <a:pPr>
+              <a:spcAft>
+                <a:spcPts val="400"/>
+              </a:spcAft>
+              <a:defRPr sz="1400">
+                <a:solidFill>
+                  <a:srgbClr val="8B949E"/>
+                </a:solidFill>
+                <a:latin typeface="Consolas"/>
+              </a:defRPr>
+            </a:pPr>
+          </a:p>
+          <a:p>
+            <a:pPr>
+              <a:spcAft>
+                <a:spcPts val="400"/>
+              </a:spcAft>
+              <a:defRPr sz="1400">
+                <a:solidFill>
+                  <a:srgbClr val="8B949E"/>
+                </a:solidFill>
+                <a:latin typeface="Consolas"/>
+              </a:defRPr>
+            </a:pPr>
+            <a:r>
+              <a:t>  // speedup = wall time DFT / wall time ML (same machine, same basis)</a:t>
             </a:r>
           </a:p>
         </p:txBody>

</xml_diff>

<commit_message>
feat(slides): scaling bars inline with table rows
Co-Authored-By: Claude Opus 4.6 <noreply@anthropic.com>
</commit_message>
<xml_diff>
--- a/presentation/presentation_v2.pptx
+++ b/presentation/presentation_v2.pptx
@@ -3853,43 +3853,14 @@
               </a:spcAft>
               <a:defRPr sz="1400">
                 <a:solidFill>
-                  <a:srgbClr val="C9D1D9"/>
-                </a:solidFill>
-                <a:latin typeface="Consolas"/>
-              </a:defRPr>
-            </a:pPr>
-            <a:r>
-              <a:t>  water        3      mace_anicc / mace_ml           1.2×</a:t>
-            </a:r>
-          </a:p>
-          <a:p>
-            <a:pPr>
-              <a:spcAft>
-                <a:spcPts val="400"/>
-              </a:spcAft>
-              <a:defRPr sz="1400">
-                <a:solidFill>
                   <a:srgbClr val="58A6FF"/>
                 </a:solidFill>
                 <a:latin typeface="Consolas"/>
               </a:defRPr>
             </a:pPr>
             <a:r>
-              <a:t>               |=                             |</a:t>
-            </a:r>
-          </a:p>
-          <a:p>
-            <a:pPr>
-              <a:spcAft>
-                <a:spcPts val="400"/>
-              </a:spcAft>
-              <a:defRPr sz="1400">
-                <a:solidFill>
-                  <a:srgbClr val="8B949E"/>
-                </a:solidFill>
-                <a:latin typeface="Consolas"/>
-              </a:defRPr>
-            </a:pPr>
+              <a:t>  water        3      mace_anicc / mace_ml         |=                             |   1.2×</a:t>
+            </a:r>
           </a:p>
           <a:p>
             <a:pPr>
@@ -3904,23 +3875,7 @@
               </a:defRPr>
             </a:pPr>
             <a:r>
-              <a:t>  aspirin     21      mace_anicc / mace_ml          35.8×</a:t>
-            </a:r>
-          </a:p>
-          <a:p>
-            <a:pPr>
-              <a:spcAft>
-                <a:spcPts val="400"/>
-              </a:spcAft>
-              <a:defRPr sz="1400">
-                <a:solidFill>
-                  <a:srgbClr val="3FB950"/>
-                </a:solidFill>
-                <a:latin typeface="Consolas"/>
-              </a:defRPr>
-            </a:pPr>
-            <a:r>
-              <a:t>               |==============================|</a:t>
+              <a:t>  aspirin     21      mace_anicc / mace_ml         |==============================|  35.8×</a:t>
             </a:r>
           </a:p>
           <a:p>

</xml_diff>

<commit_message>
feat(slides): status — built/results/next single column, updated numbers, thesis question
Co-Authored-By: Claude Opus 4.6 <noreply@anthropic.com>
</commit_message>
<xml_diff>
--- a/presentation/presentation_v2.pptx
+++ b/presentation/presentation_v2.pptx
@@ -4089,8 +4089,8 @@
         </p:nvSpPr>
         <p:spPr>
           <a:xfrm>
-            <a:off x="457200" y="1051560"/>
-            <a:ext cx="4389120" cy="4937760"/>
+            <a:off x="685800" y="1051560"/>
+            <a:ext cx="7772400" cy="4937760"/>
           </a:xfrm>
           <a:prstGeom prst="rect">
             <a:avLst/>
@@ -4105,9 +4105,9 @@
           <a:p>
             <a:pPr>
               <a:spcAft>
-                <a:spcPts val="300"/>
-              </a:spcAft>
-              <a:defRPr sz="1300">
+                <a:spcPts val="400"/>
+              </a:spcAft>
+              <a:defRPr sz="1400">
                 <a:solidFill>
                   <a:srgbClr val="58A6FF"/>
                 </a:solidFill>
@@ -4121,9 +4121,9 @@
           <a:p>
             <a:pPr>
               <a:spcAft>
-                <a:spcPts val="300"/>
-              </a:spcAft>
-              <a:defRPr sz="1300">
+                <a:spcPts val="400"/>
+              </a:spcAft>
+              <a:defRPr sz="1400">
                 <a:solidFill>
                   <a:srgbClr val="C9D1D9"/>
                 </a:solidFill>
@@ -4131,31 +4131,15 @@
               </a:defRPr>
             </a:pPr>
             <a:r>
-              <a:t>  ZMQ bridge: ML dipoles → Gaussian VPT2</a:t>
-            </a:r>
-          </a:p>
-          <a:p>
-            <a:pPr>
-              <a:spcAft>
-                <a:spcPts val="300"/>
-              </a:spcAft>
-              <a:defRPr sz="1300">
-                <a:solidFill>
-                  <a:srgbClr val="8B949E"/>
-                </a:solidFill>
-                <a:latin typeface="Consolas"/>
-              </a:defRPr>
-            </a:pPr>
-            <a:r>
-              <a:t>  CLI: mace-gaussian run molecule.xyz</a:t>
-            </a:r>
-          </a:p>
-          <a:p>
-            <a:pPr>
-              <a:spcAft>
-                <a:spcPts val="300"/>
-              </a:spcAft>
-              <a:defRPr sz="1300">
+              <a:t>  → ZMQ bridge: ML dipoles → Gaussian VPT2 (harmonic + anharmonic)</a:t>
+            </a:r>
+          </a:p>
+          <a:p>
+            <a:pPr>
+              <a:spcAft>
+                <a:spcPts val="400"/>
+              </a:spcAft>
+              <a:defRPr sz="1400">
                 <a:solidFill>
                   <a:srgbClr val="C9D1D9"/>
                 </a:solidFill>
@@ -4163,28 +4147,44 @@
               </a:defRPr>
             </a:pPr>
             <a:r>
-              <a:t>  4 energy × 2 dipole models = 8 combinations</a:t>
-            </a:r>
-          </a:p>
-          <a:p>
-            <a:pPr>
-              <a:spcAft>
-                <a:spcPts val="300"/>
-              </a:spcAft>
-              <a:defRPr sz="1300">
-                <a:solidFill>
-                  <a:srgbClr val="8B949E"/>
-                </a:solidFill>
-                <a:latin typeface="Consolas"/>
-              </a:defRPr>
-            </a:pPr>
-          </a:p>
-          <a:p>
-            <a:pPr>
-              <a:spcAft>
-                <a:spcPts val="300"/>
-              </a:spcAft>
-              <a:defRPr sz="1300">
+              <a:t>  → 4 energy × 2 dipole models = 8 calculator combinations</a:t>
+            </a:r>
+          </a:p>
+          <a:p>
+            <a:pPr>
+              <a:spcAft>
+                <a:spcPts val="400"/>
+              </a:spcAft>
+              <a:defRPr sz="1400">
+                <a:solidFill>
+                  <a:srgbClr val="8B949E"/>
+                </a:solidFill>
+                <a:latin typeface="Consolas"/>
+              </a:defRPr>
+            </a:pPr>
+            <a:r>
+              <a:t>  → CLI: mace-gaussian run molecule.xyz</a:t>
+            </a:r>
+          </a:p>
+          <a:p>
+            <a:pPr>
+              <a:spcAft>
+                <a:spcPts val="400"/>
+              </a:spcAft>
+              <a:defRPr sz="1400">
+                <a:solidFill>
+                  <a:srgbClr val="8B949E"/>
+                </a:solidFill>
+                <a:latin typeface="Consolas"/>
+              </a:defRPr>
+            </a:pPr>
+          </a:p>
+          <a:p>
+            <a:pPr>
+              <a:spcAft>
+                <a:spcPts val="400"/>
+              </a:spcAft>
+              <a:defRPr sz="1400">
                 <a:solidFill>
                   <a:srgbClr val="58A6FF"/>
                 </a:solidFill>
@@ -4192,15 +4192,92 @@
               </a:defRPr>
             </a:pPr>
             <a:r>
-              <a:t># What we ran</a:t>
-            </a:r>
-          </a:p>
-          <a:p>
-            <a:pPr>
-              <a:spcAft>
-                <a:spcPts val="300"/>
-              </a:spcAft>
-              <a:defRPr sz="1300">
+              <a:t># Preliminary results</a:t>
+            </a:r>
+          </a:p>
+          <a:p>
+            <a:pPr>
+              <a:spcAft>
+                <a:spcPts val="400"/>
+              </a:spcAft>
+              <a:defRPr sz="1400">
+                <a:solidFill>
+                  <a:srgbClr val="3FB950"/>
+                </a:solidFill>
+                <a:latin typeface="Consolas"/>
+              </a:defRPr>
+            </a:pPr>
+            <a:r>
+              <a:t>  → Frequencies: R² &gt; 0.999 for best combos (MACE-ANI-CC, MACE-OMOL)</a:t>
+            </a:r>
+          </a:p>
+          <a:p>
+            <a:pPr>
+              <a:spcAft>
+                <a:spcPts val="400"/>
+              </a:spcAft>
+              <a:defRPr sz="1400">
+                <a:solidFill>
+                  <a:srgbClr val="3FB950"/>
+                </a:solidFill>
+                <a:latin typeface="Consolas"/>
+              </a:defRPr>
+            </a:pPr>
+            <a:r>
+              <a:t>  → Intensities: MACE4IR &gt;&gt; Espaloma (R² 0.95 vs 0.25 on aspirin)</a:t>
+            </a:r>
+          </a:p>
+          <a:p>
+            <a:pPr>
+              <a:spcAft>
+                <a:spcPts val="400"/>
+              </a:spcAft>
+              <a:defRPr sz="1400">
+                <a:solidFill>
+                  <a:srgbClr val="3FB950"/>
+                </a:solidFill>
+                <a:latin typeface="Consolas"/>
+              </a:defRPr>
+            </a:pPr>
+            <a:r>
+              <a:t>  → Speedup: ~36× on aspirin (incl. anharmonic)</a:t>
+            </a:r>
+          </a:p>
+          <a:p>
+            <a:pPr>
+              <a:spcAft>
+                <a:spcPts val="400"/>
+              </a:spcAft>
+              <a:defRPr sz="1400">
+                <a:solidFill>
+                  <a:srgbClr val="8B949E"/>
+                </a:solidFill>
+                <a:latin typeface="Consolas"/>
+              </a:defRPr>
+            </a:pPr>
+          </a:p>
+          <a:p>
+            <a:pPr>
+              <a:spcAft>
+                <a:spcPts val="400"/>
+              </a:spcAft>
+              <a:defRPr sz="1400">
+                <a:solidFill>
+                  <a:srgbClr val="58A6FF"/>
+                </a:solidFill>
+                <a:latin typeface="Consolas"/>
+              </a:defRPr>
+            </a:pPr>
+            <a:r>
+              <a:t># Next steps</a:t>
+            </a:r>
+          </a:p>
+          <a:p>
+            <a:pPr>
+              <a:spcAft>
+                <a:spcPts val="400"/>
+              </a:spcAft>
+              <a:defRPr sz="1400">
                 <a:solidFill>
                   <a:srgbClr val="C9D1D9"/>
                 </a:solidFill>
@@ -4208,44 +4285,76 @@
               </a:defRPr>
             </a:pPr>
             <a:r>
-              <a:t>  Harmonic benchmark across 8 molecules</a:t>
-            </a:r>
-          </a:p>
-          <a:p>
-            <a:pPr>
-              <a:spcAft>
-                <a:spcPts val="300"/>
-              </a:spcAft>
-              <a:defRPr sz="1300">
-                <a:solidFill>
-                  <a:srgbClr val="8B949E"/>
-                </a:solidFill>
-                <a:latin typeface="Consolas"/>
-              </a:defRPr>
-            </a:pPr>
-            <a:r>
-              <a:t>  Water, aspirin, glycine, methane, ethane, NH₃, CO</a:t>
-            </a:r>
-          </a:p>
-          <a:p>
-            <a:pPr>
-              <a:spcAft>
-                <a:spcPts val="300"/>
-              </a:spcAft>
-              <a:defRPr sz="1300">
-                <a:solidFill>
-                  <a:srgbClr val="8B949E"/>
-                </a:solidFill>
-                <a:latin typeface="Consolas"/>
-              </a:defRPr>
-            </a:pPr>
-          </a:p>
-          <a:p>
-            <a:pPr>
-              <a:spcAft>
-                <a:spcPts val="300"/>
-              </a:spcAft>
-              <a:defRPr sz="1300">
+              <a:t>  → Systematic benchmark campaign</a:t>
+            </a:r>
+          </a:p>
+          <a:p>
+            <a:pPr>
+              <a:spcAft>
+                <a:spcPts val="400"/>
+              </a:spcAft>
+              <a:defRPr sz="1400">
+                <a:solidFill>
+                  <a:srgbClr val="8B949E"/>
+                </a:solidFill>
+                <a:latin typeface="Consolas"/>
+              </a:defRPr>
+            </a:pPr>
+            <a:r>
+              <a:t>    Growing molecule size: CH₄ → C₂H₆ → C₃H₈ → C₄H₁₀ (scaling)</a:t>
+            </a:r>
+          </a:p>
+          <a:p>
+            <a:pPr>
+              <a:spcAft>
+                <a:spcPts val="400"/>
+              </a:spcAft>
+              <a:defRPr sz="1400">
+                <a:solidFill>
+                  <a:srgbClr val="8B949E"/>
+                </a:solidFill>
+                <a:latin typeface="Consolas"/>
+              </a:defRPr>
+            </a:pPr>
+            <a:r>
+              <a:t>    New functional groups: methanol, acetone, aniline (chemistry)</a:t>
+            </a:r>
+          </a:p>
+          <a:p>
+            <a:pPr>
+              <a:spcAft>
+                <a:spcPts val="400"/>
+              </a:spcAft>
+              <a:defRPr sz="1400">
+                <a:solidFill>
+                  <a:srgbClr val="8B949E"/>
+                </a:solidFill>
+                <a:latin typeface="Consolas"/>
+              </a:defRPr>
+            </a:pPr>
+            <a:r>
+              <a:t>    Larger targets: paracetamol, caffeine, ibuprofen</a:t>
+            </a:r>
+          </a:p>
+          <a:p>
+            <a:pPr>
+              <a:spcAft>
+                <a:spcPts val="400"/>
+              </a:spcAft>
+              <a:defRPr sz="1400">
+                <a:solidFill>
+                  <a:srgbClr val="8B949E"/>
+                </a:solidFill>
+                <a:latin typeface="Consolas"/>
+              </a:defRPr>
+            </a:pPr>
+          </a:p>
+          <a:p>
+            <a:pPr>
+              <a:spcAft>
+                <a:spcPts val="400"/>
+              </a:spcAft>
+              <a:defRPr sz="1400">
                 <a:solidFill>
                   <a:srgbClr val="58A6FF"/>
                 </a:solidFill>
@@ -4253,55 +4362,23 @@
               </a:defRPr>
             </a:pPr>
             <a:r>
-              <a:t># What we found</a:t>
-            </a:r>
-          </a:p>
-          <a:p>
-            <a:pPr>
-              <a:spcAft>
-                <a:spcPts val="300"/>
-              </a:spcAft>
-              <a:defRPr sz="1300">
-                <a:solidFill>
-                  <a:srgbClr val="3FB950"/>
-                </a:solidFill>
-                <a:latin typeface="Consolas"/>
-              </a:defRPr>
-            </a:pPr>
-            <a:r>
-              <a:t>  Frequencies: R² &gt; 0.999 across all combos ✓</a:t>
-            </a:r>
-          </a:p>
-          <a:p>
-            <a:pPr>
-              <a:spcAft>
-                <a:spcPts val="300"/>
-              </a:spcAft>
-              <a:defRPr sz="1300">
-                <a:solidFill>
-                  <a:srgbClr val="3FB950"/>
-                </a:solidFill>
-                <a:latin typeface="Consolas"/>
-              </a:defRPr>
-            </a:pPr>
-            <a:r>
-              <a:t>  Intensities: mace_ml &gt;&gt; espaloma (0.72 vs 0.52)</a:t>
-            </a:r>
-          </a:p>
-          <a:p>
-            <a:pPr>
-              <a:spcAft>
-                <a:spcPts val="300"/>
-              </a:spcAft>
-              <a:defRPr sz="1300">
-                <a:solidFill>
-                  <a:srgbClr val="3FB950"/>
-                </a:solidFill>
-                <a:latin typeface="Consolas"/>
-              </a:defRPr>
-            </a:pPr>
-            <a:r>
-              <a:t>  Speedup scales with molecule size (aspirin: ~18×)</a:t>
+              <a:t># Thesis question</a:t>
+            </a:r>
+          </a:p>
+          <a:p>
+            <a:pPr>
+              <a:spcAft>
+                <a:spcPts val="400"/>
+              </a:spcAft>
+              <a:defRPr sz="1400">
+                <a:solidFill>
+                  <a:srgbClr val="C9D1D9"/>
+                </a:solidFill>
+                <a:latin typeface="Consolas"/>
+              </a:defRPr>
+            </a:pPr>
+            <a:r>
+              <a:t>  → How much can we accelerate while retaining DFT-level accuracy?</a:t>
             </a:r>
           </a:p>
         </p:txBody>
@@ -4309,273 +4386,6 @@
       <p:sp>
         <p:nvSpPr>
           <p:cNvPr id="4" name="TextBox 3"/>
-          <p:cNvSpPr txBox="1"/>
-          <p:nvPr/>
-        </p:nvSpPr>
-        <p:spPr>
-          <a:xfrm>
-            <a:off x="4663440" y="1051560"/>
-            <a:ext cx="4023360" cy="4937760"/>
-          </a:xfrm>
-          <a:prstGeom prst="rect">
-            <a:avLst/>
-          </a:prstGeom>
-          <a:noFill/>
-        </p:spPr>
-        <p:txBody>
-          <a:bodyPr wrap="square">
-            <a:spAutoFit/>
-          </a:bodyPr>
-          <a:lstStyle/>
-          <a:p>
-            <a:pPr>
-              <a:spcAft>
-                <a:spcPts val="300"/>
-              </a:spcAft>
-              <a:defRPr sz="1300">
-                <a:solidFill>
-                  <a:srgbClr val="58A6FF"/>
-                </a:solidFill>
-                <a:latin typeface="Consolas"/>
-              </a:defRPr>
-            </a:pPr>
-            <a:r>
-              <a:t># Still open</a:t>
-            </a:r>
-          </a:p>
-          <a:p>
-            <a:pPr>
-              <a:spcAft>
-                <a:spcPts val="300"/>
-              </a:spcAft>
-              <a:defRPr sz="1300">
-                <a:solidFill>
-                  <a:srgbClr val="8B949E"/>
-                </a:solidFill>
-                <a:latin typeface="Consolas"/>
-              </a:defRPr>
-            </a:pPr>
-          </a:p>
-          <a:p>
-            <a:pPr>
-              <a:spcAft>
-                <a:spcPts val="300"/>
-              </a:spcAft>
-              <a:defRPr sz="1300">
-                <a:solidFill>
-                  <a:srgbClr val="C9D1D9"/>
-                </a:solidFill>
-                <a:latin typeface="Consolas"/>
-              </a:defRPr>
-            </a:pPr>
-            <a:r>
-              <a:t>  Anharmonic validation:</a:t>
-            </a:r>
-          </a:p>
-          <a:p>
-            <a:pPr>
-              <a:spcAft>
-                <a:spcPts val="300"/>
-              </a:spcAft>
-              <a:defRPr sz="1300">
-                <a:solidFill>
-                  <a:srgbClr val="8B949E"/>
-                </a:solidFill>
-                <a:latin typeface="Consolas"/>
-              </a:defRPr>
-            </a:pPr>
-            <a:r>
-              <a:t>  → VPT2 pipeline runs; accuracy TBD</a:t>
-            </a:r>
-          </a:p>
-          <a:p>
-            <a:pPr>
-              <a:spcAft>
-                <a:spcPts val="300"/>
-              </a:spcAft>
-              <a:defRPr sz="1300">
-                <a:solidFill>
-                  <a:srgbClr val="8B949E"/>
-                </a:solidFill>
-                <a:latin typeface="Consolas"/>
-              </a:defRPr>
-            </a:pPr>
-            <a:r>
-              <a:t>  → Overtones + combination bands</a:t>
-            </a:r>
-          </a:p>
-          <a:p>
-            <a:pPr>
-              <a:spcAft>
-                <a:spcPts val="300"/>
-              </a:spcAft>
-              <a:defRPr sz="1300">
-                <a:solidFill>
-                  <a:srgbClr val="8B949E"/>
-                </a:solidFill>
-                <a:latin typeface="Consolas"/>
-              </a:defRPr>
-            </a:pPr>
-          </a:p>
-          <a:p>
-            <a:pPr>
-              <a:spcAft>
-                <a:spcPts val="300"/>
-              </a:spcAft>
-              <a:defRPr sz="1300">
-                <a:solidFill>
-                  <a:srgbClr val="C9D1D9"/>
-                </a:solidFill>
-                <a:latin typeface="Consolas"/>
-              </a:defRPr>
-            </a:pPr>
-            <a:r>
-              <a:t>  25-molecule benchmark campaign:</a:t>
-            </a:r>
-          </a:p>
-          <a:p>
-            <a:pPr>
-              <a:spcAft>
-                <a:spcPts val="300"/>
-              </a:spcAft>
-              <a:defRPr sz="1300">
-                <a:solidFill>
-                  <a:srgbClr val="8B949E"/>
-                </a:solidFill>
-                <a:latin typeface="Consolas"/>
-              </a:defRPr>
-            </a:pPr>
-            <a:r>
-              <a:t>  → Systematic across functional groups</a:t>
-            </a:r>
-          </a:p>
-          <a:p>
-            <a:pPr>
-              <a:spcAft>
-                <a:spcPts val="300"/>
-              </a:spcAft>
-              <a:defRPr sz="1300">
-                <a:solidFill>
-                  <a:srgbClr val="8B949E"/>
-                </a:solidFill>
-                <a:latin typeface="Consolas"/>
-              </a:defRPr>
-            </a:pPr>
-            <a:r>
-              <a:t>  → Batch runner in progress</a:t>
-            </a:r>
-          </a:p>
-          <a:p>
-            <a:pPr>
-              <a:spcAft>
-                <a:spcPts val="300"/>
-              </a:spcAft>
-              <a:defRPr sz="1300">
-                <a:solidFill>
-                  <a:srgbClr val="8B949E"/>
-                </a:solidFill>
-                <a:latin typeface="Consolas"/>
-              </a:defRPr>
-            </a:pPr>
-          </a:p>
-          <a:p>
-            <a:pPr>
-              <a:spcAft>
-                <a:spcPts val="300"/>
-              </a:spcAft>
-              <a:defRPr sz="1300">
-                <a:solidFill>
-                  <a:srgbClr val="58A6FF"/>
-                </a:solidFill>
-                <a:latin typeface="Consolas"/>
-              </a:defRPr>
-            </a:pPr>
-            <a:r>
-              <a:t># Thesis question</a:t>
-            </a:r>
-          </a:p>
-          <a:p>
-            <a:pPr>
-              <a:spcAft>
-                <a:spcPts val="300"/>
-              </a:spcAft>
-              <a:defRPr sz="1300">
-                <a:solidFill>
-                  <a:srgbClr val="C9D1D9"/>
-                </a:solidFill>
-                <a:latin typeface="Consolas"/>
-              </a:defRPr>
-            </a:pPr>
-            <a:r>
-              <a:t>  Energy surface quality</a:t>
-            </a:r>
-          </a:p>
-          <a:p>
-            <a:pPr>
-              <a:spcAft>
-                <a:spcPts val="300"/>
-              </a:spcAft>
-              <a:defRPr sz="1300">
-                <a:solidFill>
-                  <a:srgbClr val="C9D1D9"/>
-                </a:solidFill>
-                <a:latin typeface="Consolas"/>
-              </a:defRPr>
-            </a:pPr>
-            <a:r>
-              <a:t>  vs dipole model quality —</a:t>
-            </a:r>
-          </a:p>
-          <a:p>
-            <a:pPr>
-              <a:spcAft>
-                <a:spcPts val="300"/>
-              </a:spcAft>
-              <a:defRPr sz="1300">
-                <a:solidFill>
-                  <a:srgbClr val="C9D1D9"/>
-                </a:solidFill>
-                <a:latin typeface="Consolas"/>
-              </a:defRPr>
-            </a:pPr>
-            <a:r>
-              <a:t>  which dominates IR accuracy?</a:t>
-            </a:r>
-          </a:p>
-          <a:p>
-            <a:pPr>
-              <a:spcAft>
-                <a:spcPts val="300"/>
-              </a:spcAft>
-              <a:defRPr sz="1300">
-                <a:solidFill>
-                  <a:srgbClr val="8B949E"/>
-                </a:solidFill>
-                <a:latin typeface="Consolas"/>
-              </a:defRPr>
-            </a:pPr>
-          </a:p>
-          <a:p>
-            <a:pPr>
-              <a:spcAft>
-                <a:spcPts val="300"/>
-              </a:spcAft>
-              <a:defRPr sz="1300">
-                <a:solidFill>
-                  <a:srgbClr val="3FB950"/>
-                </a:solidFill>
-                <a:latin typeface="Consolas"/>
-              </a:defRPr>
-            </a:pPr>
-            <a:r>
-              <a:t>  $ mace-gaussian run molecule.xyz</a:t>
-            </a:r>
-          </a:p>
-        </p:txBody>
-      </p:sp>
-      <p:sp>
-        <p:nvSpPr>
-          <p:cNvPr id="5" name="TextBox 4"/>
           <p:cNvSpPr txBox="1"/>
           <p:nvPr/>
         </p:nvSpPr>

</xml_diff>

<commit_message>
feat(slides): status — batch/ORCA next steps, mace_ml→MACE4IR everywhere, drop CLI line
Co-Authored-By: Claude Opus 4.6 <noreply@anthropic.com>
</commit_message>
<xml_diff>
--- a/presentation/presentation_v2.pptx
+++ b/presentation/presentation_v2.pptx
@@ -3645,7 +3645,7 @@
               </a:defRPr>
             </a:pPr>
             <a:r>
-              <a:t>  → mace_ml dipole: R²(int) 0.94–0.96 vs espaloma 0.15–0.26</a:t>
+              <a:t>  → MACE4IR dipole: R²(int) 0.94–0.96 vs Espaloma 0.15–0.26</a:t>
             </a:r>
           </a:p>
         </p:txBody>
@@ -4162,22 +4162,6 @@
                 <a:latin typeface="Consolas"/>
               </a:defRPr>
             </a:pPr>
-            <a:r>
-              <a:t>  → CLI: mace-gaussian run molecule.xyz</a:t>
-            </a:r>
-          </a:p>
-          <a:p>
-            <a:pPr>
-              <a:spcAft>
-                <a:spcPts val="400"/>
-              </a:spcAft>
-              <a:defRPr sz="1400">
-                <a:solidFill>
-                  <a:srgbClr val="8B949E"/>
-                </a:solidFill>
-                <a:latin typeface="Consolas"/>
-              </a:defRPr>
-            </a:pPr>
           </a:p>
           <a:p>
             <a:pPr>
@@ -4301,68 +4285,39 @@
               </a:defRPr>
             </a:pPr>
             <a:r>
-              <a:t>    Growing molecule size: CH₄ → C₂H₆ → C₃H₈ → C₄H₁₀ (scaling)</a:t>
-            </a:r>
-          </a:p>
-          <a:p>
-            <a:pPr>
-              <a:spcAft>
-                <a:spcPts val="400"/>
-              </a:spcAft>
-              <a:defRPr sz="1400">
-                <a:solidFill>
-                  <a:srgbClr val="8B949E"/>
-                </a:solidFill>
-                <a:latin typeface="Consolas"/>
-              </a:defRPr>
-            </a:pPr>
-            <a:r>
-              <a:t>    New functional groups: methanol, acetone, aniline (chemistry)</a:t>
-            </a:r>
-          </a:p>
-          <a:p>
-            <a:pPr>
-              <a:spcAft>
-                <a:spcPts val="400"/>
-              </a:spcAft>
-              <a:defRPr sz="1400">
-                <a:solidFill>
-                  <a:srgbClr val="8B949E"/>
-                </a:solidFill>
-                <a:latin typeface="Consolas"/>
-              </a:defRPr>
-            </a:pPr>
-            <a:r>
-              <a:t>    Larger targets: paracetamol, caffeine, ibuprofen</a:t>
-            </a:r>
-          </a:p>
-          <a:p>
-            <a:pPr>
-              <a:spcAft>
-                <a:spcPts val="400"/>
-              </a:spcAft>
-              <a:defRPr sz="1400">
-                <a:solidFill>
-                  <a:srgbClr val="8B949E"/>
-                </a:solidFill>
-                <a:latin typeface="Consolas"/>
-              </a:defRPr>
-            </a:pPr>
-          </a:p>
-          <a:p>
-            <a:pPr>
-              <a:spcAft>
-                <a:spcPts val="400"/>
-              </a:spcAft>
-              <a:defRPr sz="1400">
-                <a:solidFill>
-                  <a:srgbClr val="58A6FF"/>
-                </a:solidFill>
-                <a:latin typeface="Consolas"/>
-              </a:defRPr>
-            </a:pPr>
-            <a:r>
-              <a:t># Thesis question</a:t>
+              <a:t>    Growing size: CH₄ → C₂H₆ → C₃H₈ → C₄H₁₀ (scaling)</a:t>
+            </a:r>
+          </a:p>
+          <a:p>
+            <a:pPr>
+              <a:spcAft>
+                <a:spcPts val="400"/>
+              </a:spcAft>
+              <a:defRPr sz="1400">
+                <a:solidFill>
+                  <a:srgbClr val="8B949E"/>
+                </a:solidFill>
+                <a:latin typeface="Consolas"/>
+              </a:defRPr>
+            </a:pPr>
+            <a:r>
+              <a:t>    Exotic molecules: paracetamol, caffeine, ibuprofen</a:t>
+            </a:r>
+          </a:p>
+          <a:p>
+            <a:pPr>
+              <a:spcAft>
+                <a:spcPts val="400"/>
+              </a:spcAft>
+              <a:defRPr sz="1400">
+                <a:solidFill>
+                  <a:srgbClr val="8B949E"/>
+                </a:solidFill>
+                <a:latin typeface="Consolas"/>
+              </a:defRPr>
+            </a:pPr>
+            <a:r>
+              <a:t>    Larger systems: peptides, drug-like molecules</a:t>
             </a:r>
           </a:p>
           <a:p>
@@ -4378,7 +4333,23 @@
               </a:defRPr>
             </a:pPr>
             <a:r>
-              <a:t>  → How much can we accelerate while retaining DFT-level accuracy?</a:t>
+              <a:t>  → Batch processing: HPC queue integration for large campaigns</a:t>
+            </a:r>
+          </a:p>
+          <a:p>
+            <a:pPr>
+              <a:spcAft>
+                <a:spcPts val="400"/>
+              </a:spcAft>
+              <a:defRPr sz="1400">
+                <a:solidFill>
+                  <a:srgbClr val="C9D1D9"/>
+                </a:solidFill>
+                <a:latin typeface="Consolas"/>
+              </a:defRPr>
+            </a:pPr>
+            <a:r>
+              <a:t>  → ORCA integration: open-source QM engine as Gaussian alternative</a:t>
             </a:r>
           </a:p>
         </p:txBody>
@@ -5561,7 +5532,7 @@
               </a:defRPr>
             </a:pPr>
             <a:r>
-              <a:t>  │  └──────────────────┘          │  │    (Espaloma / MACE_DIPOLE)          │</a:t>
+              <a:t>  │  └──────────────────┘          │  │    (Espaloma / MACE4IR)          │</a:t>
             </a:r>
           </a:p>
           <a:p>
@@ -8050,7 +8021,7 @@
               </a:defRPr>
             </a:pPr>
             <a:r>
-              <a:t>  → mace_ml consistently beats espaloma on intensities</a:t>
+              <a:t>  → MACE4IR consistently beats Espaloma on intensities</a:t>
             </a:r>
           </a:p>
         </p:txBody>

</xml_diff>

<commit_message>
fix(slides): shorter scaling bars to fit inline
Co-Authored-By: Claude Opus 4.6 <noreply@anthropic.com>
</commit_message>
<xml_diff>
--- a/presentation/presentation_v2.pptx
+++ b/presentation/presentation_v2.pptx
@@ -3859,7 +3859,7 @@
               </a:defRPr>
             </a:pPr>
             <a:r>
-              <a:t>  water        3      mace_anicc / mace_ml         |=                             |   1.2×</a:t>
+              <a:t>  water        3      mace_anicc / mace_ml         |=           |   1.2×</a:t>
             </a:r>
           </a:p>
           <a:p>
@@ -3875,7 +3875,7 @@
               </a:defRPr>
             </a:pPr>
             <a:r>
-              <a:t>  aspirin     21      mace_anicc / mace_ml         |==============================|  35.8×</a:t>
+              <a:t>  aspirin     21      mace_anicc / mace_ml         |============|  35.8×</a:t>
             </a:r>
           </a:p>
           <a:p>

</xml_diff>

<commit_message>
fix(slides): date→03-10, add slide numbers, dedupe 78-element line
Co-Authored-By: Claude Opus 4.6 <noreply@anthropic.com>
</commit_message>
<xml_diff>
--- a/presentation/presentation_v2.pptx
+++ b/presentation/presentation_v2.pptx
@@ -3272,7 +3272,7 @@
         <p:spPr>
           <a:xfrm>
             <a:off x="914400" y="6263640"/>
-            <a:ext cx="7315200" cy="365760"/>
+            <a:ext cx="6400800" cy="365760"/>
           </a:xfrm>
           <a:prstGeom prst="rect">
             <a:avLst/>
@@ -3294,7 +3294,43 @@
               </a:defRPr>
             </a:pPr>
             <a:r>
-              <a:t>Manuel Ott · Hofer Lab · 2026-03-11</a:t>
+              <a:t>Manuel Ott · Hofer Lab · 2026-03-10</a:t>
+            </a:r>
+          </a:p>
+        </p:txBody>
+      </p:sp>
+      <p:sp>
+        <p:nvSpPr>
+          <p:cNvPr id="5" name="TextBox 4"/>
+          <p:cNvSpPr txBox="1"/>
+          <p:nvPr/>
+        </p:nvSpPr>
+        <p:spPr>
+          <a:xfrm>
+            <a:off x="7772400" y="6263640"/>
+            <a:ext cx="914400" cy="365760"/>
+          </a:xfrm>
+          <a:prstGeom prst="rect">
+            <a:avLst/>
+          </a:prstGeom>
+          <a:noFill/>
+        </p:spPr>
+        <p:txBody>
+          <a:bodyPr wrap="none">
+            <a:spAutoFit/>
+          </a:bodyPr>
+          <a:lstStyle/>
+          <a:p>
+            <a:pPr algn="r">
+              <a:defRPr sz="1100">
+                <a:solidFill>
+                  <a:srgbClr val="8B949E"/>
+                </a:solidFill>
+                <a:latin typeface="Consolas"/>
+              </a:defRPr>
+            </a:pPr>
+            <a:r>
+              <a:t>0</a:t>
             </a:r>
           </a:p>
         </p:txBody>
@@ -3659,7 +3695,7 @@
         <p:spPr>
           <a:xfrm>
             <a:off x="914400" y="6263640"/>
-            <a:ext cx="7315200" cy="365760"/>
+            <a:ext cx="6400800" cy="365760"/>
           </a:xfrm>
           <a:prstGeom prst="rect">
             <a:avLst/>
@@ -3681,7 +3717,43 @@
               </a:defRPr>
             </a:pPr>
             <a:r>
-              <a:t>Manuel Ott · Hofer Lab · 2026-03-11</a:t>
+              <a:t>Manuel Ott · Hofer Lab · 2026-03-10</a:t>
+            </a:r>
+          </a:p>
+        </p:txBody>
+      </p:sp>
+      <p:sp>
+        <p:nvSpPr>
+          <p:cNvPr id="5" name="TextBox 4"/>
+          <p:cNvSpPr txBox="1"/>
+          <p:nvPr/>
+        </p:nvSpPr>
+        <p:spPr>
+          <a:xfrm>
+            <a:off x="7772400" y="6263640"/>
+            <a:ext cx="914400" cy="365760"/>
+          </a:xfrm>
+          <a:prstGeom prst="rect">
+            <a:avLst/>
+          </a:prstGeom>
+          <a:noFill/>
+        </p:spPr>
+        <p:txBody>
+          <a:bodyPr wrap="none">
+            <a:spAutoFit/>
+          </a:bodyPr>
+          <a:lstStyle/>
+          <a:p>
+            <a:pPr algn="r">
+              <a:defRPr sz="1100">
+                <a:solidFill>
+                  <a:srgbClr val="8B949E"/>
+                </a:solidFill>
+                <a:latin typeface="Consolas"/>
+              </a:defRPr>
+            </a:pPr>
+            <a:r>
+              <a:t>9</a:t>
             </a:r>
           </a:p>
         </p:txBody>
@@ -3992,7 +4064,7 @@
         <p:spPr>
           <a:xfrm>
             <a:off x="914400" y="6263640"/>
-            <a:ext cx="7315200" cy="365760"/>
+            <a:ext cx="6400800" cy="365760"/>
           </a:xfrm>
           <a:prstGeom prst="rect">
             <a:avLst/>
@@ -4014,7 +4086,43 @@
               </a:defRPr>
             </a:pPr>
             <a:r>
-              <a:t>Manuel Ott · Hofer Lab · 2026-03-11</a:t>
+              <a:t>Manuel Ott · Hofer Lab · 2026-03-10</a:t>
+            </a:r>
+          </a:p>
+        </p:txBody>
+      </p:sp>
+      <p:sp>
+        <p:nvSpPr>
+          <p:cNvPr id="5" name="TextBox 4"/>
+          <p:cNvSpPr txBox="1"/>
+          <p:nvPr/>
+        </p:nvSpPr>
+        <p:spPr>
+          <a:xfrm>
+            <a:off x="7772400" y="6263640"/>
+            <a:ext cx="914400" cy="365760"/>
+          </a:xfrm>
+          <a:prstGeom prst="rect">
+            <a:avLst/>
+          </a:prstGeom>
+          <a:noFill/>
+        </p:spPr>
+        <p:txBody>
+          <a:bodyPr wrap="none">
+            <a:spAutoFit/>
+          </a:bodyPr>
+          <a:lstStyle/>
+          <a:p>
+            <a:pPr algn="r">
+              <a:defRPr sz="1100">
+                <a:solidFill>
+                  <a:srgbClr val="8B949E"/>
+                </a:solidFill>
+                <a:latin typeface="Consolas"/>
+              </a:defRPr>
+            </a:pPr>
+            <a:r>
+              <a:t>10</a:t>
             </a:r>
           </a:p>
         </p:txBody>
@@ -4363,7 +4471,7 @@
         <p:spPr>
           <a:xfrm>
             <a:off x="914400" y="6263640"/>
-            <a:ext cx="7315200" cy="365760"/>
+            <a:ext cx="6400800" cy="365760"/>
           </a:xfrm>
           <a:prstGeom prst="rect">
             <a:avLst/>
@@ -4385,7 +4493,43 @@
               </a:defRPr>
             </a:pPr>
             <a:r>
-              <a:t>Manuel Ott · Hofer Lab · 2026-03-11</a:t>
+              <a:t>Manuel Ott · Hofer Lab · 2026-03-10</a:t>
+            </a:r>
+          </a:p>
+        </p:txBody>
+      </p:sp>
+      <p:sp>
+        <p:nvSpPr>
+          <p:cNvPr id="5" name="TextBox 4"/>
+          <p:cNvSpPr txBox="1"/>
+          <p:nvPr/>
+        </p:nvSpPr>
+        <p:spPr>
+          <a:xfrm>
+            <a:off x="7772400" y="6263640"/>
+            <a:ext cx="914400" cy="365760"/>
+          </a:xfrm>
+          <a:prstGeom prst="rect">
+            <a:avLst/>
+          </a:prstGeom>
+          <a:noFill/>
+        </p:spPr>
+        <p:txBody>
+          <a:bodyPr wrap="none">
+            <a:spAutoFit/>
+          </a:bodyPr>
+          <a:lstStyle/>
+          <a:p>
+            <a:pPr algn="r">
+              <a:defRPr sz="1100">
+                <a:solidFill>
+                  <a:srgbClr val="8B949E"/>
+                </a:solidFill>
+                <a:latin typeface="Consolas"/>
+              </a:defRPr>
+            </a:pPr>
+            <a:r>
+              <a:t>11</a:t>
             </a:r>
           </a:p>
         </p:txBody>
@@ -4475,7 +4619,7 @@
         <p:spPr>
           <a:xfrm>
             <a:off x="914400" y="6263640"/>
-            <a:ext cx="7315200" cy="365760"/>
+            <a:ext cx="6400800" cy="365760"/>
           </a:xfrm>
           <a:prstGeom prst="rect">
             <a:avLst/>
@@ -4497,7 +4641,43 @@
               </a:defRPr>
             </a:pPr>
             <a:r>
-              <a:t>Manuel Ott · Hofer Lab · 2026-03-11</a:t>
+              <a:t>Manuel Ott · Hofer Lab · 2026-03-10</a:t>
+            </a:r>
+          </a:p>
+        </p:txBody>
+      </p:sp>
+      <p:sp>
+        <p:nvSpPr>
+          <p:cNvPr id="4" name="TextBox 3"/>
+          <p:cNvSpPr txBox="1"/>
+          <p:nvPr/>
+        </p:nvSpPr>
+        <p:spPr>
+          <a:xfrm>
+            <a:off x="7772400" y="6263640"/>
+            <a:ext cx="914400" cy="365760"/>
+          </a:xfrm>
+          <a:prstGeom prst="rect">
+            <a:avLst/>
+          </a:prstGeom>
+          <a:noFill/>
+        </p:spPr>
+        <p:txBody>
+          <a:bodyPr wrap="none">
+            <a:spAutoFit/>
+          </a:bodyPr>
+          <a:lstStyle/>
+          <a:p>
+            <a:pPr algn="r">
+              <a:defRPr sz="1100">
+                <a:solidFill>
+                  <a:srgbClr val="8B949E"/>
+                </a:solidFill>
+                <a:latin typeface="Consolas"/>
+              </a:defRPr>
+            </a:pPr>
+            <a:r>
+              <a:t>12</a:t>
             </a:r>
           </a:p>
         </p:txBody>
@@ -4814,7 +4994,7 @@
         <p:spPr>
           <a:xfrm>
             <a:off x="914400" y="6263640"/>
-            <a:ext cx="7315200" cy="365760"/>
+            <a:ext cx="6400800" cy="365760"/>
           </a:xfrm>
           <a:prstGeom prst="rect">
             <a:avLst/>
@@ -4836,7 +5016,43 @@
               </a:defRPr>
             </a:pPr>
             <a:r>
-              <a:t>Manuel Ott · Hofer Lab · 2026-03-11</a:t>
+              <a:t>Manuel Ott · Hofer Lab · 2026-03-10</a:t>
+            </a:r>
+          </a:p>
+        </p:txBody>
+      </p:sp>
+      <p:sp>
+        <p:nvSpPr>
+          <p:cNvPr id="5" name="TextBox 4"/>
+          <p:cNvSpPr txBox="1"/>
+          <p:nvPr/>
+        </p:nvSpPr>
+        <p:spPr>
+          <a:xfrm>
+            <a:off x="7772400" y="6263640"/>
+            <a:ext cx="914400" cy="365760"/>
+          </a:xfrm>
+          <a:prstGeom prst="rect">
+            <a:avLst/>
+          </a:prstGeom>
+          <a:noFill/>
+        </p:spPr>
+        <p:txBody>
+          <a:bodyPr wrap="none">
+            <a:spAutoFit/>
+          </a:bodyPr>
+          <a:lstStyle/>
+          <a:p>
+            <a:pPr algn="r">
+              <a:defRPr sz="1100">
+                <a:solidFill>
+                  <a:srgbClr val="8B949E"/>
+                </a:solidFill>
+                <a:latin typeface="Consolas"/>
+              </a:defRPr>
+            </a:pPr>
+            <a:r>
+              <a:t>1</a:t>
             </a:r>
           </a:p>
         </p:txBody>
@@ -5217,7 +5433,7 @@
         <p:spPr>
           <a:xfrm>
             <a:off x="914400" y="6263640"/>
-            <a:ext cx="7315200" cy="365760"/>
+            <a:ext cx="6400800" cy="365760"/>
           </a:xfrm>
           <a:prstGeom prst="rect">
             <a:avLst/>
@@ -5239,7 +5455,43 @@
               </a:defRPr>
             </a:pPr>
             <a:r>
-              <a:t>Manuel Ott · Hofer Lab · 2026-03-11</a:t>
+              <a:t>Manuel Ott · Hofer Lab · 2026-03-10</a:t>
+            </a:r>
+          </a:p>
+        </p:txBody>
+      </p:sp>
+      <p:sp>
+        <p:nvSpPr>
+          <p:cNvPr id="5" name="TextBox 4"/>
+          <p:cNvSpPr txBox="1"/>
+          <p:nvPr/>
+        </p:nvSpPr>
+        <p:spPr>
+          <a:xfrm>
+            <a:off x="7772400" y="6263640"/>
+            <a:ext cx="914400" cy="365760"/>
+          </a:xfrm>
+          <a:prstGeom prst="rect">
+            <a:avLst/>
+          </a:prstGeom>
+          <a:noFill/>
+        </p:spPr>
+        <p:txBody>
+          <a:bodyPr wrap="none">
+            <a:spAutoFit/>
+          </a:bodyPr>
+          <a:lstStyle/>
+          <a:p>
+            <a:pPr algn="r">
+              <a:defRPr sz="1100">
+                <a:solidFill>
+                  <a:srgbClr val="8B949E"/>
+                </a:solidFill>
+                <a:latin typeface="Consolas"/>
+              </a:defRPr>
+            </a:pPr>
+            <a:r>
+              <a:t>2</a:t>
             </a:r>
           </a:p>
         </p:txBody>
@@ -5722,7 +5974,7 @@
         <p:spPr>
           <a:xfrm>
             <a:off x="914400" y="6263640"/>
-            <a:ext cx="7315200" cy="365760"/>
+            <a:ext cx="6400800" cy="365760"/>
           </a:xfrm>
           <a:prstGeom prst="rect">
             <a:avLst/>
@@ -5744,7 +5996,43 @@
               </a:defRPr>
             </a:pPr>
             <a:r>
-              <a:t>Manuel Ott · Hofer Lab · 2026-03-11</a:t>
+              <a:t>Manuel Ott · Hofer Lab · 2026-03-10</a:t>
+            </a:r>
+          </a:p>
+        </p:txBody>
+      </p:sp>
+      <p:sp>
+        <p:nvSpPr>
+          <p:cNvPr id="5" name="TextBox 4"/>
+          <p:cNvSpPr txBox="1"/>
+          <p:nvPr/>
+        </p:nvSpPr>
+        <p:spPr>
+          <a:xfrm>
+            <a:off x="7772400" y="6263640"/>
+            <a:ext cx="914400" cy="365760"/>
+          </a:xfrm>
+          <a:prstGeom prst="rect">
+            <a:avLst/>
+          </a:prstGeom>
+          <a:noFill/>
+        </p:spPr>
+        <p:txBody>
+          <a:bodyPr wrap="none">
+            <a:spAutoFit/>
+          </a:bodyPr>
+          <a:lstStyle/>
+          <a:p>
+            <a:pPr algn="r">
+              <a:defRPr sz="1100">
+                <a:solidFill>
+                  <a:srgbClr val="8B949E"/>
+                </a:solidFill>
+                <a:latin typeface="Consolas"/>
+              </a:defRPr>
+            </a:pPr>
+            <a:r>
+              <a:t>3</a:t>
             </a:r>
           </a:p>
         </p:txBody>
@@ -5967,23 +6255,7 @@
               </a:defRPr>
             </a:pPr>
             <a:r>
-              <a:t>  → 78-element coverage</a:t>
-            </a:r>
-          </a:p>
-          <a:p>
-            <a:pPr>
-              <a:spcAft>
-                <a:spcPts val="300"/>
-              </a:spcAft>
-              <a:defRPr sz="1300">
-                <a:solidFill>
-                  <a:srgbClr val="C9D1D9"/>
-                </a:solidFill>
-                <a:latin typeface="Consolas"/>
-              </a:defRPr>
-            </a:pPr>
-            <a:r>
-              <a:t>  → Custom MACE4IR model (78 el.)</a:t>
+              <a:t>  → Custom MACE4IR model (78 elements)</a:t>
             </a:r>
           </a:p>
           <a:p>
@@ -6434,7 +6706,7 @@
         <p:spPr>
           <a:xfrm>
             <a:off x="914400" y="6263640"/>
-            <a:ext cx="7315200" cy="365760"/>
+            <a:ext cx="6400800" cy="365760"/>
           </a:xfrm>
           <a:prstGeom prst="rect">
             <a:avLst/>
@@ -6456,7 +6728,43 @@
               </a:defRPr>
             </a:pPr>
             <a:r>
-              <a:t>Manuel Ott · Hofer Lab · 2026-03-11</a:t>
+              <a:t>Manuel Ott · Hofer Lab · 2026-03-10</a:t>
+            </a:r>
+          </a:p>
+        </p:txBody>
+      </p:sp>
+      <p:sp>
+        <p:nvSpPr>
+          <p:cNvPr id="6" name="TextBox 5"/>
+          <p:cNvSpPr txBox="1"/>
+          <p:nvPr/>
+        </p:nvSpPr>
+        <p:spPr>
+          <a:xfrm>
+            <a:off x="7772400" y="6263640"/>
+            <a:ext cx="914400" cy="365760"/>
+          </a:xfrm>
+          <a:prstGeom prst="rect">
+            <a:avLst/>
+          </a:prstGeom>
+          <a:noFill/>
+        </p:spPr>
+        <p:txBody>
+          <a:bodyPr wrap="none">
+            <a:spAutoFit/>
+          </a:bodyPr>
+          <a:lstStyle/>
+          <a:p>
+            <a:pPr algn="r">
+              <a:defRPr sz="1100">
+                <a:solidFill>
+                  <a:srgbClr val="8B949E"/>
+                </a:solidFill>
+                <a:latin typeface="Consolas"/>
+              </a:defRPr>
+            </a:pPr>
+            <a:r>
+              <a:t>4</a:t>
             </a:r>
           </a:p>
         </p:txBody>
@@ -6879,7 +7187,7 @@
         <p:spPr>
           <a:xfrm>
             <a:off x="914400" y="6263640"/>
-            <a:ext cx="7315200" cy="365760"/>
+            <a:ext cx="6400800" cy="365760"/>
           </a:xfrm>
           <a:prstGeom prst="rect">
             <a:avLst/>
@@ -6901,7 +7209,43 @@
               </a:defRPr>
             </a:pPr>
             <a:r>
-              <a:t>Manuel Ott · Hofer Lab · 2026-03-11</a:t>
+              <a:t>Manuel Ott · Hofer Lab · 2026-03-10</a:t>
+            </a:r>
+          </a:p>
+        </p:txBody>
+      </p:sp>
+      <p:sp>
+        <p:nvSpPr>
+          <p:cNvPr id="6" name="TextBox 5"/>
+          <p:cNvSpPr txBox="1"/>
+          <p:nvPr/>
+        </p:nvSpPr>
+        <p:spPr>
+          <a:xfrm>
+            <a:off x="7772400" y="6263640"/>
+            <a:ext cx="914400" cy="365760"/>
+          </a:xfrm>
+          <a:prstGeom prst="rect">
+            <a:avLst/>
+          </a:prstGeom>
+          <a:noFill/>
+        </p:spPr>
+        <p:txBody>
+          <a:bodyPr wrap="none">
+            <a:spAutoFit/>
+          </a:bodyPr>
+          <a:lstStyle/>
+          <a:p>
+            <a:pPr algn="r">
+              <a:defRPr sz="1100">
+                <a:solidFill>
+                  <a:srgbClr val="8B949E"/>
+                </a:solidFill>
+                <a:latin typeface="Consolas"/>
+              </a:defRPr>
+            </a:pPr>
+            <a:r>
+              <a:t>5</a:t>
             </a:r>
           </a:p>
         </p:txBody>
@@ -7286,7 +7630,7 @@
         <p:spPr>
           <a:xfrm>
             <a:off x="914400" y="6263640"/>
-            <a:ext cx="7315200" cy="365760"/>
+            <a:ext cx="6400800" cy="365760"/>
           </a:xfrm>
           <a:prstGeom prst="rect">
             <a:avLst/>
@@ -7308,7 +7652,43 @@
               </a:defRPr>
             </a:pPr>
             <a:r>
-              <a:t>Manuel Ott · Hofer Lab · 2026-03-11</a:t>
+              <a:t>Manuel Ott · Hofer Lab · 2026-03-10</a:t>
+            </a:r>
+          </a:p>
+        </p:txBody>
+      </p:sp>
+      <p:sp>
+        <p:nvSpPr>
+          <p:cNvPr id="5" name="TextBox 4"/>
+          <p:cNvSpPr txBox="1"/>
+          <p:nvPr/>
+        </p:nvSpPr>
+        <p:spPr>
+          <a:xfrm>
+            <a:off x="7772400" y="6263640"/>
+            <a:ext cx="914400" cy="365760"/>
+          </a:xfrm>
+          <a:prstGeom prst="rect">
+            <a:avLst/>
+          </a:prstGeom>
+          <a:noFill/>
+        </p:spPr>
+        <p:txBody>
+          <a:bodyPr wrap="none">
+            <a:spAutoFit/>
+          </a:bodyPr>
+          <a:lstStyle/>
+          <a:p>
+            <a:pPr algn="r">
+              <a:defRPr sz="1100">
+                <a:solidFill>
+                  <a:srgbClr val="8B949E"/>
+                </a:solidFill>
+                <a:latin typeface="Consolas"/>
+              </a:defRPr>
+            </a:pPr>
+            <a:r>
+              <a:t>6</a:t>
             </a:r>
           </a:p>
         </p:txBody>
@@ -7632,7 +8012,7 @@
         <p:spPr>
           <a:xfrm>
             <a:off x="914400" y="6263640"/>
-            <a:ext cx="7315200" cy="365760"/>
+            <a:ext cx="6400800" cy="365760"/>
           </a:xfrm>
           <a:prstGeom prst="rect">
             <a:avLst/>
@@ -7654,7 +8034,43 @@
               </a:defRPr>
             </a:pPr>
             <a:r>
-              <a:t>Manuel Ott · Hofer Lab · 2026-03-11</a:t>
+              <a:t>Manuel Ott · Hofer Lab · 2026-03-10</a:t>
+            </a:r>
+          </a:p>
+        </p:txBody>
+      </p:sp>
+      <p:sp>
+        <p:nvSpPr>
+          <p:cNvPr id="5" name="TextBox 4"/>
+          <p:cNvSpPr txBox="1"/>
+          <p:nvPr/>
+        </p:nvSpPr>
+        <p:spPr>
+          <a:xfrm>
+            <a:off x="7772400" y="6263640"/>
+            <a:ext cx="914400" cy="365760"/>
+          </a:xfrm>
+          <a:prstGeom prst="rect">
+            <a:avLst/>
+          </a:prstGeom>
+          <a:noFill/>
+        </p:spPr>
+        <p:txBody>
+          <a:bodyPr wrap="none">
+            <a:spAutoFit/>
+          </a:bodyPr>
+          <a:lstStyle/>
+          <a:p>
+            <a:pPr algn="r">
+              <a:defRPr sz="1100">
+                <a:solidFill>
+                  <a:srgbClr val="8B949E"/>
+                </a:solidFill>
+                <a:latin typeface="Consolas"/>
+              </a:defRPr>
+            </a:pPr>
+            <a:r>
+              <a:t>7</a:t>
             </a:r>
           </a:p>
         </p:txBody>
@@ -8035,7 +8451,7 @@
         <p:spPr>
           <a:xfrm>
             <a:off x="914400" y="6263640"/>
-            <a:ext cx="7315200" cy="365760"/>
+            <a:ext cx="6400800" cy="365760"/>
           </a:xfrm>
           <a:prstGeom prst="rect">
             <a:avLst/>
@@ -8057,7 +8473,43 @@
               </a:defRPr>
             </a:pPr>
             <a:r>
-              <a:t>Manuel Ott · Hofer Lab · 2026-03-11</a:t>
+              <a:t>Manuel Ott · Hofer Lab · 2026-03-10</a:t>
+            </a:r>
+          </a:p>
+        </p:txBody>
+      </p:sp>
+      <p:sp>
+        <p:nvSpPr>
+          <p:cNvPr id="5" name="TextBox 4"/>
+          <p:cNvSpPr txBox="1"/>
+          <p:nvPr/>
+        </p:nvSpPr>
+        <p:spPr>
+          <a:xfrm>
+            <a:off x="7772400" y="6263640"/>
+            <a:ext cx="914400" cy="365760"/>
+          </a:xfrm>
+          <a:prstGeom prst="rect">
+            <a:avLst/>
+          </a:prstGeom>
+          <a:noFill/>
+        </p:spPr>
+        <p:txBody>
+          <a:bodyPr wrap="none">
+            <a:spAutoFit/>
+          </a:bodyPr>
+          <a:lstStyle/>
+          <a:p>
+            <a:pPr algn="r">
+              <a:defRPr sz="1100">
+                <a:solidFill>
+                  <a:srgbClr val="8B949E"/>
+                </a:solidFill>
+                <a:latin typeface="Consolas"/>
+              </a:defRPr>
+            </a:pPr>
+            <a:r>
+              <a:t>8</a:t>
             </a:r>
           </a:p>
         </p:txBody>

</xml_diff>

<commit_message>
polish(slides): motivation, IR theory, calculators, ZMQ, tables, scaling, status
- Slide 1: condense impact to single line, remove benchmark campaign bullet
- Slide 2: color-highlight eigenvalues/eigenvectors, clearer bottleneck wording
- Slide 4: center "4×2=8 combos" below columns, remove from right panel
- Slide 5: more detail in ZMQ boxes, center repeat line
- Slide 6: remove (3N-dim displacement pattern) parenthetical
- Slides 8-9: mace_ml → MACE4IR in tables, remove (freq) from R² warning
- Slide 10: remove speedup footnote and harmonic-only line, wins→faster
- Slide 11: remove parentheticals from results, add "more" before exotic

Co-Authored-By: Claude Opus 4.6 <noreply@anthropic.com>
</commit_message>
<xml_diff>
--- a/presentation/presentation_v2.pptx
+++ b/presentation/presentation_v2.pptx
@@ -3508,7 +3508,7 @@
               </a:defRPr>
             </a:pPr>
             <a:r>
-              <a:t>  mace_anicc      mace_ml        7.6 cm⁻¹   0.9999   0.94     35.8×</a:t>
+              <a:t>  mace_anicc      MACE4IR        7.6 cm⁻¹   0.9999   0.94     35.8×</a:t>
             </a:r>
           </a:p>
           <a:p>
@@ -3556,7 +3556,7 @@
               </a:defRPr>
             </a:pPr>
             <a:r>
-              <a:t>  mace_omol       mace_ml        8.8 cm⁻¹   0.9998   0.96     20.5×</a:t>
+              <a:t>  mace_omol       MACE4IR        8.8 cm⁻¹   0.9998   0.96     20.5×</a:t>
             </a:r>
           </a:p>
           <a:p>
@@ -3588,7 +3588,7 @@
               </a:defRPr>
             </a:pPr>
             <a:r>
-              <a:t>  mace_off        mace_ml       11.8 cm⁻¹   0.9998   0.95     18.8×</a:t>
+              <a:t>  mace_off        MACE4IR       11.8 cm⁻¹   0.9998   0.95     18.8×</a:t>
             </a:r>
           </a:p>
           <a:p>
@@ -3604,7 +3604,7 @@
               </a:defRPr>
             </a:pPr>
             <a:r>
-              <a:t>  mace_mp         mace_ml       97.8 cm⁻¹   0.9958   0.56     32.1×</a:t>
+              <a:t>  mace_mp         MACE4IR       97.8 cm⁻¹   0.9958   0.56     32.1×</a:t>
             </a:r>
           </a:p>
           <a:p>
@@ -3931,7 +3931,7 @@
               </a:defRPr>
             </a:pPr>
             <a:r>
-              <a:t>  water        3      mace_anicc / mace_ml         |=           |   1.2×</a:t>
+              <a:t>  water        3      mace_anicc / MACE4IR         |=           |   1.2×</a:t>
             </a:r>
           </a:p>
           <a:p>
@@ -3947,7 +3947,7 @@
               </a:defRPr>
             </a:pPr>
             <a:r>
-              <a:t>  aspirin     21      mace_anicc / mace_ml         |============|  35.8×</a:t>
+              <a:t>  aspirin     21      mace_anicc / MACE4IR         |============|  35.8×</a:t>
             </a:r>
           </a:p>
           <a:p>
@@ -4005,52 +4005,7 @@
               </a:defRPr>
             </a:pPr>
             <a:r>
-              <a:t>  → Aspirin: 21 atoms × 3 dirs × 2 = 126 displacements → ML wins</a:t>
-            </a:r>
-          </a:p>
-          <a:p>
-            <a:pPr>
-              <a:spcAft>
-                <a:spcPts val="400"/>
-              </a:spcAft>
-              <a:defRPr sz="1400">
-                <a:solidFill>
-                  <a:srgbClr val="C9D1D9"/>
-                </a:solidFill>
-                <a:latin typeface="Consolas"/>
-              </a:defRPr>
-            </a:pPr>
-            <a:r>
-              <a:t>  → Harmonic-only would be even faster (less Gaussian overhead)</a:t>
-            </a:r>
-          </a:p>
-          <a:p>
-            <a:pPr>
-              <a:spcAft>
-                <a:spcPts val="400"/>
-              </a:spcAft>
-              <a:defRPr sz="1400">
-                <a:solidFill>
-                  <a:srgbClr val="8B949E"/>
-                </a:solidFill>
-                <a:latin typeface="Consolas"/>
-              </a:defRPr>
-            </a:pPr>
-          </a:p>
-          <a:p>
-            <a:pPr>
-              <a:spcAft>
-                <a:spcPts val="400"/>
-              </a:spcAft>
-              <a:defRPr sz="1400">
-                <a:solidFill>
-                  <a:srgbClr val="8B949E"/>
-                </a:solidFill>
-                <a:latin typeface="Consolas"/>
-              </a:defRPr>
-            </a:pPr>
-            <a:r>
-              <a:t>  // speedup = wall time DFT / wall time ML (same machine, same basis)</a:t>
+              <a:t>  → Aspirin: 21 atoms × 3 dirs × 2 = 126 displacements → ML faster</a:t>
             </a:r>
           </a:p>
         </p:txBody>
@@ -4300,7 +4255,7 @@
               </a:defRPr>
             </a:pPr>
             <a:r>
-              <a:t>  → Frequencies: R² &gt; 0.999 for best combos (MACE-ANI-CC, MACE-OMOL)</a:t>
+              <a:t>  → Frequencies: R² &gt; 0.999 for best combos</a:t>
             </a:r>
           </a:p>
           <a:p>
@@ -4316,7 +4271,7 @@
               </a:defRPr>
             </a:pPr>
             <a:r>
-              <a:t>  → Intensities: MACE4IR &gt;&gt; Espaloma (R² 0.95 vs 0.25 on aspirin)</a:t>
+              <a:t>  → Intensities: MACE4IR &gt;&gt; Espaloma</a:t>
             </a:r>
           </a:p>
           <a:p>
@@ -4332,7 +4287,7 @@
               </a:defRPr>
             </a:pPr>
             <a:r>
-              <a:t>  → Speedup: ~36× on aspirin (incl. anharmonic)</a:t>
+              <a:t>  → Speedup: ~36× on aspirin</a:t>
             </a:r>
           </a:p>
           <a:p>
@@ -4409,7 +4364,7 @@
               </a:defRPr>
             </a:pPr>
             <a:r>
-              <a:t>    Molecules with exotic atoms: S, P, halogens, metals</a:t>
+              <a:t>    Molecules with more exotic atoms: S, P, halogens, metals</a:t>
             </a:r>
           </a:p>
           <a:p>
@@ -4820,13 +4775,74 @@
               </a:spcAft>
               <a:defRPr sz="1400">
                 <a:solidFill>
+                  <a:srgbClr val="8B949E"/>
+                </a:solidFill>
+                <a:latin typeface="Consolas"/>
+              </a:defRPr>
+            </a:pPr>
+          </a:p>
+          <a:p>
+            <a:pPr>
+              <a:spcAft>
+                <a:spcPts val="400"/>
+              </a:spcAft>
+              <a:defRPr sz="1400">
+                <a:solidFill>
+                  <a:srgbClr val="58A6FF"/>
+                </a:solidFill>
+                <a:latin typeface="Consolas"/>
+              </a:defRPr>
+            </a:pPr>
+            <a:r>
+              <a:t># Solution</a:t>
+            </a:r>
+          </a:p>
+          <a:p>
+            <a:pPr>
+              <a:spcAft>
+                <a:spcPts val="400"/>
+              </a:spcAft>
+              <a:defRPr sz="1400">
+                <a:solidFill>
                   <a:srgbClr val="C9D1D9"/>
                 </a:solidFill>
                 <a:latin typeface="Consolas"/>
               </a:defRPr>
             </a:pPr>
             <a:r>
-              <a:t>  → Bottleneck for systematic benchmark campaigns</a:t>
+              <a:t>  → Hybrid ML-QM approach</a:t>
+            </a:r>
+          </a:p>
+          <a:p>
+            <a:pPr>
+              <a:spcAft>
+                <a:spcPts val="400"/>
+              </a:spcAft>
+              <a:defRPr sz="1400">
+                <a:solidFill>
+                  <a:srgbClr val="C9D1D9"/>
+                </a:solidFill>
+                <a:latin typeface="Consolas"/>
+              </a:defRPr>
+            </a:pPr>
+            <a:r>
+              <a:t>  → ML dipoles and energies</a:t>
+            </a:r>
+          </a:p>
+          <a:p>
+            <a:pPr>
+              <a:spcAft>
+                <a:spcPts val="400"/>
+              </a:spcAft>
+              <a:defRPr sz="1400">
+                <a:solidFill>
+                  <a:srgbClr val="C9D1D9"/>
+                </a:solidFill>
+                <a:latin typeface="Consolas"/>
+              </a:defRPr>
+            </a:pPr>
+            <a:r>
+              <a:t>  → Possibly 10–100× faster than pure DFT</a:t>
             </a:r>
           </a:p>
           <a:p>
@@ -4855,7 +4871,7 @@
               </a:defRPr>
             </a:pPr>
             <a:r>
-              <a:t># Solution</a:t>
+              <a:t># Impact</a:t>
             </a:r>
           </a:p>
           <a:p>
@@ -4871,116 +4887,7 @@
               </a:defRPr>
             </a:pPr>
             <a:r>
-              <a:t>  → Hybrid ML-QM approach</a:t>
-            </a:r>
-          </a:p>
-          <a:p>
-            <a:pPr>
-              <a:spcAft>
-                <a:spcPts val="400"/>
-              </a:spcAft>
-              <a:defRPr sz="1400">
-                <a:solidFill>
-                  <a:srgbClr val="C9D1D9"/>
-                </a:solidFill>
-                <a:latin typeface="Consolas"/>
-              </a:defRPr>
-            </a:pPr>
-            <a:r>
-              <a:t>  → ML dipoles and energies</a:t>
-            </a:r>
-          </a:p>
-          <a:p>
-            <a:pPr>
-              <a:spcAft>
-                <a:spcPts val="400"/>
-              </a:spcAft>
-              <a:defRPr sz="1400">
-                <a:solidFill>
-                  <a:srgbClr val="C9D1D9"/>
-                </a:solidFill>
-                <a:latin typeface="Consolas"/>
-              </a:defRPr>
-            </a:pPr>
-            <a:r>
-              <a:t>  → Possibly 10–100× faster than pure DFT</a:t>
-            </a:r>
-          </a:p>
-          <a:p>
-            <a:pPr>
-              <a:spcAft>
-                <a:spcPts val="400"/>
-              </a:spcAft>
-              <a:defRPr sz="1400">
-                <a:solidFill>
-                  <a:srgbClr val="8B949E"/>
-                </a:solidFill>
-                <a:latin typeface="Consolas"/>
-              </a:defRPr>
-            </a:pPr>
-          </a:p>
-          <a:p>
-            <a:pPr>
-              <a:spcAft>
-                <a:spcPts val="400"/>
-              </a:spcAft>
-              <a:defRPr sz="1400">
-                <a:solidFill>
-                  <a:srgbClr val="58A6FF"/>
-                </a:solidFill>
-                <a:latin typeface="Consolas"/>
-              </a:defRPr>
-            </a:pPr>
-            <a:r>
-              <a:t># Impact</a:t>
-            </a:r>
-          </a:p>
-          <a:p>
-            <a:pPr>
-              <a:spcAft>
-                <a:spcPts val="400"/>
-              </a:spcAft>
-              <a:defRPr sz="1400">
-                <a:solidFill>
-                  <a:srgbClr val="C9D1D9"/>
-                </a:solidFill>
-                <a:latin typeface="Consolas"/>
-              </a:defRPr>
-            </a:pPr>
-            <a:r>
-              <a:t>  → Enable rapid IR spectral predictions</a:t>
-            </a:r>
-          </a:p>
-          <a:p>
-            <a:pPr>
-              <a:spcAft>
-                <a:spcPts val="400"/>
-              </a:spcAft>
-              <a:defRPr sz="1400">
-                <a:solidFill>
-                  <a:srgbClr val="C9D1D9"/>
-                </a:solidFill>
-                <a:latin typeface="Consolas"/>
-              </a:defRPr>
-            </a:pPr>
-            <a:r>
-              <a:t>  → Maintain DFT-level accuracy</a:t>
-            </a:r>
-          </a:p>
-          <a:p>
-            <a:pPr>
-              <a:spcAft>
-                <a:spcPts val="400"/>
-              </a:spcAft>
-              <a:defRPr sz="1400">
-                <a:solidFill>
-                  <a:srgbClr val="C9D1D9"/>
-                </a:solidFill>
-                <a:latin typeface="Consolas"/>
-              </a:defRPr>
-            </a:pPr>
-            <a:r>
-              <a:t>  → Systematic comparison: energy surface vs dipole model quality</a:t>
+              <a:t>  → Accelerate IR spectral predictions while maintaining DFT-level accuracy</a:t>
             </a:r>
           </a:p>
         </p:txBody>
@@ -5211,13 +5118,74 @@
               </a:spcAft>
               <a:defRPr sz="1400">
                 <a:solidFill>
+                  <a:srgbClr val="3FB950"/>
+                </a:solidFill>
+                <a:latin typeface="Consolas"/>
+              </a:defRPr>
+            </a:pPr>
+            <a:r>
+              <a:t>  → Eigenvalues = frequencies</a:t>
+            </a:r>
+          </a:p>
+          <a:p>
+            <a:pPr>
+              <a:spcAft>
+                <a:spcPts val="400"/>
+              </a:spcAft>
+              <a:defRPr sz="1400">
+                <a:solidFill>
+                  <a:srgbClr val="D29922"/>
+                </a:solidFill>
+                <a:latin typeface="Consolas"/>
+              </a:defRPr>
+            </a:pPr>
+            <a:r>
+              <a:t>  → Eigenvectors = normal modes</a:t>
+            </a:r>
+          </a:p>
+          <a:p>
+            <a:pPr>
+              <a:spcAft>
+                <a:spcPts val="400"/>
+              </a:spcAft>
+              <a:defRPr sz="1400">
+                <a:solidFill>
                   <a:srgbClr val="C9D1D9"/>
                 </a:solidFill>
                 <a:latin typeface="Consolas"/>
               </a:defRPr>
             </a:pPr>
             <a:r>
-              <a:t>  → Eigenvalues = frequencies, eigenvectors = normal modes</a:t>
+              <a:t>  → 3N−6 modes for N atoms  (e.g. water: 3 modes)</a:t>
+            </a:r>
+          </a:p>
+          <a:p>
+            <a:pPr>
+              <a:spcAft>
+                <a:spcPts val="400"/>
+              </a:spcAft>
+              <a:defRPr sz="1400">
+                <a:solidFill>
+                  <a:srgbClr val="8B949E"/>
+                </a:solidFill>
+                <a:latin typeface="Consolas"/>
+              </a:defRPr>
+            </a:pPr>
+          </a:p>
+          <a:p>
+            <a:pPr>
+              <a:spcAft>
+                <a:spcPts val="400"/>
+              </a:spcAft>
+              <a:defRPr sz="1400">
+                <a:solidFill>
+                  <a:srgbClr val="58A6FF"/>
+                </a:solidFill>
+                <a:latin typeface="Consolas"/>
+              </a:defRPr>
+            </a:pPr>
+            <a:r>
+              <a:t># Where do intensities come from?</a:t>
             </a:r>
           </a:p>
           <a:p>
@@ -5233,7 +5201,55 @@
               </a:defRPr>
             </a:pPr>
             <a:r>
-              <a:t>  → 3N−6 modes for N atoms  (e.g. water: 3 modes)</a:t>
+              <a:t>  → Dipole μ⃗ = charge distribution of the molecule</a:t>
+            </a:r>
+          </a:p>
+          <a:p>
+            <a:pPr>
+              <a:spcAft>
+                <a:spcPts val="400"/>
+              </a:spcAft>
+              <a:defRPr sz="1400">
+                <a:solidFill>
+                  <a:srgbClr val="C9D1D9"/>
+                </a:solidFill>
+                <a:latin typeface="Consolas"/>
+              </a:defRPr>
+            </a:pPr>
+            <a:r>
+              <a:t>  → When atoms vibrate, μ⃗ changes → molecule absorbs IR light</a:t>
+            </a:r>
+          </a:p>
+          <a:p>
+            <a:pPr>
+              <a:spcAft>
+                <a:spcPts val="400"/>
+              </a:spcAft>
+              <a:defRPr sz="1400">
+                <a:solidFill>
+                  <a:srgbClr val="C9D1D9"/>
+                </a:solidFill>
+                <a:latin typeface="Consolas"/>
+              </a:defRPr>
+            </a:pPr>
+            <a:r>
+              <a:t>  → Intensity ∝ |∂μ/∂Q|²  (how much dipole changes per mode)</a:t>
+            </a:r>
+          </a:p>
+          <a:p>
+            <a:pPr>
+              <a:spcAft>
+                <a:spcPts val="400"/>
+              </a:spcAft>
+              <a:defRPr sz="1400">
+                <a:solidFill>
+                  <a:srgbClr val="C9D1D9"/>
+                </a:solidFill>
+                <a:latin typeface="Consolas"/>
+              </a:defRPr>
+            </a:pPr>
+            <a:r>
+              <a:t>  → Dipole μ⃗ must also be evaluated at every displaced geometry</a:t>
             </a:r>
           </a:p>
           <a:p>
@@ -5262,7 +5278,7 @@
               </a:defRPr>
             </a:pPr>
             <a:r>
-              <a:t># Where do intensities come from?</a:t>
+              <a:t># The bottleneck</a:t>
             </a:r>
           </a:p>
           <a:p>
@@ -5278,7 +5294,7 @@
               </a:defRPr>
             </a:pPr>
             <a:r>
-              <a:t>  → Dipole μ⃗ = charge distribution of the molecule</a:t>
+              <a:t>  → Each displacement requires E, forces F, and dipole μ⃗</a:t>
             </a:r>
           </a:p>
           <a:p>
@@ -5294,116 +5310,7 @@
               </a:defRPr>
             </a:pPr>
             <a:r>
-              <a:t>  → When atoms vibrate, μ⃗ changes → molecule absorbs IR light</a:t>
-            </a:r>
-          </a:p>
-          <a:p>
-            <a:pPr>
-              <a:spcAft>
-                <a:spcPts val="400"/>
-              </a:spcAft>
-              <a:defRPr sz="1400">
-                <a:solidFill>
-                  <a:srgbClr val="C9D1D9"/>
-                </a:solidFill>
-                <a:latin typeface="Consolas"/>
-              </a:defRPr>
-            </a:pPr>
-            <a:r>
-              <a:t>  → Intensity ∝ |∂μ/∂Q|²  (how much dipole changes per mode)</a:t>
-            </a:r>
-          </a:p>
-          <a:p>
-            <a:pPr>
-              <a:spcAft>
-                <a:spcPts val="400"/>
-              </a:spcAft>
-              <a:defRPr sz="1400">
-                <a:solidFill>
-                  <a:srgbClr val="C9D1D9"/>
-                </a:solidFill>
-                <a:latin typeface="Consolas"/>
-              </a:defRPr>
-            </a:pPr>
-            <a:r>
-              <a:t>  → So we also need μ⃗ at every displaced geometry</a:t>
-            </a:r>
-          </a:p>
-          <a:p>
-            <a:pPr>
-              <a:spcAft>
-                <a:spcPts val="400"/>
-              </a:spcAft>
-              <a:defRPr sz="1400">
-                <a:solidFill>
-                  <a:srgbClr val="8B949E"/>
-                </a:solidFill>
-                <a:latin typeface="Consolas"/>
-              </a:defRPr>
-            </a:pPr>
-          </a:p>
-          <a:p>
-            <a:pPr>
-              <a:spcAft>
-                <a:spcPts val="400"/>
-              </a:spcAft>
-              <a:defRPr sz="1400">
-                <a:solidFill>
-                  <a:srgbClr val="58A6FF"/>
-                </a:solidFill>
-                <a:latin typeface="Consolas"/>
-              </a:defRPr>
-            </a:pPr>
-            <a:r>
-              <a:t># The bottleneck</a:t>
-            </a:r>
-          </a:p>
-          <a:p>
-            <a:pPr>
-              <a:spcAft>
-                <a:spcPts val="400"/>
-              </a:spcAft>
-              <a:defRPr sz="1400">
-                <a:solidFill>
-                  <a:srgbClr val="C9D1D9"/>
-                </a:solidFill>
-                <a:latin typeface="Consolas"/>
-              </a:defRPr>
-            </a:pPr>
-            <a:r>
-              <a:t>  → Gaussian displaces the molecule hundreds of times</a:t>
-            </a:r>
-          </a:p>
-          <a:p>
-            <a:pPr>
-              <a:spcAft>
-                <a:spcPts val="400"/>
-              </a:spcAft>
-              <a:defRPr sz="1400">
-                <a:solidFill>
-                  <a:srgbClr val="C9D1D9"/>
-                </a:solidFill>
-                <a:latin typeface="Consolas"/>
-              </a:defRPr>
-            </a:pPr>
-            <a:r>
-              <a:t>  → Each time: needs energy E, forces F, and dipole μ⃗</a:t>
-            </a:r>
-          </a:p>
-          <a:p>
-            <a:pPr>
-              <a:spcAft>
-                <a:spcPts val="400"/>
-              </a:spcAft>
-              <a:defRPr sz="1400">
-                <a:solidFill>
-                  <a:srgbClr val="C9D1D9"/>
-                </a:solidFill>
-                <a:latin typeface="Consolas"/>
-              </a:defRPr>
-            </a:pPr>
-            <a:r>
-              <a:t>  → With DFT: minutes to hours per molecule</a:t>
+              <a:t>  → DFT: full electronic structure solve per displacement (min–hrs)</a:t>
             </a:r>
           </a:p>
           <a:p>
@@ -5419,7 +5326,7 @@
               </a:defRPr>
             </a:pPr>
             <a:r>
-              <a:t>  → With ML:  seconds  ← this is what we replace</a:t>
+              <a:t>  → ML:  single forward pass per displacement (seconds)</a:t>
             </a:r>
           </a:p>
         </p:txBody>
@@ -6666,35 +6573,6 @@
               <a:t>  MACE-ANI-CC   organic (CC training data)</a:t>
             </a:r>
           </a:p>
-          <a:p>
-            <a:pPr>
-              <a:spcAft>
-                <a:spcPts val="300"/>
-              </a:spcAft>
-              <a:defRPr sz="1300">
-                <a:solidFill>
-                  <a:srgbClr val="8B949E"/>
-                </a:solidFill>
-                <a:latin typeface="Consolas"/>
-              </a:defRPr>
-            </a:pPr>
-          </a:p>
-          <a:p>
-            <a:pPr>
-              <a:spcAft>
-                <a:spcPts val="300"/>
-              </a:spcAft>
-              <a:defRPr sz="1300">
-                <a:solidFill>
-                  <a:srgbClr val="C9D1D9"/>
-                </a:solidFill>
-                <a:latin typeface="Consolas"/>
-              </a:defRPr>
-            </a:pPr>
-            <a:r>
-              <a:t>  → 4 energy × 2 dipole = 8 combos</a:t>
-            </a:r>
-          </a:p>
         </p:txBody>
       </p:sp>
       <p:sp>
@@ -6765,6 +6643,42 @@
             </a:pPr>
             <a:r>
               <a:t>4</a:t>
+            </a:r>
+          </a:p>
+        </p:txBody>
+      </p:sp>
+      <p:sp>
+        <p:nvSpPr>
+          <p:cNvPr id="7" name="TextBox 6"/>
+          <p:cNvSpPr txBox="1"/>
+          <p:nvPr/>
+        </p:nvSpPr>
+        <p:spPr>
+          <a:xfrm>
+            <a:off x="914400" y="5760720"/>
+            <a:ext cx="7315200" cy="365760"/>
+          </a:xfrm>
+          <a:prstGeom prst="rect">
+            <a:avLst/>
+          </a:prstGeom>
+          <a:noFill/>
+        </p:spPr>
+        <p:txBody>
+          <a:bodyPr wrap="none">
+            <a:spAutoFit/>
+          </a:bodyPr>
+          <a:lstStyle/>
+          <a:p>
+            <a:pPr algn="ctr">
+              <a:defRPr sz="1400" b="1">
+                <a:solidFill>
+                  <a:srgbClr val="58A6FF"/>
+                </a:solidFill>
+                <a:latin typeface="Consolas"/>
+              </a:defRPr>
+            </a:pPr>
+            <a:r>
+              <a:t>4 energy × 2 dipole = 8 combinations</a:t>
             </a:r>
           </a:p>
         </p:txBody>
@@ -6952,7 +6866,7 @@
               </a:defRPr>
             </a:pPr>
             <a:r>
-              <a:t>  │                     │   displacement #n  │                             │</a:t>
+              <a:t>  │                     │  input file        │                             │</a:t>
             </a:r>
           </a:p>
           <a:p>
@@ -6968,7 +6882,7 @@
               </a:defRPr>
             </a:pPr>
             <a:r>
-              <a:t>  │    GAUSSIAN 16      │ ──────────────────→│     gm_helper.py            │</a:t>
+              <a:t>  │    GAUSSIAN 16      │  (geometry #n)     │     gm_helper.py            │</a:t>
             </a:r>
           </a:p>
           <a:p>
@@ -6984,7 +6898,7 @@
               </a:defRPr>
             </a:pPr>
             <a:r>
-              <a:t>  │                     │                    │     (External script)        │</a:t>
+              <a:t>  │                     │ ──────────────────→│     (External script)        │</a:t>
             </a:r>
           </a:p>
           <a:p>
@@ -7000,7 +6914,7 @@
               </a:defRPr>
             </a:pPr>
             <a:r>
-              <a:t>  │    freq=anharmonic  │                    └──────────────┬──────────────┘</a:t>
+              <a:t>  │  freq=anharmonic    │                    │  sends filenames via ZMQ     │</a:t>
             </a:r>
           </a:p>
           <a:p>
@@ -7016,7 +6930,7 @@
               </a:defRPr>
             </a:pPr>
             <a:r>
-              <a:t>  │    external='...'   │                                   │ ZMQ IPC</a:t>
+              <a:t>  │  external='...'     │                    └──────────────┬──────────────┘</a:t>
             </a:r>
           </a:p>
           <a:p>
@@ -7032,7 +6946,7 @@
               </a:defRPr>
             </a:pPr>
             <a:r>
-              <a:t>  │                     │                                   ▼</a:t>
+              <a:t>  │                     │                                   │ ZMQ IPC</a:t>
             </a:r>
           </a:p>
           <a:p>
@@ -7048,7 +6962,7 @@
               </a:defRPr>
             </a:pPr>
             <a:r>
-              <a:t>  │                     │                    ┌─────────────────────────────┐</a:t>
+              <a:t>  │  Displaces molecule │                                   ▼</a:t>
             </a:r>
           </a:p>
           <a:p>
@@ -7058,13 +6972,29 @@
               </a:spcAft>
               <a:defRPr sz="1400">
                 <a:solidFill>
+                  <a:srgbClr val="8B949E"/>
+                </a:solidFill>
+                <a:latin typeface="Consolas"/>
+              </a:defRPr>
+            </a:pPr>
+            <a:r>
+              <a:t>  │  along each coord   │                    ┌─────────────────────────────┐</a:t>
+            </a:r>
+          </a:p>
+          <a:p>
+            <a:pPr>
+              <a:spcAft>
+                <a:spcPts val="0"/>
+              </a:spcAft>
+              <a:defRPr sz="1400">
+                <a:solidFill>
                   <a:srgbClr val="58A6FF"/>
                 </a:solidFill>
                 <a:latin typeface="Consolas"/>
               </a:defRPr>
             </a:pPr>
             <a:r>
-              <a:t>  │                     │                    │     zmq_server.py           │</a:t>
+              <a:t>  │  and calls external │                    │     zmq_server.py           │</a:t>
             </a:r>
           </a:p>
           <a:p>
@@ -7080,7 +7010,7 @@
               </a:defRPr>
             </a:pPr>
             <a:r>
-              <a:t>  │                     │                    │                             │</a:t>
+              <a:t>  │  script each time   │                    │                             │</a:t>
             </a:r>
           </a:p>
           <a:p>
@@ -7090,13 +7020,29 @@
               </a:spcAft>
               <a:defRPr sz="1400">
                 <a:solidFill>
+                  <a:srgbClr val="8B949E"/>
+                </a:solidFill>
+                <a:latin typeface="Consolas"/>
+              </a:defRPr>
+            </a:pPr>
+            <a:r>
+              <a:t>  │                     │     fort.7         │  reads geometry from file    │</a:t>
+            </a:r>
+          </a:p>
+          <a:p>
+            <a:pPr>
+              <a:spcAft>
+                <a:spcPts val="0"/>
+              </a:spcAft>
+              <a:defRPr sz="1400">
+                <a:solidFill>
                   <a:srgbClr val="3FB950"/>
                 </a:solidFill>
                 <a:latin typeface="Consolas"/>
               </a:defRPr>
             </a:pPr>
             <a:r>
-              <a:t>  │                     │     fort.7         │  ┌─ MACE energy → E, F     │</a:t>
+              <a:t>  │                     │ ←──────────────────│  MACE energy calc → E, F    │</a:t>
             </a:r>
           </a:p>
           <a:p>
@@ -7112,7 +7058,7 @@
               </a:defRPr>
             </a:pPr>
             <a:r>
-              <a:t>  │                     │ ←──────────────────│  └─ MACE dipole → μ⃗        │</a:t>
+              <a:t>  │                     │   E, F, μ⃗          │  MACE dipole calc → μ⃗       │</a:t>
             </a:r>
           </a:p>
           <a:p>
@@ -7128,7 +7074,7 @@
               </a:defRPr>
             </a:pPr>
             <a:r>
-              <a:t>  │                     │   E, F, μ⃗          │                             │</a:t>
+              <a:t>  │                     │                    │  writes results to fort.7    │</a:t>
             </a:r>
           </a:p>
           <a:p>
@@ -7147,25 +7093,32 @@
               <a:t>  └─────────────────────┘                    └─────────────────────────────┘</a:t>
             </a:r>
           </a:p>
-          <a:p>
-            <a:pPr>
-              <a:spcAft>
-                <a:spcPts val="0"/>
-              </a:spcAft>
-              <a:defRPr sz="1400">
-                <a:solidFill>
-                  <a:srgbClr val="8B949E"/>
-                </a:solidFill>
-                <a:latin typeface="Consolas"/>
-              </a:defRPr>
-            </a:pPr>
-          </a:p>
-          <a:p>
-            <a:pPr>
-              <a:spcAft>
-                <a:spcPts val="0"/>
-              </a:spcAft>
-              <a:defRPr sz="1400">
+        </p:txBody>
+      </p:sp>
+      <p:sp>
+        <p:nvSpPr>
+          <p:cNvPr id="5" name="TextBox 4"/>
+          <p:cNvSpPr txBox="1"/>
+          <p:nvPr/>
+        </p:nvSpPr>
+        <p:spPr>
+          <a:xfrm>
+            <a:off x="914400" y="5760720"/>
+            <a:ext cx="7315200" cy="365760"/>
+          </a:xfrm>
+          <a:prstGeom prst="rect">
+            <a:avLst/>
+          </a:prstGeom>
+          <a:noFill/>
+        </p:spPr>
+        <p:txBody>
+          <a:bodyPr wrap="none">
+            <a:spAutoFit/>
+          </a:bodyPr>
+          <a:lstStyle/>
+          <a:p>
+            <a:pPr algn="ctr">
+              <a:defRPr sz="1300">
                 <a:solidFill>
                   <a:srgbClr val="C9D1D9"/>
                 </a:solidFill>
@@ -7173,14 +7126,14 @@
               </a:defRPr>
             </a:pPr>
             <a:r>
-              <a:t>  ↻ repeats for every displacement (hundreds per molecule)</a:t>
-            </a:r>
-          </a:p>
-        </p:txBody>
-      </p:sp>
-      <p:sp>
-        <p:nvSpPr>
-          <p:cNvPr id="5" name="TextBox 4"/>
+              <a:t>↻ repeats for every displacement (hundreds per molecule)</a:t>
+            </a:r>
+          </a:p>
+        </p:txBody>
+      </p:sp>
+      <p:sp>
+        <p:nvSpPr>
+          <p:cNvPr id="6" name="TextBox 5"/>
           <p:cNvSpPr txBox="1"/>
           <p:nvPr/>
         </p:nvSpPr>
@@ -7216,7 +7169,7 @@
       </p:sp>
       <p:sp>
         <p:nvSpPr>
-          <p:cNvPr id="6" name="TextBox 5"/>
+          <p:cNvPr id="7" name="TextBox 6"/>
           <p:cNvSpPr txBox="1"/>
           <p:nvPr/>
         </p:nvSpPr>
@@ -7465,7 +7418,7 @@
               </a:defRPr>
             </a:pPr>
             <a:r>
-              <a:t>  Each mode = eigenvector (3N-dim displacement pattern)</a:t>
+              <a:t>  Each mode = eigenvector of the Hessian</a:t>
             </a:r>
           </a:p>
           <a:p>
@@ -8248,7 +8201,7 @@
               </a:defRPr>
             </a:pPr>
             <a:r>
-              <a:t>  mace_anicc      mace_ml       19.0 cm⁻¹   1.0000   0.72</a:t>
+              <a:t>  mace_anicc      MACE4IR       19.0 cm⁻¹   1.0000   0.72</a:t>
             </a:r>
           </a:p>
           <a:p>
@@ -8296,7 +8249,7 @@
               </a:defRPr>
             </a:pPr>
             <a:r>
-              <a:t>  mace_off        mace_ml       20.7 cm⁻¹   0.9999   0.72</a:t>
+              <a:t>  mace_off        MACE4IR       20.7 cm⁻¹   0.9999   0.72</a:t>
             </a:r>
           </a:p>
           <a:p>
@@ -8328,7 +8281,7 @@
               </a:defRPr>
             </a:pPr>
             <a:r>
-              <a:t>  mace_omol       mace_ml       22.7 cm⁻¹   1.0000   0.72</a:t>
+              <a:t>  mace_omol       MACE4IR       22.7 cm⁻¹   1.0000   0.72</a:t>
             </a:r>
           </a:p>
           <a:p>
@@ -8344,7 +8297,7 @@
               </a:defRPr>
             </a:pPr>
             <a:r>
-              <a:t>  mace_mp         mace_ml      106.3 cm⁻¹   1.0000   0.72</a:t>
+              <a:t>  mace_mp         MACE4IR      106.3 cm⁻¹   1.0000   0.72</a:t>
             </a:r>
           </a:p>
           <a:p>
@@ -8389,7 +8342,7 @@
               </a:defRPr>
             </a:pPr>
             <a:r>
-              <a:t>  ⚠ R²(freq) misleading: only 3 data points — any line fits well</a:t>
+              <a:t>  ⚠ R² misleading: only 3 data points — any line fits well</a:t>
             </a:r>
           </a:p>
           <a:p>

</xml_diff>

<commit_message>
polish(slides): drop R² significance line from aspirin slide
Co-Authored-By: Claude Opus 4.6 <noreply@anthropic.com>
</commit_message>
<xml_diff>
--- a/presentation/presentation_v2.pptx
+++ b/presentation/presentation_v2.pptx
@@ -3635,22 +3635,6 @@
                 <a:latin typeface="Consolas"/>
               </a:defRPr>
             </a:pPr>
-          </a:p>
-          <a:p>
-            <a:pPr>
-              <a:spcAft>
-                <a:spcPts val="400"/>
-              </a:spcAft>
-              <a:defRPr sz="1400">
-                <a:solidFill>
-                  <a:srgbClr val="C9D1D9"/>
-                </a:solidFill>
-                <a:latin typeface="Consolas"/>
-              </a:defRPr>
-            </a:pPr>
-            <a:r>
-              <a:t>  → 57 modes: R² now meaningful — MACE-MP drops to 0.9958</a:t>
-            </a:r>
           </a:p>
           <a:p>
             <a:pPr>

</xml_diff>

<commit_message>
fix(slides): add ZMQ 'done' return arrow from server to gm_helper
Co-Authored-By: Claude Opus 4.6 <noreply@anthropic.com>
</commit_message>
<xml_diff>
--- a/presentation/presentation_v2.pptx
+++ b/presentation/presentation_v2.pptx
@@ -6914,7 +6914,7 @@
               </a:defRPr>
             </a:pPr>
             <a:r>
-              <a:t>  │  external='...'     │                    └──────────────┬──────────────┘</a:t>
+              <a:t>  │  external='...'     │                    └───────────┬────────────────┘</a:t>
             </a:r>
           </a:p>
           <a:p>
@@ -6930,7 +6930,7 @@
               </a:defRPr>
             </a:pPr>
             <a:r>
-              <a:t>  │                     │                                   │ ZMQ IPC</a:t>
+              <a:t>  │                     │                          ZMQ ↓ ↑ 'done'</a:t>
             </a:r>
           </a:p>
           <a:p>
@@ -6946,7 +6946,7 @@
               </a:defRPr>
             </a:pPr>
             <a:r>
-              <a:t>  │  Displaces molecule │                                   ▼</a:t>
+              <a:t>  │  Displaces molecule │                    ┌───────────┴────────────────┐</a:t>
             </a:r>
           </a:p>
           <a:p>
@@ -6956,13 +6956,13 @@
               </a:spcAft>
               <a:defRPr sz="1400">
                 <a:solidFill>
-                  <a:srgbClr val="8B949E"/>
-                </a:solidFill>
-                <a:latin typeface="Consolas"/>
-              </a:defRPr>
-            </a:pPr>
-            <a:r>
-              <a:t>  │  along each coord   │                    ┌─────────────────────────────┐</a:t>
+                  <a:srgbClr val="58A6FF"/>
+                </a:solidFill>
+                <a:latin typeface="Consolas"/>
+              </a:defRPr>
+            </a:pPr>
+            <a:r>
+              <a:t>  │  along each coord   │                    │     zmq_server.py           │</a:t>
             </a:r>
           </a:p>
           <a:p>
@@ -6972,13 +6972,13 @@
               </a:spcAft>
               <a:defRPr sz="1400">
                 <a:solidFill>
-                  <a:srgbClr val="58A6FF"/>
-                </a:solidFill>
-                <a:latin typeface="Consolas"/>
-              </a:defRPr>
-            </a:pPr>
-            <a:r>
-              <a:t>  │  and calls external │                    │     zmq_server.py           │</a:t>
+                  <a:srgbClr val="8B949E"/>
+                </a:solidFill>
+                <a:latin typeface="Consolas"/>
+              </a:defRPr>
+            </a:pPr>
+            <a:r>
+              <a:t>  │  and calls external │                    │                             │</a:t>
             </a:r>
           </a:p>
           <a:p>
@@ -6994,7 +6994,7 @@
               </a:defRPr>
             </a:pPr>
             <a:r>
-              <a:t>  │  script each time   │                    │                             │</a:t>
+              <a:t>  │  script each time   │                    │  reads geometry from file    │</a:t>
             </a:r>
           </a:p>
           <a:p>
@@ -7004,13 +7004,13 @@
               </a:spcAft>
               <a:defRPr sz="1400">
                 <a:solidFill>
-                  <a:srgbClr val="8B949E"/>
-                </a:solidFill>
-                <a:latin typeface="Consolas"/>
-              </a:defRPr>
-            </a:pPr>
-            <a:r>
-              <a:t>  │                     │     fort.7         │  reads geometry from file    │</a:t>
+                  <a:srgbClr val="3FB950"/>
+                </a:solidFill>
+                <a:latin typeface="Consolas"/>
+              </a:defRPr>
+            </a:pPr>
+            <a:r>
+              <a:t>  │                     │                    │  MACE energy calc → E, F    │</a:t>
             </a:r>
           </a:p>
           <a:p>
@@ -7026,7 +7026,7 @@
               </a:defRPr>
             </a:pPr>
             <a:r>
-              <a:t>  │                     │ ←──────────────────│  MACE energy calc → E, F    │</a:t>
+              <a:t>  │  reads fort.7 when  │     fort.7         │  MACE dipole calc → μ⃗       │</a:t>
             </a:r>
           </a:p>
           <a:p>
@@ -7036,29 +7036,13 @@
               </a:spcAft>
               <a:defRPr sz="1400">
                 <a:solidFill>
-                  <a:srgbClr val="3FB950"/>
-                </a:solidFill>
-                <a:latin typeface="Consolas"/>
-              </a:defRPr>
-            </a:pPr>
-            <a:r>
-              <a:t>  │                     │   E, F, μ⃗          │  MACE dipole calc → μ⃗       │</a:t>
-            </a:r>
-          </a:p>
-          <a:p>
-            <a:pPr>
-              <a:spcAft>
-                <a:spcPts val="0"/>
-              </a:spcAft>
-              <a:defRPr sz="1400">
-                <a:solidFill>
-                  <a:srgbClr val="8B949E"/>
-                </a:solidFill>
-                <a:latin typeface="Consolas"/>
-              </a:defRPr>
-            </a:pPr>
-            <a:r>
-              <a:t>  │                     │                    │  writes results to fort.7    │</a:t>
+                  <a:srgbClr val="8B949E"/>
+                </a:solidFill>
+                <a:latin typeface="Consolas"/>
+              </a:defRPr>
+            </a:pPr>
+            <a:r>
+              <a:t>  │  helper exits       │ ←──────────────────│  writes results to fort.7    │</a:t>
             </a:r>
           </a:p>
           <a:p>

</xml_diff>

<commit_message>
fix(slides): ZMQ diagram — restore E,F,mu line, fix box alignment, consistent arrows
Co-Authored-By: Claude Opus 4.6 <noreply@anthropic.com>
</commit_message>
<xml_diff>
--- a/presentation/presentation_v2.pptx
+++ b/presentation/presentation_v2.pptx
@@ -6914,7 +6914,7 @@
               </a:defRPr>
             </a:pPr>
             <a:r>
-              <a:t>  │  external='...'     │                    └───────────┬────────────────┘</a:t>
+              <a:t>  │  external='...'     │                    └──────────────┬──────────────┘</a:t>
             </a:r>
           </a:p>
           <a:p>
@@ -6930,7 +6930,7 @@
               </a:defRPr>
             </a:pPr>
             <a:r>
-              <a:t>  │                     │                          ZMQ ↓ ↑ 'done'</a:t>
+              <a:t>  │                     │                            ZMQ ▼ ▲ 'done'</a:t>
             </a:r>
           </a:p>
           <a:p>
@@ -6946,7 +6946,7 @@
               </a:defRPr>
             </a:pPr>
             <a:r>
-              <a:t>  │  Displaces molecule │                    ┌───────────┴────────────────┐</a:t>
+              <a:t>  │  Displaces molecule │                    ┌──────────────┴──────────────┐</a:t>
             </a:r>
           </a:p>
           <a:p>
@@ -7043,6 +7043,22 @@
             </a:pPr>
             <a:r>
               <a:t>  │  helper exits       │ ←──────────────────│  writes results to fort.7    │</a:t>
+            </a:r>
+          </a:p>
+          <a:p>
+            <a:pPr>
+              <a:spcAft>
+                <a:spcPts val="0"/>
+              </a:spcAft>
+              <a:defRPr sz="1400">
+                <a:solidFill>
+                  <a:srgbClr val="8B949E"/>
+                </a:solidFill>
+                <a:latin typeface="Consolas"/>
+              </a:defRPr>
+            </a:pPr>
+            <a:r>
+              <a:t>  │                     │   E, F, μ⃗          │                             │</a:t>
             </a:r>
           </a:p>
           <a:p>

</xml_diff>

<commit_message>
fix(slides): ZMQ diagram — clean box edges, fix colors for E,F,mu and fort.7
Co-Authored-By: Claude Opus 4.6 <noreply@anthropic.com>
</commit_message>
<xml_diff>
--- a/presentation/presentation_v2.pptx
+++ b/presentation/presentation_v2.pptx
@@ -6882,7 +6882,7 @@
               </a:defRPr>
             </a:pPr>
             <a:r>
-              <a:t>  │                     │ ──────────────────→│     (External script)        │</a:t>
+              <a:t>  │                     │ ──────────────────→│     (External script)       │</a:t>
             </a:r>
           </a:p>
           <a:p>
@@ -6898,7 +6898,7 @@
               </a:defRPr>
             </a:pPr>
             <a:r>
-              <a:t>  │  freq=anharmonic    │                    │  sends filenames via ZMQ     │</a:t>
+              <a:t>  │  freq=anharmonic    │                    │  sends filenames via ZMQ    │</a:t>
             </a:r>
           </a:p>
           <a:p>
@@ -6914,7 +6914,7 @@
               </a:defRPr>
             </a:pPr>
             <a:r>
-              <a:t>  │  external='...'     │                    └──────────────┬──────────────┘</a:t>
+              <a:t>  │  external='...'     │                    └─────────────────────────────┘</a:t>
             </a:r>
           </a:p>
           <a:p>
@@ -6946,7 +6946,7 @@
               </a:defRPr>
             </a:pPr>
             <a:r>
-              <a:t>  │  Displaces molecule │                    ┌──────────────┴──────────────┐</a:t>
+              <a:t>  │  Displaces molecule │                    ┌─────────────────────────────┐</a:t>
             </a:r>
           </a:p>
           <a:p>
@@ -6994,7 +6994,7 @@
               </a:defRPr>
             </a:pPr>
             <a:r>
-              <a:t>  │  script each time   │                    │  reads geometry from file    │</a:t>
+              <a:t>  │  script each time   │                    │  reads geometry from file   │</a:t>
             </a:r>
           </a:p>
           <a:p>
@@ -7010,7 +7010,7 @@
               </a:defRPr>
             </a:pPr>
             <a:r>
-              <a:t>  │                     │                    │  MACE energy calc → E, F    │</a:t>
+              <a:t>  │                     │                    │  MACE energy calc → E, F   │</a:t>
             </a:r>
           </a:p>
           <a:p>
@@ -7026,7 +7026,7 @@
               </a:defRPr>
             </a:pPr>
             <a:r>
-              <a:t>  │  reads fort.7 when  │     fort.7         │  MACE dipole calc → μ⃗       │</a:t>
+              <a:t>  │  reads fort.7 when  │     fort.7         │  MACE dipole calc → μ⃗      │</a:t>
             </a:r>
           </a:p>
           <a:p>
@@ -7042,7 +7042,7 @@
               </a:defRPr>
             </a:pPr>
             <a:r>
-              <a:t>  │  helper exits       │ ←──────────────────│  writes results to fort.7    │</a:t>
+              <a:t>  │  helper exits       │ ←──────────────────│  writes results to fort.7  │</a:t>
             </a:r>
           </a:p>
           <a:p>
@@ -7052,7 +7052,7 @@
               </a:spcAft>
               <a:defRPr sz="1400">
                 <a:solidFill>
-                  <a:srgbClr val="8B949E"/>
+                  <a:srgbClr val="3FB950"/>
                 </a:solidFill>
                 <a:latin typeface="Consolas"/>
               </a:defRPr>

</xml_diff>